<commit_message>
Add the poster illustration to the deck cover and drop the corner kickers
The cover now shows the poster-1 illustration on the right with the
logo beside the title. The small orange labels in each slide's top-left
corner are removed; the school-required section names and appendix
letters move into the titles so cross-references still resolve. The
break-even box now says 4 paid Pro accounts and shows revenue against
cost instead of a bare '4 accounts'.

Co-Authored-By: Claude Opus 5.5 <noreply@anthropic.com>
</commit_message>
<xml_diff>
--- a/output/ppt-review-20261011/final/MeBOD_複審簡報_第二輪修訂版.pptx
+++ b/output/ppt-review-20261011/final/MeBOD_複審簡報_第二輪修訂版.pptx
@@ -3536,6 +3536,30 @@
       <p:grpSpPr>
         <a:xfrm xmlns:a="http://schemas.openxmlformats.org/drawingml/2006/main"/>
       </p:grpSpPr>
+      <p:pic xmlns:a="http://schemas.openxmlformats.org/drawingml/2006/main" xmlns:r="http://schemas.openxmlformats.org/officeDocument/2006/relationships">
+        <p:nvPicPr>
+          <p:cNvPr id="12" name="Cover Illustration" descr="cover-hero.png"/>
+          <p:cNvPicPr>
+            <a:picLocks noChangeAspect="1"/>
+          </p:cNvPicPr>
+          <p:nvPr/>
+        </p:nvPicPr>
+        <p:blipFill>
+          <a:blip r:embed="rId5"/>
+          <a:stretch>
+            <a:fillRect/>
+          </a:stretch>
+        </p:blipFill>
+        <p:spPr>
+          <a:xfrm>
+            <a:off x="6309360" y="0"/>
+            <a:ext cx="5880199" cy="6858000"/>
+          </a:xfrm>
+          <a:prstGeom prst="rect">
+            <a:avLst/>
+          </a:prstGeom>
+        </p:spPr>
+      </p:pic>
       <p:sp>
         <p:nvSpPr>
           <p:cNvPr id="5" name="Text 2">
@@ -3553,7 +3577,7 @@
         <p:spPr>
           <a:xfrm xmlns:a="http://schemas.openxmlformats.org/drawingml/2006/main">
             <a:off x="731520" y="1463040"/>
-            <a:ext cx="7315200" cy="320040"/>
+            <a:ext cx="5577840" cy="320040"/>
           </a:xfrm>
           <a:prstGeom xmlns:a="http://schemas.openxmlformats.org/drawingml/2006/main" prst="rect">
             <a:avLst/>
@@ -3598,8 +3622,8 @@
         </p:nvSpPr>
         <p:spPr>
           <a:xfrm xmlns:a="http://schemas.openxmlformats.org/drawingml/2006/main">
-            <a:off x="731520" y="1874520"/>
-            <a:ext cx="7315200" cy="1005840"/>
+            <a:off x="1783080" y="1874520"/>
+            <a:ext cx="4480560" cy="1005840"/>
           </a:xfrm>
           <a:prstGeom xmlns:a="http://schemas.openxmlformats.org/drawingml/2006/main" prst="rect">
             <a:avLst/>
@@ -3645,7 +3669,7 @@
         <p:spPr>
           <a:xfrm xmlns:a="http://schemas.openxmlformats.org/drawingml/2006/main">
             <a:off x="731520" y="2926080"/>
-            <a:ext cx="7315200" cy="502920"/>
+            <a:ext cx="5577840" cy="502920"/>
           </a:xfrm>
           <a:prstGeom xmlns:a="http://schemas.openxmlformats.org/drawingml/2006/main" prst="rect">
             <a:avLst/>
@@ -3691,7 +3715,7 @@
         <p:spPr>
           <a:xfrm xmlns:a="http://schemas.openxmlformats.org/drawingml/2006/main">
             <a:off x="731520" y="3611880"/>
-            <a:ext cx="7680960" cy="411480"/>
+            <a:ext cx="5577840" cy="411480"/>
           </a:xfrm>
           <a:prstGeom xmlns:a="http://schemas.openxmlformats.org/drawingml/2006/main" prst="rect">
             <a:avLst/>
@@ -3736,8 +3760,8 @@
         </p:nvSpPr>
         <p:spPr>
           <a:xfrm xmlns:a="http://schemas.openxmlformats.org/drawingml/2006/main">
-            <a:off x="731520" y="5623560"/>
-            <a:ext cx="10058400" cy="320040"/>
+            <a:off x="731520" y="5257800"/>
+            <a:ext cx="5577840" cy="731520"/>
           </a:xfrm>
           <a:prstGeom xmlns:a="http://schemas.openxmlformats.org/drawingml/2006/main" prst="rect">
             <a:avLst/>
@@ -3760,10 +3784,27 @@
                 <a:ea typeface="Microsoft JhengHei"/>
                 <a:cs typeface="Microsoft JhengHei"/>
               </a:rPr>
-              <a:t>組長 陳威帆 11246044　｜　組員 許家全 11246039　｜　指導老師 陳信宏</a:t>
+              <a:t>組長 陳威帆 11246044　｜　組員 許家全 11246039</a:t>
             </a:r>
             <a:endParaRPr sz="1400"/>
           </a:p>
+          <a:p xmlns:a="http://schemas.openxmlformats.org/drawingml/2006/main">
+            <a:pPr marL="0" indent="0">
+              <a:buNone/>
+            </a:pPr>
+            <a:r>
+              <a:rPr sz="1400">
+                <a:solidFill>
+                  <a:srgbClr val="7A8CA3"/>
+                </a:solidFill>
+                <a:latin typeface="Microsoft JhengHei"/>
+                <a:ea typeface="Microsoft JhengHei"/>
+                <a:cs typeface="Microsoft JhengHei"/>
+              </a:rPr>
+              <a:t>指導老師 陳信宏 老師</a:t>
+            </a:r>
+            <a:endParaRPr sz="1400"/>
+          </a:p>
         </p:txBody>
       </p:sp>
       <p:sp>
@@ -3783,7 +3824,7 @@
         <p:spPr>
           <a:xfrm xmlns:a="http://schemas.openxmlformats.org/drawingml/2006/main">
             <a:off x="731520" y="5989320"/>
-            <a:ext cx="10058400" cy="320040"/>
+            <a:ext cx="5577840" cy="320040"/>
           </a:xfrm>
           <a:prstGeom xmlns:a="http://schemas.openxmlformats.org/drawingml/2006/main" prst="rect">
             <a:avLst/>
@@ -3872,7 +3913,7 @@
       </p:sp>
       <p:pic xmlns:a="http://schemas.openxmlformats.org/drawingml/2006/main" xmlns:r="http://schemas.openxmlformats.org/officeDocument/2006/relationships">
         <p:nvPicPr>
-          <p:cNvPr id="12" name="MeBOD Logo" descr="mebod-mark.png"/>
+          <p:cNvPr id="13" name="MeBOD Logo" descr="image.png"/>
           <p:cNvPicPr>
             <a:picLocks noChangeAspect="1"/>
           </p:cNvPicPr>
@@ -3886,16 +3927,16 @@
         </p:blipFill>
         <p:spPr>
           <a:xfrm>
-            <a:off x="8915400" y="1325880"/>
-            <a:ext cx="2514600" cy="2514600"/>
+            <a:off x="731520" y="1984248"/>
+            <a:ext cx="868680" cy="868680"/>
           </a:xfrm>
           <a:prstGeom prst="rect">
             <a:avLst/>
           </a:prstGeom>
           <a:effectLst>
-            <a:outerShdw blurRad="381000" dist="152400" dir="5400000" algn="t" rotWithShape="0">
+            <a:outerShdw blurRad="152400" dist="50800" dir="5400000" algn="t" rotWithShape="0">
               <a:srgbClr val="4F46E5">
-                <a:alpha val="28000"/>
+                <a:alpha val="30000"/>
               </a:srgbClr>
             </a:outerShdw>
           </a:effectLst>
@@ -3932,52 +3973,6 @@
       </p:grpSpPr>
       <p:sp>
         <p:nvSpPr>
-          <p:cNvPr id="2" name="Text 0">
-            <a:extLst xmlns:a="http://schemas.openxmlformats.org/drawingml/2006/main">
-              <a:ext uri="{FF2B5EF4-FFF2-40B4-BE49-F238E27FC236}">
-                <a16:creationId xmlns:a16="http://schemas.microsoft.com/office/drawing/2014/main" id="{AB329953-4910-47FA-969C-2A92C2CC35F4}"/>
-              </a:ext>
-            </a:extLst>
-          </p:cNvPr>
-          <p:cNvSpPr>
-            <a:spLocks xmlns:a="http://schemas.openxmlformats.org/drawingml/2006/main" noGrp="1"/>
-          </p:cNvSpPr>
-          <p:nvPr/>
-        </p:nvSpPr>
-        <p:spPr>
-          <a:xfrm xmlns:a="http://schemas.openxmlformats.org/drawingml/2006/main">
-            <a:off x="731520" y="457200"/>
-            <a:ext cx="7315200" cy="274320"/>
-          </a:xfrm>
-          <a:prstGeom xmlns:a="http://schemas.openxmlformats.org/drawingml/2006/main" prst="rect">
-            <a:avLst/>
-          </a:prstGeom>
-          <a:noFill xmlns:a="http://schemas.openxmlformats.org/drawingml/2006/main"/>
-        </p:spPr>
-        <p:txBody>
-          <a:bodyPr xmlns:a="http://schemas.openxmlformats.org/drawingml/2006/main" wrap="square" lIns="0" tIns="0" rIns="0" bIns="0" anchor="t"/>
-          <a:lstStyle xmlns:a="http://schemas.openxmlformats.org/drawingml/2006/main"/>
-          <a:p xmlns:a="http://schemas.openxmlformats.org/drawingml/2006/main">
-            <a:pPr marL="0" indent="0">
-              <a:buNone/>
-            </a:pPr>
-            <a:r>
-              <a:rPr sz="1300" b="1" spc="200">
-                <a:solidFill>
-                  <a:srgbClr val="D46A12"/>
-                </a:solidFill>
-                <a:latin typeface="Microsoft JhengHei"/>
-                <a:ea typeface="Microsoft JhengHei"/>
-                <a:cs typeface="Microsoft JhengHei"/>
-              </a:rPr>
-              <a:t>評審C · 爬蟲觸發 ／ 評審B · 資料篩選</a:t>
-            </a:r>
-            <a:endParaRPr sz="1300"/>
-          </a:p>
-        </p:txBody>
-      </p:sp>
-      <p:sp>
-        <p:nvSpPr>
           <p:cNvPr id="4" name="Text 2">
             <a:extLst xmlns:a="http://schemas.openxmlformats.org/drawingml/2006/main">
               <a:ext uri="{FF2B5EF4-FFF2-40B4-BE49-F238E27FC236}">
@@ -4056,6 +4051,10 @@
             <a:prstDash val="solid"/>
           </a:ln>
         </p:spPr>
+        <p:txBody xmlns:a="http://schemas.openxmlformats.org/drawingml/2006/main">
+          <a:bodyPr/>
+          <a:p/>
+        </p:txBody>
       </p:sp>
       <p:sp>
         <p:nvSpPr>
@@ -4089,6 +4088,10 @@
             <a:prstDash val="solid"/>
           </a:ln>
         </p:spPr>
+        <p:txBody xmlns:a="http://schemas.openxmlformats.org/drawingml/2006/main">
+          <a:bodyPr/>
+          <a:p/>
+        </p:txBody>
       </p:sp>
       <p:pic>
         <p:nvPicPr>
@@ -4293,6 +4296,10 @@
             <a:prstDash val="solid"/>
           </a:ln>
         </p:spPr>
+        <p:txBody xmlns:a="http://schemas.openxmlformats.org/drawingml/2006/main">
+          <a:bodyPr/>
+          <a:p/>
+        </p:txBody>
       </p:sp>
       <p:sp>
         <p:nvSpPr>
@@ -4326,6 +4333,10 @@
             <a:prstDash val="solid"/>
           </a:ln>
         </p:spPr>
+        <p:txBody xmlns:a="http://schemas.openxmlformats.org/drawingml/2006/main">
+          <a:bodyPr/>
+          <a:p/>
+        </p:txBody>
       </p:sp>
       <p:pic>
         <p:nvPicPr>
@@ -4530,6 +4541,10 @@
             <a:prstDash val="solid"/>
           </a:ln>
         </p:spPr>
+        <p:txBody xmlns:a="http://schemas.openxmlformats.org/drawingml/2006/main">
+          <a:bodyPr/>
+          <a:p/>
+        </p:txBody>
       </p:sp>
       <p:sp>
         <p:nvSpPr>
@@ -4563,6 +4578,10 @@
             <a:prstDash val="solid"/>
           </a:ln>
         </p:spPr>
+        <p:txBody xmlns:a="http://schemas.openxmlformats.org/drawingml/2006/main">
+          <a:bodyPr/>
+          <a:p/>
+        </p:txBody>
       </p:sp>
       <p:pic>
         <p:nvPicPr>
@@ -4766,6 +4785,10 @@
             <a:prstDash val="solid"/>
           </a:ln>
         </p:spPr>
+        <p:txBody xmlns:a="http://schemas.openxmlformats.org/drawingml/2006/main">
+          <a:bodyPr/>
+          <a:p/>
+        </p:txBody>
       </p:sp>
       <p:sp>
         <p:nvSpPr>
@@ -4799,6 +4822,10 @@
             <a:prstDash val="solid"/>
           </a:ln>
         </p:spPr>
+        <p:txBody xmlns:a="http://schemas.openxmlformats.org/drawingml/2006/main">
+          <a:bodyPr/>
+          <a:p/>
+        </p:txBody>
       </p:sp>
       <p:pic>
         <p:nvPicPr>
@@ -4973,6 +5000,10 @@
             <a:prstDash val="solid"/>
           </a:ln>
         </p:spPr>
+        <p:txBody xmlns:a="http://schemas.openxmlformats.org/drawingml/2006/main">
+          <a:bodyPr/>
+          <a:p/>
+        </p:txBody>
       </p:sp>
       <p:sp>
         <p:nvSpPr>
@@ -5054,6 +5085,10 @@
             <a:prstDash val="solid"/>
           </a:ln>
         </p:spPr>
+        <p:txBody xmlns:a="http://schemas.openxmlformats.org/drawingml/2006/main">
+          <a:bodyPr/>
+          <a:p/>
+        </p:txBody>
       </p:sp>
       <p:sp>
         <p:nvSpPr>
@@ -5135,6 +5170,10 @@
             <a:prstDash val="solid"/>
           </a:ln>
         </p:spPr>
+        <p:txBody xmlns:a="http://schemas.openxmlformats.org/drawingml/2006/main">
+          <a:bodyPr/>
+          <a:p/>
+        </p:txBody>
       </p:sp>
       <p:sp>
         <p:nvSpPr>
@@ -5329,64 +5368,6 @@
       </p:grpSpPr>
       <p:sp>
         <p:nvSpPr>
-          <p:cNvPr id="25" name="評審 B · RAG 修正">
-            <a:extLst xmlns:a="http://schemas.openxmlformats.org/drawingml/2006/main">
-              <a:ext uri="{FF2B5EF4-FFF2-40B4-BE49-F238E27FC236}">
-                <a16:creationId xmlns:a16="http://schemas.microsoft.com/office/drawing/2014/main" id="{75DE63E1-E2C4-45FD-85D0-6BD338CA52D7}"/>
-              </a:ext>
-            </a:extLst>
-          </p:cNvPr>
-          <p:cNvSpPr>
-            <a:spLocks xmlns:a="http://schemas.openxmlformats.org/drawingml/2006/main" noGrp="1"/>
-          </p:cNvSpPr>
-          <p:nvPr/>
-        </p:nvSpPr>
-        <p:spPr>
-          <a:xfrm xmlns:a="http://schemas.openxmlformats.org/drawingml/2006/main">
-            <a:off x="733425" y="447675"/>
-            <a:ext cx="10287000" cy="304800"/>
-          </a:xfrm>
-          <a:prstGeom xmlns:a="http://schemas.openxmlformats.org/drawingml/2006/main" prst="rect">
-            <a:avLst/>
-          </a:prstGeom>
-          <a:noFill xmlns:a="http://schemas.openxmlformats.org/drawingml/2006/main"/>
-          <a:ln xmlns:a="http://schemas.openxmlformats.org/drawingml/2006/main" w="0">
-            <a:noFill/>
-          </a:ln>
-        </p:spPr>
-        <p:txBody>
-          <a:bodyPr xmlns:a="http://schemas.openxmlformats.org/drawingml/2006/main" lIns="0" tIns="0" rIns="0" bIns="0"/>
-          <a:lstStyle xmlns:a="http://schemas.openxmlformats.org/drawingml/2006/main">
-            <a:defPPr>
-              <a:defRPr sz="1350" b="1">
-                <a:solidFill>
-                  <a:srgbClr val="C85C00"/>
-                </a:solidFill>
-              </a:defRPr>
-            </a:defPPr>
-          </a:lstStyle>
-          <a:p xmlns:a="http://schemas.openxmlformats.org/drawingml/2006/main">
-            <a:pPr>
-              <a:buNone/>
-              <a:defRPr sz="1350" b="1">
-                <a:solidFill>
-                  <a:srgbClr val="C85C00"/>
-                </a:solidFill>
-              </a:defRPr>
-            </a:pPr>
-            <a:r>
-              <a:rPr sz="1350" b="1">
-                <a:solidFill>
-                  <a:srgbClr val="C85C00"/>
-                </a:solidFill>
-              </a:rPr>
-              <a:t>評審 B · RAG 修正</a:t>
-            </a:r>
-          </a:p>
-        </p:txBody>
-      </p:sp>
-      <p:sp>
-        <p:nvSpPr>
           <p:cNvPr id="2" name="RAG：先找證據，再依問題整理答案">
             <a:extLst xmlns:a="http://schemas.openxmlformats.org/drawingml/2006/main">
               <a:ext uri="{FF2B5EF4-FFF2-40B4-BE49-F238E27FC236}">
@@ -5476,6 +5457,10 @@
             </a:solidFill>
           </a:ln>
         </p:spPr>
+        <p:txBody xmlns:a="http://schemas.openxmlformats.org/drawingml/2006/main">
+          <a:bodyPr/>
+          <a:p/>
+        </p:txBody>
       </p:sp>
       <p:sp>
         <p:nvSpPr>
@@ -5702,6 +5687,10 @@
             </a:solidFill>
           </a:ln>
         </p:spPr>
+        <p:txBody xmlns:a="http://schemas.openxmlformats.org/drawingml/2006/main">
+          <a:bodyPr/>
+          <a:p/>
+        </p:txBody>
       </p:sp>
       <p:sp>
         <p:nvSpPr>
@@ -5928,6 +5917,10 @@
             </a:solidFill>
           </a:ln>
         </p:spPr>
+        <p:txBody xmlns:a="http://schemas.openxmlformats.org/drawingml/2006/main">
+          <a:bodyPr/>
+          <a:p/>
+        </p:txBody>
       </p:sp>
       <p:sp>
         <p:nvSpPr>
@@ -6154,6 +6147,10 @@
             </a:solidFill>
           </a:ln>
         </p:spPr>
+        <p:txBody xmlns:a="http://schemas.openxmlformats.org/drawingml/2006/main">
+          <a:bodyPr/>
+          <a:p/>
+        </p:txBody>
       </p:sp>
       <p:sp>
         <p:nvSpPr>
@@ -6496,6 +6493,10 @@
             </a:solidFill>
           </a:ln>
         </p:spPr>
+        <p:txBody xmlns:a="http://schemas.openxmlformats.org/drawingml/2006/main">
+          <a:bodyPr/>
+          <a:p/>
+        </p:txBody>
       </p:sp>
       <p:sp>
         <p:nvSpPr>
@@ -6702,52 +6703,6 @@
       </p:grpSpPr>
       <p:sp>
         <p:nvSpPr>
-          <p:cNvPr id="2" name="Text 0">
-            <a:extLst xmlns:a="http://schemas.openxmlformats.org/drawingml/2006/main">
-              <a:ext uri="{FF2B5EF4-FFF2-40B4-BE49-F238E27FC236}">
-                <a16:creationId xmlns:a16="http://schemas.microsoft.com/office/drawing/2014/main" id="{7BAAFB14-3979-4C29-A168-E86AC5F85444}"/>
-              </a:ext>
-            </a:extLst>
-          </p:cNvPr>
-          <p:cNvSpPr>
-            <a:spLocks xmlns:a="http://schemas.openxmlformats.org/drawingml/2006/main" noGrp="1"/>
-          </p:cNvSpPr>
-          <p:nvPr/>
-        </p:nvSpPr>
-        <p:spPr>
-          <a:xfrm xmlns:a="http://schemas.openxmlformats.org/drawingml/2006/main">
-            <a:off x="731520" y="457200"/>
-            <a:ext cx="7315200" cy="274320"/>
-          </a:xfrm>
-          <a:prstGeom xmlns:a="http://schemas.openxmlformats.org/drawingml/2006/main" prst="rect">
-            <a:avLst/>
-          </a:prstGeom>
-          <a:noFill xmlns:a="http://schemas.openxmlformats.org/drawingml/2006/main"/>
-        </p:spPr>
-        <p:txBody>
-          <a:bodyPr xmlns:a="http://schemas.openxmlformats.org/drawingml/2006/main" wrap="square" lIns="0" tIns="0" rIns="0" bIns="0" anchor="t"/>
-          <a:lstStyle xmlns:a="http://schemas.openxmlformats.org/drawingml/2006/main"/>
-          <a:p xmlns:a="http://schemas.openxmlformats.org/drawingml/2006/main">
-            <a:pPr marL="0" indent="0">
-              <a:buNone/>
-            </a:pPr>
-            <a:r>
-              <a:rPr sz="1300" b="1" spc="200">
-                <a:solidFill>
-                  <a:srgbClr val="D46A12"/>
-                </a:solidFill>
-                <a:latin typeface="Microsoft JhengHei"/>
-                <a:ea typeface="Microsoft JhengHei"/>
-                <a:cs typeface="Microsoft JhengHei"/>
-              </a:rPr>
-              <a:t>評審B · 分數一致性</a:t>
-            </a:r>
-            <a:endParaRPr sz="1300"/>
-          </a:p>
-        </p:txBody>
-      </p:sp>
-      <p:sp>
-        <p:nvSpPr>
           <p:cNvPr id="4" name="Text 2">
             <a:extLst xmlns:a="http://schemas.openxmlformats.org/drawingml/2006/main">
               <a:ext uri="{FF2B5EF4-FFF2-40B4-BE49-F238E27FC236}">
@@ -6826,6 +6781,10 @@
             <a:prstDash val="solid"/>
           </a:ln>
         </p:spPr>
+        <p:txBody xmlns:a="http://schemas.openxmlformats.org/drawingml/2006/main">
+          <a:bodyPr/>
+          <a:p/>
+        </p:txBody>
       </p:sp>
       <p:sp>
         <p:nvSpPr>
@@ -6999,6 +6958,10 @@
             <a:prstDash val="solid"/>
           </a:ln>
         </p:spPr>
+        <p:txBody xmlns:a="http://schemas.openxmlformats.org/drawingml/2006/main">
+          <a:bodyPr/>
+          <a:p/>
+        </p:txBody>
       </p:sp>
       <p:sp>
         <p:nvSpPr>
@@ -7172,6 +7135,10 @@
             <a:prstDash val="solid"/>
           </a:ln>
         </p:spPr>
+        <p:txBody xmlns:a="http://schemas.openxmlformats.org/drawingml/2006/main">
+          <a:bodyPr/>
+          <a:p/>
+        </p:txBody>
       </p:sp>
       <p:sp>
         <p:nvSpPr>
@@ -7345,6 +7312,10 @@
             <a:prstDash val="solid"/>
           </a:ln>
         </p:spPr>
+        <p:txBody xmlns:a="http://schemas.openxmlformats.org/drawingml/2006/main">
+          <a:bodyPr/>
+          <a:p/>
+        </p:txBody>
       </p:sp>
       <p:sp>
         <p:nvSpPr>
@@ -7472,6 +7443,10 @@
             <a:prstDash val="solid"/>
           </a:ln>
         </p:spPr>
+        <p:txBody xmlns:a="http://schemas.openxmlformats.org/drawingml/2006/main">
+          <a:bodyPr/>
+          <a:p/>
+        </p:txBody>
       </p:sp>
       <p:sp>
         <p:nvSpPr>
@@ -7666,52 +7641,6 @@
       </p:grpSpPr>
       <p:sp>
         <p:nvSpPr>
-          <p:cNvPr id="2" name="Text 0">
-            <a:extLst xmlns:a="http://schemas.openxmlformats.org/drawingml/2006/main">
-              <a:ext uri="{FF2B5EF4-FFF2-40B4-BE49-F238E27FC236}">
-                <a16:creationId xmlns:a16="http://schemas.microsoft.com/office/drawing/2014/main" id="{58E45A7A-556D-4F81-83A7-14615AB27198}"/>
-              </a:ext>
-            </a:extLst>
-          </p:cNvPr>
-          <p:cNvSpPr>
-            <a:spLocks xmlns:a="http://schemas.openxmlformats.org/drawingml/2006/main" noGrp="1"/>
-          </p:cNvSpPr>
-          <p:nvPr/>
-        </p:nvSpPr>
-        <p:spPr>
-          <a:xfrm xmlns:a="http://schemas.openxmlformats.org/drawingml/2006/main">
-            <a:off x="731520" y="457200"/>
-            <a:ext cx="7315200" cy="274320"/>
-          </a:xfrm>
-          <a:prstGeom xmlns:a="http://schemas.openxmlformats.org/drawingml/2006/main" prst="rect">
-            <a:avLst/>
-          </a:prstGeom>
-          <a:noFill xmlns:a="http://schemas.openxmlformats.org/drawingml/2006/main"/>
-        </p:spPr>
-        <p:txBody>
-          <a:bodyPr xmlns:a="http://schemas.openxmlformats.org/drawingml/2006/main" wrap="square" lIns="0" tIns="0" rIns="0" bIns="0" anchor="t"/>
-          <a:lstStyle xmlns:a="http://schemas.openxmlformats.org/drawingml/2006/main"/>
-          <a:p xmlns:a="http://schemas.openxmlformats.org/drawingml/2006/main">
-            <a:pPr marL="0" indent="0">
-              <a:buNone/>
-            </a:pPr>
-            <a:r>
-              <a:rPr sz="1300" b="1" spc="200">
-                <a:solidFill>
-                  <a:srgbClr val="D46A12"/>
-                </a:solidFill>
-                <a:latin typeface="Microsoft JhengHei"/>
-                <a:ea typeface="Microsoft JhengHei"/>
-                <a:cs typeface="Microsoft JhengHei"/>
-              </a:rPr>
-              <a:t>系統完成度</a:t>
-            </a:r>
-            <a:endParaRPr sz="1300"/>
-          </a:p>
-        </p:txBody>
-      </p:sp>
-      <p:sp>
-        <p:nvSpPr>
           <p:cNvPr id="4" name="Text 2">
             <a:extLst xmlns:a="http://schemas.openxmlformats.org/drawingml/2006/main">
               <a:ext uri="{FF2B5EF4-FFF2-40B4-BE49-F238E27FC236}">
@@ -7790,6 +7719,10 @@
             <a:prstDash val="solid"/>
           </a:ln>
         </p:spPr>
+        <p:txBody xmlns:a="http://schemas.openxmlformats.org/drawingml/2006/main">
+          <a:bodyPr/>
+          <a:p/>
+        </p:txBody>
       </p:sp>
       <p:sp>
         <p:nvSpPr>
@@ -7823,6 +7756,10 @@
             <a:prstDash val="solid"/>
           </a:ln>
         </p:spPr>
+        <p:txBody xmlns:a="http://schemas.openxmlformats.org/drawingml/2006/main">
+          <a:bodyPr/>
+          <a:p/>
+        </p:txBody>
       </p:sp>
       <p:pic>
         <p:nvPicPr>
@@ -8083,6 +8020,10 @@
             <a:prstDash val="solid"/>
           </a:ln>
         </p:spPr>
+        <p:txBody xmlns:a="http://schemas.openxmlformats.org/drawingml/2006/main">
+          <a:bodyPr/>
+          <a:p/>
+        </p:txBody>
       </p:sp>
       <p:sp>
         <p:nvSpPr>
@@ -8116,6 +8057,10 @@
             <a:prstDash val="solid"/>
           </a:ln>
         </p:spPr>
+        <p:txBody xmlns:a="http://schemas.openxmlformats.org/drawingml/2006/main">
+          <a:bodyPr/>
+          <a:p/>
+        </p:txBody>
       </p:sp>
       <p:pic>
         <p:nvPicPr>
@@ -8336,6 +8281,10 @@
             <a:prstDash val="solid"/>
           </a:ln>
         </p:spPr>
+        <p:txBody xmlns:a="http://schemas.openxmlformats.org/drawingml/2006/main">
+          <a:bodyPr/>
+          <a:p/>
+        </p:txBody>
       </p:sp>
       <p:sp>
         <p:nvSpPr>
@@ -8369,6 +8318,10 @@
             <a:prstDash val="solid"/>
           </a:ln>
         </p:spPr>
+        <p:txBody xmlns:a="http://schemas.openxmlformats.org/drawingml/2006/main">
+          <a:bodyPr/>
+          <a:p/>
+        </p:txBody>
       </p:sp>
       <p:pic>
         <p:nvPicPr>
@@ -8589,6 +8542,10 @@
             <a:prstDash val="solid"/>
           </a:ln>
         </p:spPr>
+        <p:txBody xmlns:a="http://schemas.openxmlformats.org/drawingml/2006/main">
+          <a:bodyPr/>
+          <a:p/>
+        </p:txBody>
       </p:sp>
       <p:sp>
         <p:nvSpPr>
@@ -8783,22 +8740,22 @@
       </p:grpSpPr>
       <p:sp>
         <p:nvSpPr>
-          <p:cNvPr id="8" name="功能完整性">
-            <a:extLst xmlns:a="http://schemas.openxmlformats.org/drawingml/2006/main">
-              <a:ext uri="{FF2B5EF4-FFF2-40B4-BE49-F238E27FC236}">
-                <a16:creationId xmlns:a16="http://schemas.microsoft.com/office/drawing/2014/main" id="{6E42A8D1-38E0-47A4-9BC4-5B5DFEDFCB2F}"/>
-              </a:ext>
-            </a:extLst>
-          </p:cNvPr>
-          <p:cNvSpPr>
-            <a:spLocks xmlns:a="http://schemas.openxmlformats.org/drawingml/2006/main" noGrp="1"/>
-          </p:cNvSpPr>
-          <p:nvPr/>
-        </p:nvSpPr>
-        <p:spPr>
-          <a:xfrm xmlns:a="http://schemas.openxmlformats.org/drawingml/2006/main">
-            <a:off x="733425" y="447675"/>
-            <a:ext cx="10287000" cy="304800"/>
+          <p:cNvPr id="2" name="一條研究流程，對應六組可操作功能">
+            <a:extLst xmlns:a="http://schemas.openxmlformats.org/drawingml/2006/main">
+              <a:ext uri="{FF2B5EF4-FFF2-40B4-BE49-F238E27FC236}">
+                <a16:creationId xmlns:a16="http://schemas.microsoft.com/office/drawing/2014/main" id="{BE27C868-2AD2-4089-8BF8-60D6F295EC7D}"/>
+              </a:ext>
+            </a:extLst>
+          </p:cNvPr>
+          <p:cNvSpPr>
+            <a:spLocks xmlns:a="http://schemas.openxmlformats.org/drawingml/2006/main" noGrp="1"/>
+          </p:cNvSpPr>
+          <p:nvPr/>
+        </p:nvSpPr>
+        <p:spPr>
+          <a:xfrm xmlns:a="http://schemas.openxmlformats.org/drawingml/2006/main">
+            <a:off x="733425" y="933450"/>
+            <a:ext cx="10725150" cy="619125"/>
           </a:xfrm>
           <a:prstGeom xmlns:a="http://schemas.openxmlformats.org/drawingml/2006/main" prst="rect">
             <a:avLst/>
@@ -8812,9 +8769,9 @@
           <a:bodyPr xmlns:a="http://schemas.openxmlformats.org/drawingml/2006/main" lIns="0" tIns="0" rIns="0" bIns="0"/>
           <a:lstStyle xmlns:a="http://schemas.openxmlformats.org/drawingml/2006/main">
             <a:defPPr>
-              <a:defRPr sz="1350" b="1">
-                <a:solidFill>
-                  <a:srgbClr val="C85C00"/>
+              <a:defRPr sz="2700" b="1">
+                <a:solidFill>
+                  <a:srgbClr val="14243A"/>
                 </a:solidFill>
               </a:defRPr>
             </a:defPPr>
@@ -8822,77 +8779,19 @@
           <a:p xmlns:a="http://schemas.openxmlformats.org/drawingml/2006/main">
             <a:pPr>
               <a:buNone/>
-              <a:defRPr sz="1350" b="1">
-                <a:solidFill>
-                  <a:srgbClr val="C85C00"/>
+              <a:defRPr sz="2700" b="1">
+                <a:solidFill>
+                  <a:srgbClr val="14243A"/>
                 </a:solidFill>
               </a:defRPr>
             </a:pPr>
             <a:r>
-              <a:rPr sz="1350" b="1">
-                <a:solidFill>
-                  <a:srgbClr val="C85C00"/>
-                </a:solidFill>
-              </a:rPr>
-              <a:t>功能完整性</a:t>
-            </a:r>
-          </a:p>
-        </p:txBody>
-      </p:sp>
-      <p:sp>
-        <p:nvSpPr>
-          <p:cNvPr id="2" name="一條研究流程，對應六組可操作功能">
-            <a:extLst xmlns:a="http://schemas.openxmlformats.org/drawingml/2006/main">
-              <a:ext uri="{FF2B5EF4-FFF2-40B4-BE49-F238E27FC236}">
-                <a16:creationId xmlns:a16="http://schemas.microsoft.com/office/drawing/2014/main" id="{BE27C868-2AD2-4089-8BF8-60D6F295EC7D}"/>
-              </a:ext>
-            </a:extLst>
-          </p:cNvPr>
-          <p:cNvSpPr>
-            <a:spLocks xmlns:a="http://schemas.openxmlformats.org/drawingml/2006/main" noGrp="1"/>
-          </p:cNvSpPr>
-          <p:nvPr/>
-        </p:nvSpPr>
-        <p:spPr>
-          <a:xfrm xmlns:a="http://schemas.openxmlformats.org/drawingml/2006/main">
-            <a:off x="733425" y="933450"/>
-            <a:ext cx="10725150" cy="619125"/>
-          </a:xfrm>
-          <a:prstGeom xmlns:a="http://schemas.openxmlformats.org/drawingml/2006/main" prst="rect">
-            <a:avLst/>
-          </a:prstGeom>
-          <a:noFill xmlns:a="http://schemas.openxmlformats.org/drawingml/2006/main"/>
-          <a:ln xmlns:a="http://schemas.openxmlformats.org/drawingml/2006/main" w="0">
-            <a:noFill/>
-          </a:ln>
-        </p:spPr>
-        <p:txBody>
-          <a:bodyPr xmlns:a="http://schemas.openxmlformats.org/drawingml/2006/main" lIns="0" tIns="0" rIns="0" bIns="0"/>
-          <a:lstStyle xmlns:a="http://schemas.openxmlformats.org/drawingml/2006/main">
-            <a:defPPr>
-              <a:defRPr sz="2700" b="1">
+              <a:rPr sz="2700" b="1">
                 <a:solidFill>
                   <a:srgbClr val="14243A"/>
                 </a:solidFill>
-              </a:defRPr>
-            </a:defPPr>
-          </a:lstStyle>
-          <a:p xmlns:a="http://schemas.openxmlformats.org/drawingml/2006/main">
-            <a:pPr>
-              <a:buNone/>
-              <a:defRPr sz="2700" b="1">
-                <a:solidFill>
-                  <a:srgbClr val="14243A"/>
-                </a:solidFill>
-              </a:defRPr>
-            </a:pPr>
-            <a:r>
-              <a:rPr sz="2700" b="1">
-                <a:solidFill>
-                  <a:srgbClr val="14243A"/>
-                </a:solidFill>
-              </a:rPr>
-              <a:t>一條研究流程，對應六組可操作功能</a:t>
+              </a:rPr>
+              <a:t>功能完整性：一條研究流程，對應六組可操作功能</a:t>
             </a:r>
           </a:p>
         </p:txBody>
@@ -9726,6 +9625,10 @@
             </a:solidFill>
           </a:ln>
         </p:spPr>
+        <p:txBody xmlns:a="http://schemas.openxmlformats.org/drawingml/2006/main">
+          <a:bodyPr/>
+          <a:p/>
+        </p:txBody>
       </p:sp>
       <p:sp>
         <p:nvSpPr>
@@ -9932,64 +9835,6 @@
       </p:grpSpPr>
       <p:sp>
         <p:nvSpPr>
-          <p:cNvPr id="14" name="實機展示 · 2 分 20 秒">
-            <a:extLst xmlns:a="http://schemas.openxmlformats.org/drawingml/2006/main">
-              <a:ext uri="{FF2B5EF4-FFF2-40B4-BE49-F238E27FC236}">
-                <a16:creationId xmlns:a16="http://schemas.microsoft.com/office/drawing/2014/main" id="{6A4537BA-0D5D-4481-9844-C69165E11B8D}"/>
-              </a:ext>
-            </a:extLst>
-          </p:cNvPr>
-          <p:cNvSpPr>
-            <a:spLocks xmlns:a="http://schemas.openxmlformats.org/drawingml/2006/main" noGrp="1"/>
-          </p:cNvSpPr>
-          <p:nvPr/>
-        </p:nvSpPr>
-        <p:spPr>
-          <a:xfrm xmlns:a="http://schemas.openxmlformats.org/drawingml/2006/main">
-            <a:off x="733425" y="447675"/>
-            <a:ext cx="10287000" cy="304800"/>
-          </a:xfrm>
-          <a:prstGeom xmlns:a="http://schemas.openxmlformats.org/drawingml/2006/main" prst="rect">
-            <a:avLst/>
-          </a:prstGeom>
-          <a:noFill xmlns:a="http://schemas.openxmlformats.org/drawingml/2006/main"/>
-          <a:ln xmlns:a="http://schemas.openxmlformats.org/drawingml/2006/main" w="0">
-            <a:noFill/>
-          </a:ln>
-        </p:spPr>
-        <p:txBody>
-          <a:bodyPr xmlns:a="http://schemas.openxmlformats.org/drawingml/2006/main" lIns="0" tIns="0" rIns="0" bIns="0"/>
-          <a:lstStyle xmlns:a="http://schemas.openxmlformats.org/drawingml/2006/main">
-            <a:defPPr>
-              <a:defRPr sz="1350" b="1">
-                <a:solidFill>
-                  <a:srgbClr val="C85C00"/>
-                </a:solidFill>
-              </a:defRPr>
-            </a:defPPr>
-          </a:lstStyle>
-          <a:p xmlns:a="http://schemas.openxmlformats.org/drawingml/2006/main">
-            <a:pPr>
-              <a:buNone/>
-              <a:defRPr sz="1350" b="1">
-                <a:solidFill>
-                  <a:srgbClr val="C85C00"/>
-                </a:solidFill>
-              </a:defRPr>
-            </a:pPr>
-            <a:r>
-              <a:rPr sz="1350" b="1">
-                <a:solidFill>
-                  <a:srgbClr val="C85C00"/>
-                </a:solidFill>
-              </a:rPr>
-              <a:t>實機展示 · 2 分 20 秒</a:t>
-            </a:r>
-          </a:p>
-        </p:txBody>
-      </p:sp>
-      <p:sp>
-        <p:nvSpPr>
           <p:cNvPr id="2" name="Demo：完成一次跨平台口碑研究">
             <a:extLst xmlns:a="http://schemas.openxmlformats.org/drawingml/2006/main">
               <a:ext uri="{FF2B5EF4-FFF2-40B4-BE49-F238E27FC236}">
@@ -10491,6 +10336,10 @@
             </a:solidFill>
           </a:ln>
         </p:spPr>
+        <p:txBody xmlns:a="http://schemas.openxmlformats.org/drawingml/2006/main">
+          <a:bodyPr/>
+          <a:p/>
+        </p:txBody>
       </p:sp>
       <p:sp>
         <p:nvSpPr>
@@ -10695,64 +10544,6 @@
       <p:grpSpPr>
         <a:xfrm xmlns:a="http://schemas.openxmlformats.org/drawingml/2006/main"/>
       </p:grpSpPr>
-      <p:sp>
-        <p:nvSpPr>
-          <p:cNvPr id="9" name="驗證證據">
-            <a:extLst xmlns:a="http://schemas.openxmlformats.org/drawingml/2006/main">
-              <a:ext uri="{FF2B5EF4-FFF2-40B4-BE49-F238E27FC236}">
-                <a16:creationId xmlns:a16="http://schemas.microsoft.com/office/drawing/2014/main" id="{38E10553-FCB4-4202-94B2-40896151ED1D}"/>
-              </a:ext>
-            </a:extLst>
-          </p:cNvPr>
-          <p:cNvSpPr>
-            <a:spLocks xmlns:a="http://schemas.openxmlformats.org/drawingml/2006/main" noGrp="1"/>
-          </p:cNvSpPr>
-          <p:nvPr/>
-        </p:nvSpPr>
-        <p:spPr>
-          <a:xfrm xmlns:a="http://schemas.openxmlformats.org/drawingml/2006/main">
-            <a:off x="733425" y="447675"/>
-            <a:ext cx="10287000" cy="304800"/>
-          </a:xfrm>
-          <a:prstGeom xmlns:a="http://schemas.openxmlformats.org/drawingml/2006/main" prst="rect">
-            <a:avLst/>
-          </a:prstGeom>
-          <a:noFill xmlns:a="http://schemas.openxmlformats.org/drawingml/2006/main"/>
-          <a:ln xmlns:a="http://schemas.openxmlformats.org/drawingml/2006/main" w="0">
-            <a:noFill/>
-          </a:ln>
-        </p:spPr>
-        <p:txBody>
-          <a:bodyPr xmlns:a="http://schemas.openxmlformats.org/drawingml/2006/main" lIns="0" tIns="0" rIns="0" bIns="0"/>
-          <a:lstStyle xmlns:a="http://schemas.openxmlformats.org/drawingml/2006/main">
-            <a:defPPr>
-              <a:defRPr sz="1350" b="1">
-                <a:solidFill>
-                  <a:srgbClr val="C85C00"/>
-                </a:solidFill>
-              </a:defRPr>
-            </a:defPPr>
-          </a:lstStyle>
-          <a:p xmlns:a="http://schemas.openxmlformats.org/drawingml/2006/main">
-            <a:pPr>
-              <a:buNone/>
-              <a:defRPr sz="1350" b="1">
-                <a:solidFill>
-                  <a:srgbClr val="C85C00"/>
-                </a:solidFill>
-              </a:defRPr>
-            </a:pPr>
-            <a:r>
-              <a:rPr sz="1350" b="1">
-                <a:solidFill>
-                  <a:srgbClr val="C85C00"/>
-                </a:solidFill>
-              </a:rPr>
-              <a:t>驗證證據</a:t>
-            </a:r>
-          </a:p>
-        </p:txBody>
-      </p:sp>
       <p:sp>
         <p:nvSpPr>
           <p:cNvPr id="2" name="分層測試：區分原始報告與原稿紀錄">
@@ -11694,52 +11485,6 @@
       </p:grpSpPr>
       <p:sp>
         <p:nvSpPr>
-          <p:cNvPr id="2" name="Text 0">
-            <a:extLst xmlns:a="http://schemas.openxmlformats.org/drawingml/2006/main">
-              <a:ext uri="{FF2B5EF4-FFF2-40B4-BE49-F238E27FC236}">
-                <a16:creationId xmlns:a16="http://schemas.microsoft.com/office/drawing/2014/main" id="{677474F0-F8F4-49B2-B021-2841AA6251A6}"/>
-              </a:ext>
-            </a:extLst>
-          </p:cNvPr>
-          <p:cNvSpPr>
-            <a:spLocks xmlns:a="http://schemas.openxmlformats.org/drawingml/2006/main" noGrp="1"/>
-          </p:cNvSpPr>
-          <p:nvPr/>
-        </p:nvSpPr>
-        <p:spPr>
-          <a:xfrm xmlns:a="http://schemas.openxmlformats.org/drawingml/2006/main">
-            <a:off x="731520" y="457200"/>
-            <a:ext cx="7315200" cy="274320"/>
-          </a:xfrm>
-          <a:prstGeom xmlns:a="http://schemas.openxmlformats.org/drawingml/2006/main" prst="rect">
-            <a:avLst/>
-          </a:prstGeom>
-          <a:noFill xmlns:a="http://schemas.openxmlformats.org/drawingml/2006/main"/>
-        </p:spPr>
-        <p:txBody>
-          <a:bodyPr xmlns:a="http://schemas.openxmlformats.org/drawingml/2006/main" wrap="square" lIns="0" tIns="0" rIns="0" bIns="0" anchor="t"/>
-          <a:lstStyle xmlns:a="http://schemas.openxmlformats.org/drawingml/2006/main"/>
-          <a:p xmlns:a="http://schemas.openxmlformats.org/drawingml/2006/main">
-            <a:pPr marL="0" indent="0">
-              <a:buNone/>
-            </a:pPr>
-            <a:r>
-              <a:rPr sz="1300" b="1" spc="200">
-                <a:solidFill>
-                  <a:srgbClr val="D46A12"/>
-                </a:solidFill>
-                <a:latin typeface="Microsoft JhengHei"/>
-                <a:ea typeface="Microsoft JhengHei"/>
-                <a:cs typeface="Microsoft JhengHei"/>
-              </a:rPr>
-              <a:t>評審C · 甘特圖年月 ／ GitHub</a:t>
-            </a:r>
-            <a:endParaRPr sz="1300"/>
-          </a:p>
-        </p:txBody>
-      </p:sp>
-      <p:sp>
-        <p:nvSpPr>
           <p:cNvPr id="4" name="Text 2">
             <a:extLst xmlns:a="http://schemas.openxmlformats.org/drawingml/2006/main">
               <a:ext uri="{FF2B5EF4-FFF2-40B4-BE49-F238E27FC236}">
@@ -12370,6 +12115,10 @@
             <a:prstDash val="solid"/>
           </a:ln>
         </p:spPr>
+        <p:txBody xmlns:a="http://schemas.openxmlformats.org/drawingml/2006/main">
+          <a:bodyPr/>
+          <a:p/>
+        </p:txBody>
       </p:sp>
       <p:sp>
         <p:nvSpPr>
@@ -12451,6 +12200,10 @@
             <a:prstDash val="solid"/>
           </a:ln>
         </p:spPr>
+        <p:txBody xmlns:a="http://schemas.openxmlformats.org/drawingml/2006/main">
+          <a:bodyPr/>
+          <a:p/>
+        </p:txBody>
       </p:sp>
       <p:sp>
         <p:nvSpPr>
@@ -12532,6 +12285,10 @@
             <a:prstDash val="solid"/>
           </a:ln>
         </p:spPr>
+        <p:txBody xmlns:a="http://schemas.openxmlformats.org/drawingml/2006/main">
+          <a:bodyPr/>
+          <a:p/>
+        </p:txBody>
       </p:sp>
       <p:sp>
         <p:nvSpPr>
@@ -12613,6 +12370,10 @@
             <a:prstDash val="solid"/>
           </a:ln>
         </p:spPr>
+        <p:txBody xmlns:a="http://schemas.openxmlformats.org/drawingml/2006/main">
+          <a:bodyPr/>
+          <a:p/>
+        </p:txBody>
       </p:sp>
       <p:sp>
         <p:nvSpPr>
@@ -12692,6 +12453,10 @@
             <a:prstDash val="solid"/>
           </a:ln>
         </p:spPr>
+        <p:txBody xmlns:a="http://schemas.openxmlformats.org/drawingml/2006/main">
+          <a:bodyPr/>
+          <a:p/>
+        </p:txBody>
       </p:sp>
       <p:sp>
         <p:nvSpPr>
@@ -12788,6 +12553,10 @@
             <a:prstDash val="solid"/>
           </a:ln>
         </p:spPr>
+        <p:txBody xmlns:a="http://schemas.openxmlformats.org/drawingml/2006/main">
+          <a:bodyPr/>
+          <a:p/>
+        </p:txBody>
       </p:sp>
       <p:sp>
         <p:nvSpPr>
@@ -12884,6 +12653,10 @@
             <a:prstDash val="solid"/>
           </a:ln>
         </p:spPr>
+        <p:txBody xmlns:a="http://schemas.openxmlformats.org/drawingml/2006/main">
+          <a:bodyPr/>
+          <a:p/>
+        </p:txBody>
       </p:sp>
       <p:sp>
         <p:nvSpPr>
@@ -12980,6 +12753,10 @@
             <a:prstDash val="solid"/>
           </a:ln>
         </p:spPr>
+        <p:txBody xmlns:a="http://schemas.openxmlformats.org/drawingml/2006/main">
+          <a:bodyPr/>
+          <a:p/>
+        </p:txBody>
       </p:sp>
       <p:sp>
         <p:nvSpPr>
@@ -13078,6 +12855,10 @@
             <a:prstDash val="solid"/>
           </a:ln>
         </p:spPr>
+        <p:txBody xmlns:a="http://schemas.openxmlformats.org/drawingml/2006/main">
+          <a:bodyPr/>
+          <a:p/>
+        </p:txBody>
       </p:sp>
       <p:sp>
         <p:nvSpPr>
@@ -13113,6 +12894,10 @@
             <a:prstDash val="solid"/>
           </a:ln>
         </p:spPr>
+        <p:txBody xmlns:a="http://schemas.openxmlformats.org/drawingml/2006/main">
+          <a:bodyPr/>
+          <a:p/>
+        </p:txBody>
       </p:sp>
       <p:sp>
         <p:nvSpPr>
@@ -13148,6 +12933,10 @@
             <a:prstDash val="solid"/>
           </a:ln>
         </p:spPr>
+        <p:txBody xmlns:a="http://schemas.openxmlformats.org/drawingml/2006/main">
+          <a:bodyPr/>
+          <a:p/>
+        </p:txBody>
       </p:sp>
       <p:sp>
         <p:nvSpPr>
@@ -13275,6 +13064,10 @@
             <a:prstDash val="solid"/>
           </a:ln>
         </p:spPr>
+        <p:txBody xmlns:a="http://schemas.openxmlformats.org/drawingml/2006/main">
+          <a:bodyPr/>
+          <a:p/>
+        </p:txBody>
       </p:sp>
       <p:sp>
         <p:nvSpPr>
@@ -13402,6 +13195,10 @@
             <a:prstDash val="solid"/>
           </a:ln>
         </p:spPr>
+        <p:txBody xmlns:a="http://schemas.openxmlformats.org/drawingml/2006/main">
+          <a:bodyPr/>
+          <a:p/>
+        </p:txBody>
       </p:sp>
       <p:sp>
         <p:nvSpPr>
@@ -13529,6 +13326,10 @@
             <a:prstDash val="solid"/>
           </a:ln>
         </p:spPr>
+        <p:txBody xmlns:a="http://schemas.openxmlformats.org/drawingml/2006/main">
+          <a:bodyPr/>
+          <a:p/>
+        </p:txBody>
       </p:sp>
       <p:sp>
         <p:nvSpPr>
@@ -13656,6 +13457,10 @@
             <a:prstDash val="solid"/>
           </a:ln>
         </p:spPr>
+        <p:txBody xmlns:a="http://schemas.openxmlformats.org/drawingml/2006/main">
+          <a:bodyPr/>
+          <a:p/>
+        </p:txBody>
       </p:sp>
       <p:sp>
         <p:nvSpPr>
@@ -13783,6 +13588,10 @@
             <a:prstDash val="solid"/>
           </a:ln>
         </p:spPr>
+        <p:txBody xmlns:a="http://schemas.openxmlformats.org/drawingml/2006/main">
+          <a:bodyPr/>
+          <a:p/>
+        </p:txBody>
       </p:sp>
       <p:sp>
         <p:nvSpPr>
@@ -13999,52 +13808,6 @@
       </p:grpSpPr>
       <p:sp>
         <p:nvSpPr>
-          <p:cNvPr id="2" name="Text 0">
-            <a:extLst xmlns:a="http://schemas.openxmlformats.org/drawingml/2006/main">
-              <a:ext uri="{FF2B5EF4-FFF2-40B4-BE49-F238E27FC236}">
-                <a16:creationId xmlns:a16="http://schemas.microsoft.com/office/drawing/2014/main" id="{B16872A3-C2B2-4E51-AA59-7D118329E014}"/>
-              </a:ext>
-            </a:extLst>
-          </p:cNvPr>
-          <p:cNvSpPr>
-            <a:spLocks xmlns:a="http://schemas.openxmlformats.org/drawingml/2006/main" noGrp="1"/>
-          </p:cNvSpPr>
-          <p:nvPr/>
-        </p:nvSpPr>
-        <p:spPr>
-          <a:xfrm xmlns:a="http://schemas.openxmlformats.org/drawingml/2006/main">
-            <a:off x="731520" y="457200"/>
-            <a:ext cx="7315200" cy="274320"/>
-          </a:xfrm>
-          <a:prstGeom xmlns:a="http://schemas.openxmlformats.org/drawingml/2006/main" prst="rect">
-            <a:avLst/>
-          </a:prstGeom>
-          <a:noFill xmlns:a="http://schemas.openxmlformats.org/drawingml/2006/main"/>
-        </p:spPr>
-        <p:txBody>
-          <a:bodyPr xmlns:a="http://schemas.openxmlformats.org/drawingml/2006/main" wrap="square" lIns="0" tIns="0" rIns="0" bIns="0" anchor="t"/>
-          <a:lstStyle xmlns:a="http://schemas.openxmlformats.org/drawingml/2006/main"/>
-          <a:p xmlns:a="http://schemas.openxmlformats.org/drawingml/2006/main">
-            <a:pPr marL="0" indent="0">
-              <a:buNone/>
-            </a:pPr>
-            <a:r>
-              <a:rPr sz="1300" b="1" spc="200">
-                <a:solidFill>
-                  <a:srgbClr val="D46A12"/>
-                </a:solidFill>
-                <a:latin typeface="Microsoft JhengHei"/>
-                <a:ea typeface="Microsoft JhengHei"/>
-                <a:cs typeface="Microsoft JhengHei"/>
-              </a:rPr>
-              <a:t>分工參與</a:t>
-            </a:r>
-            <a:endParaRPr sz="1300"/>
-          </a:p>
-        </p:txBody>
-      </p:sp>
-      <p:sp>
-        <p:nvSpPr>
           <p:cNvPr id="4" name="Text 2">
             <a:extLst xmlns:a="http://schemas.openxmlformats.org/drawingml/2006/main">
               <a:ext uri="{FF2B5EF4-FFF2-40B4-BE49-F238E27FC236}">
@@ -14123,6 +13886,10 @@
             <a:prstDash val="solid"/>
           </a:ln>
         </p:spPr>
+        <p:txBody xmlns:a="http://schemas.openxmlformats.org/drawingml/2006/main">
+          <a:bodyPr/>
+          <a:p/>
+        </p:txBody>
       </p:sp>
       <p:sp>
         <p:nvSpPr>
@@ -14156,6 +13923,10 @@
             <a:prstDash val="solid"/>
           </a:ln>
         </p:spPr>
+        <p:txBody xmlns:a="http://schemas.openxmlformats.org/drawingml/2006/main">
+          <a:bodyPr/>
+          <a:p/>
+        </p:txBody>
       </p:sp>
       <p:pic>
         <p:nvPicPr>
@@ -14422,6 +14193,10 @@
             <a:prstDash val="solid"/>
           </a:ln>
         </p:spPr>
+        <p:txBody xmlns:a="http://schemas.openxmlformats.org/drawingml/2006/main">
+          <a:bodyPr/>
+          <a:p/>
+        </p:txBody>
       </p:sp>
       <p:sp>
         <p:nvSpPr>
@@ -14455,6 +14230,10 @@
             <a:prstDash val="solid"/>
           </a:ln>
         </p:spPr>
+        <p:txBody xmlns:a="http://schemas.openxmlformats.org/drawingml/2006/main">
+          <a:bodyPr/>
+          <a:p/>
+        </p:txBody>
       </p:sp>
       <p:pic>
         <p:nvPicPr>
@@ -14721,6 +14500,10 @@
             <a:prstDash val="solid"/>
           </a:ln>
         </p:spPr>
+        <p:txBody xmlns:a="http://schemas.openxmlformats.org/drawingml/2006/main">
+          <a:bodyPr/>
+          <a:p/>
+        </p:txBody>
       </p:sp>
       <p:sp>
         <p:nvSpPr>
@@ -14915,52 +14698,6 @@
       </p:grpSpPr>
       <p:sp>
         <p:nvSpPr>
-          <p:cNvPr id="2" name="Text 0">
-            <a:extLst xmlns:a="http://schemas.openxmlformats.org/drawingml/2006/main">
-              <a:ext uri="{FF2B5EF4-FFF2-40B4-BE49-F238E27FC236}">
-                <a16:creationId xmlns:a16="http://schemas.microsoft.com/office/drawing/2014/main" id="{04112E93-58A0-4FBC-948D-8502D6A3142D}"/>
-              </a:ext>
-            </a:extLst>
-          </p:cNvPr>
-          <p:cNvSpPr>
-            <a:spLocks xmlns:a="http://schemas.openxmlformats.org/drawingml/2006/main" noGrp="1"/>
-          </p:cNvSpPr>
-          <p:nvPr/>
-        </p:nvSpPr>
-        <p:spPr>
-          <a:xfrm xmlns:a="http://schemas.openxmlformats.org/drawingml/2006/main">
-            <a:off x="731520" y="457200"/>
-            <a:ext cx="7315200" cy="274320"/>
-          </a:xfrm>
-          <a:prstGeom xmlns:a="http://schemas.openxmlformats.org/drawingml/2006/main" prst="rect">
-            <a:avLst/>
-          </a:prstGeom>
-          <a:noFill xmlns:a="http://schemas.openxmlformats.org/drawingml/2006/main"/>
-        </p:spPr>
-        <p:txBody>
-          <a:bodyPr xmlns:a="http://schemas.openxmlformats.org/drawingml/2006/main" wrap="square" lIns="0" tIns="0" rIns="0" bIns="0" anchor="t"/>
-          <a:lstStyle xmlns:a="http://schemas.openxmlformats.org/drawingml/2006/main"/>
-          <a:p xmlns:a="http://schemas.openxmlformats.org/drawingml/2006/main">
-            <a:pPr marL="0" indent="0">
-              <a:buNone/>
-            </a:pPr>
-            <a:r>
-              <a:rPr sz="1300" b="1" spc="200">
-                <a:solidFill>
-                  <a:srgbClr val="D46A12"/>
-                </a:solidFill>
-                <a:latin typeface="Microsoft JhengHei"/>
-                <a:ea typeface="Microsoft JhengHei"/>
-                <a:cs typeface="Microsoft JhengHei"/>
-              </a:rPr>
-              <a:t>WRAP-UP</a:t>
-            </a:r>
-            <a:endParaRPr sz="1300"/>
-          </a:p>
-        </p:txBody>
-      </p:sp>
-      <p:sp>
-        <p:nvSpPr>
           <p:cNvPr id="4" name="Text 2">
             <a:extLst xmlns:a="http://schemas.openxmlformats.org/drawingml/2006/main">
               <a:ext uri="{FF2B5EF4-FFF2-40B4-BE49-F238E27FC236}">
@@ -15039,6 +14776,10 @@
             <a:prstDash val="solid"/>
           </a:ln>
         </p:spPr>
+        <p:txBody xmlns:a="http://schemas.openxmlformats.org/drawingml/2006/main">
+          <a:bodyPr/>
+          <a:p/>
+        </p:txBody>
       </p:sp>
       <p:sp>
         <p:nvSpPr>
@@ -15072,6 +14813,10 @@
             <a:prstDash val="solid"/>
           </a:ln>
         </p:spPr>
+        <p:txBody xmlns:a="http://schemas.openxmlformats.org/drawingml/2006/main">
+          <a:bodyPr/>
+          <a:p/>
+        </p:txBody>
       </p:sp>
       <p:pic>
         <p:nvPicPr>
@@ -15312,6 +15057,10 @@
             <a:prstDash val="solid"/>
           </a:ln>
         </p:spPr>
+        <p:txBody xmlns:a="http://schemas.openxmlformats.org/drawingml/2006/main">
+          <a:bodyPr/>
+          <a:p/>
+        </p:txBody>
       </p:sp>
       <p:sp>
         <p:nvSpPr>
@@ -15345,6 +15094,10 @@
             <a:prstDash val="solid"/>
           </a:ln>
         </p:spPr>
+        <p:txBody xmlns:a="http://schemas.openxmlformats.org/drawingml/2006/main">
+          <a:bodyPr/>
+          <a:p/>
+        </p:txBody>
       </p:sp>
       <p:pic>
         <p:nvPicPr>
@@ -15585,6 +15338,10 @@
             <a:prstDash val="solid"/>
           </a:ln>
         </p:spPr>
+        <p:txBody xmlns:a="http://schemas.openxmlformats.org/drawingml/2006/main">
+          <a:bodyPr/>
+          <a:p/>
+        </p:txBody>
       </p:sp>
       <p:sp>
         <p:nvSpPr>
@@ -15618,6 +15375,10 @@
             <a:prstDash val="solid"/>
           </a:ln>
         </p:spPr>
+        <p:txBody xmlns:a="http://schemas.openxmlformats.org/drawingml/2006/main">
+          <a:bodyPr/>
+          <a:p/>
+        </p:txBody>
       </p:sp>
       <p:pic>
         <p:nvPicPr>
@@ -15858,6 +15619,10 @@
             <a:prstDash val="solid"/>
           </a:ln>
         </p:spPr>
+        <p:txBody xmlns:a="http://schemas.openxmlformats.org/drawingml/2006/main">
+          <a:bodyPr/>
+          <a:p/>
+        </p:txBody>
       </p:sp>
       <p:sp>
         <p:nvSpPr>
@@ -16052,52 +15817,6 @@
       </p:grpSpPr>
       <p:sp>
         <p:nvSpPr>
-          <p:cNvPr id="2" name="Text 0">
-            <a:extLst xmlns:a="http://schemas.openxmlformats.org/drawingml/2006/main">
-              <a:ext uri="{FF2B5EF4-FFF2-40B4-BE49-F238E27FC236}">
-                <a16:creationId xmlns:a16="http://schemas.microsoft.com/office/drawing/2014/main" id="{1C455A85-E8A3-4FD7-BB36-5887F2307008}"/>
-              </a:ext>
-            </a:extLst>
-          </p:cNvPr>
-          <p:cNvSpPr>
-            <a:spLocks xmlns:a="http://schemas.openxmlformats.org/drawingml/2006/main" noGrp="1"/>
-          </p:cNvSpPr>
-          <p:nvPr/>
-        </p:nvSpPr>
-        <p:spPr>
-          <a:xfrm xmlns:a="http://schemas.openxmlformats.org/drawingml/2006/main">
-            <a:off x="731520" y="457200"/>
-            <a:ext cx="7315200" cy="274320"/>
-          </a:xfrm>
-          <a:prstGeom xmlns:a="http://schemas.openxmlformats.org/drawingml/2006/main" prst="rect">
-            <a:avLst/>
-          </a:prstGeom>
-          <a:noFill xmlns:a="http://schemas.openxmlformats.org/drawingml/2006/main"/>
-        </p:spPr>
-        <p:txBody>
-          <a:bodyPr xmlns:a="http://schemas.openxmlformats.org/drawingml/2006/main" wrap="square" lIns="0" tIns="0" rIns="0" bIns="0" anchor="t"/>
-          <a:lstStyle xmlns:a="http://schemas.openxmlformats.org/drawingml/2006/main"/>
-          <a:p xmlns:a="http://schemas.openxmlformats.org/drawingml/2006/main">
-            <a:pPr marL="0" indent="0">
-              <a:buNone/>
-            </a:pPr>
-            <a:r>
-              <a:rPr sz="1300" b="1" spc="200">
-                <a:solidFill>
-                  <a:srgbClr val="D46A12"/>
-                </a:solidFill>
-                <a:latin typeface="Microsoft JhengHei"/>
-                <a:ea typeface="Microsoft JhengHei"/>
-                <a:cs typeface="Microsoft JhengHei"/>
-              </a:rPr>
-              <a:t>AGENDA</a:t>
-            </a:r>
-            <a:endParaRPr sz="1300"/>
-          </a:p>
-        </p:txBody>
-      </p:sp>
-      <p:sp>
-        <p:nvSpPr>
           <p:cNvPr id="4" name="Text 2">
             <a:extLst xmlns:a="http://schemas.openxmlformats.org/drawingml/2006/main">
               <a:ext uri="{FF2B5EF4-FFF2-40B4-BE49-F238E27FC236}">
@@ -16176,6 +15895,10 @@
             <a:prstDash val="solid"/>
           </a:ln>
         </p:spPr>
+        <p:txBody xmlns:a="http://schemas.openxmlformats.org/drawingml/2006/main">
+          <a:bodyPr/>
+          <a:p/>
+        </p:txBody>
       </p:sp>
       <p:sp>
         <p:nvSpPr>
@@ -16366,6 +16089,10 @@
             <a:prstDash val="solid"/>
           </a:ln>
         </p:spPr>
+        <p:txBody xmlns:a="http://schemas.openxmlformats.org/drawingml/2006/main">
+          <a:bodyPr/>
+          <a:p/>
+        </p:txBody>
       </p:sp>
       <p:sp>
         <p:nvSpPr>
@@ -16493,6 +16220,10 @@
             <a:prstDash val="solid"/>
           </a:ln>
         </p:spPr>
+        <p:txBody xmlns:a="http://schemas.openxmlformats.org/drawingml/2006/main">
+          <a:bodyPr/>
+          <a:p/>
+        </p:txBody>
       </p:sp>
       <p:sp>
         <p:nvSpPr>
@@ -16683,6 +16414,10 @@
             <a:prstDash val="solid"/>
           </a:ln>
         </p:spPr>
+        <p:txBody xmlns:a="http://schemas.openxmlformats.org/drawingml/2006/main">
+          <a:bodyPr/>
+          <a:p/>
+        </p:txBody>
       </p:sp>
       <p:sp>
         <p:nvSpPr>
@@ -16810,6 +16545,10 @@
             <a:prstDash val="solid"/>
           </a:ln>
         </p:spPr>
+        <p:txBody xmlns:a="http://schemas.openxmlformats.org/drawingml/2006/main">
+          <a:bodyPr/>
+          <a:p/>
+        </p:txBody>
       </p:sp>
       <p:sp>
         <p:nvSpPr>
@@ -17000,6 +16739,10 @@
             <a:prstDash val="solid"/>
           </a:ln>
         </p:spPr>
+        <p:txBody xmlns:a="http://schemas.openxmlformats.org/drawingml/2006/main">
+          <a:bodyPr/>
+          <a:p/>
+        </p:txBody>
       </p:sp>
       <p:sp>
         <p:nvSpPr>
@@ -17127,6 +16870,10 @@
             <a:prstDash val="solid"/>
           </a:ln>
         </p:spPr>
+        <p:txBody xmlns:a="http://schemas.openxmlformats.org/drawingml/2006/main">
+          <a:bodyPr/>
+          <a:p/>
+        </p:txBody>
       </p:sp>
       <p:sp>
         <p:nvSpPr>
@@ -17317,6 +17064,10 @@
             <a:prstDash val="solid"/>
           </a:ln>
         </p:spPr>
+        <p:txBody xmlns:a="http://schemas.openxmlformats.org/drawingml/2006/main">
+          <a:bodyPr/>
+          <a:p/>
+        </p:txBody>
       </p:sp>
       <p:sp>
         <p:nvSpPr>
@@ -17444,6 +17195,10 @@
             <a:prstDash val="solid"/>
           </a:ln>
         </p:spPr>
+        <p:txBody xmlns:a="http://schemas.openxmlformats.org/drawingml/2006/main">
+          <a:bodyPr/>
+          <a:p/>
+        </p:txBody>
       </p:sp>
       <p:sp>
         <p:nvSpPr>
@@ -17485,7 +17240,7 @@
                 <a:ea typeface="Microsoft JhengHei"/>
                 <a:cs typeface="Microsoft JhengHei"/>
               </a:rPr>
-              <a:t>每頁左上角標示這頁回應的初審評審意見</a:t>
+              <a:t>16 項初評意見與回應頁碼，逐條對照於附錄 A、B</a:t>
             </a:r>
             <a:endParaRPr sz="1400"/>
           </a:p>
@@ -17638,22 +17393,22 @@
       </p:grpSpPr>
       <p:sp>
         <p:nvSpPr>
-          <p:cNvPr id="5" name="附錄 A · 前次評審意見修正情形">
-            <a:extLst xmlns:a="http://schemas.openxmlformats.org/drawingml/2006/main">
-              <a:ext uri="{FF2B5EF4-FFF2-40B4-BE49-F238E27FC236}">
-                <a16:creationId xmlns:a16="http://schemas.microsoft.com/office/drawing/2014/main" id="{857FA5A3-3658-46EE-AAB5-0C9EECE77345}"/>
-              </a:ext>
-            </a:extLst>
-          </p:cNvPr>
-          <p:cNvSpPr>
-            <a:spLocks xmlns:a="http://schemas.openxmlformats.org/drawingml/2006/main" noGrp="1"/>
-          </p:cNvSpPr>
-          <p:nvPr/>
-        </p:nvSpPr>
-        <p:spPr>
-          <a:xfrm xmlns:a="http://schemas.openxmlformats.org/drawingml/2006/main">
-            <a:off x="733425" y="447675"/>
-            <a:ext cx="10287000" cy="304800"/>
+          <p:cNvPr id="2" name="16 項意見對照：定位、營運與實作（1/2）">
+            <a:extLst xmlns:a="http://schemas.openxmlformats.org/drawingml/2006/main">
+              <a:ext uri="{FF2B5EF4-FFF2-40B4-BE49-F238E27FC236}">
+                <a16:creationId xmlns:a16="http://schemas.microsoft.com/office/drawing/2014/main" id="{E2BC45AA-4715-493E-B4D5-33FB96DEDD6F}"/>
+              </a:ext>
+            </a:extLst>
+          </p:cNvPr>
+          <p:cNvSpPr>
+            <a:spLocks xmlns:a="http://schemas.openxmlformats.org/drawingml/2006/main" noGrp="1"/>
+          </p:cNvSpPr>
+          <p:nvPr/>
+        </p:nvSpPr>
+        <p:spPr>
+          <a:xfrm xmlns:a="http://schemas.openxmlformats.org/drawingml/2006/main">
+            <a:off x="733425" y="933450"/>
+            <a:ext cx="10725150" cy="619125"/>
           </a:xfrm>
           <a:prstGeom xmlns:a="http://schemas.openxmlformats.org/drawingml/2006/main" prst="rect">
             <a:avLst/>
@@ -17667,9 +17422,9 @@
           <a:bodyPr xmlns:a="http://schemas.openxmlformats.org/drawingml/2006/main" lIns="0" tIns="0" rIns="0" bIns="0"/>
           <a:lstStyle xmlns:a="http://schemas.openxmlformats.org/drawingml/2006/main">
             <a:defPPr>
-              <a:defRPr sz="1350" b="1">
-                <a:solidFill>
-                  <a:srgbClr val="C85C00"/>
+              <a:defRPr sz="2700" b="1">
+                <a:solidFill>
+                  <a:srgbClr val="14243A"/>
                 </a:solidFill>
               </a:defRPr>
             </a:defPPr>
@@ -17677,77 +17432,19 @@
           <a:p xmlns:a="http://schemas.openxmlformats.org/drawingml/2006/main">
             <a:pPr>
               <a:buNone/>
-              <a:defRPr sz="1350" b="1">
-                <a:solidFill>
-                  <a:srgbClr val="C85C00"/>
+              <a:defRPr sz="2700" b="1">
+                <a:solidFill>
+                  <a:srgbClr val="14243A"/>
                 </a:solidFill>
               </a:defRPr>
             </a:pPr>
             <a:r>
-              <a:rPr sz="1350" b="1">
-                <a:solidFill>
-                  <a:srgbClr val="C85C00"/>
-                </a:solidFill>
-              </a:rPr>
-              <a:t>附錄 A · 前次評審意見修正情形</a:t>
-            </a:r>
-          </a:p>
-        </p:txBody>
-      </p:sp>
-      <p:sp>
-        <p:nvSpPr>
-          <p:cNvPr id="2" name="16 項意見對照：定位、營運與實作（1/2）">
-            <a:extLst xmlns:a="http://schemas.openxmlformats.org/drawingml/2006/main">
-              <a:ext uri="{FF2B5EF4-FFF2-40B4-BE49-F238E27FC236}">
-                <a16:creationId xmlns:a16="http://schemas.microsoft.com/office/drawing/2014/main" id="{E2BC45AA-4715-493E-B4D5-33FB96DEDD6F}"/>
-              </a:ext>
-            </a:extLst>
-          </p:cNvPr>
-          <p:cNvSpPr>
-            <a:spLocks xmlns:a="http://schemas.openxmlformats.org/drawingml/2006/main" noGrp="1"/>
-          </p:cNvSpPr>
-          <p:nvPr/>
-        </p:nvSpPr>
-        <p:spPr>
-          <a:xfrm xmlns:a="http://schemas.openxmlformats.org/drawingml/2006/main">
-            <a:off x="733425" y="933450"/>
-            <a:ext cx="10725150" cy="619125"/>
-          </a:xfrm>
-          <a:prstGeom xmlns:a="http://schemas.openxmlformats.org/drawingml/2006/main" prst="rect">
-            <a:avLst/>
-          </a:prstGeom>
-          <a:noFill xmlns:a="http://schemas.openxmlformats.org/drawingml/2006/main"/>
-          <a:ln xmlns:a="http://schemas.openxmlformats.org/drawingml/2006/main" w="0">
-            <a:noFill/>
-          </a:ln>
-        </p:spPr>
-        <p:txBody>
-          <a:bodyPr xmlns:a="http://schemas.openxmlformats.org/drawingml/2006/main" lIns="0" tIns="0" rIns="0" bIns="0"/>
-          <a:lstStyle xmlns:a="http://schemas.openxmlformats.org/drawingml/2006/main">
-            <a:defPPr>
-              <a:defRPr sz="2700" b="1">
+              <a:rPr sz="2700" b="1">
                 <a:solidFill>
                   <a:srgbClr val="14243A"/>
                 </a:solidFill>
-              </a:defRPr>
-            </a:defPPr>
-          </a:lstStyle>
-          <a:p xmlns:a="http://schemas.openxmlformats.org/drawingml/2006/main">
-            <a:pPr>
-              <a:buNone/>
-              <a:defRPr sz="2700" b="1">
-                <a:solidFill>
-                  <a:srgbClr val="14243A"/>
-                </a:solidFill>
-              </a:defRPr>
-            </a:pPr>
-            <a:r>
-              <a:rPr sz="2700" b="1">
-                <a:solidFill>
-                  <a:srgbClr val="14243A"/>
-                </a:solidFill>
-              </a:rPr>
-              <a:t>16 項意見對照：定位、營運與實作（1/2）</a:t>
+              </a:rPr>
+              <a:t>附錄 A｜16 項意見對照：定位、營運與實作（1/2）</a:t>
             </a:r>
           </a:p>
         </p:txBody>
@@ -18851,22 +18548,22 @@
       </p:grpSpPr>
       <p:sp>
         <p:nvSpPr>
-          <p:cNvPr id="7" name="附錄 B · 前次評審意見修正情形">
-            <a:extLst xmlns:a="http://schemas.openxmlformats.org/drawingml/2006/main">
-              <a:ext uri="{FF2B5EF4-FFF2-40B4-BE49-F238E27FC236}">
-                <a16:creationId xmlns:a16="http://schemas.microsoft.com/office/drawing/2014/main" id="{642ACF4E-61A3-4305-ADAD-3A0BA3122366}"/>
-              </a:ext>
-            </a:extLst>
-          </p:cNvPr>
-          <p:cNvSpPr>
-            <a:spLocks xmlns:a="http://schemas.openxmlformats.org/drawingml/2006/main" noGrp="1"/>
-          </p:cNvSpPr>
-          <p:nvPr/>
-        </p:nvSpPr>
-        <p:spPr>
-          <a:xfrm xmlns:a="http://schemas.openxmlformats.org/drawingml/2006/main">
-            <a:off x="733425" y="447675"/>
-            <a:ext cx="10287000" cy="304800"/>
+          <p:cNvPr id="2" name="16 項意見對照：資料品質與驗證（2/2）">
+            <a:extLst xmlns:a="http://schemas.openxmlformats.org/drawingml/2006/main">
+              <a:ext uri="{FF2B5EF4-FFF2-40B4-BE49-F238E27FC236}">
+                <a16:creationId xmlns:a16="http://schemas.microsoft.com/office/drawing/2014/main" id="{CF353B7E-532B-48C0-B4DB-3B5F5BA6C063}"/>
+              </a:ext>
+            </a:extLst>
+          </p:cNvPr>
+          <p:cNvSpPr>
+            <a:spLocks xmlns:a="http://schemas.openxmlformats.org/drawingml/2006/main" noGrp="1"/>
+          </p:cNvSpPr>
+          <p:nvPr/>
+        </p:nvSpPr>
+        <p:spPr>
+          <a:xfrm xmlns:a="http://schemas.openxmlformats.org/drawingml/2006/main">
+            <a:off x="733425" y="933450"/>
+            <a:ext cx="10725150" cy="619125"/>
           </a:xfrm>
           <a:prstGeom xmlns:a="http://schemas.openxmlformats.org/drawingml/2006/main" prst="rect">
             <a:avLst/>
@@ -18880,9 +18577,9 @@
           <a:bodyPr xmlns:a="http://schemas.openxmlformats.org/drawingml/2006/main" lIns="0" tIns="0" rIns="0" bIns="0"/>
           <a:lstStyle xmlns:a="http://schemas.openxmlformats.org/drawingml/2006/main">
             <a:defPPr>
-              <a:defRPr sz="1350" b="1">
-                <a:solidFill>
-                  <a:srgbClr val="C85C00"/>
+              <a:defRPr sz="2700" b="1">
+                <a:solidFill>
+                  <a:srgbClr val="14243A"/>
                 </a:solidFill>
               </a:defRPr>
             </a:defPPr>
@@ -18890,77 +18587,19 @@
           <a:p xmlns:a="http://schemas.openxmlformats.org/drawingml/2006/main">
             <a:pPr>
               <a:buNone/>
-              <a:defRPr sz="1350" b="1">
-                <a:solidFill>
-                  <a:srgbClr val="C85C00"/>
+              <a:defRPr sz="2700" b="1">
+                <a:solidFill>
+                  <a:srgbClr val="14243A"/>
                 </a:solidFill>
               </a:defRPr>
             </a:pPr>
             <a:r>
-              <a:rPr sz="1350" b="1">
-                <a:solidFill>
-                  <a:srgbClr val="C85C00"/>
-                </a:solidFill>
-              </a:rPr>
-              <a:t>附錄 B · 前次評審意見修正情形</a:t>
-            </a:r>
-          </a:p>
-        </p:txBody>
-      </p:sp>
-      <p:sp>
-        <p:nvSpPr>
-          <p:cNvPr id="2" name="16 項意見對照：資料品質與驗證（2/2）">
-            <a:extLst xmlns:a="http://schemas.openxmlformats.org/drawingml/2006/main">
-              <a:ext uri="{FF2B5EF4-FFF2-40B4-BE49-F238E27FC236}">
-                <a16:creationId xmlns:a16="http://schemas.microsoft.com/office/drawing/2014/main" id="{CF353B7E-532B-48C0-B4DB-3B5F5BA6C063}"/>
-              </a:ext>
-            </a:extLst>
-          </p:cNvPr>
-          <p:cNvSpPr>
-            <a:spLocks xmlns:a="http://schemas.openxmlformats.org/drawingml/2006/main" noGrp="1"/>
-          </p:cNvSpPr>
-          <p:nvPr/>
-        </p:nvSpPr>
-        <p:spPr>
-          <a:xfrm xmlns:a="http://schemas.openxmlformats.org/drawingml/2006/main">
-            <a:off x="733425" y="933450"/>
-            <a:ext cx="10725150" cy="619125"/>
-          </a:xfrm>
-          <a:prstGeom xmlns:a="http://schemas.openxmlformats.org/drawingml/2006/main" prst="rect">
-            <a:avLst/>
-          </a:prstGeom>
-          <a:noFill xmlns:a="http://schemas.openxmlformats.org/drawingml/2006/main"/>
-          <a:ln xmlns:a="http://schemas.openxmlformats.org/drawingml/2006/main" w="0">
-            <a:noFill/>
-          </a:ln>
-        </p:spPr>
-        <p:txBody>
-          <a:bodyPr xmlns:a="http://schemas.openxmlformats.org/drawingml/2006/main" lIns="0" tIns="0" rIns="0" bIns="0"/>
-          <a:lstStyle xmlns:a="http://schemas.openxmlformats.org/drawingml/2006/main">
-            <a:defPPr>
-              <a:defRPr sz="2700" b="1">
+              <a:rPr sz="2700" b="1">
                 <a:solidFill>
                   <a:srgbClr val="14243A"/>
                 </a:solidFill>
-              </a:defRPr>
-            </a:defPPr>
-          </a:lstStyle>
-          <a:p xmlns:a="http://schemas.openxmlformats.org/drawingml/2006/main">
-            <a:pPr>
-              <a:buNone/>
-              <a:defRPr sz="2700" b="1">
-                <a:solidFill>
-                  <a:srgbClr val="14243A"/>
-                </a:solidFill>
-              </a:defRPr>
-            </a:pPr>
-            <a:r>
-              <a:rPr sz="2700" b="1">
-                <a:solidFill>
-                  <a:srgbClr val="14243A"/>
-                </a:solidFill>
-              </a:rPr>
-              <a:t>16 項意見對照：資料品質與驗證（2/2）</a:t>
+              </a:rPr>
+              <a:t>附錄 B｜16 項意見對照：資料品質與驗證（2/2）</a:t>
             </a:r>
           </a:p>
         </p:txBody>
@@ -20008,6 +19647,10 @@
             </a:solidFill>
           </a:ln>
         </p:spPr>
+        <p:txBody xmlns:a="http://schemas.openxmlformats.org/drawingml/2006/main">
+          <a:bodyPr/>
+          <a:p/>
+        </p:txBody>
       </p:sp>
       <p:sp>
         <p:nvSpPr>
@@ -20156,22 +19799,22 @@
       </p:grpSpPr>
       <p:sp>
         <p:nvSpPr>
-          <p:cNvPr id="8" name="附錄 C · 成本敏感度（純情境）">
-            <a:extLst xmlns:a="http://schemas.openxmlformats.org/drawingml/2006/main">
-              <a:ext uri="{FF2B5EF4-FFF2-40B4-BE49-F238E27FC236}">
-                <a16:creationId xmlns:a16="http://schemas.microsoft.com/office/drawing/2014/main" id="{214F1E84-FCAD-443F-93C1-46E80450F956}"/>
-              </a:ext>
-            </a:extLst>
-          </p:cNvPr>
-          <p:cNvSpPr>
-            <a:spLocks xmlns:a="http://schemas.openxmlformats.org/drawingml/2006/main" noGrp="1"/>
-          </p:cNvSpPr>
-          <p:nvPr/>
-        </p:nvSpPr>
-        <p:spPr>
-          <a:xfrm xmlns:a="http://schemas.openxmlformats.org/drawingml/2006/main">
-            <a:off x="733425" y="447675"/>
-            <a:ext cx="10287000" cy="304800"/>
+          <p:cNvPr id="2" name="人力成本納入後，平衡帳號數會上升">
+            <a:extLst xmlns:a="http://schemas.openxmlformats.org/drawingml/2006/main">
+              <a:ext uri="{FF2B5EF4-FFF2-40B4-BE49-F238E27FC236}">
+                <a16:creationId xmlns:a16="http://schemas.microsoft.com/office/drawing/2014/main" id="{D86BB3C5-1D82-4414-88DB-A862FA32F41C}"/>
+              </a:ext>
+            </a:extLst>
+          </p:cNvPr>
+          <p:cNvSpPr>
+            <a:spLocks xmlns:a="http://schemas.openxmlformats.org/drawingml/2006/main" noGrp="1"/>
+          </p:cNvSpPr>
+          <p:nvPr/>
+        </p:nvSpPr>
+        <p:spPr>
+          <a:xfrm xmlns:a="http://schemas.openxmlformats.org/drawingml/2006/main">
+            <a:off x="733425" y="933450"/>
+            <a:ext cx="10725150" cy="619125"/>
           </a:xfrm>
           <a:prstGeom xmlns:a="http://schemas.openxmlformats.org/drawingml/2006/main" prst="rect">
             <a:avLst/>
@@ -20185,9 +19828,9 @@
           <a:bodyPr xmlns:a="http://schemas.openxmlformats.org/drawingml/2006/main" lIns="0" tIns="0" rIns="0" bIns="0"/>
           <a:lstStyle xmlns:a="http://schemas.openxmlformats.org/drawingml/2006/main">
             <a:defPPr>
-              <a:defRPr sz="1350" b="1">
-                <a:solidFill>
-                  <a:srgbClr val="C85C00"/>
+              <a:defRPr sz="2700" b="1">
+                <a:solidFill>
+                  <a:srgbClr val="14243A"/>
                 </a:solidFill>
               </a:defRPr>
             </a:defPPr>
@@ -20195,77 +19838,19 @@
           <a:p xmlns:a="http://schemas.openxmlformats.org/drawingml/2006/main">
             <a:pPr>
               <a:buNone/>
-              <a:defRPr sz="1350" b="1">
-                <a:solidFill>
-                  <a:srgbClr val="C85C00"/>
+              <a:defRPr sz="2700" b="1">
+                <a:solidFill>
+                  <a:srgbClr val="14243A"/>
                 </a:solidFill>
               </a:defRPr>
             </a:pPr>
             <a:r>
-              <a:rPr sz="1350" b="1">
-                <a:solidFill>
-                  <a:srgbClr val="C85C00"/>
-                </a:solidFill>
-              </a:rPr>
-              <a:t>附錄 C · 成本敏感度（加入人力）</a:t>
-            </a:r>
-          </a:p>
-        </p:txBody>
-      </p:sp>
-      <p:sp>
-        <p:nvSpPr>
-          <p:cNvPr id="2" name="人力成本納入後，平衡帳號數會上升">
-            <a:extLst xmlns:a="http://schemas.openxmlformats.org/drawingml/2006/main">
-              <a:ext uri="{FF2B5EF4-FFF2-40B4-BE49-F238E27FC236}">
-                <a16:creationId xmlns:a16="http://schemas.microsoft.com/office/drawing/2014/main" id="{D86BB3C5-1D82-4414-88DB-A862FA32F41C}"/>
-              </a:ext>
-            </a:extLst>
-          </p:cNvPr>
-          <p:cNvSpPr>
-            <a:spLocks xmlns:a="http://schemas.openxmlformats.org/drawingml/2006/main" noGrp="1"/>
-          </p:cNvSpPr>
-          <p:nvPr/>
-        </p:nvSpPr>
-        <p:spPr>
-          <a:xfrm xmlns:a="http://schemas.openxmlformats.org/drawingml/2006/main">
-            <a:off x="733425" y="933450"/>
-            <a:ext cx="10725150" cy="619125"/>
-          </a:xfrm>
-          <a:prstGeom xmlns:a="http://schemas.openxmlformats.org/drawingml/2006/main" prst="rect">
-            <a:avLst/>
-          </a:prstGeom>
-          <a:noFill xmlns:a="http://schemas.openxmlformats.org/drawingml/2006/main"/>
-          <a:ln xmlns:a="http://schemas.openxmlformats.org/drawingml/2006/main" w="0">
-            <a:noFill/>
-          </a:ln>
-        </p:spPr>
-        <p:txBody>
-          <a:bodyPr xmlns:a="http://schemas.openxmlformats.org/drawingml/2006/main" lIns="0" tIns="0" rIns="0" bIns="0"/>
-          <a:lstStyle xmlns:a="http://schemas.openxmlformats.org/drawingml/2006/main">
-            <a:defPPr>
-              <a:defRPr sz="2700" b="1">
+              <a:rPr sz="2700" b="1">
                 <a:solidFill>
                   <a:srgbClr val="14243A"/>
                 </a:solidFill>
-              </a:defRPr>
-            </a:defPPr>
-          </a:lstStyle>
-          <a:p xmlns:a="http://schemas.openxmlformats.org/drawingml/2006/main">
-            <a:pPr>
-              <a:buNone/>
-              <a:defRPr sz="2700" b="1">
-                <a:solidFill>
-                  <a:srgbClr val="14243A"/>
-                </a:solidFill>
-              </a:defRPr>
-            </a:pPr>
-            <a:r>
-              <a:rPr sz="2700" b="1">
-                <a:solidFill>
-                  <a:srgbClr val="14243A"/>
-                </a:solidFill>
-              </a:rPr>
-              <a:t>加入維運人力後，平衡帳號數變成 12～21 個</a:t>
+              </a:rPr>
+              <a:t>附錄 C｜加入維運人力後，平衡帳號數變成 12～21 個</a:t>
             </a:r>
           </a:p>
         </p:txBody>
@@ -20988,22 +20573,22 @@
       </p:grpSpPr>
       <p:sp>
         <p:nvSpPr>
-          <p:cNvPr id="7" name="附錄 D · Demo 備援畫面">
-            <a:extLst xmlns:a="http://schemas.openxmlformats.org/drawingml/2006/main">
-              <a:ext uri="{FF2B5EF4-FFF2-40B4-BE49-F238E27FC236}">
-                <a16:creationId xmlns:a16="http://schemas.microsoft.com/office/drawing/2014/main" id="{5CE1F2A8-0EE7-40D8-80F0-F729CCA9E822}"/>
-              </a:ext>
-            </a:extLst>
-          </p:cNvPr>
-          <p:cNvSpPr>
-            <a:spLocks xmlns:a="http://schemas.openxmlformats.org/drawingml/2006/main" noGrp="1"/>
-          </p:cNvSpPr>
-          <p:nvPr/>
-        </p:nvSpPr>
-        <p:spPr>
-          <a:xfrm xmlns:a="http://schemas.openxmlformats.org/drawingml/2006/main">
-            <a:off x="733425" y="447675"/>
-            <a:ext cx="10287000" cy="304800"/>
+          <p:cNvPr id="2" name="AI 問答：從回答回到引用文章">
+            <a:extLst xmlns:a="http://schemas.openxmlformats.org/drawingml/2006/main">
+              <a:ext uri="{FF2B5EF4-FFF2-40B4-BE49-F238E27FC236}">
+                <a16:creationId xmlns:a16="http://schemas.microsoft.com/office/drawing/2014/main" id="{CD4E88AE-E5B8-4FC4-AFE2-AC0F898C4A3F}"/>
+              </a:ext>
+            </a:extLst>
+          </p:cNvPr>
+          <p:cNvSpPr>
+            <a:spLocks xmlns:a="http://schemas.openxmlformats.org/drawingml/2006/main" noGrp="1"/>
+          </p:cNvSpPr>
+          <p:nvPr/>
+        </p:nvSpPr>
+        <p:spPr>
+          <a:xfrm xmlns:a="http://schemas.openxmlformats.org/drawingml/2006/main">
+            <a:off x="733425" y="933450"/>
+            <a:ext cx="10725150" cy="619125"/>
           </a:xfrm>
           <a:prstGeom xmlns:a="http://schemas.openxmlformats.org/drawingml/2006/main" prst="rect">
             <a:avLst/>
@@ -21017,9 +20602,9 @@
           <a:bodyPr xmlns:a="http://schemas.openxmlformats.org/drawingml/2006/main" lIns="0" tIns="0" rIns="0" bIns="0"/>
           <a:lstStyle xmlns:a="http://schemas.openxmlformats.org/drawingml/2006/main">
             <a:defPPr>
-              <a:defRPr sz="1350" b="1">
-                <a:solidFill>
-                  <a:srgbClr val="C85C00"/>
+              <a:defRPr sz="2700" b="1">
+                <a:solidFill>
+                  <a:srgbClr val="14243A"/>
                 </a:solidFill>
               </a:defRPr>
             </a:defPPr>
@@ -21027,77 +20612,19 @@
           <a:p xmlns:a="http://schemas.openxmlformats.org/drawingml/2006/main">
             <a:pPr>
               <a:buNone/>
-              <a:defRPr sz="1350" b="1">
-                <a:solidFill>
-                  <a:srgbClr val="C85C00"/>
+              <a:defRPr sz="2700" b="1">
+                <a:solidFill>
+                  <a:srgbClr val="14243A"/>
                 </a:solidFill>
               </a:defRPr>
             </a:pPr>
             <a:r>
-              <a:rPr sz="1350" b="1">
-                <a:solidFill>
-                  <a:srgbClr val="C85C00"/>
-                </a:solidFill>
-              </a:rPr>
-              <a:t>附錄 D · Demo 備援畫面</a:t>
-            </a:r>
-          </a:p>
-        </p:txBody>
-      </p:sp>
-      <p:sp>
-        <p:nvSpPr>
-          <p:cNvPr id="2" name="AI 問答：從回答回到引用文章">
-            <a:extLst xmlns:a="http://schemas.openxmlformats.org/drawingml/2006/main">
-              <a:ext uri="{FF2B5EF4-FFF2-40B4-BE49-F238E27FC236}">
-                <a16:creationId xmlns:a16="http://schemas.microsoft.com/office/drawing/2014/main" id="{CD4E88AE-E5B8-4FC4-AFE2-AC0F898C4A3F}"/>
-              </a:ext>
-            </a:extLst>
-          </p:cNvPr>
-          <p:cNvSpPr>
-            <a:spLocks xmlns:a="http://schemas.openxmlformats.org/drawingml/2006/main" noGrp="1"/>
-          </p:cNvSpPr>
-          <p:nvPr/>
-        </p:nvSpPr>
-        <p:spPr>
-          <a:xfrm xmlns:a="http://schemas.openxmlformats.org/drawingml/2006/main">
-            <a:off x="733425" y="933450"/>
-            <a:ext cx="10725150" cy="619125"/>
-          </a:xfrm>
-          <a:prstGeom xmlns:a="http://schemas.openxmlformats.org/drawingml/2006/main" prst="rect">
-            <a:avLst/>
-          </a:prstGeom>
-          <a:noFill xmlns:a="http://schemas.openxmlformats.org/drawingml/2006/main"/>
-          <a:ln xmlns:a="http://schemas.openxmlformats.org/drawingml/2006/main" w="0">
-            <a:noFill/>
-          </a:ln>
-        </p:spPr>
-        <p:txBody>
-          <a:bodyPr xmlns:a="http://schemas.openxmlformats.org/drawingml/2006/main" lIns="0" tIns="0" rIns="0" bIns="0"/>
-          <a:lstStyle xmlns:a="http://schemas.openxmlformats.org/drawingml/2006/main">
-            <a:defPPr>
-              <a:defRPr sz="2700" b="1">
+              <a:rPr sz="2700" b="1">
                 <a:solidFill>
                   <a:srgbClr val="14243A"/>
                 </a:solidFill>
-              </a:defRPr>
-            </a:defPPr>
-          </a:lstStyle>
-          <a:p xmlns:a="http://schemas.openxmlformats.org/drawingml/2006/main">
-            <a:pPr>
-              <a:buNone/>
-              <a:defRPr sz="2700" b="1">
-                <a:solidFill>
-                  <a:srgbClr val="14243A"/>
-                </a:solidFill>
-              </a:defRPr>
-            </a:pPr>
-            <a:r>
-              <a:rPr sz="2700" b="1">
-                <a:solidFill>
-                  <a:srgbClr val="14243A"/>
-                </a:solidFill>
-              </a:rPr>
-              <a:t>AI 問答：從回答回到引用文章</a:t>
+              </a:rPr>
+              <a:t>附錄 D｜AI 問答：從回答回到引用文章</a:t>
             </a:r>
           </a:p>
         </p:txBody>
@@ -21163,6 +20690,10 @@
             </a:solidFill>
           </a:ln>
         </p:spPr>
+        <p:txBody xmlns:a="http://schemas.openxmlformats.org/drawingml/2006/main">
+          <a:bodyPr/>
+          <a:p/>
+        </p:txBody>
       </p:sp>
       <p:sp>
         <p:nvSpPr>
@@ -21311,22 +20842,22 @@
       </p:grpSpPr>
       <p:sp>
         <p:nvSpPr>
-          <p:cNvPr id="7" name="附錄 E · Demo 備援畫面">
-            <a:extLst xmlns:a="http://schemas.openxmlformats.org/drawingml/2006/main">
-              <a:ext uri="{FF2B5EF4-FFF2-40B4-BE49-F238E27FC236}">
-                <a16:creationId xmlns:a16="http://schemas.microsoft.com/office/drawing/2014/main" id="{5EA75AAF-5CFE-49EB-A641-5693FBDAF375}"/>
-              </a:ext>
-            </a:extLst>
-          </p:cNvPr>
-          <p:cNvSpPr>
-            <a:spLocks xmlns:a="http://schemas.openxmlformats.org/drawingml/2006/main" noGrp="1"/>
-          </p:cNvSpPr>
-          <p:nvPr/>
-        </p:nvSpPr>
-        <p:spPr>
-          <a:xfrm xmlns:a="http://schemas.openxmlformats.org/drawingml/2006/main">
-            <a:off x="733425" y="447675"/>
-            <a:ext cx="10287000" cy="304800"/>
+          <p:cNvPr id="2" name="歷史比較：保留兩次查詢的分析結果">
+            <a:extLst xmlns:a="http://schemas.openxmlformats.org/drawingml/2006/main">
+              <a:ext uri="{FF2B5EF4-FFF2-40B4-BE49-F238E27FC236}">
+                <a16:creationId xmlns:a16="http://schemas.microsoft.com/office/drawing/2014/main" id="{18FF3E2A-7776-4E3F-9C3A-5421CE753764}"/>
+              </a:ext>
+            </a:extLst>
+          </p:cNvPr>
+          <p:cNvSpPr>
+            <a:spLocks xmlns:a="http://schemas.openxmlformats.org/drawingml/2006/main" noGrp="1"/>
+          </p:cNvSpPr>
+          <p:nvPr/>
+        </p:nvSpPr>
+        <p:spPr>
+          <a:xfrm xmlns:a="http://schemas.openxmlformats.org/drawingml/2006/main">
+            <a:off x="733425" y="933450"/>
+            <a:ext cx="10725150" cy="619125"/>
           </a:xfrm>
           <a:prstGeom xmlns:a="http://schemas.openxmlformats.org/drawingml/2006/main" prst="rect">
             <a:avLst/>
@@ -21340,9 +20871,9 @@
           <a:bodyPr xmlns:a="http://schemas.openxmlformats.org/drawingml/2006/main" lIns="0" tIns="0" rIns="0" bIns="0"/>
           <a:lstStyle xmlns:a="http://schemas.openxmlformats.org/drawingml/2006/main">
             <a:defPPr>
-              <a:defRPr sz="1350" b="1">
-                <a:solidFill>
-                  <a:srgbClr val="C85C00"/>
+              <a:defRPr sz="2700" b="1">
+                <a:solidFill>
+                  <a:srgbClr val="14243A"/>
                 </a:solidFill>
               </a:defRPr>
             </a:defPPr>
@@ -21350,77 +20881,19 @@
           <a:p xmlns:a="http://schemas.openxmlformats.org/drawingml/2006/main">
             <a:pPr>
               <a:buNone/>
-              <a:defRPr sz="1350" b="1">
-                <a:solidFill>
-                  <a:srgbClr val="C85C00"/>
+              <a:defRPr sz="2700" b="1">
+                <a:solidFill>
+                  <a:srgbClr val="14243A"/>
                 </a:solidFill>
               </a:defRPr>
             </a:pPr>
             <a:r>
-              <a:rPr sz="1350" b="1">
-                <a:solidFill>
-                  <a:srgbClr val="C85C00"/>
-                </a:solidFill>
-              </a:rPr>
-              <a:t>附錄 E · Demo 備援畫面</a:t>
-            </a:r>
-          </a:p>
-        </p:txBody>
-      </p:sp>
-      <p:sp>
-        <p:nvSpPr>
-          <p:cNvPr id="2" name="歷史比較：保留兩次查詢的分析結果">
-            <a:extLst xmlns:a="http://schemas.openxmlformats.org/drawingml/2006/main">
-              <a:ext uri="{FF2B5EF4-FFF2-40B4-BE49-F238E27FC236}">
-                <a16:creationId xmlns:a16="http://schemas.microsoft.com/office/drawing/2014/main" id="{18FF3E2A-7776-4E3F-9C3A-5421CE753764}"/>
-              </a:ext>
-            </a:extLst>
-          </p:cNvPr>
-          <p:cNvSpPr>
-            <a:spLocks xmlns:a="http://schemas.openxmlformats.org/drawingml/2006/main" noGrp="1"/>
-          </p:cNvSpPr>
-          <p:nvPr/>
-        </p:nvSpPr>
-        <p:spPr>
-          <a:xfrm xmlns:a="http://schemas.openxmlformats.org/drawingml/2006/main">
-            <a:off x="733425" y="933450"/>
-            <a:ext cx="10725150" cy="619125"/>
-          </a:xfrm>
-          <a:prstGeom xmlns:a="http://schemas.openxmlformats.org/drawingml/2006/main" prst="rect">
-            <a:avLst/>
-          </a:prstGeom>
-          <a:noFill xmlns:a="http://schemas.openxmlformats.org/drawingml/2006/main"/>
-          <a:ln xmlns:a="http://schemas.openxmlformats.org/drawingml/2006/main" w="0">
-            <a:noFill/>
-          </a:ln>
-        </p:spPr>
-        <p:txBody>
-          <a:bodyPr xmlns:a="http://schemas.openxmlformats.org/drawingml/2006/main" lIns="0" tIns="0" rIns="0" bIns="0"/>
-          <a:lstStyle xmlns:a="http://schemas.openxmlformats.org/drawingml/2006/main">
-            <a:defPPr>
-              <a:defRPr sz="2700" b="1">
+              <a:rPr sz="2700" b="1">
                 <a:solidFill>
                   <a:srgbClr val="14243A"/>
                 </a:solidFill>
-              </a:defRPr>
-            </a:defPPr>
-          </a:lstStyle>
-          <a:p xmlns:a="http://schemas.openxmlformats.org/drawingml/2006/main">
-            <a:pPr>
-              <a:buNone/>
-              <a:defRPr sz="2700" b="1">
-                <a:solidFill>
-                  <a:srgbClr val="14243A"/>
-                </a:solidFill>
-              </a:defRPr>
-            </a:pPr>
-            <a:r>
-              <a:rPr sz="2700" b="1">
-                <a:solidFill>
-                  <a:srgbClr val="14243A"/>
-                </a:solidFill>
-              </a:rPr>
-              <a:t>歷史比較：保留兩次查詢的分析結果</a:t>
+              </a:rPr>
+              <a:t>附錄 E｜歷史比較：保留兩次查詢的分析結果</a:t>
             </a:r>
           </a:p>
         </p:txBody>
@@ -21486,6 +20959,10 @@
             </a:solidFill>
           </a:ln>
         </p:spPr>
+        <p:txBody xmlns:a="http://schemas.openxmlformats.org/drawingml/2006/main">
+          <a:bodyPr/>
+          <a:p/>
+        </p:txBody>
       </p:sp>
       <p:sp>
         <p:nvSpPr>
@@ -21634,22 +21111,22 @@
       </p:grpSpPr>
       <p:sp>
         <p:nvSpPr>
-          <p:cNvPr id="8" name="附錄 C · 成本敏感度（純情境）">
-            <a:extLst xmlns:a="http://schemas.openxmlformats.org/drawingml/2006/main">
-              <a:ext uri="{FF2B5EF4-FFF2-40B4-BE49-F238E27FC236}">
-                <a16:creationId xmlns:a16="http://schemas.microsoft.com/office/drawing/2014/main" id="{214F1E84-FCAD-443F-93C1-46E80450F956}"/>
-              </a:ext>
-            </a:extLst>
-          </p:cNvPr>
-          <p:cNvSpPr>
-            <a:spLocks xmlns:a="http://schemas.openxmlformats.org/drawingml/2006/main" noGrp="1"/>
-          </p:cNvSpPr>
-          <p:nvPr/>
-        </p:nvSpPr>
-        <p:spPr>
-          <a:xfrm xmlns:a="http://schemas.openxmlformats.org/drawingml/2006/main">
-            <a:off x="733425" y="447675"/>
-            <a:ext cx="10287000" cy="304800"/>
+          <p:cNvPr id="2" name="人力成本納入後，平衡帳號數會上升">
+            <a:extLst xmlns:a="http://schemas.openxmlformats.org/drawingml/2006/main">
+              <a:ext uri="{FF2B5EF4-FFF2-40B4-BE49-F238E27FC236}">
+                <a16:creationId xmlns:a16="http://schemas.microsoft.com/office/drawing/2014/main" id="{D86BB3C5-1D82-4414-88DB-A862FA32F41C}"/>
+              </a:ext>
+            </a:extLst>
+          </p:cNvPr>
+          <p:cNvSpPr>
+            <a:spLocks xmlns:a="http://schemas.openxmlformats.org/drawingml/2006/main" noGrp="1"/>
+          </p:cNvSpPr>
+          <p:nvPr/>
+        </p:nvSpPr>
+        <p:spPr>
+          <a:xfrm xmlns:a="http://schemas.openxmlformats.org/drawingml/2006/main">
+            <a:off x="733425" y="933450"/>
+            <a:ext cx="10725150" cy="619125"/>
           </a:xfrm>
           <a:prstGeom xmlns:a="http://schemas.openxmlformats.org/drawingml/2006/main" prst="rect">
             <a:avLst/>
@@ -21663,9 +21140,9 @@
           <a:bodyPr xmlns:a="http://schemas.openxmlformats.org/drawingml/2006/main" lIns="0" tIns="0" rIns="0" bIns="0"/>
           <a:lstStyle xmlns:a="http://schemas.openxmlformats.org/drawingml/2006/main">
             <a:defPPr>
-              <a:defRPr sz="1350" b="1">
-                <a:solidFill>
-                  <a:srgbClr val="C85C00"/>
+              <a:defRPr sz="2700" b="1">
+                <a:solidFill>
+                  <a:srgbClr val="14243A"/>
                 </a:solidFill>
               </a:defRPr>
             </a:defPPr>
@@ -21673,77 +21150,19 @@
           <a:p xmlns:a="http://schemas.openxmlformats.org/drawingml/2006/main">
             <a:pPr>
               <a:buNone/>
-              <a:defRPr sz="1350" b="1">
-                <a:solidFill>
-                  <a:srgbClr val="C85C00"/>
+              <a:defRPr sz="2700" b="1">
+                <a:solidFill>
+                  <a:srgbClr val="14243A"/>
                 </a:solidFill>
               </a:defRPr>
             </a:pPr>
             <a:r>
-              <a:rPr sz="1350" b="1">
-                <a:solidFill>
-                  <a:srgbClr val="C85C00"/>
-                </a:solidFill>
-              </a:rPr>
-              <a:t>附錄 F · 成本明細與來源</a:t>
-            </a:r>
-          </a:p>
-        </p:txBody>
-      </p:sp>
-      <p:sp>
-        <p:nvSpPr>
-          <p:cNvPr id="2" name="人力成本納入後，平衡帳號數會上升">
-            <a:extLst xmlns:a="http://schemas.openxmlformats.org/drawingml/2006/main">
-              <a:ext uri="{FF2B5EF4-FFF2-40B4-BE49-F238E27FC236}">
-                <a16:creationId xmlns:a16="http://schemas.microsoft.com/office/drawing/2014/main" id="{D86BB3C5-1D82-4414-88DB-A862FA32F41C}"/>
-              </a:ext>
-            </a:extLst>
-          </p:cNvPr>
-          <p:cNvSpPr>
-            <a:spLocks xmlns:a="http://schemas.openxmlformats.org/drawingml/2006/main" noGrp="1"/>
-          </p:cNvSpPr>
-          <p:nvPr/>
-        </p:nvSpPr>
-        <p:spPr>
-          <a:xfrm xmlns:a="http://schemas.openxmlformats.org/drawingml/2006/main">
-            <a:off x="733425" y="933450"/>
-            <a:ext cx="10725150" cy="619125"/>
-          </a:xfrm>
-          <a:prstGeom xmlns:a="http://schemas.openxmlformats.org/drawingml/2006/main" prst="rect">
-            <a:avLst/>
-          </a:prstGeom>
-          <a:noFill xmlns:a="http://schemas.openxmlformats.org/drawingml/2006/main"/>
-          <a:ln xmlns:a="http://schemas.openxmlformats.org/drawingml/2006/main" w="0">
-            <a:noFill/>
-          </a:ln>
-        </p:spPr>
-        <p:txBody>
-          <a:bodyPr xmlns:a="http://schemas.openxmlformats.org/drawingml/2006/main" lIns="0" tIns="0" rIns="0" bIns="0"/>
-          <a:lstStyle xmlns:a="http://schemas.openxmlformats.org/drawingml/2006/main">
-            <a:defPPr>
-              <a:defRPr sz="2700" b="1">
+              <a:rPr sz="2700" b="1">
                 <a:solidFill>
                   <a:srgbClr val="14243A"/>
                 </a:solidFill>
-              </a:defRPr>
-            </a:defPPr>
-          </a:lstStyle>
-          <a:p xmlns:a="http://schemas.openxmlformats.org/drawingml/2006/main">
-            <a:pPr>
-              <a:buNone/>
-              <a:defRPr sz="2700" b="1">
-                <a:solidFill>
-                  <a:srgbClr val="14243A"/>
-                </a:solidFill>
-              </a:defRPr>
-            </a:pPr>
-            <a:r>
-              <a:rPr sz="2700" b="1">
-                <a:solidFill>
-                  <a:srgbClr val="14243A"/>
-                </a:solidFill>
-              </a:rPr>
-              <a:t>每一個數字的算法與出處</a:t>
+              </a:rPr>
+              <a:t>附錄 F｜每一個數字的算法與出處</a:t>
             </a:r>
           </a:p>
         </p:txBody>
@@ -22729,52 +22148,6 @@
       </p:grpSpPr>
       <p:sp>
         <p:nvSpPr>
-          <p:cNvPr id="2" name="Text 0">
-            <a:extLst xmlns:a="http://schemas.openxmlformats.org/drawingml/2006/main">
-              <a:ext uri="{FF2B5EF4-FFF2-40B4-BE49-F238E27FC236}">
-                <a16:creationId xmlns:a16="http://schemas.microsoft.com/office/drawing/2014/main" id="{D5EFDA59-683B-4B95-90AF-A7AFA2728D43}"/>
-              </a:ext>
-            </a:extLst>
-          </p:cNvPr>
-          <p:cNvSpPr>
-            <a:spLocks xmlns:a="http://schemas.openxmlformats.org/drawingml/2006/main" noGrp="1"/>
-          </p:cNvSpPr>
-          <p:nvPr/>
-        </p:nvSpPr>
-        <p:spPr>
-          <a:xfrm xmlns:a="http://schemas.openxmlformats.org/drawingml/2006/main">
-            <a:off x="731520" y="457200"/>
-            <a:ext cx="7315200" cy="274320"/>
-          </a:xfrm>
-          <a:prstGeom xmlns:a="http://schemas.openxmlformats.org/drawingml/2006/main" prst="rect">
-            <a:avLst/>
-          </a:prstGeom>
-          <a:noFill xmlns:a="http://schemas.openxmlformats.org/drawingml/2006/main"/>
-        </p:spPr>
-        <p:txBody>
-          <a:bodyPr xmlns:a="http://schemas.openxmlformats.org/drawingml/2006/main" wrap="square" lIns="0" tIns="0" rIns="0" bIns="0" anchor="t"/>
-          <a:lstStyle xmlns:a="http://schemas.openxmlformats.org/drawingml/2006/main"/>
-          <a:p xmlns:a="http://schemas.openxmlformats.org/drawingml/2006/main">
-            <a:pPr marL="0" indent="0">
-              <a:buNone/>
-            </a:pPr>
-            <a:r>
-              <a:rPr sz="1300" b="1" spc="200">
-                <a:solidFill>
-                  <a:srgbClr val="D46A12"/>
-                </a:solidFill>
-                <a:latin typeface="Microsoft JhengHei"/>
-                <a:ea typeface="Microsoft JhengHei"/>
-                <a:cs typeface="Microsoft JhengHei"/>
-              </a:rPr>
-              <a:t>WHY · 問題與動機</a:t>
-            </a:r>
-            <a:endParaRPr sz="1300"/>
-          </a:p>
-        </p:txBody>
-      </p:sp>
-      <p:sp>
-        <p:nvSpPr>
           <p:cNvPr id="4" name="Text 2">
             <a:extLst xmlns:a="http://schemas.openxmlformats.org/drawingml/2006/main">
               <a:ext uri="{FF2B5EF4-FFF2-40B4-BE49-F238E27FC236}">
@@ -22853,6 +22226,10 @@
             <a:prstDash val="solid"/>
           </a:ln>
         </p:spPr>
+        <p:txBody xmlns:a="http://schemas.openxmlformats.org/drawingml/2006/main">
+          <a:bodyPr/>
+          <a:p/>
+        </p:txBody>
       </p:sp>
       <p:sp>
         <p:nvSpPr>
@@ -22886,6 +22263,10 @@
             <a:prstDash val="solid"/>
           </a:ln>
         </p:spPr>
+        <p:txBody xmlns:a="http://schemas.openxmlformats.org/drawingml/2006/main">
+          <a:bodyPr/>
+          <a:p/>
+        </p:txBody>
       </p:sp>
       <p:pic>
         <p:nvPicPr>
@@ -23060,6 +22441,10 @@
             <a:prstDash val="solid"/>
           </a:ln>
         </p:spPr>
+        <p:txBody xmlns:a="http://schemas.openxmlformats.org/drawingml/2006/main">
+          <a:bodyPr/>
+          <a:p/>
+        </p:txBody>
       </p:sp>
       <p:sp>
         <p:nvSpPr>
@@ -23093,6 +22478,10 @@
             <a:prstDash val="solid"/>
           </a:ln>
         </p:spPr>
+        <p:txBody xmlns:a="http://schemas.openxmlformats.org/drawingml/2006/main">
+          <a:bodyPr/>
+          <a:p/>
+        </p:txBody>
       </p:sp>
       <p:pic>
         <p:nvPicPr>
@@ -23267,6 +22656,10 @@
             <a:prstDash val="solid"/>
           </a:ln>
         </p:spPr>
+        <p:txBody xmlns:a="http://schemas.openxmlformats.org/drawingml/2006/main">
+          <a:bodyPr/>
+          <a:p/>
+        </p:txBody>
       </p:sp>
       <p:sp>
         <p:nvSpPr>
@@ -23300,6 +22693,10 @@
             <a:prstDash val="solid"/>
           </a:ln>
         </p:spPr>
+        <p:txBody xmlns:a="http://schemas.openxmlformats.org/drawingml/2006/main">
+          <a:bodyPr/>
+          <a:p/>
+        </p:txBody>
       </p:sp>
       <p:pic>
         <p:nvPicPr>
@@ -23474,6 +22871,10 @@
             <a:prstDash val="solid"/>
           </a:ln>
         </p:spPr>
+        <p:txBody xmlns:a="http://schemas.openxmlformats.org/drawingml/2006/main">
+          <a:bodyPr/>
+          <a:p/>
+        </p:txBody>
       </p:sp>
       <p:sp>
         <p:nvSpPr>
@@ -23631,6 +23032,10 @@
             <a:prstDash val="solid"/>
           </a:ln>
         </p:spPr>
+        <p:txBody xmlns:a="http://schemas.openxmlformats.org/drawingml/2006/main">
+          <a:bodyPr/>
+          <a:p/>
+        </p:txBody>
       </p:sp>
       <p:sp>
         <p:nvSpPr>
@@ -23788,6 +23193,10 @@
             <a:prstDash val="solid"/>
           </a:ln>
         </p:spPr>
+        <p:txBody xmlns:a="http://schemas.openxmlformats.org/drawingml/2006/main">
+          <a:bodyPr/>
+          <a:p/>
+        </p:txBody>
       </p:sp>
       <p:sp>
         <p:nvSpPr>
@@ -23915,6 +23324,10 @@
             <a:prstDash val="solid"/>
           </a:ln>
         </p:spPr>
+        <p:txBody xmlns:a="http://schemas.openxmlformats.org/drawingml/2006/main">
+          <a:bodyPr/>
+          <a:p/>
+        </p:txBody>
       </p:sp>
       <p:sp>
         <p:nvSpPr>
@@ -24109,22 +23522,22 @@
       </p:grpSpPr>
       <p:sp>
         <p:nvSpPr>
-          <p:cNvPr id="8" name="前次評審意見修正情形">
-            <a:extLst xmlns:a="http://schemas.openxmlformats.org/drawingml/2006/main">
-              <a:ext uri="{FF2B5EF4-FFF2-40B4-BE49-F238E27FC236}">
-                <a16:creationId xmlns:a16="http://schemas.microsoft.com/office/drawing/2014/main" id="{6AF31943-CD07-4715-B488-8A905AEC654F}"/>
-              </a:ext>
-            </a:extLst>
-          </p:cNvPr>
-          <p:cNvSpPr>
-            <a:spLocks xmlns:a="http://schemas.openxmlformats.org/drawingml/2006/main" noGrp="1"/>
-          </p:cNvSpPr>
-          <p:nvPr/>
-        </p:nvSpPr>
-        <p:spPr>
-          <a:xfrm xmlns:a="http://schemas.openxmlformats.org/drawingml/2006/main">
-            <a:off x="733425" y="447675"/>
-            <a:ext cx="10287000" cy="304800"/>
+          <p:cNvPr id="2" name="初評意見已轉成具體修正與待辦">
+            <a:extLst xmlns:a="http://schemas.openxmlformats.org/drawingml/2006/main">
+              <a:ext uri="{FF2B5EF4-FFF2-40B4-BE49-F238E27FC236}">
+                <a16:creationId xmlns:a16="http://schemas.microsoft.com/office/drawing/2014/main" id="{4FD84B34-62B7-42E5-BDA4-DEAC158EE649}"/>
+              </a:ext>
+            </a:extLst>
+          </p:cNvPr>
+          <p:cNvSpPr>
+            <a:spLocks xmlns:a="http://schemas.openxmlformats.org/drawingml/2006/main" noGrp="1"/>
+          </p:cNvSpPr>
+          <p:nvPr/>
+        </p:nvSpPr>
+        <p:spPr>
+          <a:xfrm xmlns:a="http://schemas.openxmlformats.org/drawingml/2006/main">
+            <a:off x="733425" y="933450"/>
+            <a:ext cx="10725150" cy="619125"/>
           </a:xfrm>
           <a:prstGeom xmlns:a="http://schemas.openxmlformats.org/drawingml/2006/main" prst="rect">
             <a:avLst/>
@@ -24138,9 +23551,9 @@
           <a:bodyPr xmlns:a="http://schemas.openxmlformats.org/drawingml/2006/main" lIns="0" tIns="0" rIns="0" bIns="0"/>
           <a:lstStyle xmlns:a="http://schemas.openxmlformats.org/drawingml/2006/main">
             <a:defPPr>
-              <a:defRPr sz="1350" b="1">
-                <a:solidFill>
-                  <a:srgbClr val="C85C00"/>
+              <a:defRPr sz="2700" b="1">
+                <a:solidFill>
+                  <a:srgbClr val="14243A"/>
                 </a:solidFill>
               </a:defRPr>
             </a:defPPr>
@@ -24148,77 +23561,19 @@
           <a:p xmlns:a="http://schemas.openxmlformats.org/drawingml/2006/main">
             <a:pPr>
               <a:buNone/>
-              <a:defRPr sz="1350" b="1">
-                <a:solidFill>
-                  <a:srgbClr val="C85C00"/>
+              <a:defRPr sz="2700" b="1">
+                <a:solidFill>
+                  <a:srgbClr val="14243A"/>
                 </a:solidFill>
               </a:defRPr>
             </a:pPr>
             <a:r>
-              <a:rPr sz="1350" b="1">
-                <a:solidFill>
-                  <a:srgbClr val="C85C00"/>
-                </a:solidFill>
-              </a:rPr>
-              <a:t>前次評審意見修正情形</a:t>
-            </a:r>
-          </a:p>
-        </p:txBody>
-      </p:sp>
-      <p:sp>
-        <p:nvSpPr>
-          <p:cNvPr id="2" name="初評意見已轉成具體修正與待辦">
-            <a:extLst xmlns:a="http://schemas.openxmlformats.org/drawingml/2006/main">
-              <a:ext uri="{FF2B5EF4-FFF2-40B4-BE49-F238E27FC236}">
-                <a16:creationId xmlns:a16="http://schemas.microsoft.com/office/drawing/2014/main" id="{4FD84B34-62B7-42E5-BDA4-DEAC158EE649}"/>
-              </a:ext>
-            </a:extLst>
-          </p:cNvPr>
-          <p:cNvSpPr>
-            <a:spLocks xmlns:a="http://schemas.openxmlformats.org/drawingml/2006/main" noGrp="1"/>
-          </p:cNvSpPr>
-          <p:nvPr/>
-        </p:nvSpPr>
-        <p:spPr>
-          <a:xfrm xmlns:a="http://schemas.openxmlformats.org/drawingml/2006/main">
-            <a:off x="733425" y="933450"/>
-            <a:ext cx="10725150" cy="619125"/>
-          </a:xfrm>
-          <a:prstGeom xmlns:a="http://schemas.openxmlformats.org/drawingml/2006/main" prst="rect">
-            <a:avLst/>
-          </a:prstGeom>
-          <a:noFill xmlns:a="http://schemas.openxmlformats.org/drawingml/2006/main"/>
-          <a:ln xmlns:a="http://schemas.openxmlformats.org/drawingml/2006/main" w="0">
-            <a:noFill/>
-          </a:ln>
-        </p:spPr>
-        <p:txBody>
-          <a:bodyPr xmlns:a="http://schemas.openxmlformats.org/drawingml/2006/main" lIns="0" tIns="0" rIns="0" bIns="0"/>
-          <a:lstStyle xmlns:a="http://schemas.openxmlformats.org/drawingml/2006/main">
-            <a:defPPr>
-              <a:defRPr sz="2700" b="1">
+              <a:rPr sz="2700" b="1">
                 <a:solidFill>
                   <a:srgbClr val="14243A"/>
                 </a:solidFill>
-              </a:defRPr>
-            </a:defPPr>
-          </a:lstStyle>
-          <a:p xmlns:a="http://schemas.openxmlformats.org/drawingml/2006/main">
-            <a:pPr>
-              <a:buNone/>
-              <a:defRPr sz="2700" b="1">
-                <a:solidFill>
-                  <a:srgbClr val="14243A"/>
-                </a:solidFill>
-              </a:defRPr>
-            </a:pPr>
-            <a:r>
-              <a:rPr sz="2700" b="1">
-                <a:solidFill>
-                  <a:srgbClr val="14243A"/>
-                </a:solidFill>
-              </a:rPr>
-              <a:t>初評意見已轉成具體修正與待辦</a:t>
+              </a:rPr>
+              <a:t>前次評審意見修正情形：初評意見已轉成具體修正與待辦</a:t>
             </a:r>
           </a:p>
         </p:txBody>
@@ -24838,6 +24193,10 @@
             </a:solidFill>
           </a:ln>
         </p:spPr>
+        <p:txBody xmlns:a="http://schemas.openxmlformats.org/drawingml/2006/main">
+          <a:bodyPr/>
+          <a:p/>
+        </p:txBody>
       </p:sp>
       <p:sp>
         <p:nvSpPr>
@@ -25044,52 +24403,6 @@
       </p:grpSpPr>
       <p:sp>
         <p:nvSpPr>
-          <p:cNvPr id="2" name="Text 0">
-            <a:extLst xmlns:a="http://schemas.openxmlformats.org/drawingml/2006/main">
-              <a:ext uri="{FF2B5EF4-FFF2-40B4-BE49-F238E27FC236}">
-                <a16:creationId xmlns:a16="http://schemas.microsoft.com/office/drawing/2014/main" id="{8378EB1E-5866-46B2-B727-E02E66C706AA}"/>
-              </a:ext>
-            </a:extLst>
-          </p:cNvPr>
-          <p:cNvSpPr>
-            <a:spLocks xmlns:a="http://schemas.openxmlformats.org/drawingml/2006/main" noGrp="1"/>
-          </p:cNvSpPr>
-          <p:nvPr/>
-        </p:nvSpPr>
-        <p:spPr>
-          <a:xfrm xmlns:a="http://schemas.openxmlformats.org/drawingml/2006/main">
-            <a:off x="731520" y="457200"/>
-            <a:ext cx="7315200" cy="274320"/>
-          </a:xfrm>
-          <a:prstGeom xmlns:a="http://schemas.openxmlformats.org/drawingml/2006/main" prst="rect">
-            <a:avLst/>
-          </a:prstGeom>
-          <a:noFill xmlns:a="http://schemas.openxmlformats.org/drawingml/2006/main"/>
-        </p:spPr>
-        <p:txBody>
-          <a:bodyPr xmlns:a="http://schemas.openxmlformats.org/drawingml/2006/main" wrap="square" lIns="0" tIns="0" rIns="0" bIns="0" anchor="t"/>
-          <a:lstStyle xmlns:a="http://schemas.openxmlformats.org/drawingml/2006/main"/>
-          <a:p xmlns:a="http://schemas.openxmlformats.org/drawingml/2006/main">
-            <a:pPr marL="0" indent="0">
-              <a:buNone/>
-            </a:pPr>
-            <a:r>
-              <a:rPr sz="1300" b="1" spc="200">
-                <a:solidFill>
-                  <a:srgbClr val="D46A12"/>
-                </a:solidFill>
-                <a:latin typeface="Microsoft JhengHei"/>
-                <a:ea typeface="Microsoft JhengHei"/>
-                <a:cs typeface="Microsoft JhengHei"/>
-              </a:rPr>
-              <a:t>評審A · 使用對象</a:t>
-            </a:r>
-            <a:endParaRPr sz="1300"/>
-          </a:p>
-        </p:txBody>
-      </p:sp>
-      <p:sp>
-        <p:nvSpPr>
           <p:cNvPr id="4" name="Text 2">
             <a:extLst xmlns:a="http://schemas.openxmlformats.org/drawingml/2006/main">
               <a:ext uri="{FF2B5EF4-FFF2-40B4-BE49-F238E27FC236}">
@@ -25168,6 +24481,10 @@
             <a:prstDash val="solid"/>
           </a:ln>
         </p:spPr>
+        <p:txBody xmlns:a="http://schemas.openxmlformats.org/drawingml/2006/main">
+          <a:bodyPr/>
+          <a:p/>
+        </p:txBody>
       </p:sp>
       <p:sp>
         <p:nvSpPr>
@@ -25201,6 +24518,10 @@
             <a:prstDash val="solid"/>
           </a:ln>
         </p:spPr>
+        <p:txBody xmlns:a="http://schemas.openxmlformats.org/drawingml/2006/main">
+          <a:bodyPr/>
+          <a:p/>
+        </p:txBody>
       </p:sp>
       <p:pic>
         <p:nvPicPr>
@@ -25404,6 +24725,10 @@
             <a:prstDash val="solid"/>
           </a:ln>
         </p:spPr>
+        <p:txBody xmlns:a="http://schemas.openxmlformats.org/drawingml/2006/main">
+          <a:bodyPr/>
+          <a:p/>
+        </p:txBody>
       </p:sp>
       <p:sp>
         <p:nvSpPr>
@@ -25485,6 +24810,10 @@
             <a:prstDash val="solid"/>
           </a:ln>
         </p:spPr>
+        <p:txBody xmlns:a="http://schemas.openxmlformats.org/drawingml/2006/main">
+          <a:bodyPr/>
+          <a:p/>
+        </p:txBody>
       </p:sp>
       <p:sp>
         <p:nvSpPr>
@@ -25566,6 +24895,10 @@
             <a:prstDash val="solid"/>
           </a:ln>
         </p:spPr>
+        <p:txBody xmlns:a="http://schemas.openxmlformats.org/drawingml/2006/main">
+          <a:bodyPr/>
+          <a:p/>
+        </p:txBody>
       </p:sp>
       <p:sp>
         <p:nvSpPr>
@@ -25739,6 +25072,10 @@
             <a:prstDash val="solid"/>
           </a:ln>
         </p:spPr>
+        <p:txBody xmlns:a="http://schemas.openxmlformats.org/drawingml/2006/main">
+          <a:bodyPr/>
+          <a:p/>
+        </p:txBody>
       </p:sp>
       <p:sp>
         <p:nvSpPr>
@@ -25850,6 +25187,10 @@
             <a:prstDash val="solid"/>
           </a:ln>
         </p:spPr>
+        <p:txBody xmlns:a="http://schemas.openxmlformats.org/drawingml/2006/main">
+          <a:bodyPr/>
+          <a:p/>
+        </p:txBody>
       </p:sp>
       <p:sp>
         <p:nvSpPr>
@@ -25931,6 +25272,10 @@
             <a:prstDash val="solid"/>
           </a:ln>
         </p:spPr>
+        <p:txBody xmlns:a="http://schemas.openxmlformats.org/drawingml/2006/main">
+          <a:bodyPr/>
+          <a:p/>
+        </p:txBody>
       </p:sp>
       <p:sp>
         <p:nvSpPr>
@@ -26042,6 +25387,10 @@
             <a:prstDash val="solid"/>
           </a:ln>
         </p:spPr>
+        <p:txBody xmlns:a="http://schemas.openxmlformats.org/drawingml/2006/main">
+          <a:bodyPr/>
+          <a:p/>
+        </p:txBody>
       </p:sp>
       <p:sp>
         <p:nvSpPr>
@@ -26123,6 +25472,10 @@
             <a:prstDash val="solid"/>
           </a:ln>
         </p:spPr>
+        <p:txBody xmlns:a="http://schemas.openxmlformats.org/drawingml/2006/main">
+          <a:bodyPr/>
+          <a:p/>
+        </p:txBody>
       </p:sp>
       <p:sp>
         <p:nvSpPr>
@@ -26234,6 +25587,10 @@
             <a:prstDash val="solid"/>
           </a:ln>
         </p:spPr>
+        <p:txBody xmlns:a="http://schemas.openxmlformats.org/drawingml/2006/main">
+          <a:bodyPr/>
+          <a:p/>
+        </p:txBody>
       </p:sp>
       <p:sp>
         <p:nvSpPr>
@@ -26315,6 +25672,10 @@
             <a:prstDash val="solid"/>
           </a:ln>
         </p:spPr>
+        <p:txBody xmlns:a="http://schemas.openxmlformats.org/drawingml/2006/main">
+          <a:bodyPr/>
+          <a:p/>
+        </p:txBody>
       </p:sp>
       <p:sp>
         <p:nvSpPr>
@@ -26426,6 +25787,10 @@
             <a:prstDash val="solid"/>
           </a:ln>
         </p:spPr>
+        <p:txBody xmlns:a="http://schemas.openxmlformats.org/drawingml/2006/main">
+          <a:bodyPr/>
+          <a:p/>
+        </p:txBody>
       </p:sp>
       <p:sp>
         <p:nvSpPr>
@@ -26507,6 +25872,10 @@
             <a:prstDash val="solid"/>
           </a:ln>
         </p:spPr>
+        <p:txBody xmlns:a="http://schemas.openxmlformats.org/drawingml/2006/main">
+          <a:bodyPr/>
+          <a:p/>
+        </p:txBody>
       </p:sp>
       <p:sp>
         <p:nvSpPr>
@@ -26701,52 +26070,6 @@
       </p:grpSpPr>
       <p:sp>
         <p:nvSpPr>
-          <p:cNvPr id="2" name="Text 0">
-            <a:extLst xmlns:a="http://schemas.openxmlformats.org/drawingml/2006/main">
-              <a:ext uri="{FF2B5EF4-FFF2-40B4-BE49-F238E27FC236}">
-                <a16:creationId xmlns:a16="http://schemas.microsoft.com/office/drawing/2014/main" id="{CE48E66F-7B16-4B77-A90F-18E4CCBD9A61}"/>
-              </a:ext>
-            </a:extLst>
-          </p:cNvPr>
-          <p:cNvSpPr>
-            <a:spLocks xmlns:a="http://schemas.openxmlformats.org/drawingml/2006/main" noGrp="1"/>
-          </p:cNvSpPr>
-          <p:nvPr/>
-        </p:nvSpPr>
-        <p:spPr>
-          <a:xfrm xmlns:a="http://schemas.openxmlformats.org/drawingml/2006/main">
-            <a:off x="731520" y="457200"/>
-            <a:ext cx="7315200" cy="274320"/>
-          </a:xfrm>
-          <a:prstGeom xmlns:a="http://schemas.openxmlformats.org/drawingml/2006/main" prst="rect">
-            <a:avLst/>
-          </a:prstGeom>
-          <a:noFill xmlns:a="http://schemas.openxmlformats.org/drawingml/2006/main"/>
-        </p:spPr>
-        <p:txBody>
-          <a:bodyPr xmlns:a="http://schemas.openxmlformats.org/drawingml/2006/main" wrap="square" lIns="0" tIns="0" rIns="0" bIns="0" anchor="t"/>
-          <a:lstStyle xmlns:a="http://schemas.openxmlformats.org/drawingml/2006/main"/>
-          <a:p xmlns:a="http://schemas.openxmlformats.org/drawingml/2006/main">
-            <a:pPr marL="0" indent="0">
-              <a:buNone/>
-            </a:pPr>
-            <a:r>
-              <a:rPr sz="1300" b="1" spc="200">
-                <a:solidFill>
-                  <a:srgbClr val="D46A12"/>
-                </a:solidFill>
-                <a:latin typeface="Microsoft JhengHei"/>
-                <a:ea typeface="Microsoft JhengHei"/>
-                <a:cs typeface="Microsoft JhengHei"/>
-              </a:rPr>
-              <a:t>評審C · 商業模式九大區塊</a:t>
-            </a:r>
-            <a:endParaRPr sz="1300"/>
-          </a:p>
-        </p:txBody>
-      </p:sp>
-      <p:sp>
-        <p:nvSpPr>
           <p:cNvPr id="4" name="Text 2">
             <a:extLst xmlns:a="http://schemas.openxmlformats.org/drawingml/2006/main">
               <a:ext uri="{FF2B5EF4-FFF2-40B4-BE49-F238E27FC236}">
@@ -26825,6 +26148,10 @@
             <a:prstDash val="solid"/>
           </a:ln>
         </p:spPr>
+        <p:txBody xmlns:a="http://schemas.openxmlformats.org/drawingml/2006/main">
+          <a:bodyPr/>
+          <a:p/>
+        </p:txBody>
       </p:sp>
       <p:sp>
         <p:nvSpPr>
@@ -26969,6 +26296,10 @@
             <a:prstDash val="solid"/>
           </a:ln>
         </p:spPr>
+        <p:txBody xmlns:a="http://schemas.openxmlformats.org/drawingml/2006/main">
+          <a:bodyPr/>
+          <a:p/>
+        </p:txBody>
       </p:sp>
       <p:sp>
         <p:nvSpPr>
@@ -27113,6 +26444,10 @@
             <a:prstDash val="solid"/>
           </a:ln>
         </p:spPr>
+        <p:txBody xmlns:a="http://schemas.openxmlformats.org/drawingml/2006/main">
+          <a:bodyPr/>
+          <a:p/>
+        </p:txBody>
       </p:sp>
       <p:sp>
         <p:nvSpPr>
@@ -27257,6 +26592,10 @@
             <a:prstDash val="solid"/>
           </a:ln>
         </p:spPr>
+        <p:txBody xmlns:a="http://schemas.openxmlformats.org/drawingml/2006/main">
+          <a:bodyPr/>
+          <a:p/>
+        </p:txBody>
       </p:sp>
       <p:sp>
         <p:nvSpPr>
@@ -27401,6 +26740,10 @@
             <a:prstDash val="solid"/>
           </a:ln>
         </p:spPr>
+        <p:txBody xmlns:a="http://schemas.openxmlformats.org/drawingml/2006/main">
+          <a:bodyPr/>
+          <a:p/>
+        </p:txBody>
       </p:sp>
       <p:sp>
         <p:nvSpPr>
@@ -27545,6 +26888,10 @@
             <a:prstDash val="solid"/>
           </a:ln>
         </p:spPr>
+        <p:txBody xmlns:a="http://schemas.openxmlformats.org/drawingml/2006/main">
+          <a:bodyPr/>
+          <a:p/>
+        </p:txBody>
       </p:sp>
       <p:sp>
         <p:nvSpPr>
@@ -27689,6 +27036,10 @@
             <a:prstDash val="solid"/>
           </a:ln>
         </p:spPr>
+        <p:txBody xmlns:a="http://schemas.openxmlformats.org/drawingml/2006/main">
+          <a:bodyPr/>
+          <a:p/>
+        </p:txBody>
       </p:sp>
       <p:sp>
         <p:nvSpPr>
@@ -27833,6 +27184,10 @@
             <a:prstDash val="solid"/>
           </a:ln>
         </p:spPr>
+        <p:txBody xmlns:a="http://schemas.openxmlformats.org/drawingml/2006/main">
+          <a:bodyPr/>
+          <a:p/>
+        </p:txBody>
       </p:sp>
       <p:sp>
         <p:nvSpPr>
@@ -27976,6 +27331,10 @@
             <a:prstDash val="solid"/>
           </a:ln>
         </p:spPr>
+        <p:txBody xmlns:a="http://schemas.openxmlformats.org/drawingml/2006/main">
+          <a:bodyPr/>
+          <a:p/>
+        </p:txBody>
       </p:sp>
       <p:sp>
         <p:nvSpPr>
@@ -28120,6 +27479,10 @@
             <a:prstDash val="solid"/>
           </a:ln>
         </p:spPr>
+        <p:txBody xmlns:a="http://schemas.openxmlformats.org/drawingml/2006/main">
+          <a:bodyPr/>
+          <a:p/>
+        </p:txBody>
       </p:sp>
       <p:sp>
         <p:nvSpPr>
@@ -28314,52 +27677,6 @@
       </p:grpSpPr>
       <p:sp>
         <p:nvSpPr>
-          <p:cNvPr id="2" name="Text 0">
-            <a:extLst xmlns:a="http://schemas.openxmlformats.org/drawingml/2006/main">
-              <a:ext uri="{FF2B5EF4-FFF2-40B4-BE49-F238E27FC236}">
-                <a16:creationId xmlns:a16="http://schemas.microsoft.com/office/drawing/2014/main" id="{D5251437-2CBB-4C6D-8413-BC466264DD57}"/>
-              </a:ext>
-            </a:extLst>
-          </p:cNvPr>
-          <p:cNvSpPr>
-            <a:spLocks xmlns:a="http://schemas.openxmlformats.org/drawingml/2006/main" noGrp="1"/>
-          </p:cNvSpPr>
-          <p:nvPr/>
-        </p:nvSpPr>
-        <p:spPr>
-          <a:xfrm xmlns:a="http://schemas.openxmlformats.org/drawingml/2006/main">
-            <a:off x="731520" y="457200"/>
-            <a:ext cx="7315200" cy="274320"/>
-          </a:xfrm>
-          <a:prstGeom xmlns:a="http://schemas.openxmlformats.org/drawingml/2006/main" prst="rect">
-            <a:avLst/>
-          </a:prstGeom>
-          <a:noFill xmlns:a="http://schemas.openxmlformats.org/drawingml/2006/main"/>
-        </p:spPr>
-        <p:txBody>
-          <a:bodyPr xmlns:a="http://schemas.openxmlformats.org/drawingml/2006/main" wrap="square" lIns="0" tIns="0" rIns="0" bIns="0" anchor="t"/>
-          <a:lstStyle xmlns:a="http://schemas.openxmlformats.org/drawingml/2006/main"/>
-          <a:p xmlns:a="http://schemas.openxmlformats.org/drawingml/2006/main">
-            <a:pPr marL="0" indent="0">
-              <a:buNone/>
-            </a:pPr>
-            <a:r>
-              <a:rPr sz="1300" b="1" spc="200">
-                <a:solidFill>
-                  <a:srgbClr val="D46A12"/>
-                </a:solidFill>
-                <a:latin typeface="Microsoft JhengHei"/>
-                <a:ea typeface="Microsoft JhengHei"/>
-                <a:cs typeface="Microsoft JhengHei"/>
-              </a:rPr>
-              <a:t>評審C · 量化</a:t>
-            </a:r>
-            <a:endParaRPr sz="1300"/>
-          </a:p>
-        </p:txBody>
-      </p:sp>
-      <p:sp>
-        <p:nvSpPr>
           <p:cNvPr id="4" name="Text 2">
             <a:extLst xmlns:a="http://schemas.openxmlformats.org/drawingml/2006/main">
               <a:ext uri="{FF2B5EF4-FFF2-40B4-BE49-F238E27FC236}">
@@ -28438,6 +27755,10 @@
             <a:prstDash val="solid"/>
           </a:ln>
         </p:spPr>
+        <p:txBody xmlns:a="http://schemas.openxmlformats.org/drawingml/2006/main">
+          <a:bodyPr/>
+          <a:p/>
+        </p:txBody>
       </p:sp>
       <p:sp>
         <p:nvSpPr>
@@ -28611,6 +27932,10 @@
             <a:prstDash val="solid"/>
           </a:ln>
         </p:spPr>
+        <p:txBody xmlns:a="http://schemas.openxmlformats.org/drawingml/2006/main">
+          <a:bodyPr/>
+          <a:p/>
+        </p:txBody>
       </p:sp>
       <p:sp>
         <p:nvSpPr>
@@ -28784,6 +28109,10 @@
             <a:prstDash val="solid"/>
           </a:ln>
         </p:spPr>
+        <p:txBody xmlns:a="http://schemas.openxmlformats.org/drawingml/2006/main">
+          <a:bodyPr/>
+          <a:p/>
+        </p:txBody>
       </p:sp>
       <p:sp>
         <p:nvSpPr>
@@ -28957,6 +28286,10 @@
             <a:prstDash val="solid"/>
           </a:ln>
         </p:spPr>
+        <p:txBody xmlns:a="http://schemas.openxmlformats.org/drawingml/2006/main">
+          <a:bodyPr/>
+          <a:p/>
+        </p:txBody>
       </p:sp>
       <p:sp>
         <p:nvSpPr>
@@ -28998,7 +28331,7 @@
                 <a:ea typeface="Microsoft JhengHei"/>
                 <a:cs typeface="Microsoft JhengHei"/>
               </a:rPr>
-              <a:t>營運支出平衡</a:t>
+              <a:t>損益平衡點</a:t>
             </a:r>
             <a:endParaRPr sz="1600"/>
           </a:p>
@@ -29044,7 +28377,7 @@
                 <a:ea typeface="Microsoft JhengHei"/>
                 <a:cs typeface="Microsoft JhengHei"/>
               </a:rPr>
-              <a:t>4 帳號</a:t>
+              <a:t>4 個</a:t>
             </a:r>
             <a:endParaRPr sz="5200"/>
           </a:p>
@@ -29082,7 +28415,7 @@
               <a:buNone/>
             </a:pPr>
             <a:r>
-              <a:rPr sz="1200">
+              <a:rPr sz="1400" b="1">
                 <a:solidFill>
                   <a:srgbClr val="3F546C"/>
                 </a:solidFill>
@@ -29090,7 +28423,7 @@
                 <a:ea typeface="Microsoft JhengHei"/>
                 <a:cs typeface="Microsoft JhengHei"/>
               </a:rPr>
-              <a:t>⌈1,450 ÷ (490 − 27)⌉</a:t>
+              <a:t>專業版付費帳號／月</a:t>
             </a:r>
             <a:endParaRPr sz="1200"/>
           </a:p>
@@ -29128,7 +28461,7 @@
               <a:buNone/>
             </a:pPr>
             <a:r>
-              <a:rPr sz="1200">
+              <a:rPr sz="1400">
                 <a:solidFill>
                   <a:srgbClr val="3F546C"/>
                 </a:solidFill>
@@ -29136,7 +28469,7 @@
                 <a:ea typeface="Microsoft JhengHei"/>
                 <a:cs typeface="Microsoft JhengHei"/>
               </a:rPr>
-              <a:t>4 帳號每月餘額 402 元</a:t>
+              <a:t>收入 1,960 ＞ 支出 1,558</a:t>
             </a:r>
             <a:endParaRPr sz="1200"/>
           </a:p>
@@ -29182,7 +28515,7 @@
                 <a:ea typeface="Microsoft JhengHei"/>
                 <a:cs typeface="Microsoft JhengHei"/>
               </a:rPr>
-              <a:t>月費 490 元為團隊假設</a:t>
+              <a:t>每月 1,450 固定支出＋每帳號 27</a:t>
             </a:r>
             <a:endParaRPr sz="1200"/>
           </a:p>
@@ -29222,6 +28555,10 @@
             <a:prstDash val="solid"/>
           </a:ln>
         </p:spPr>
+        <p:txBody xmlns:a="http://schemas.openxmlformats.org/drawingml/2006/main">
+          <a:bodyPr/>
+          <a:p/>
+        </p:txBody>
       </p:sp>
       <p:sp>
         <p:nvSpPr>
@@ -29257,6 +28594,10 @@
             <a:prstDash val="solid"/>
           </a:ln>
         </p:spPr>
+        <p:txBody xmlns:a="http://schemas.openxmlformats.org/drawingml/2006/main">
+          <a:bodyPr/>
+          <a:p/>
+        </p:txBody>
       </p:sp>
       <p:sp>
         <p:nvSpPr>
@@ -29473,52 +28814,6 @@
       </p:grpSpPr>
       <p:sp>
         <p:nvSpPr>
-          <p:cNvPr id="2" name="Text 0">
-            <a:extLst xmlns:a="http://schemas.openxmlformats.org/drawingml/2006/main">
-              <a:ext uri="{FF2B5EF4-FFF2-40B4-BE49-F238E27FC236}">
-                <a16:creationId xmlns:a16="http://schemas.microsoft.com/office/drawing/2014/main" id="{9DD8379D-9BFF-494D-AFB5-B484A88F09BF}"/>
-              </a:ext>
-            </a:extLst>
-          </p:cNvPr>
-          <p:cNvSpPr>
-            <a:spLocks xmlns:a="http://schemas.openxmlformats.org/drawingml/2006/main" noGrp="1"/>
-          </p:cNvSpPr>
-          <p:nvPr/>
-        </p:nvSpPr>
-        <p:spPr>
-          <a:xfrm xmlns:a="http://schemas.openxmlformats.org/drawingml/2006/main">
-            <a:off x="731520" y="457200"/>
-            <a:ext cx="7315200" cy="274320"/>
-          </a:xfrm>
-          <a:prstGeom xmlns:a="http://schemas.openxmlformats.org/drawingml/2006/main" prst="rect">
-            <a:avLst/>
-          </a:prstGeom>
-          <a:noFill xmlns:a="http://schemas.openxmlformats.org/drawingml/2006/main"/>
-        </p:spPr>
-        <p:txBody>
-          <a:bodyPr xmlns:a="http://schemas.openxmlformats.org/drawingml/2006/main" wrap="square" lIns="0" tIns="0" rIns="0" bIns="0" anchor="t"/>
-          <a:lstStyle xmlns:a="http://schemas.openxmlformats.org/drawingml/2006/main"/>
-          <a:p xmlns:a="http://schemas.openxmlformats.org/drawingml/2006/main">
-            <a:pPr marL="0" indent="0">
-              <a:buNone/>
-            </a:pPr>
-            <a:r>
-              <a:rPr sz="1300" b="1" spc="200">
-                <a:solidFill>
-                  <a:srgbClr val="D46A12"/>
-                </a:solidFill>
-                <a:latin typeface="Microsoft JhengHei"/>
-                <a:ea typeface="Microsoft JhengHei"/>
-                <a:cs typeface="Microsoft JhengHei"/>
-              </a:rPr>
-              <a:t>評審C · SWOT → TOWS ／ Agentic AI</a:t>
-            </a:r>
-            <a:endParaRPr sz="1300"/>
-          </a:p>
-        </p:txBody>
-      </p:sp>
-      <p:sp>
-        <p:nvSpPr>
           <p:cNvPr id="4" name="Text 2">
             <a:extLst xmlns:a="http://schemas.openxmlformats.org/drawingml/2006/main">
               <a:ext uri="{FF2B5EF4-FFF2-40B4-BE49-F238E27FC236}">
@@ -29597,6 +28892,10 @@
             <a:prstDash val="solid"/>
           </a:ln>
         </p:spPr>
+        <p:txBody xmlns:a="http://schemas.openxmlformats.org/drawingml/2006/main">
+          <a:bodyPr/>
+          <a:p/>
+        </p:txBody>
       </p:sp>
       <p:sp>
         <p:nvSpPr>
@@ -29678,6 +28977,10 @@
             <a:prstDash val="solid"/>
           </a:ln>
         </p:spPr>
+        <p:txBody xmlns:a="http://schemas.openxmlformats.org/drawingml/2006/main">
+          <a:bodyPr/>
+          <a:p/>
+        </p:txBody>
       </p:sp>
       <p:sp>
         <p:nvSpPr>
@@ -29805,6 +29108,10 @@
             <a:prstDash val="solid"/>
           </a:ln>
         </p:spPr>
+        <p:txBody xmlns:a="http://schemas.openxmlformats.org/drawingml/2006/main">
+          <a:bodyPr/>
+          <a:p/>
+        </p:txBody>
       </p:sp>
       <p:sp>
         <p:nvSpPr>
@@ -29949,6 +29256,10 @@
             <a:prstDash val="solid"/>
           </a:ln>
         </p:spPr>
+        <p:txBody xmlns:a="http://schemas.openxmlformats.org/drawingml/2006/main">
+          <a:bodyPr/>
+          <a:p/>
+        </p:txBody>
       </p:sp>
       <p:sp>
         <p:nvSpPr>
@@ -30093,6 +29404,10 @@
             <a:prstDash val="solid"/>
           </a:ln>
         </p:spPr>
+        <p:txBody xmlns:a="http://schemas.openxmlformats.org/drawingml/2006/main">
+          <a:bodyPr/>
+          <a:p/>
+        </p:txBody>
       </p:sp>
       <p:sp>
         <p:nvSpPr>
@@ -30237,6 +29552,10 @@
             <a:prstDash val="solid"/>
           </a:ln>
         </p:spPr>
+        <p:txBody xmlns:a="http://schemas.openxmlformats.org/drawingml/2006/main">
+          <a:bodyPr/>
+          <a:p/>
+        </p:txBody>
       </p:sp>
       <p:sp>
         <p:nvSpPr>
@@ -30410,6 +29729,10 @@
             <a:prstDash val="solid"/>
           </a:ln>
         </p:spPr>
+        <p:txBody xmlns:a="http://schemas.openxmlformats.org/drawingml/2006/main">
+          <a:bodyPr/>
+          <a:p/>
+        </p:txBody>
       </p:sp>
       <p:sp>
         <p:nvSpPr>
@@ -30600,6 +29923,10 @@
             <a:prstDash val="solid"/>
           </a:ln>
         </p:spPr>
+        <p:txBody xmlns:a="http://schemas.openxmlformats.org/drawingml/2006/main">
+          <a:bodyPr/>
+          <a:p/>
+        </p:txBody>
       </p:sp>
       <p:sp>
         <p:nvSpPr>
@@ -30773,6 +30100,10 @@
             <a:prstDash val="solid"/>
           </a:ln>
         </p:spPr>
+        <p:txBody xmlns:a="http://schemas.openxmlformats.org/drawingml/2006/main">
+          <a:bodyPr/>
+          <a:p/>
+        </p:txBody>
       </p:sp>
       <p:sp>
         <p:nvSpPr>
@@ -30946,6 +30277,10 @@
             <a:prstDash val="solid"/>
           </a:ln>
         </p:spPr>
+        <p:txBody xmlns:a="http://schemas.openxmlformats.org/drawingml/2006/main">
+          <a:bodyPr/>
+          <a:p/>
+        </p:txBody>
       </p:sp>
       <p:sp>
         <p:nvSpPr>
@@ -31140,52 +30475,6 @@
       </p:grpSpPr>
       <p:sp>
         <p:nvSpPr>
-          <p:cNvPr id="2" name="Text 0">
-            <a:extLst xmlns:a="http://schemas.openxmlformats.org/drawingml/2006/main">
-              <a:ext uri="{FF2B5EF4-FFF2-40B4-BE49-F238E27FC236}">
-                <a16:creationId xmlns:a16="http://schemas.microsoft.com/office/drawing/2014/main" id="{6A382AC0-1725-4E97-8880-5B5576A9C65F}"/>
-              </a:ext>
-            </a:extLst>
-          </p:cNvPr>
-          <p:cNvSpPr>
-            <a:spLocks xmlns:a="http://schemas.openxmlformats.org/drawingml/2006/main" noGrp="1"/>
-          </p:cNvSpPr>
-          <p:nvPr/>
-        </p:nvSpPr>
-        <p:spPr>
-          <a:xfrm xmlns:a="http://schemas.openxmlformats.org/drawingml/2006/main">
-            <a:off x="731520" y="457200"/>
-            <a:ext cx="7315200" cy="274320"/>
-          </a:xfrm>
-          <a:prstGeom xmlns:a="http://schemas.openxmlformats.org/drawingml/2006/main" prst="rect">
-            <a:avLst/>
-          </a:prstGeom>
-          <a:noFill xmlns:a="http://schemas.openxmlformats.org/drawingml/2006/main"/>
-        </p:spPr>
-        <p:txBody>
-          <a:bodyPr xmlns:a="http://schemas.openxmlformats.org/drawingml/2006/main" wrap="square" lIns="0" tIns="0" rIns="0" bIns="0" anchor="t"/>
-          <a:lstStyle xmlns:a="http://schemas.openxmlformats.org/drawingml/2006/main"/>
-          <a:p xmlns:a="http://schemas.openxmlformats.org/drawingml/2006/main">
-            <a:pPr marL="0" indent="0">
-              <a:buNone/>
-            </a:pPr>
-            <a:r>
-              <a:rPr sz="1300" b="1" spc="200">
-                <a:solidFill>
-                  <a:srgbClr val="D46A12"/>
-                </a:solidFill>
-                <a:latin typeface="Microsoft JhengHei"/>
-                <a:ea typeface="Microsoft JhengHei"/>
-                <a:cs typeface="Microsoft JhengHei"/>
-              </a:rPr>
-              <a:t>HOW · 系統架構</a:t>
-            </a:r>
-            <a:endParaRPr sz="1300"/>
-          </a:p>
-        </p:txBody>
-      </p:sp>
-      <p:sp>
-        <p:nvSpPr>
           <p:cNvPr id="4" name="Text 2">
             <a:extLst xmlns:a="http://schemas.openxmlformats.org/drawingml/2006/main">
               <a:ext uri="{FF2B5EF4-FFF2-40B4-BE49-F238E27FC236}">
@@ -31264,6 +30553,10 @@
             <a:prstDash val="solid"/>
           </a:ln>
         </p:spPr>
+        <p:txBody xmlns:a="http://schemas.openxmlformats.org/drawingml/2006/main">
+          <a:bodyPr/>
+          <a:p/>
+        </p:txBody>
       </p:sp>
       <p:sp>
         <p:nvSpPr>
@@ -31297,6 +30590,10 @@
             <a:prstDash val="solid"/>
           </a:ln>
         </p:spPr>
+        <p:txBody xmlns:a="http://schemas.openxmlformats.org/drawingml/2006/main">
+          <a:bodyPr/>
+          <a:p/>
+        </p:txBody>
       </p:sp>
       <p:pic>
         <p:nvPicPr>
@@ -31501,6 +30798,10 @@
             <a:prstDash val="solid"/>
           </a:ln>
         </p:spPr>
+        <p:txBody xmlns:a="http://schemas.openxmlformats.org/drawingml/2006/main">
+          <a:bodyPr/>
+          <a:p/>
+        </p:txBody>
       </p:sp>
       <p:sp>
         <p:nvSpPr>
@@ -31534,6 +30835,10 @@
             <a:prstDash val="solid"/>
           </a:ln>
         </p:spPr>
+        <p:txBody xmlns:a="http://schemas.openxmlformats.org/drawingml/2006/main">
+          <a:bodyPr/>
+          <a:p/>
+        </p:txBody>
       </p:sp>
       <p:pic>
         <p:nvPicPr>
@@ -31738,6 +31043,10 @@
             <a:prstDash val="solid"/>
           </a:ln>
         </p:spPr>
+        <p:txBody xmlns:a="http://schemas.openxmlformats.org/drawingml/2006/main">
+          <a:bodyPr/>
+          <a:p/>
+        </p:txBody>
       </p:sp>
       <p:sp>
         <p:nvSpPr>
@@ -31771,6 +31080,10 @@
             <a:prstDash val="solid"/>
           </a:ln>
         </p:spPr>
+        <p:txBody xmlns:a="http://schemas.openxmlformats.org/drawingml/2006/main">
+          <a:bodyPr/>
+          <a:p/>
+        </p:txBody>
       </p:sp>
       <p:pic>
         <p:nvPicPr>
@@ -31945,6 +31258,10 @@
             <a:prstDash val="solid"/>
           </a:ln>
         </p:spPr>
+        <p:txBody xmlns:a="http://schemas.openxmlformats.org/drawingml/2006/main">
+          <a:bodyPr/>
+          <a:p/>
+        </p:txBody>
       </p:sp>
       <p:sp>
         <p:nvSpPr>
@@ -32026,6 +31343,10 @@
             <a:prstDash val="solid"/>
           </a:ln>
         </p:spPr>
+        <p:txBody xmlns:a="http://schemas.openxmlformats.org/drawingml/2006/main">
+          <a:bodyPr/>
+          <a:p/>
+        </p:txBody>
       </p:sp>
       <p:sp>
         <p:nvSpPr>
@@ -32107,6 +31428,10 @@
             <a:prstDash val="solid"/>
           </a:ln>
         </p:spPr>
+        <p:txBody xmlns:a="http://schemas.openxmlformats.org/drawingml/2006/main">
+          <a:bodyPr/>
+          <a:p/>
+        </p:txBody>
       </p:sp>
       <p:sp>
         <p:nvSpPr>
@@ -32188,6 +31513,10 @@
             <a:prstDash val="solid"/>
           </a:ln>
         </p:spPr>
+        <p:txBody xmlns:a="http://schemas.openxmlformats.org/drawingml/2006/main">
+          <a:bodyPr/>
+          <a:p/>
+        </p:txBody>
       </p:sp>
       <p:sp>
         <p:nvSpPr>
@@ -32269,6 +31598,10 @@
             <a:prstDash val="solid"/>
           </a:ln>
         </p:spPr>
+        <p:txBody xmlns:a="http://schemas.openxmlformats.org/drawingml/2006/main">
+          <a:bodyPr/>
+          <a:p/>
+        </p:txBody>
       </p:sp>
       <p:sp>
         <p:nvSpPr>

</xml_diff>

<commit_message>
Remove presentation timings from the slides
Drops '15 MIN' from the cover, the 14:30 headline and card time ranges
from the agenda, and the speaker-and-time label in each slide's top
right. Timings stay in the speaker notes for rehearsal. The PDF is
re-exported under its official name.

Co-Authored-By: Claude Opus 5.5 <noreply@anthropic.com>
</commit_message>
<xml_diff>
--- a/output/ppt-review-20261011/final/MeBOD_複審簡報_第二輪修訂版.pptx
+++ b/output/ppt-review-20261011/final/MeBOD_複審簡報_第二輪修訂版.pptx
@@ -3600,7 +3600,7 @@
                 <a:ea typeface="Microsoft JhengHei"/>
                 <a:cs typeface="Microsoft JhengHei"/>
               </a:rPr>
-              <a:t>複審 · 15 MIN · 第115405組</a:t>
+              <a:t>複審 · 第115405組</a:t>
             </a:r>
             <a:endParaRPr sz="1500"/>
           </a:p>
@@ -5223,64 +5223,6 @@
       </p:sp>
       <p:sp>
         <p:nvSpPr>
-          <p:cNvPr id="35" name="許家全 · 5:10–5:50">
-            <a:extLst xmlns:a="http://schemas.openxmlformats.org/drawingml/2006/main">
-              <a:ext uri="{FF2B5EF4-FFF2-40B4-BE49-F238E27FC236}">
-                <a16:creationId xmlns:a16="http://schemas.microsoft.com/office/drawing/2014/main" id="{1199BFDD-CEBC-4035-91D6-76DEC2CFE29F}"/>
-              </a:ext>
-            </a:extLst>
-          </p:cNvPr>
-          <p:cNvSpPr>
-            <a:spLocks xmlns:a="http://schemas.openxmlformats.org/drawingml/2006/main" noGrp="1"/>
-          </p:cNvSpPr>
-          <p:nvPr/>
-        </p:nvSpPr>
-        <p:spPr>
-          <a:xfrm xmlns:a="http://schemas.openxmlformats.org/drawingml/2006/main">
-            <a:off x="8667750" y="457200"/>
-            <a:ext cx="2790825" cy="266700"/>
-          </a:xfrm>
-          <a:prstGeom xmlns:a="http://schemas.openxmlformats.org/drawingml/2006/main" prst="rect">
-            <a:avLst/>
-          </a:prstGeom>
-          <a:noFill xmlns:a="http://schemas.openxmlformats.org/drawingml/2006/main"/>
-          <a:ln xmlns:a="http://schemas.openxmlformats.org/drawingml/2006/main" w="0">
-            <a:noFill/>
-          </a:ln>
-        </p:spPr>
-        <p:txBody>
-          <a:bodyPr xmlns:a="http://schemas.openxmlformats.org/drawingml/2006/main" lIns="0" tIns="0" rIns="0" bIns="0"/>
-          <a:lstStyle xmlns:a="http://schemas.openxmlformats.org/drawingml/2006/main">
-            <a:defPPr>
-              <a:defRPr sz="1275" b="0">
-                <a:solidFill>
-                  <a:srgbClr val="465E78"/>
-                </a:solidFill>
-              </a:defRPr>
-            </a:defPPr>
-          </a:lstStyle>
-          <a:p xmlns:a="http://schemas.openxmlformats.org/drawingml/2006/main">
-            <a:pPr>
-              <a:buNone/>
-              <a:defRPr sz="1275" b="0">
-                <a:solidFill>
-                  <a:srgbClr val="465E78"/>
-                </a:solidFill>
-              </a:defRPr>
-            </a:pPr>
-            <a:r>
-              <a:rPr sz="1275" b="0">
-                <a:solidFill>
-                  <a:srgbClr val="465E78"/>
-                </a:solidFill>
-              </a:rPr>
-              <a:t>許家全 · 5:10–5:50</a:t>
-            </a:r>
-          </a:p>
-        </p:txBody>
-      </p:sp>
-      <p:sp>
-        <p:nvSpPr>
           <p:cNvPr id="36" name="10">
             <a:extLst xmlns:a="http://schemas.openxmlformats.org/drawingml/2006/main">
               <a:ext uri="{FF2B5EF4-FFF2-40B4-BE49-F238E27FC236}">
@@ -6558,64 +6500,6 @@
       </p:sp>
       <p:sp>
         <p:nvSpPr>
-          <p:cNvPr id="23" name="許家全 · 5:50–6:35">
-            <a:extLst xmlns:a="http://schemas.openxmlformats.org/drawingml/2006/main">
-              <a:ext uri="{FF2B5EF4-FFF2-40B4-BE49-F238E27FC236}">
-                <a16:creationId xmlns:a16="http://schemas.microsoft.com/office/drawing/2014/main" id="{209D6858-4F66-42BB-AE07-5F5B74BFBB01}"/>
-              </a:ext>
-            </a:extLst>
-          </p:cNvPr>
-          <p:cNvSpPr>
-            <a:spLocks xmlns:a="http://schemas.openxmlformats.org/drawingml/2006/main" noGrp="1"/>
-          </p:cNvSpPr>
-          <p:nvPr/>
-        </p:nvSpPr>
-        <p:spPr>
-          <a:xfrm xmlns:a="http://schemas.openxmlformats.org/drawingml/2006/main">
-            <a:off x="8667750" y="457200"/>
-            <a:ext cx="2790825" cy="266700"/>
-          </a:xfrm>
-          <a:prstGeom xmlns:a="http://schemas.openxmlformats.org/drawingml/2006/main" prst="rect">
-            <a:avLst/>
-          </a:prstGeom>
-          <a:noFill xmlns:a="http://schemas.openxmlformats.org/drawingml/2006/main"/>
-          <a:ln xmlns:a="http://schemas.openxmlformats.org/drawingml/2006/main" w="0">
-            <a:noFill/>
-          </a:ln>
-        </p:spPr>
-        <p:txBody>
-          <a:bodyPr xmlns:a="http://schemas.openxmlformats.org/drawingml/2006/main" lIns="0" tIns="0" rIns="0" bIns="0"/>
-          <a:lstStyle xmlns:a="http://schemas.openxmlformats.org/drawingml/2006/main">
-            <a:defPPr>
-              <a:defRPr sz="1275" b="0">
-                <a:solidFill>
-                  <a:srgbClr val="465E78"/>
-                </a:solidFill>
-              </a:defRPr>
-            </a:defPPr>
-          </a:lstStyle>
-          <a:p xmlns:a="http://schemas.openxmlformats.org/drawingml/2006/main">
-            <a:pPr>
-              <a:buNone/>
-              <a:defRPr sz="1275" b="0">
-                <a:solidFill>
-                  <a:srgbClr val="465E78"/>
-                </a:solidFill>
-              </a:defRPr>
-            </a:pPr>
-            <a:r>
-              <a:rPr sz="1275" b="0">
-                <a:solidFill>
-                  <a:srgbClr val="465E78"/>
-                </a:solidFill>
-              </a:rPr>
-              <a:t>許家全 · 5:50–6:35</a:t>
-            </a:r>
-          </a:p>
-        </p:txBody>
-      </p:sp>
-      <p:sp>
-        <p:nvSpPr>
           <p:cNvPr id="24" name="11">
             <a:extLst xmlns:a="http://schemas.openxmlformats.org/drawingml/2006/main">
               <a:ext uri="{FF2B5EF4-FFF2-40B4-BE49-F238E27FC236}">
@@ -7496,64 +7380,6 @@
       </p:sp>
       <p:sp>
         <p:nvSpPr>
-          <p:cNvPr id="23" name="許家全 · 6:35–7:20">
-            <a:extLst xmlns:a="http://schemas.openxmlformats.org/drawingml/2006/main">
-              <a:ext uri="{FF2B5EF4-FFF2-40B4-BE49-F238E27FC236}">
-                <a16:creationId xmlns:a16="http://schemas.microsoft.com/office/drawing/2014/main" id="{FA88BA15-74D1-4710-8B9E-0D832E8BFF67}"/>
-              </a:ext>
-            </a:extLst>
-          </p:cNvPr>
-          <p:cNvSpPr>
-            <a:spLocks xmlns:a="http://schemas.openxmlformats.org/drawingml/2006/main" noGrp="1"/>
-          </p:cNvSpPr>
-          <p:nvPr/>
-        </p:nvSpPr>
-        <p:spPr>
-          <a:xfrm xmlns:a="http://schemas.openxmlformats.org/drawingml/2006/main">
-            <a:off x="8667750" y="457200"/>
-            <a:ext cx="2790825" cy="266700"/>
-          </a:xfrm>
-          <a:prstGeom xmlns:a="http://schemas.openxmlformats.org/drawingml/2006/main" prst="rect">
-            <a:avLst/>
-          </a:prstGeom>
-          <a:noFill xmlns:a="http://schemas.openxmlformats.org/drawingml/2006/main"/>
-          <a:ln xmlns:a="http://schemas.openxmlformats.org/drawingml/2006/main" w="0">
-            <a:noFill/>
-          </a:ln>
-        </p:spPr>
-        <p:txBody>
-          <a:bodyPr xmlns:a="http://schemas.openxmlformats.org/drawingml/2006/main" lIns="0" tIns="0" rIns="0" bIns="0"/>
-          <a:lstStyle xmlns:a="http://schemas.openxmlformats.org/drawingml/2006/main">
-            <a:defPPr>
-              <a:defRPr sz="1275" b="0">
-                <a:solidFill>
-                  <a:srgbClr val="465E78"/>
-                </a:solidFill>
-              </a:defRPr>
-            </a:defPPr>
-          </a:lstStyle>
-          <a:p xmlns:a="http://schemas.openxmlformats.org/drawingml/2006/main">
-            <a:pPr>
-              <a:buNone/>
-              <a:defRPr sz="1275" b="0">
-                <a:solidFill>
-                  <a:srgbClr val="465E78"/>
-                </a:solidFill>
-              </a:defRPr>
-            </a:pPr>
-            <a:r>
-              <a:rPr sz="1275" b="0">
-                <a:solidFill>
-                  <a:srgbClr val="465E78"/>
-                </a:solidFill>
-              </a:rPr>
-              <a:t>許家全 · 6:35–7:20</a:t>
-            </a:r>
-          </a:p>
-        </p:txBody>
-      </p:sp>
-      <p:sp>
-        <p:nvSpPr>
           <p:cNvPr id="24" name="12">
             <a:extLst xmlns:a="http://schemas.openxmlformats.org/drawingml/2006/main">
               <a:ext uri="{FF2B5EF4-FFF2-40B4-BE49-F238E27FC236}">
@@ -8590,64 +8416,6 @@
               <a:t>依「已實作／待驗證／規劃」分列；未定義驗收分母，不宣稱完成百分比。</a:t>
             </a:r>
             <a:endParaRPr sz="1400"/>
-          </a:p>
-        </p:txBody>
-      </p:sp>
-      <p:sp>
-        <p:nvSpPr>
-          <p:cNvPr id="23" name="許家全 · 7:20–8:00">
-            <a:extLst xmlns:a="http://schemas.openxmlformats.org/drawingml/2006/main">
-              <a:ext uri="{FF2B5EF4-FFF2-40B4-BE49-F238E27FC236}">
-                <a16:creationId xmlns:a16="http://schemas.microsoft.com/office/drawing/2014/main" id="{3CFAA62A-AF22-4B52-AE23-A600D1B91FE2}"/>
-              </a:ext>
-            </a:extLst>
-          </p:cNvPr>
-          <p:cNvSpPr>
-            <a:spLocks xmlns:a="http://schemas.openxmlformats.org/drawingml/2006/main" noGrp="1"/>
-          </p:cNvSpPr>
-          <p:nvPr/>
-        </p:nvSpPr>
-        <p:spPr>
-          <a:xfrm xmlns:a="http://schemas.openxmlformats.org/drawingml/2006/main">
-            <a:off x="8667750" y="457200"/>
-            <a:ext cx="2790825" cy="266700"/>
-          </a:xfrm>
-          <a:prstGeom xmlns:a="http://schemas.openxmlformats.org/drawingml/2006/main" prst="rect">
-            <a:avLst/>
-          </a:prstGeom>
-          <a:noFill xmlns:a="http://schemas.openxmlformats.org/drawingml/2006/main"/>
-          <a:ln xmlns:a="http://schemas.openxmlformats.org/drawingml/2006/main" w="0">
-            <a:noFill/>
-          </a:ln>
-        </p:spPr>
-        <p:txBody>
-          <a:bodyPr xmlns:a="http://schemas.openxmlformats.org/drawingml/2006/main" lIns="0" tIns="0" rIns="0" bIns="0"/>
-          <a:lstStyle xmlns:a="http://schemas.openxmlformats.org/drawingml/2006/main">
-            <a:defPPr>
-              <a:defRPr sz="1275" b="0">
-                <a:solidFill>
-                  <a:srgbClr val="465E78"/>
-                </a:solidFill>
-              </a:defRPr>
-            </a:defPPr>
-          </a:lstStyle>
-          <a:p xmlns:a="http://schemas.openxmlformats.org/drawingml/2006/main">
-            <a:pPr>
-              <a:buNone/>
-              <a:defRPr sz="1275" b="0">
-                <a:solidFill>
-                  <a:srgbClr val="465E78"/>
-                </a:solidFill>
-              </a:defRPr>
-            </a:pPr>
-            <a:r>
-              <a:rPr sz="1275" b="0">
-                <a:solidFill>
-                  <a:srgbClr val="465E78"/>
-                </a:solidFill>
-              </a:rPr>
-              <a:t>許家全 · 7:20–8:00</a:t>
-            </a:r>
           </a:p>
         </p:txBody>
       </p:sp>
@@ -9690,64 +9458,6 @@
       </p:sp>
       <p:sp>
         <p:nvSpPr>
-          <p:cNvPr id="6" name="許家全 · 8:00–8:35">
-            <a:extLst xmlns:a="http://schemas.openxmlformats.org/drawingml/2006/main">
-              <a:ext uri="{FF2B5EF4-FFF2-40B4-BE49-F238E27FC236}">
-                <a16:creationId xmlns:a16="http://schemas.microsoft.com/office/drawing/2014/main" id="{256D84E3-1A04-45AE-B6C2-61D7838A920C}"/>
-              </a:ext>
-            </a:extLst>
-          </p:cNvPr>
-          <p:cNvSpPr>
-            <a:spLocks xmlns:a="http://schemas.openxmlformats.org/drawingml/2006/main" noGrp="1"/>
-          </p:cNvSpPr>
-          <p:nvPr/>
-        </p:nvSpPr>
-        <p:spPr>
-          <a:xfrm xmlns:a="http://schemas.openxmlformats.org/drawingml/2006/main">
-            <a:off x="8667750" y="457200"/>
-            <a:ext cx="2790825" cy="266700"/>
-          </a:xfrm>
-          <a:prstGeom xmlns:a="http://schemas.openxmlformats.org/drawingml/2006/main" prst="rect">
-            <a:avLst/>
-          </a:prstGeom>
-          <a:noFill xmlns:a="http://schemas.openxmlformats.org/drawingml/2006/main"/>
-          <a:ln xmlns:a="http://schemas.openxmlformats.org/drawingml/2006/main" w="0">
-            <a:noFill/>
-          </a:ln>
-        </p:spPr>
-        <p:txBody>
-          <a:bodyPr xmlns:a="http://schemas.openxmlformats.org/drawingml/2006/main" lIns="0" tIns="0" rIns="0" bIns="0"/>
-          <a:lstStyle xmlns:a="http://schemas.openxmlformats.org/drawingml/2006/main">
-            <a:defPPr>
-              <a:defRPr sz="1275" b="0">
-                <a:solidFill>
-                  <a:srgbClr val="465E78"/>
-                </a:solidFill>
-              </a:defRPr>
-            </a:defPPr>
-          </a:lstStyle>
-          <a:p xmlns:a="http://schemas.openxmlformats.org/drawingml/2006/main">
-            <a:pPr>
-              <a:buNone/>
-              <a:defRPr sz="1275" b="0">
-                <a:solidFill>
-                  <a:srgbClr val="465E78"/>
-                </a:solidFill>
-              </a:defRPr>
-            </a:pPr>
-            <a:r>
-              <a:rPr sz="1275" b="0">
-                <a:solidFill>
-                  <a:srgbClr val="465E78"/>
-                </a:solidFill>
-              </a:rPr>
-              <a:t>許家全 · 8:00–8:35</a:t>
-            </a:r>
-          </a:p>
-        </p:txBody>
-      </p:sp>
-      <p:sp>
-        <p:nvSpPr>
           <p:cNvPr id="7" name="14">
             <a:extLst xmlns:a="http://schemas.openxmlformats.org/drawingml/2006/main">
               <a:ext uri="{FF2B5EF4-FFF2-40B4-BE49-F238E27FC236}">
@@ -10395,64 +10105,6 @@
                 </a:solidFill>
               </a:rPr>
               <a:t>示範重點：相同查詢條件、可回查的來源、可留存的結果。</a:t>
-            </a:r>
-          </a:p>
-        </p:txBody>
-      </p:sp>
-      <p:sp>
-        <p:nvSpPr>
-          <p:cNvPr id="12" name="許家全 · 8:35–10:55">
-            <a:extLst xmlns:a="http://schemas.openxmlformats.org/drawingml/2006/main">
-              <a:ext uri="{FF2B5EF4-FFF2-40B4-BE49-F238E27FC236}">
-                <a16:creationId xmlns:a16="http://schemas.microsoft.com/office/drawing/2014/main" id="{3FAED758-A0C2-4EBA-A42C-BB1D0193EE4E}"/>
-              </a:ext>
-            </a:extLst>
-          </p:cNvPr>
-          <p:cNvSpPr>
-            <a:spLocks xmlns:a="http://schemas.openxmlformats.org/drawingml/2006/main" noGrp="1"/>
-          </p:cNvSpPr>
-          <p:nvPr/>
-        </p:nvSpPr>
-        <p:spPr>
-          <a:xfrm xmlns:a="http://schemas.openxmlformats.org/drawingml/2006/main">
-            <a:off x="8667750" y="457200"/>
-            <a:ext cx="2790825" cy="266700"/>
-          </a:xfrm>
-          <a:prstGeom xmlns:a="http://schemas.openxmlformats.org/drawingml/2006/main" prst="rect">
-            <a:avLst/>
-          </a:prstGeom>
-          <a:noFill xmlns:a="http://schemas.openxmlformats.org/drawingml/2006/main"/>
-          <a:ln xmlns:a="http://schemas.openxmlformats.org/drawingml/2006/main" w="0">
-            <a:noFill/>
-          </a:ln>
-        </p:spPr>
-        <p:txBody>
-          <a:bodyPr xmlns:a="http://schemas.openxmlformats.org/drawingml/2006/main" lIns="0" tIns="0" rIns="0" bIns="0"/>
-          <a:lstStyle xmlns:a="http://schemas.openxmlformats.org/drawingml/2006/main">
-            <a:defPPr>
-              <a:defRPr sz="1275" b="0">
-                <a:solidFill>
-                  <a:srgbClr val="465E78"/>
-                </a:solidFill>
-              </a:defRPr>
-            </a:defPPr>
-          </a:lstStyle>
-          <a:p xmlns:a="http://schemas.openxmlformats.org/drawingml/2006/main">
-            <a:pPr>
-              <a:buNone/>
-              <a:defRPr sz="1275" b="0">
-                <a:solidFill>
-                  <a:srgbClr val="465E78"/>
-                </a:solidFill>
-              </a:defRPr>
-            </a:pPr>
-            <a:r>
-              <a:rPr sz="1275" b="0">
-                <a:solidFill>
-                  <a:srgbClr val="465E78"/>
-                </a:solidFill>
-              </a:rPr>
-              <a:t>許家全 · 8:35–10:55</a:t>
             </a:r>
           </a:p>
         </p:txBody>
@@ -11340,64 +10992,6 @@
       </p:sp>
       <p:sp>
         <p:nvSpPr>
-          <p:cNvPr id="7" name="許家全 · 10:55–11:30">
-            <a:extLst xmlns:a="http://schemas.openxmlformats.org/drawingml/2006/main">
-              <a:ext uri="{FF2B5EF4-FFF2-40B4-BE49-F238E27FC236}">
-                <a16:creationId xmlns:a16="http://schemas.microsoft.com/office/drawing/2014/main" id="{ADC34263-8249-4F0D-8E5E-90DCF42FB234}"/>
-              </a:ext>
-            </a:extLst>
-          </p:cNvPr>
-          <p:cNvSpPr>
-            <a:spLocks xmlns:a="http://schemas.openxmlformats.org/drawingml/2006/main" noGrp="1"/>
-          </p:cNvSpPr>
-          <p:nvPr/>
-        </p:nvSpPr>
-        <p:spPr>
-          <a:xfrm xmlns:a="http://schemas.openxmlformats.org/drawingml/2006/main">
-            <a:off x="8667750" y="457200"/>
-            <a:ext cx="2790825" cy="266700"/>
-          </a:xfrm>
-          <a:prstGeom xmlns:a="http://schemas.openxmlformats.org/drawingml/2006/main" prst="rect">
-            <a:avLst/>
-          </a:prstGeom>
-          <a:noFill xmlns:a="http://schemas.openxmlformats.org/drawingml/2006/main"/>
-          <a:ln xmlns:a="http://schemas.openxmlformats.org/drawingml/2006/main" w="0">
-            <a:noFill/>
-          </a:ln>
-        </p:spPr>
-        <p:txBody>
-          <a:bodyPr xmlns:a="http://schemas.openxmlformats.org/drawingml/2006/main" lIns="0" tIns="0" rIns="0" bIns="0"/>
-          <a:lstStyle xmlns:a="http://schemas.openxmlformats.org/drawingml/2006/main">
-            <a:defPPr>
-              <a:defRPr sz="1275" b="0">
-                <a:solidFill>
-                  <a:srgbClr val="465E78"/>
-                </a:solidFill>
-              </a:defRPr>
-            </a:defPPr>
-          </a:lstStyle>
-          <a:p xmlns:a="http://schemas.openxmlformats.org/drawingml/2006/main">
-            <a:pPr>
-              <a:buNone/>
-              <a:defRPr sz="1275" b="0">
-                <a:solidFill>
-                  <a:srgbClr val="465E78"/>
-                </a:solidFill>
-              </a:defRPr>
-            </a:pPr>
-            <a:r>
-              <a:rPr sz="1275" b="0">
-                <a:solidFill>
-                  <a:srgbClr val="465E78"/>
-                </a:solidFill>
-              </a:rPr>
-              <a:t>許家全 · 10:55–11:30</a:t>
-            </a:r>
-          </a:p>
-        </p:txBody>
-      </p:sp>
-      <p:sp>
-        <p:nvSpPr>
           <p:cNvPr id="8" name="16">
             <a:extLst xmlns:a="http://schemas.openxmlformats.org/drawingml/2006/main">
               <a:ext uri="{FF2B5EF4-FFF2-40B4-BE49-F238E27FC236}">
@@ -13636,64 +13230,6 @@
               <a:t>GitHub：7–10 月 146 次提交（截至 10/12，皆已推送）；非逐人貢獻比例。</a:t>
             </a:r>
             <a:endParaRPr sz="1400"/>
-          </a:p>
-        </p:txBody>
-      </p:sp>
-      <p:sp>
-        <p:nvSpPr>
-          <p:cNvPr id="54" name="陳威帆 · 11:30–12:15">
-            <a:extLst xmlns:a="http://schemas.openxmlformats.org/drawingml/2006/main">
-              <a:ext uri="{FF2B5EF4-FFF2-40B4-BE49-F238E27FC236}">
-                <a16:creationId xmlns:a16="http://schemas.microsoft.com/office/drawing/2014/main" id="{CB8A64D2-E498-4020-B1A2-49E6B8E7474F}"/>
-              </a:ext>
-            </a:extLst>
-          </p:cNvPr>
-          <p:cNvSpPr>
-            <a:spLocks xmlns:a="http://schemas.openxmlformats.org/drawingml/2006/main" noGrp="1"/>
-          </p:cNvSpPr>
-          <p:nvPr/>
-        </p:nvSpPr>
-        <p:spPr>
-          <a:xfrm xmlns:a="http://schemas.openxmlformats.org/drawingml/2006/main">
-            <a:off x="8667750" y="457200"/>
-            <a:ext cx="2790825" cy="266700"/>
-          </a:xfrm>
-          <a:prstGeom xmlns:a="http://schemas.openxmlformats.org/drawingml/2006/main" prst="rect">
-            <a:avLst/>
-          </a:prstGeom>
-          <a:noFill xmlns:a="http://schemas.openxmlformats.org/drawingml/2006/main"/>
-          <a:ln xmlns:a="http://schemas.openxmlformats.org/drawingml/2006/main" w="0">
-            <a:noFill/>
-          </a:ln>
-        </p:spPr>
-        <p:txBody>
-          <a:bodyPr xmlns:a="http://schemas.openxmlformats.org/drawingml/2006/main" lIns="0" tIns="0" rIns="0" bIns="0"/>
-          <a:lstStyle xmlns:a="http://schemas.openxmlformats.org/drawingml/2006/main">
-            <a:defPPr>
-              <a:defRPr sz="1275" b="0">
-                <a:solidFill>
-                  <a:srgbClr val="465E78"/>
-                </a:solidFill>
-              </a:defRPr>
-            </a:defPPr>
-          </a:lstStyle>
-          <a:p xmlns:a="http://schemas.openxmlformats.org/drawingml/2006/main">
-            <a:pPr>
-              <a:buNone/>
-              <a:defRPr sz="1275" b="0">
-                <a:solidFill>
-                  <a:srgbClr val="465E78"/>
-                </a:solidFill>
-              </a:defRPr>
-            </a:pPr>
-            <a:r>
-              <a:rPr sz="1275" b="0">
-                <a:solidFill>
-                  <a:srgbClr val="465E78"/>
-                </a:solidFill>
-              </a:rPr>
-              <a:t>陳威帆 · 11:30–12:15</a:t>
-            </a:r>
           </a:p>
         </p:txBody>
       </p:sp>
@@ -14553,64 +14089,6 @@
       </p:sp>
       <p:sp>
         <p:nvSpPr>
-          <p:cNvPr id="20" name="陳威帆 · 12:15–12:45">
-            <a:extLst xmlns:a="http://schemas.openxmlformats.org/drawingml/2006/main">
-              <a:ext uri="{FF2B5EF4-FFF2-40B4-BE49-F238E27FC236}">
-                <a16:creationId xmlns:a16="http://schemas.microsoft.com/office/drawing/2014/main" id="{D2AEDEB7-F2B9-4051-8EE1-9EAEFFA5EF28}"/>
-              </a:ext>
-            </a:extLst>
-          </p:cNvPr>
-          <p:cNvSpPr>
-            <a:spLocks xmlns:a="http://schemas.openxmlformats.org/drawingml/2006/main" noGrp="1"/>
-          </p:cNvSpPr>
-          <p:nvPr/>
-        </p:nvSpPr>
-        <p:spPr>
-          <a:xfrm xmlns:a="http://schemas.openxmlformats.org/drawingml/2006/main">
-            <a:off x="8667750" y="457200"/>
-            <a:ext cx="2790825" cy="266700"/>
-          </a:xfrm>
-          <a:prstGeom xmlns:a="http://schemas.openxmlformats.org/drawingml/2006/main" prst="rect">
-            <a:avLst/>
-          </a:prstGeom>
-          <a:noFill xmlns:a="http://schemas.openxmlformats.org/drawingml/2006/main"/>
-          <a:ln xmlns:a="http://schemas.openxmlformats.org/drawingml/2006/main" w="0">
-            <a:noFill/>
-          </a:ln>
-        </p:spPr>
-        <p:txBody>
-          <a:bodyPr xmlns:a="http://schemas.openxmlformats.org/drawingml/2006/main" lIns="0" tIns="0" rIns="0" bIns="0"/>
-          <a:lstStyle xmlns:a="http://schemas.openxmlformats.org/drawingml/2006/main">
-            <a:defPPr>
-              <a:defRPr sz="1275" b="0">
-                <a:solidFill>
-                  <a:srgbClr val="465E78"/>
-                </a:solidFill>
-              </a:defRPr>
-            </a:defPPr>
-          </a:lstStyle>
-          <a:p xmlns:a="http://schemas.openxmlformats.org/drawingml/2006/main">
-            <a:pPr>
-              <a:buNone/>
-              <a:defRPr sz="1275" b="0">
-                <a:solidFill>
-                  <a:srgbClr val="465E78"/>
-                </a:solidFill>
-              </a:defRPr>
-            </a:pPr>
-            <a:r>
-              <a:rPr sz="1275" b="0">
-                <a:solidFill>
-                  <a:srgbClr val="465E78"/>
-                </a:solidFill>
-              </a:rPr>
-              <a:t>陳威帆 · 12:15–12:45</a:t>
-            </a:r>
-          </a:p>
-        </p:txBody>
-      </p:sp>
-      <p:sp>
-        <p:nvSpPr>
           <p:cNvPr id="21" name="18">
             <a:extLst xmlns:a="http://schemas.openxmlformats.org/drawingml/2006/main">
               <a:ext uri="{FF2B5EF4-FFF2-40B4-BE49-F238E27FC236}">
@@ -15672,64 +15150,6 @@
       </p:sp>
       <p:sp>
         <p:nvSpPr>
-          <p:cNvPr id="23" name="陳威帆 · 12:45–14:30">
-            <a:extLst xmlns:a="http://schemas.openxmlformats.org/drawingml/2006/main">
-              <a:ext uri="{FF2B5EF4-FFF2-40B4-BE49-F238E27FC236}">
-                <a16:creationId xmlns:a16="http://schemas.microsoft.com/office/drawing/2014/main" id="{E7AAF622-5A08-4036-802C-FF55E4684AD2}"/>
-              </a:ext>
-            </a:extLst>
-          </p:cNvPr>
-          <p:cNvSpPr>
-            <a:spLocks xmlns:a="http://schemas.openxmlformats.org/drawingml/2006/main" noGrp="1"/>
-          </p:cNvSpPr>
-          <p:nvPr/>
-        </p:nvSpPr>
-        <p:spPr>
-          <a:xfrm xmlns:a="http://schemas.openxmlformats.org/drawingml/2006/main">
-            <a:off x="8667750" y="457200"/>
-            <a:ext cx="2790825" cy="266700"/>
-          </a:xfrm>
-          <a:prstGeom xmlns:a="http://schemas.openxmlformats.org/drawingml/2006/main" prst="rect">
-            <a:avLst/>
-          </a:prstGeom>
-          <a:noFill xmlns:a="http://schemas.openxmlformats.org/drawingml/2006/main"/>
-          <a:ln xmlns:a="http://schemas.openxmlformats.org/drawingml/2006/main" w="0">
-            <a:noFill/>
-          </a:ln>
-        </p:spPr>
-        <p:txBody>
-          <a:bodyPr xmlns:a="http://schemas.openxmlformats.org/drawingml/2006/main" lIns="0" tIns="0" rIns="0" bIns="0"/>
-          <a:lstStyle xmlns:a="http://schemas.openxmlformats.org/drawingml/2006/main">
-            <a:defPPr>
-              <a:defRPr sz="1275" b="0">
-                <a:solidFill>
-                  <a:srgbClr val="465E78"/>
-                </a:solidFill>
-              </a:defRPr>
-            </a:defPPr>
-          </a:lstStyle>
-          <a:p xmlns:a="http://schemas.openxmlformats.org/drawingml/2006/main">
-            <a:pPr>
-              <a:buNone/>
-              <a:defRPr sz="1275" b="0">
-                <a:solidFill>
-                  <a:srgbClr val="465E78"/>
-                </a:solidFill>
-              </a:defRPr>
-            </a:pPr>
-            <a:r>
-              <a:rPr sz="1275" b="0">
-                <a:solidFill>
-                  <a:srgbClr val="465E78"/>
-                </a:solidFill>
-              </a:rPr>
-              <a:t>陳威帆 · 12:45–14:30</a:t>
-            </a:r>
-          </a:p>
-        </p:txBody>
-      </p:sp>
-      <p:sp>
-        <p:nvSpPr>
           <p:cNvPr id="24" name="19">
             <a:extLst xmlns:a="http://schemas.openxmlformats.org/drawingml/2006/main">
               <a:ext uri="{FF2B5EF4-FFF2-40B4-BE49-F238E27FC236}">
@@ -15855,7 +15275,7 @@
                 <a:ea typeface="Microsoft JhengHei"/>
                 <a:cs typeface="Microsoft JhengHei"/>
               </a:rPr>
-              <a:t>14 分 30 秒主講，保留 30 秒緩衝</a:t>
+              <a:t>報告流程</a:t>
             </a:r>
             <a:endParaRPr sz="3000"/>
           </a:p>
@@ -16142,52 +15562,6 @@
       </p:sp>
       <p:sp>
         <p:nvSpPr>
-          <p:cNvPr id="12" name="Text 10">
-            <a:extLst xmlns:a="http://schemas.openxmlformats.org/drawingml/2006/main">
-              <a:ext uri="{FF2B5EF4-FFF2-40B4-BE49-F238E27FC236}">
-                <a16:creationId xmlns:a16="http://schemas.microsoft.com/office/drawing/2014/main" id="{A4337ECD-DA45-4041-86CE-5B52C9456FBC}"/>
-              </a:ext>
-            </a:extLst>
-          </p:cNvPr>
-          <p:cNvSpPr>
-            <a:spLocks xmlns:a="http://schemas.openxmlformats.org/drawingml/2006/main" noGrp="1"/>
-          </p:cNvSpPr>
-          <p:nvPr/>
-        </p:nvSpPr>
-        <p:spPr>
-          <a:xfrm xmlns:a="http://schemas.openxmlformats.org/drawingml/2006/main">
-            <a:off x="731520" y="4937760"/>
-            <a:ext cx="2523744" cy="274320"/>
-          </a:xfrm>
-          <a:prstGeom xmlns:a="http://schemas.openxmlformats.org/drawingml/2006/main" prst="rect">
-            <a:avLst/>
-          </a:prstGeom>
-          <a:noFill xmlns:a="http://schemas.openxmlformats.org/drawingml/2006/main"/>
-        </p:spPr>
-        <p:txBody>
-          <a:bodyPr xmlns:a="http://schemas.openxmlformats.org/drawingml/2006/main" wrap="square" lIns="0" tIns="0" rIns="0" bIns="0" anchor="ctr"/>
-          <a:lstStyle xmlns:a="http://schemas.openxmlformats.org/drawingml/2006/main"/>
-          <a:p xmlns:a="http://schemas.openxmlformats.org/drawingml/2006/main">
-            <a:pPr marL="0" indent="0" algn="ctr">
-              <a:buNone/>
-            </a:pPr>
-            <a:r>
-              <a:rPr sz="1200">
-                <a:solidFill>
-                  <a:srgbClr val="7A8CA3"/>
-                </a:solidFill>
-                <a:latin typeface="Microsoft JhengHei"/>
-                <a:ea typeface="Microsoft JhengHei"/>
-                <a:cs typeface="Microsoft JhengHei"/>
-              </a:rPr>
-              <a:t>0:35–4:25</a:t>
-            </a:r>
-            <a:endParaRPr sz="1200"/>
-          </a:p>
-        </p:txBody>
-      </p:sp>
-      <p:sp>
-        <p:nvSpPr>
           <p:cNvPr id="13" name="Shape 11">
             <a:extLst xmlns:a="http://schemas.openxmlformats.org/drawingml/2006/main">
               <a:ext uri="{FF2B5EF4-FFF2-40B4-BE49-F238E27FC236}">
@@ -16467,52 +15841,6 @@
       </p:sp>
       <p:sp>
         <p:nvSpPr>
-          <p:cNvPr id="19" name="Text 17">
-            <a:extLst xmlns:a="http://schemas.openxmlformats.org/drawingml/2006/main">
-              <a:ext uri="{FF2B5EF4-FFF2-40B4-BE49-F238E27FC236}">
-                <a16:creationId xmlns:a16="http://schemas.microsoft.com/office/drawing/2014/main" id="{A5CB081B-9640-426B-B589-1CA1FDE16795}"/>
-              </a:ext>
-            </a:extLst>
-          </p:cNvPr>
-          <p:cNvSpPr>
-            <a:spLocks xmlns:a="http://schemas.openxmlformats.org/drawingml/2006/main" noGrp="1"/>
-          </p:cNvSpPr>
-          <p:nvPr/>
-        </p:nvSpPr>
-        <p:spPr>
-          <a:xfrm xmlns:a="http://schemas.openxmlformats.org/drawingml/2006/main">
-            <a:off x="3465576" y="4937760"/>
-            <a:ext cx="2523744" cy="274320"/>
-          </a:xfrm>
-          <a:prstGeom xmlns:a="http://schemas.openxmlformats.org/drawingml/2006/main" prst="rect">
-            <a:avLst/>
-          </a:prstGeom>
-          <a:noFill xmlns:a="http://schemas.openxmlformats.org/drawingml/2006/main"/>
-        </p:spPr>
-        <p:txBody>
-          <a:bodyPr xmlns:a="http://schemas.openxmlformats.org/drawingml/2006/main" wrap="square" lIns="0" tIns="0" rIns="0" bIns="0" anchor="ctr"/>
-          <a:lstStyle xmlns:a="http://schemas.openxmlformats.org/drawingml/2006/main"/>
-          <a:p xmlns:a="http://schemas.openxmlformats.org/drawingml/2006/main">
-            <a:pPr marL="0" indent="0" algn="ctr">
-              <a:buNone/>
-            </a:pPr>
-            <a:r>
-              <a:rPr sz="1200">
-                <a:solidFill>
-                  <a:srgbClr val="7A8CA3"/>
-                </a:solidFill>
-                <a:latin typeface="Microsoft JhengHei"/>
-                <a:ea typeface="Microsoft JhengHei"/>
-                <a:cs typeface="Microsoft JhengHei"/>
-              </a:rPr>
-              <a:t>4:25–7:20</a:t>
-            </a:r>
-            <a:endParaRPr sz="1200"/>
-          </a:p>
-        </p:txBody>
-      </p:sp>
-      <p:sp>
-        <p:nvSpPr>
           <p:cNvPr id="20" name="Shape 18">
             <a:extLst xmlns:a="http://schemas.openxmlformats.org/drawingml/2006/main">
               <a:ext uri="{FF2B5EF4-FFF2-40B4-BE49-F238E27FC236}">
@@ -16792,52 +16120,6 @@
       </p:sp>
       <p:sp>
         <p:nvSpPr>
-          <p:cNvPr id="26" name="Text 24">
-            <a:extLst xmlns:a="http://schemas.openxmlformats.org/drawingml/2006/main">
-              <a:ext uri="{FF2B5EF4-FFF2-40B4-BE49-F238E27FC236}">
-                <a16:creationId xmlns:a16="http://schemas.microsoft.com/office/drawing/2014/main" id="{31707E0E-4583-4848-9066-6812488A681D}"/>
-              </a:ext>
-            </a:extLst>
-          </p:cNvPr>
-          <p:cNvSpPr>
-            <a:spLocks xmlns:a="http://schemas.openxmlformats.org/drawingml/2006/main" noGrp="1"/>
-          </p:cNvSpPr>
-          <p:nvPr/>
-        </p:nvSpPr>
-        <p:spPr>
-          <a:xfrm xmlns:a="http://schemas.openxmlformats.org/drawingml/2006/main">
-            <a:off x="6199632" y="4937760"/>
-            <a:ext cx="2523744" cy="274320"/>
-          </a:xfrm>
-          <a:prstGeom xmlns:a="http://schemas.openxmlformats.org/drawingml/2006/main" prst="rect">
-            <a:avLst/>
-          </a:prstGeom>
-          <a:noFill xmlns:a="http://schemas.openxmlformats.org/drawingml/2006/main"/>
-        </p:spPr>
-        <p:txBody>
-          <a:bodyPr xmlns:a="http://schemas.openxmlformats.org/drawingml/2006/main" wrap="square" lIns="0" tIns="0" rIns="0" bIns="0" anchor="ctr"/>
-          <a:lstStyle xmlns:a="http://schemas.openxmlformats.org/drawingml/2006/main"/>
-          <a:p xmlns:a="http://schemas.openxmlformats.org/drawingml/2006/main">
-            <a:pPr marL="0" indent="0" algn="ctr">
-              <a:buNone/>
-            </a:pPr>
-            <a:r>
-              <a:rPr sz="1200">
-                <a:solidFill>
-                  <a:srgbClr val="7A8CA3"/>
-                </a:solidFill>
-                <a:latin typeface="Microsoft JhengHei"/>
-                <a:ea typeface="Microsoft JhengHei"/>
-                <a:cs typeface="Microsoft JhengHei"/>
-              </a:rPr>
-              <a:t>7:20–11:30</a:t>
-            </a:r>
-            <a:endParaRPr sz="1200"/>
-          </a:p>
-        </p:txBody>
-      </p:sp>
-      <p:sp>
-        <p:nvSpPr>
           <p:cNvPr id="27" name="Shape 25">
             <a:extLst xmlns:a="http://schemas.openxmlformats.org/drawingml/2006/main">
               <a:ext uri="{FF2B5EF4-FFF2-40B4-BE49-F238E27FC236}">
@@ -17117,52 +16399,6 @@
       </p:sp>
       <p:sp>
         <p:nvSpPr>
-          <p:cNvPr id="33" name="Text 31">
-            <a:extLst xmlns:a="http://schemas.openxmlformats.org/drawingml/2006/main">
-              <a:ext uri="{FF2B5EF4-FFF2-40B4-BE49-F238E27FC236}">
-                <a16:creationId xmlns:a16="http://schemas.microsoft.com/office/drawing/2014/main" id="{FFCA79A7-477B-467C-A67D-655C618F8EFF}"/>
-              </a:ext>
-            </a:extLst>
-          </p:cNvPr>
-          <p:cNvSpPr>
-            <a:spLocks xmlns:a="http://schemas.openxmlformats.org/drawingml/2006/main" noGrp="1"/>
-          </p:cNvSpPr>
-          <p:nvPr/>
-        </p:nvSpPr>
-        <p:spPr>
-          <a:xfrm xmlns:a="http://schemas.openxmlformats.org/drawingml/2006/main">
-            <a:off x="8933688" y="4937760"/>
-            <a:ext cx="2523744" cy="274320"/>
-          </a:xfrm>
-          <a:prstGeom xmlns:a="http://schemas.openxmlformats.org/drawingml/2006/main" prst="rect">
-            <a:avLst/>
-          </a:prstGeom>
-          <a:noFill xmlns:a="http://schemas.openxmlformats.org/drawingml/2006/main"/>
-        </p:spPr>
-        <p:txBody>
-          <a:bodyPr xmlns:a="http://schemas.openxmlformats.org/drawingml/2006/main" wrap="square" lIns="0" tIns="0" rIns="0" bIns="0" anchor="ctr"/>
-          <a:lstStyle xmlns:a="http://schemas.openxmlformats.org/drawingml/2006/main"/>
-          <a:p xmlns:a="http://schemas.openxmlformats.org/drawingml/2006/main">
-            <a:pPr marL="0" indent="0" algn="ctr">
-              <a:buNone/>
-            </a:pPr>
-            <a:r>
-              <a:rPr sz="1200">
-                <a:solidFill>
-                  <a:srgbClr val="7A8CA3"/>
-                </a:solidFill>
-                <a:latin typeface="Microsoft JhengHei"/>
-                <a:ea typeface="Microsoft JhengHei"/>
-                <a:cs typeface="Microsoft JhengHei"/>
-              </a:rPr>
-              <a:t>11:30–14:30</a:t>
-            </a:r>
-            <a:endParaRPr sz="1200"/>
-          </a:p>
-        </p:txBody>
-      </p:sp>
-      <p:sp>
-        <p:nvSpPr>
           <p:cNvPr id="34" name="Shape 32">
             <a:extLst xmlns:a="http://schemas.openxmlformats.org/drawingml/2006/main">
               <a:ext uri="{FF2B5EF4-FFF2-40B4-BE49-F238E27FC236}">
@@ -17243,64 +16479,6 @@
               <a:t>16 項初評意見與回應頁碼，逐條對照於附錄 A、B</a:t>
             </a:r>
             <a:endParaRPr sz="1400"/>
-          </a:p>
-        </p:txBody>
-      </p:sp>
-      <p:sp>
-        <p:nvSpPr>
-          <p:cNvPr id="36" name="陳威帆 · 0:20–0:35">
-            <a:extLst xmlns:a="http://schemas.openxmlformats.org/drawingml/2006/main">
-              <a:ext uri="{FF2B5EF4-FFF2-40B4-BE49-F238E27FC236}">
-                <a16:creationId xmlns:a16="http://schemas.microsoft.com/office/drawing/2014/main" id="{A7B5A32B-B239-4E44-AC24-585C9C8A01EA}"/>
-              </a:ext>
-            </a:extLst>
-          </p:cNvPr>
-          <p:cNvSpPr>
-            <a:spLocks xmlns:a="http://schemas.openxmlformats.org/drawingml/2006/main" noGrp="1"/>
-          </p:cNvSpPr>
-          <p:nvPr/>
-        </p:nvSpPr>
-        <p:spPr>
-          <a:xfrm xmlns:a="http://schemas.openxmlformats.org/drawingml/2006/main">
-            <a:off x="8667750" y="457200"/>
-            <a:ext cx="2790825" cy="266700"/>
-          </a:xfrm>
-          <a:prstGeom xmlns:a="http://schemas.openxmlformats.org/drawingml/2006/main" prst="rect">
-            <a:avLst/>
-          </a:prstGeom>
-          <a:noFill xmlns:a="http://schemas.openxmlformats.org/drawingml/2006/main"/>
-          <a:ln xmlns:a="http://schemas.openxmlformats.org/drawingml/2006/main" w="0">
-            <a:noFill/>
-          </a:ln>
-        </p:spPr>
-        <p:txBody>
-          <a:bodyPr xmlns:a="http://schemas.openxmlformats.org/drawingml/2006/main" lIns="0" tIns="0" rIns="0" bIns="0"/>
-          <a:lstStyle xmlns:a="http://schemas.openxmlformats.org/drawingml/2006/main">
-            <a:defPPr>
-              <a:defRPr sz="1275" b="0">
-                <a:solidFill>
-                  <a:srgbClr val="465E78"/>
-                </a:solidFill>
-              </a:defRPr>
-            </a:defPPr>
-          </a:lstStyle>
-          <a:p xmlns:a="http://schemas.openxmlformats.org/drawingml/2006/main">
-            <a:pPr>
-              <a:buNone/>
-              <a:defRPr sz="1275" b="0">
-                <a:solidFill>
-                  <a:srgbClr val="465E78"/>
-                </a:solidFill>
-              </a:defRPr>
-            </a:pPr>
-            <a:r>
-              <a:rPr sz="1275" b="0">
-                <a:solidFill>
-                  <a:srgbClr val="465E78"/>
-                </a:solidFill>
-              </a:rPr>
-              <a:t>陳威帆 · 0:20–0:35</a:t>
-            </a:r>
           </a:p>
         </p:txBody>
       </p:sp>
@@ -23377,64 +22555,6 @@
       </p:sp>
       <p:sp>
         <p:nvSpPr>
-          <p:cNvPr id="34" name="陳威帆 · 0:35–1:15">
-            <a:extLst xmlns:a="http://schemas.openxmlformats.org/drawingml/2006/main">
-              <a:ext uri="{FF2B5EF4-FFF2-40B4-BE49-F238E27FC236}">
-                <a16:creationId xmlns:a16="http://schemas.microsoft.com/office/drawing/2014/main" id="{34BD9E31-64E3-4CAB-A968-734B96A5BD63}"/>
-              </a:ext>
-            </a:extLst>
-          </p:cNvPr>
-          <p:cNvSpPr>
-            <a:spLocks xmlns:a="http://schemas.openxmlformats.org/drawingml/2006/main" noGrp="1"/>
-          </p:cNvSpPr>
-          <p:nvPr/>
-        </p:nvSpPr>
-        <p:spPr>
-          <a:xfrm xmlns:a="http://schemas.openxmlformats.org/drawingml/2006/main">
-            <a:off x="8667750" y="457200"/>
-            <a:ext cx="2790825" cy="266700"/>
-          </a:xfrm>
-          <a:prstGeom xmlns:a="http://schemas.openxmlformats.org/drawingml/2006/main" prst="rect">
-            <a:avLst/>
-          </a:prstGeom>
-          <a:noFill xmlns:a="http://schemas.openxmlformats.org/drawingml/2006/main"/>
-          <a:ln xmlns:a="http://schemas.openxmlformats.org/drawingml/2006/main" w="0">
-            <a:noFill/>
-          </a:ln>
-        </p:spPr>
-        <p:txBody>
-          <a:bodyPr xmlns:a="http://schemas.openxmlformats.org/drawingml/2006/main" lIns="0" tIns="0" rIns="0" bIns="0"/>
-          <a:lstStyle xmlns:a="http://schemas.openxmlformats.org/drawingml/2006/main">
-            <a:defPPr>
-              <a:defRPr sz="1275" b="0">
-                <a:solidFill>
-                  <a:srgbClr val="465E78"/>
-                </a:solidFill>
-              </a:defRPr>
-            </a:defPPr>
-          </a:lstStyle>
-          <a:p xmlns:a="http://schemas.openxmlformats.org/drawingml/2006/main">
-            <a:pPr>
-              <a:buNone/>
-              <a:defRPr sz="1275" b="0">
-                <a:solidFill>
-                  <a:srgbClr val="465E78"/>
-                </a:solidFill>
-              </a:defRPr>
-            </a:pPr>
-            <a:r>
-              <a:rPr sz="1275" b="0">
-                <a:solidFill>
-                  <a:srgbClr val="465E78"/>
-                </a:solidFill>
-              </a:rPr>
-              <a:t>陳威帆 · 0:35–1:15</a:t>
-            </a:r>
-          </a:p>
-        </p:txBody>
-      </p:sp>
-      <p:sp>
-        <p:nvSpPr>
           <p:cNvPr id="35" name="03">
             <a:extLst xmlns:a="http://schemas.openxmlformats.org/drawingml/2006/main">
               <a:ext uri="{FF2B5EF4-FFF2-40B4-BE49-F238E27FC236}">
@@ -24258,64 +23378,6 @@
       </p:sp>
       <p:sp>
         <p:nvSpPr>
-          <p:cNvPr id="6" name="陳威帆 · 1:15–1:50">
-            <a:extLst xmlns:a="http://schemas.openxmlformats.org/drawingml/2006/main">
-              <a:ext uri="{FF2B5EF4-FFF2-40B4-BE49-F238E27FC236}">
-                <a16:creationId xmlns:a16="http://schemas.microsoft.com/office/drawing/2014/main" id="{11F455A9-78D6-42C9-91DB-A24956B1CB3E}"/>
-              </a:ext>
-            </a:extLst>
-          </p:cNvPr>
-          <p:cNvSpPr>
-            <a:spLocks xmlns:a="http://schemas.openxmlformats.org/drawingml/2006/main" noGrp="1"/>
-          </p:cNvSpPr>
-          <p:nvPr/>
-        </p:nvSpPr>
-        <p:spPr>
-          <a:xfrm xmlns:a="http://schemas.openxmlformats.org/drawingml/2006/main">
-            <a:off x="8667750" y="457200"/>
-            <a:ext cx="2790825" cy="266700"/>
-          </a:xfrm>
-          <a:prstGeom xmlns:a="http://schemas.openxmlformats.org/drawingml/2006/main" prst="rect">
-            <a:avLst/>
-          </a:prstGeom>
-          <a:noFill xmlns:a="http://schemas.openxmlformats.org/drawingml/2006/main"/>
-          <a:ln xmlns:a="http://schemas.openxmlformats.org/drawingml/2006/main" w="0">
-            <a:noFill/>
-          </a:ln>
-        </p:spPr>
-        <p:txBody>
-          <a:bodyPr xmlns:a="http://schemas.openxmlformats.org/drawingml/2006/main" lIns="0" tIns="0" rIns="0" bIns="0"/>
-          <a:lstStyle xmlns:a="http://schemas.openxmlformats.org/drawingml/2006/main">
-            <a:defPPr>
-              <a:defRPr sz="1275" b="0">
-                <a:solidFill>
-                  <a:srgbClr val="465E78"/>
-                </a:solidFill>
-              </a:defRPr>
-            </a:defPPr>
-          </a:lstStyle>
-          <a:p xmlns:a="http://schemas.openxmlformats.org/drawingml/2006/main">
-            <a:pPr>
-              <a:buNone/>
-              <a:defRPr sz="1275" b="0">
-                <a:solidFill>
-                  <a:srgbClr val="465E78"/>
-                </a:solidFill>
-              </a:defRPr>
-            </a:pPr>
-            <a:r>
-              <a:rPr sz="1275" b="0">
-                <a:solidFill>
-                  <a:srgbClr val="465E78"/>
-                </a:solidFill>
-              </a:rPr>
-              <a:t>陳威帆 · 1:15–1:50</a:t>
-            </a:r>
-          </a:p>
-        </p:txBody>
-      </p:sp>
-      <p:sp>
-        <p:nvSpPr>
           <p:cNvPr id="7" name="04">
             <a:extLst xmlns:a="http://schemas.openxmlformats.org/drawingml/2006/main">
               <a:ext uri="{FF2B5EF4-FFF2-40B4-BE49-F238E27FC236}">
@@ -25925,64 +24987,6 @@
       </p:sp>
       <p:sp>
         <p:nvSpPr>
-          <p:cNvPr id="42" name="陳威帆 · 1:50–2:30">
-            <a:extLst xmlns:a="http://schemas.openxmlformats.org/drawingml/2006/main">
-              <a:ext uri="{FF2B5EF4-FFF2-40B4-BE49-F238E27FC236}">
-                <a16:creationId xmlns:a16="http://schemas.microsoft.com/office/drawing/2014/main" id="{1239E67C-7E93-40E5-97FD-9F90C84DC5A8}"/>
-              </a:ext>
-            </a:extLst>
-          </p:cNvPr>
-          <p:cNvSpPr>
-            <a:spLocks xmlns:a="http://schemas.openxmlformats.org/drawingml/2006/main" noGrp="1"/>
-          </p:cNvSpPr>
-          <p:nvPr/>
-        </p:nvSpPr>
-        <p:spPr>
-          <a:xfrm xmlns:a="http://schemas.openxmlformats.org/drawingml/2006/main">
-            <a:off x="8667750" y="457200"/>
-            <a:ext cx="2790825" cy="266700"/>
-          </a:xfrm>
-          <a:prstGeom xmlns:a="http://schemas.openxmlformats.org/drawingml/2006/main" prst="rect">
-            <a:avLst/>
-          </a:prstGeom>
-          <a:noFill xmlns:a="http://schemas.openxmlformats.org/drawingml/2006/main"/>
-          <a:ln xmlns:a="http://schemas.openxmlformats.org/drawingml/2006/main" w="0">
-            <a:noFill/>
-          </a:ln>
-        </p:spPr>
-        <p:txBody>
-          <a:bodyPr xmlns:a="http://schemas.openxmlformats.org/drawingml/2006/main" lIns="0" tIns="0" rIns="0" bIns="0"/>
-          <a:lstStyle xmlns:a="http://schemas.openxmlformats.org/drawingml/2006/main">
-            <a:defPPr>
-              <a:defRPr sz="1275" b="0">
-                <a:solidFill>
-                  <a:srgbClr val="465E78"/>
-                </a:solidFill>
-              </a:defRPr>
-            </a:defPPr>
-          </a:lstStyle>
-          <a:p xmlns:a="http://schemas.openxmlformats.org/drawingml/2006/main">
-            <a:pPr>
-              <a:buNone/>
-              <a:defRPr sz="1275" b="0">
-                <a:solidFill>
-                  <a:srgbClr val="465E78"/>
-                </a:solidFill>
-              </a:defRPr>
-            </a:pPr>
-            <a:r>
-              <a:rPr sz="1275" b="0">
-                <a:solidFill>
-                  <a:srgbClr val="465E78"/>
-                </a:solidFill>
-              </a:rPr>
-              <a:t>陳威帆 · 1:50–2:30</a:t>
-            </a:r>
-          </a:p>
-        </p:txBody>
-      </p:sp>
-      <p:sp>
-        <p:nvSpPr>
           <p:cNvPr id="43" name="05">
             <a:extLst xmlns:a="http://schemas.openxmlformats.org/drawingml/2006/main">
               <a:ext uri="{FF2B5EF4-FFF2-40B4-BE49-F238E27FC236}">
@@ -27532,64 +26536,6 @@
       </p:sp>
       <p:sp>
         <p:nvSpPr>
-          <p:cNvPr id="35" name="陳威帆 · 2:30–3:05">
-            <a:extLst xmlns:a="http://schemas.openxmlformats.org/drawingml/2006/main">
-              <a:ext uri="{FF2B5EF4-FFF2-40B4-BE49-F238E27FC236}">
-                <a16:creationId xmlns:a16="http://schemas.microsoft.com/office/drawing/2014/main" id="{BC982EA8-545D-477C-8DB7-CB5D129DE4EB}"/>
-              </a:ext>
-            </a:extLst>
-          </p:cNvPr>
-          <p:cNvSpPr>
-            <a:spLocks xmlns:a="http://schemas.openxmlformats.org/drawingml/2006/main" noGrp="1"/>
-          </p:cNvSpPr>
-          <p:nvPr/>
-        </p:nvSpPr>
-        <p:spPr>
-          <a:xfrm xmlns:a="http://schemas.openxmlformats.org/drawingml/2006/main">
-            <a:off x="8667750" y="457200"/>
-            <a:ext cx="2790825" cy="266700"/>
-          </a:xfrm>
-          <a:prstGeom xmlns:a="http://schemas.openxmlformats.org/drawingml/2006/main" prst="rect">
-            <a:avLst/>
-          </a:prstGeom>
-          <a:noFill xmlns:a="http://schemas.openxmlformats.org/drawingml/2006/main"/>
-          <a:ln xmlns:a="http://schemas.openxmlformats.org/drawingml/2006/main" w="0">
-            <a:noFill/>
-          </a:ln>
-        </p:spPr>
-        <p:txBody>
-          <a:bodyPr xmlns:a="http://schemas.openxmlformats.org/drawingml/2006/main" lIns="0" tIns="0" rIns="0" bIns="0"/>
-          <a:lstStyle xmlns:a="http://schemas.openxmlformats.org/drawingml/2006/main">
-            <a:defPPr>
-              <a:defRPr sz="1275" b="0">
-                <a:solidFill>
-                  <a:srgbClr val="465E78"/>
-                </a:solidFill>
-              </a:defRPr>
-            </a:defPPr>
-          </a:lstStyle>
-          <a:p xmlns:a="http://schemas.openxmlformats.org/drawingml/2006/main">
-            <a:pPr>
-              <a:buNone/>
-              <a:defRPr sz="1275" b="0">
-                <a:solidFill>
-                  <a:srgbClr val="465E78"/>
-                </a:solidFill>
-              </a:defRPr>
-            </a:pPr>
-            <a:r>
-              <a:rPr sz="1275" b="0">
-                <a:solidFill>
-                  <a:srgbClr val="465E78"/>
-                </a:solidFill>
-              </a:rPr>
-              <a:t>陳威帆 · 2:30–3:05</a:t>
-            </a:r>
-          </a:p>
-        </p:txBody>
-      </p:sp>
-      <p:sp>
-        <p:nvSpPr>
           <p:cNvPr id="36" name="06">
             <a:extLst xmlns:a="http://schemas.openxmlformats.org/drawingml/2006/main">
               <a:ext uri="{FF2B5EF4-FFF2-40B4-BE49-F238E27FC236}">
@@ -28642,64 +27588,6 @@
               <a:t>新臺幣／月；官方單價查於 10/12（1 USD≈32 元）；未含人力，見附錄 C、F。</a:t>
             </a:r>
             <a:endParaRPr sz="1400"/>
-          </a:p>
-        </p:txBody>
-      </p:sp>
-      <p:sp>
-        <p:nvSpPr>
-          <p:cNvPr id="28" name="陳威帆 · 3:05–3:50">
-            <a:extLst xmlns:a="http://schemas.openxmlformats.org/drawingml/2006/main">
-              <a:ext uri="{FF2B5EF4-FFF2-40B4-BE49-F238E27FC236}">
-                <a16:creationId xmlns:a16="http://schemas.microsoft.com/office/drawing/2014/main" id="{6B13CACB-5429-4B4E-8705-C61874EECB50}"/>
-              </a:ext>
-            </a:extLst>
-          </p:cNvPr>
-          <p:cNvSpPr>
-            <a:spLocks xmlns:a="http://schemas.openxmlformats.org/drawingml/2006/main" noGrp="1"/>
-          </p:cNvSpPr>
-          <p:nvPr/>
-        </p:nvSpPr>
-        <p:spPr>
-          <a:xfrm xmlns:a="http://schemas.openxmlformats.org/drawingml/2006/main">
-            <a:off x="8667750" y="457200"/>
-            <a:ext cx="2790825" cy="266700"/>
-          </a:xfrm>
-          <a:prstGeom xmlns:a="http://schemas.openxmlformats.org/drawingml/2006/main" prst="rect">
-            <a:avLst/>
-          </a:prstGeom>
-          <a:noFill xmlns:a="http://schemas.openxmlformats.org/drawingml/2006/main"/>
-          <a:ln xmlns:a="http://schemas.openxmlformats.org/drawingml/2006/main" w="0">
-            <a:noFill/>
-          </a:ln>
-        </p:spPr>
-        <p:txBody>
-          <a:bodyPr xmlns:a="http://schemas.openxmlformats.org/drawingml/2006/main" lIns="0" tIns="0" rIns="0" bIns="0"/>
-          <a:lstStyle xmlns:a="http://schemas.openxmlformats.org/drawingml/2006/main">
-            <a:defPPr>
-              <a:defRPr sz="1275" b="0">
-                <a:solidFill>
-                  <a:srgbClr val="465E78"/>
-                </a:solidFill>
-              </a:defRPr>
-            </a:defPPr>
-          </a:lstStyle>
-          <a:p xmlns:a="http://schemas.openxmlformats.org/drawingml/2006/main">
-            <a:pPr>
-              <a:buNone/>
-              <a:defRPr sz="1275" b="0">
-                <a:solidFill>
-                  <a:srgbClr val="465E78"/>
-                </a:solidFill>
-              </a:defRPr>
-            </a:pPr>
-            <a:r>
-              <a:rPr sz="1275" b="0">
-                <a:solidFill>
-                  <a:srgbClr val="465E78"/>
-                </a:solidFill>
-              </a:rPr>
-              <a:t>陳威帆 · 3:05–3:50</a:t>
-            </a:r>
           </a:p>
         </p:txBody>
       </p:sp>
@@ -30330,64 +29218,6 @@
       </p:sp>
       <p:sp>
         <p:nvSpPr>
-          <p:cNvPr id="38" name="陳威帆 · 3:50–4:25">
-            <a:extLst xmlns:a="http://schemas.openxmlformats.org/drawingml/2006/main">
-              <a:ext uri="{FF2B5EF4-FFF2-40B4-BE49-F238E27FC236}">
-                <a16:creationId xmlns:a16="http://schemas.microsoft.com/office/drawing/2014/main" id="{5E1A92CE-5E9B-40D4-AB1B-030C85CB2A2F}"/>
-              </a:ext>
-            </a:extLst>
-          </p:cNvPr>
-          <p:cNvSpPr>
-            <a:spLocks xmlns:a="http://schemas.openxmlformats.org/drawingml/2006/main" noGrp="1"/>
-          </p:cNvSpPr>
-          <p:nvPr/>
-        </p:nvSpPr>
-        <p:spPr>
-          <a:xfrm xmlns:a="http://schemas.openxmlformats.org/drawingml/2006/main">
-            <a:off x="8667750" y="457200"/>
-            <a:ext cx="2790825" cy="266700"/>
-          </a:xfrm>
-          <a:prstGeom xmlns:a="http://schemas.openxmlformats.org/drawingml/2006/main" prst="rect">
-            <a:avLst/>
-          </a:prstGeom>
-          <a:noFill xmlns:a="http://schemas.openxmlformats.org/drawingml/2006/main"/>
-          <a:ln xmlns:a="http://schemas.openxmlformats.org/drawingml/2006/main" w="0">
-            <a:noFill/>
-          </a:ln>
-        </p:spPr>
-        <p:txBody>
-          <a:bodyPr xmlns:a="http://schemas.openxmlformats.org/drawingml/2006/main" lIns="0" tIns="0" rIns="0" bIns="0"/>
-          <a:lstStyle xmlns:a="http://schemas.openxmlformats.org/drawingml/2006/main">
-            <a:defPPr>
-              <a:defRPr sz="1275" b="0">
-                <a:solidFill>
-                  <a:srgbClr val="465E78"/>
-                </a:solidFill>
-              </a:defRPr>
-            </a:defPPr>
-          </a:lstStyle>
-          <a:p xmlns:a="http://schemas.openxmlformats.org/drawingml/2006/main">
-            <a:pPr>
-              <a:buNone/>
-              <a:defRPr sz="1275" b="0">
-                <a:solidFill>
-                  <a:srgbClr val="465E78"/>
-                </a:solidFill>
-              </a:defRPr>
-            </a:pPr>
-            <a:r>
-              <a:rPr sz="1275" b="0">
-                <a:solidFill>
-                  <a:srgbClr val="465E78"/>
-                </a:solidFill>
-              </a:rPr>
-              <a:t>陳威帆 · 3:50–4:25</a:t>
-            </a:r>
-          </a:p>
-        </p:txBody>
-      </p:sp>
-      <p:sp>
-        <p:nvSpPr>
           <p:cNvPr id="39" name="08">
             <a:extLst xmlns:a="http://schemas.openxmlformats.org/drawingml/2006/main">
               <a:ext uri="{FF2B5EF4-FFF2-40B4-BE49-F238E27FC236}">
@@ -31646,64 +30476,6 @@
               <a:t>權限與額度皆在後端檢查；預警的查詢、已讀與即時檢查已依帳號隔離。</a:t>
             </a:r>
             <a:endParaRPr sz="1400"/>
-          </a:p>
-        </p:txBody>
-      </p:sp>
-      <p:sp>
-        <p:nvSpPr>
-          <p:cNvPr id="33" name="許家全 · 4:25–5:10">
-            <a:extLst xmlns:a="http://schemas.openxmlformats.org/drawingml/2006/main">
-              <a:ext uri="{FF2B5EF4-FFF2-40B4-BE49-F238E27FC236}">
-                <a16:creationId xmlns:a16="http://schemas.microsoft.com/office/drawing/2014/main" id="{D88E650D-A0FC-41A9-8332-49B526C11F61}"/>
-              </a:ext>
-            </a:extLst>
-          </p:cNvPr>
-          <p:cNvSpPr>
-            <a:spLocks xmlns:a="http://schemas.openxmlformats.org/drawingml/2006/main" noGrp="1"/>
-          </p:cNvSpPr>
-          <p:nvPr/>
-        </p:nvSpPr>
-        <p:spPr>
-          <a:xfrm xmlns:a="http://schemas.openxmlformats.org/drawingml/2006/main">
-            <a:off x="8667750" y="457200"/>
-            <a:ext cx="2790825" cy="266700"/>
-          </a:xfrm>
-          <a:prstGeom xmlns:a="http://schemas.openxmlformats.org/drawingml/2006/main" prst="rect">
-            <a:avLst/>
-          </a:prstGeom>
-          <a:noFill xmlns:a="http://schemas.openxmlformats.org/drawingml/2006/main"/>
-          <a:ln xmlns:a="http://schemas.openxmlformats.org/drawingml/2006/main" w="0">
-            <a:noFill/>
-          </a:ln>
-        </p:spPr>
-        <p:txBody>
-          <a:bodyPr xmlns:a="http://schemas.openxmlformats.org/drawingml/2006/main" lIns="0" tIns="0" rIns="0" bIns="0"/>
-          <a:lstStyle xmlns:a="http://schemas.openxmlformats.org/drawingml/2006/main">
-            <a:defPPr>
-              <a:defRPr sz="1275" b="0">
-                <a:solidFill>
-                  <a:srgbClr val="465E78"/>
-                </a:solidFill>
-              </a:defRPr>
-            </a:defPPr>
-          </a:lstStyle>
-          <a:p xmlns:a="http://schemas.openxmlformats.org/drawingml/2006/main">
-            <a:pPr>
-              <a:buNone/>
-              <a:defRPr sz="1275" b="0">
-                <a:solidFill>
-                  <a:srgbClr val="465E78"/>
-                </a:solidFill>
-              </a:defRPr>
-            </a:pPr>
-            <a:r>
-              <a:rPr sz="1275" b="0">
-                <a:solidFill>
-                  <a:srgbClr val="465E78"/>
-                </a:solidFill>
-              </a:rPr>
-              <a:t>許家全 · 4:25–5:10</a:t>
-            </a:r>
           </a:p>
         </p:txBody>
       </p:sp>

</xml_diff>

<commit_message>
Drop the test-evidence slide from the deck
Removes the former slide 16 as requested, renumbers the footers, updates
the appendix page references (16, 17, 18) and takes 'test evidence' off
the agenda card.

Co-Authored-By: Claude Opus 5.5 <noreply@anthropic.com>
</commit_message>
<xml_diff>
--- a/output/ppt-review-20261011/final/MeBOD_複審簡報_第二輪修訂版.pptx
+++ b/output/ppt-review-20261011/final/MeBOD_複審簡報_第二輪修訂版.pptx
@@ -23,7 +23,6 @@
     <p:sldId xmlns:r="http://schemas.openxmlformats.org/officeDocument/2006/relationships" id="268" r:id="R2e34a04d4951441f"/>
     <p:sldId xmlns:r="http://schemas.openxmlformats.org/officeDocument/2006/relationships" id="269" r:id="Rc0e2eaea6c8a454c"/>
     <p:sldId xmlns:r="http://schemas.openxmlformats.org/officeDocument/2006/relationships" id="270" r:id="Rc427127a7a1a4820"/>
-    <p:sldId xmlns:r="http://schemas.openxmlformats.org/officeDocument/2006/relationships" id="271" r:id="Rd84d0f967edf4479"/>
     <p:sldId xmlns:r="http://schemas.openxmlformats.org/officeDocument/2006/relationships" id="272" r:id="Rb13b1a1201294e36"/>
     <p:sldId xmlns:r="http://schemas.openxmlformats.org/officeDocument/2006/relationships" id="273" r:id="R24f78b4f98114178"/>
     <p:sldId xmlns:r="http://schemas.openxmlformats.org/officeDocument/2006/relationships" id="274" r:id="R2ffa6da9ff1d4ab9"/>
@@ -1032,77 +1031,6 @@
           <a:p xmlns:a="http://schemas.openxmlformats.org/drawingml/2006/main">
             <a:r>
               <a:t>【許家全｜140 秒】預先登入正確帳號並備妥兩筆歷史。0–45秒：查詢醫美、設定平台與期間，讀趨勢並點文章。45–95秒：詢問消費者關注重點，展開引用並回原文；可用已完成的答案避免現場等待。95–140秒：歷史比較並匯出Excel。若網站10秒無回應，改以本頁和附錄實際畫面說明，不宣稱即時成功。畫面為原稿嵌入截圖，其數字只屬拍攝當時查詢。</a:t>
-            </a:r>
-            <a:endParaRPr/>
-          </a:p>
-        </p:txBody>
-      </p:sp>
-      <p:sp>
-        <p:nvSpPr>
-          <p:cNvPr id="4" name="Slide Number Placeholder 3"/>
-          <p:cNvSpPr>
-            <a:spLocks xmlns:a="http://schemas.openxmlformats.org/drawingml/2006/main" noGrp="1"/>
-          </p:cNvSpPr>
-          <p:nvPr>
-            <p:ph type="sldNum" idx="5"/>
-          </p:nvPr>
-        </p:nvSpPr>
-        <p:spPr/>
-        <p:txBody>
-          <a:bodyPr xmlns:a="http://schemas.openxmlformats.org/drawingml/2006/main"/>
-          <a:lstStyle xmlns:a="http://schemas.openxmlformats.org/drawingml/2006/main"/>
-          <a:p xmlns:a="http://schemas.openxmlformats.org/drawingml/2006/main"/>
-        </p:txBody>
-      </p:sp>
-    </p:spTree>
-  </p:cSld>
-  <p:clrMapOvr>
-    <a:masterClrMapping xmlns:a="http://schemas.openxmlformats.org/drawingml/2006/main"/>
-  </p:clrMapOvr>
-</p:notes>
-</file>
-
-<file path=ppt/notesSlides/notesSlide16.xml><?xml version="1.0" encoding="utf-8"?>
-<p:notes xmlns:p="http://schemas.openxmlformats.org/presentationml/2006/main">
-  <p:cSld>
-    <p:spTree>
-      <p:nvGrpSpPr>
-        <p:cNvPr id="1" name=""/>
-        <p:cNvGrpSpPr/>
-        <p:nvPr/>
-      </p:nvGrpSpPr>
-      <p:grpSpPr>
-        <a:xfrm xmlns:a="http://schemas.openxmlformats.org/drawingml/2006/main"/>
-      </p:grpSpPr>
-      <p:sp>
-        <p:nvSpPr>
-          <p:cNvPr id="2" name="Slide Image Placeholder 1"/>
-          <p:cNvSpPr>
-            <a:spLocks xmlns:a="http://schemas.openxmlformats.org/drawingml/2006/main" noGrp="1"/>
-          </p:cNvSpPr>
-          <p:nvPr>
-            <p:ph type="sldImg" idx="0"/>
-          </p:nvPr>
-        </p:nvSpPr>
-        <p:spPr/>
-      </p:sp>
-      <p:sp>
-        <p:nvSpPr>
-          <p:cNvPr id="3" name="Notes Placeholder 2"/>
-          <p:cNvSpPr>
-            <a:spLocks xmlns:a="http://schemas.openxmlformats.org/drawingml/2006/main" noGrp="1"/>
-          </p:cNvSpPr>
-          <p:nvPr>
-            <p:ph type="body" idx="1"/>
-          </p:nvPr>
-        </p:nvSpPr>
-        <p:spPr/>
-        <p:txBody>
-          <a:bodyPr xmlns:a="http://schemas.openxmlformats.org/drawingml/2006/main"/>
-          <a:lstStyle xmlns:a="http://schemas.openxmlformats.org/drawingml/2006/main"/>
-          <a:p xmlns:a="http://schemas.openxmlformats.org/drawingml/2006/main">
-            <a:r>
-              <a:t>【許家全｜35 秒】PostgreSQL10項可核對2026/10/03原始XML；E2E4項可核對2026/09/27 17:14的all-results.xml，較早一份曾有1項失敗，保留失敗歷程。後端pytest與前端Vitest已於10/12重跑：後端493通過、1略過，前端43通過，報告存於backend/.test-artifacts。高負載、人工標註與檢索題組尚待驗證。來源：backend/.test-artifacts/pytest-20261012.xml、vitest-20261012.xml、postgres-results.xml、all-results.xml。</a:t>
             </a:r>
             <a:endParaRPr/>
           </a:p>
@@ -10177,887 +10105,6 @@
 </p:sld>
 </file>
 
-<file path=ppt/slides/slide16.xml><?xml version="1.0" encoding="utf-8"?>
-<p:sld xmlns:p="http://schemas.openxmlformats.org/presentationml/2006/main">
-  <p:cSld>
-    <p:bg>
-      <p:bgPr>
-        <a:solidFill xmlns:a="http://schemas.openxmlformats.org/drawingml/2006/main">
-          <a:srgbClr val="F5F8FC"/>
-        </a:solidFill>
-      </p:bgPr>
-    </p:bg>
-    <p:spTree>
-      <p:nvGrpSpPr>
-        <p:cNvPr id="1" name=""/>
-        <p:cNvGrpSpPr/>
-        <p:nvPr/>
-      </p:nvGrpSpPr>
-      <p:grpSpPr>
-        <a:xfrm xmlns:a="http://schemas.openxmlformats.org/drawingml/2006/main"/>
-      </p:grpSpPr>
-      <p:sp>
-        <p:nvSpPr>
-          <p:cNvPr id="2" name="分層測試：區分原始報告與原稿紀錄">
-            <a:extLst xmlns:a="http://schemas.openxmlformats.org/drawingml/2006/main">
-              <a:ext uri="{FF2B5EF4-FFF2-40B4-BE49-F238E27FC236}">
-                <a16:creationId xmlns:a16="http://schemas.microsoft.com/office/drawing/2014/main" id="{D16A66BA-E063-48C5-8CED-B168A753D08B}"/>
-              </a:ext>
-            </a:extLst>
-          </p:cNvPr>
-          <p:cNvSpPr>
-            <a:spLocks xmlns:a="http://schemas.openxmlformats.org/drawingml/2006/main" noGrp="1"/>
-          </p:cNvSpPr>
-          <p:nvPr/>
-        </p:nvSpPr>
-        <p:spPr>
-          <a:xfrm xmlns:a="http://schemas.openxmlformats.org/drawingml/2006/main">
-            <a:off x="733425" y="933450"/>
-            <a:ext cx="10725150" cy="619125"/>
-          </a:xfrm>
-          <a:prstGeom xmlns:a="http://schemas.openxmlformats.org/drawingml/2006/main" prst="rect">
-            <a:avLst/>
-          </a:prstGeom>
-          <a:noFill xmlns:a="http://schemas.openxmlformats.org/drawingml/2006/main"/>
-          <a:ln xmlns:a="http://schemas.openxmlformats.org/drawingml/2006/main" w="0">
-            <a:noFill/>
-          </a:ln>
-        </p:spPr>
-        <p:txBody>
-          <a:bodyPr xmlns:a="http://schemas.openxmlformats.org/drawingml/2006/main" lIns="0" tIns="0" rIns="0" bIns="0"/>
-          <a:lstStyle xmlns:a="http://schemas.openxmlformats.org/drawingml/2006/main">
-            <a:defPPr>
-              <a:defRPr sz="2700" b="1">
-                <a:solidFill>
-                  <a:srgbClr val="14243A"/>
-                </a:solidFill>
-              </a:defRPr>
-            </a:defPPr>
-          </a:lstStyle>
-          <a:p xmlns:a="http://schemas.openxmlformats.org/drawingml/2006/main">
-            <a:pPr>
-              <a:buNone/>
-              <a:defRPr sz="2700" b="1">
-                <a:solidFill>
-                  <a:srgbClr val="14243A"/>
-                </a:solidFill>
-              </a:defRPr>
-            </a:pPr>
-            <a:r>
-              <a:rPr sz="2700" b="1">
-                <a:solidFill>
-                  <a:srgbClr val="14243A"/>
-                </a:solidFill>
-              </a:rPr>
-              <a:t>分層測試：每一層都有可核對的原始報告</a:t>
-            </a:r>
-          </a:p>
-        </p:txBody>
-      </p:sp>
-      <p:graphicFrame>
-        <p:nvGraphicFramePr>
-          <p:cNvPr id="3" name="">
-            <a:extLst xmlns:a="http://schemas.openxmlformats.org/drawingml/2006/main">
-              <a:ext uri="{FF2B5EF4-FFF2-40B4-BE49-F238E27FC236}">
-                <a16:creationId xmlns:a16="http://schemas.microsoft.com/office/drawing/2014/main" id="{A34A74EC-4A35-461F-ABDB-A1528177ABA7}"/>
-              </a:ext>
-            </a:extLst>
-          </p:cNvPr>
-          <p:cNvGraphicFramePr/>
-          <p:nvPr/>
-        </p:nvGraphicFramePr>
-        <p:xfrm>
-          <a:off xmlns:a="http://schemas.openxmlformats.org/drawingml/2006/main" x="733425" y="1771650"/>
-          <a:ext xmlns:a="http://schemas.openxmlformats.org/drawingml/2006/main" cx="10725150" cy="3190875"/>
-        </p:xfrm>
-        <a:graphic xmlns:a="http://schemas.openxmlformats.org/drawingml/2006/main">
-          <a:graphicData uri="http://schemas.openxmlformats.org/drawingml/2006/table">
-            <a:tbl>
-              <a:tblPr/>
-              <a:tblGrid>
-                <a:gridCol w="2419350"/>
-                <a:gridCol w="4000500"/>
-                <a:gridCol w="4305300"/>
-              </a:tblGrid>
-              <a:tr h="638175">
-                <a:tc>
-                  <a:txBody>
-                    <a:bodyPr/>
-                    <a:lstStyle/>
-                    <a:p>
-                      <a:r>
-                        <a:rPr sz="1650" b="1">
-                          <a:solidFill>
-                            <a:srgbClr val="2073BE"/>
-                          </a:solidFill>
-                        </a:rPr>
-                        <a:t>層級</a:t>
-                      </a:r>
-                    </a:p>
-                  </a:txBody>
-                  <a:tcPr marL="114300" marR="114300" marT="76200" marB="76200" anchor="ctr">
-                    <a:lnL w="9525">
-                      <a:solidFill>
-                        <a:srgbClr val="D3DEEA"/>
-                      </a:solidFill>
-                      <a:prstDash val="solid"/>
-                    </a:lnL>
-                    <a:lnR w="9525">
-                      <a:solidFill>
-                        <a:srgbClr val="D3DEEA"/>
-                      </a:solidFill>
-                      <a:prstDash val="solid"/>
-                    </a:lnR>
-                    <a:lnT w="9525">
-                      <a:solidFill>
-                        <a:srgbClr val="D3DEEA"/>
-                      </a:solidFill>
-                      <a:prstDash val="solid"/>
-                    </a:lnT>
-                    <a:lnB w="9525">
-                      <a:solidFill>
-                        <a:srgbClr val="D3DEEA"/>
-                      </a:solidFill>
-                      <a:prstDash val="solid"/>
-                    </a:lnB>
-                    <a:solidFill>
-                      <a:srgbClr val="E2EEFA"/>
-                    </a:solidFill>
-                  </a:tcPr>
-                </a:tc>
-                <a:tc>
-                  <a:txBody>
-                    <a:bodyPr/>
-                    <a:lstStyle/>
-                    <a:p>
-                      <a:r>
-                        <a:rPr sz="1650" b="1">
-                          <a:solidFill>
-                            <a:srgbClr val="2073BE"/>
-                          </a:solidFill>
-                        </a:rPr>
-                        <a:t>結果與日期</a:t>
-                      </a:r>
-                    </a:p>
-                  </a:txBody>
-                  <a:tcPr marL="114300" marR="114300" marT="76200" marB="76200" anchor="ctr">
-                    <a:lnR w="9525">
-                      <a:solidFill>
-                        <a:srgbClr val="D3DEEA"/>
-                      </a:solidFill>
-                      <a:prstDash val="solid"/>
-                    </a:lnR>
-                    <a:lnT w="9525">
-                      <a:solidFill>
-                        <a:srgbClr val="D3DEEA"/>
-                      </a:solidFill>
-                      <a:prstDash val="solid"/>
-                    </a:lnT>
-                    <a:lnB w="9525">
-                      <a:solidFill>
-                        <a:srgbClr val="D3DEEA"/>
-                      </a:solidFill>
-                      <a:prstDash val="solid"/>
-                    </a:lnB>
-                    <a:solidFill>
-                      <a:srgbClr val="E2EEFA"/>
-                    </a:solidFill>
-                  </a:tcPr>
-                </a:tc>
-                <a:tc>
-                  <a:txBody>
-                    <a:bodyPr/>
-                    <a:lstStyle/>
-                    <a:p>
-                      <a:r>
-                        <a:rPr sz="1650" b="1">
-                          <a:solidFill>
-                            <a:srgbClr val="2073BE"/>
-                          </a:solidFill>
-                        </a:rPr>
-                        <a:t>本次可核對的證據</a:t>
-                      </a:r>
-                    </a:p>
-                  </a:txBody>
-                  <a:tcPr marL="114300" marR="114300" marT="76200" marB="76200" anchor="ctr">
-                    <a:lnR w="9525">
-                      <a:solidFill>
-                        <a:srgbClr val="D3DEEA"/>
-                      </a:solidFill>
-                      <a:prstDash val="solid"/>
-                    </a:lnR>
-                    <a:lnT w="9525">
-                      <a:solidFill>
-                        <a:srgbClr val="D3DEEA"/>
-                      </a:solidFill>
-                      <a:prstDash val="solid"/>
-                    </a:lnT>
-                    <a:lnB w="9525">
-                      <a:solidFill>
-                        <a:srgbClr val="D3DEEA"/>
-                      </a:solidFill>
-                      <a:prstDash val="solid"/>
-                    </a:lnB>
-                    <a:solidFill>
-                      <a:srgbClr val="E2EEFA"/>
-                    </a:solidFill>
-                  </a:tcPr>
-                </a:tc>
-              </a:tr>
-              <a:tr h="638175">
-                <a:tc>
-                  <a:txBody>
-                    <a:bodyPr/>
-                    <a:lstStyle/>
-                    <a:p>
-                      <a:r>
-                        <a:rPr sz="1650" b="0">
-                          <a:solidFill>
-                            <a:srgbClr val="14243A"/>
-                          </a:solidFill>
-                        </a:rPr>
-                        <a:t>PostgreSQL 整合</a:t>
-                      </a:r>
-                    </a:p>
-                  </a:txBody>
-                  <a:tcPr marL="114300" marR="114300" marT="76200" marB="76200" anchor="ctr">
-                    <a:lnL w="9525">
-                      <a:solidFill>
-                        <a:srgbClr val="D3DEEA"/>
-                      </a:solidFill>
-                      <a:prstDash val="solid"/>
-                    </a:lnL>
-                    <a:lnR w="9525">
-                      <a:solidFill>
-                        <a:srgbClr val="D3DEEA"/>
-                      </a:solidFill>
-                      <a:prstDash val="solid"/>
-                    </a:lnR>
-                    <a:lnB w="9525">
-                      <a:solidFill>
-                        <a:srgbClr val="D3DEEA"/>
-                      </a:solidFill>
-                      <a:prstDash val="solid"/>
-                    </a:lnB>
-                    <a:solidFill>
-                      <a:srgbClr val="FFFFFF"/>
-                    </a:solidFill>
-                  </a:tcPr>
-                </a:tc>
-                <a:tc>
-                  <a:txBody>
-                    <a:bodyPr/>
-                    <a:lstStyle/>
-                    <a:p>
-                      <a:r>
-                        <a:rPr sz="1650" b="0">
-                          <a:solidFill>
-                            <a:srgbClr val="14243A"/>
-                          </a:solidFill>
-                        </a:rPr>
-                        <a:t>10 通過｜2026/10/03</a:t>
-                      </a:r>
-                    </a:p>
-                  </a:txBody>
-                  <a:tcPr marL="114300" marR="114300" marT="76200" marB="76200" anchor="ctr">
-                    <a:lnR w="9525">
-                      <a:solidFill>
-                        <a:srgbClr val="D3DEEA"/>
-                      </a:solidFill>
-                      <a:prstDash val="solid"/>
-                    </a:lnR>
-                    <a:lnB w="9525">
-                      <a:solidFill>
-                        <a:srgbClr val="D3DEEA"/>
-                      </a:solidFill>
-                      <a:prstDash val="solid"/>
-                    </a:lnB>
-                    <a:solidFill>
-                      <a:srgbClr val="FFFFFF"/>
-                    </a:solidFill>
-                  </a:tcPr>
-                </a:tc>
-                <a:tc>
-                  <a:txBody>
-                    <a:bodyPr/>
-                    <a:lstStyle/>
-                    <a:p>
-                      <a:r>
-                        <a:rPr sz="1650" b="0">
-                          <a:solidFill>
-                            <a:srgbClr val="14243A"/>
-                          </a:solidFill>
-                        </a:rPr>
-                        <a:t>postgres-results.xml</a:t>
-                      </a:r>
-                    </a:p>
-                  </a:txBody>
-                  <a:tcPr marL="114300" marR="114300" marT="76200" marB="76200" anchor="ctr">
-                    <a:lnR w="9525">
-                      <a:solidFill>
-                        <a:srgbClr val="D3DEEA"/>
-                      </a:solidFill>
-                      <a:prstDash val="solid"/>
-                    </a:lnR>
-                    <a:lnB w="9525">
-                      <a:solidFill>
-                        <a:srgbClr val="D3DEEA"/>
-                      </a:solidFill>
-                      <a:prstDash val="solid"/>
-                    </a:lnB>
-                    <a:solidFill>
-                      <a:srgbClr val="FFFFFF"/>
-                    </a:solidFill>
-                  </a:tcPr>
-                </a:tc>
-              </a:tr>
-              <a:tr h="638175">
-                <a:tc>
-                  <a:txBody>
-                    <a:bodyPr/>
-                    <a:lstStyle/>
-                    <a:p>
-                      <a:r>
-                        <a:rPr sz="1650" b="0">
-                          <a:solidFill>
-                            <a:srgbClr val="14243A"/>
-                          </a:solidFill>
-                        </a:rPr>
-                        <a:t>Chromium 端對端</a:t>
-                      </a:r>
-                    </a:p>
-                  </a:txBody>
-                  <a:tcPr marL="114300" marR="114300" marT="76200" marB="76200" anchor="ctr">
-                    <a:lnL w="9525">
-                      <a:solidFill>
-                        <a:srgbClr val="D3DEEA"/>
-                      </a:solidFill>
-                      <a:prstDash val="solid"/>
-                    </a:lnL>
-                    <a:lnR w="9525">
-                      <a:solidFill>
-                        <a:srgbClr val="D3DEEA"/>
-                      </a:solidFill>
-                      <a:prstDash val="solid"/>
-                    </a:lnR>
-                    <a:lnB w="9525">
-                      <a:solidFill>
-                        <a:srgbClr val="D3DEEA"/>
-                      </a:solidFill>
-                      <a:prstDash val="solid"/>
-                    </a:lnB>
-                    <a:solidFill>
-                      <a:srgbClr val="F0F5FB"/>
-                    </a:solidFill>
-                  </a:tcPr>
-                </a:tc>
-                <a:tc>
-                  <a:txBody>
-                    <a:bodyPr/>
-                    <a:lstStyle/>
-                    <a:p>
-                      <a:r>
-                        <a:rPr sz="1650" b="0">
-                          <a:solidFill>
-                            <a:srgbClr val="14243A"/>
-                          </a:solidFill>
-                        </a:rPr>
-                        <a:t>4 通過｜2026/09/27</a:t>
-                      </a:r>
-                    </a:p>
-                  </a:txBody>
-                  <a:tcPr marL="114300" marR="114300" marT="76200" marB="76200" anchor="ctr">
-                    <a:lnR w="9525">
-                      <a:solidFill>
-                        <a:srgbClr val="D3DEEA"/>
-                      </a:solidFill>
-                      <a:prstDash val="solid"/>
-                    </a:lnR>
-                    <a:lnB w="9525">
-                      <a:solidFill>
-                        <a:srgbClr val="D3DEEA"/>
-                      </a:solidFill>
-                      <a:prstDash val="solid"/>
-                    </a:lnB>
-                    <a:solidFill>
-                      <a:srgbClr val="F0F5FB"/>
-                    </a:solidFill>
-                  </a:tcPr>
-                </a:tc>
-                <a:tc>
-                  <a:txBody>
-                    <a:bodyPr/>
-                    <a:lstStyle/>
-                    <a:p>
-                      <a:r>
-                        <a:rPr sz="1650" b="0">
-                          <a:solidFill>
-                            <a:srgbClr val="14243A"/>
-                          </a:solidFill>
-                        </a:rPr>
-                        <a:t>all-results.xml 內 4 個 E2E 案例</a:t>
-                      </a:r>
-                    </a:p>
-                  </a:txBody>
-                  <a:tcPr marL="114300" marR="114300" marT="76200" marB="76200" anchor="ctr">
-                    <a:lnR w="9525">
-                      <a:solidFill>
-                        <a:srgbClr val="D3DEEA"/>
-                      </a:solidFill>
-                      <a:prstDash val="solid"/>
-                    </a:lnR>
-                    <a:lnB w="9525">
-                      <a:solidFill>
-                        <a:srgbClr val="D3DEEA"/>
-                      </a:solidFill>
-                      <a:prstDash val="solid"/>
-                    </a:lnB>
-                    <a:solidFill>
-                      <a:srgbClr val="F0F5FB"/>
-                    </a:solidFill>
-                  </a:tcPr>
-                </a:tc>
-              </a:tr>
-              <a:tr h="638175">
-                <a:tc>
-                  <a:txBody>
-                    <a:bodyPr/>
-                    <a:lstStyle/>
-                    <a:p>
-                      <a:r>
-                        <a:rPr sz="1650" b="0">
-                          <a:solidFill>
-                            <a:srgbClr val="14243A"/>
-                          </a:solidFill>
-                        </a:rPr>
-                        <a:t>後端 pytest</a:t>
-                      </a:r>
-                    </a:p>
-                  </a:txBody>
-                  <a:tcPr marL="114300" marR="114300" marT="76200" marB="76200" anchor="ctr">
-                    <a:lnL w="9525">
-                      <a:solidFill>
-                        <a:srgbClr val="D3DEEA"/>
-                      </a:solidFill>
-                      <a:prstDash val="solid"/>
-                    </a:lnL>
-                    <a:lnR w="9525">
-                      <a:solidFill>
-                        <a:srgbClr val="D3DEEA"/>
-                      </a:solidFill>
-                      <a:prstDash val="solid"/>
-                    </a:lnR>
-                    <a:lnB w="9525">
-                      <a:solidFill>
-                        <a:srgbClr val="D3DEEA"/>
-                      </a:solidFill>
-                      <a:prstDash val="solid"/>
-                    </a:lnB>
-                    <a:solidFill>
-                      <a:srgbClr val="FFFFFF"/>
-                    </a:solidFill>
-                  </a:tcPr>
-                </a:tc>
-                <a:tc>
-                  <a:txBody>
-                    <a:bodyPr/>
-                    <a:lstStyle/>
-                    <a:p>
-                      <a:r>
-                        <a:rPr sz="1650" b="0">
-                          <a:solidFill>
-                            <a:srgbClr val="14243A"/>
-                          </a:solidFill>
-                        </a:rPr>
-                        <a:t>493 通過、1 略過｜2026/10/12</a:t>
-                      </a:r>
-                    </a:p>
-                  </a:txBody>
-                  <a:tcPr marL="114300" marR="114300" marT="76200" marB="76200" anchor="ctr">
-                    <a:lnR w="9525">
-                      <a:solidFill>
-                        <a:srgbClr val="D3DEEA"/>
-                      </a:solidFill>
-                      <a:prstDash val="solid"/>
-                    </a:lnR>
-                    <a:lnB w="9525">
-                      <a:solidFill>
-                        <a:srgbClr val="D3DEEA"/>
-                      </a:solidFill>
-                      <a:prstDash val="solid"/>
-                    </a:lnB>
-                    <a:solidFill>
-                      <a:srgbClr val="FFFFFF"/>
-                    </a:solidFill>
-                  </a:tcPr>
-                </a:tc>
-                <a:tc>
-                  <a:txBody>
-                    <a:bodyPr/>
-                    <a:lstStyle/>
-                    <a:p>
-                      <a:r>
-                        <a:rPr sz="1650" b="0">
-                          <a:solidFill>
-                            <a:srgbClr val="14243A"/>
-                          </a:solidFill>
-                        </a:rPr>
-                        <a:t>pytest-20261012.xml</a:t>
-                      </a:r>
-                    </a:p>
-                  </a:txBody>
-                  <a:tcPr marL="114300" marR="114300" marT="76200" marB="76200" anchor="ctr">
-                    <a:lnR w="9525">
-                      <a:solidFill>
-                        <a:srgbClr val="D3DEEA"/>
-                      </a:solidFill>
-                      <a:prstDash val="solid"/>
-                    </a:lnR>
-                    <a:lnB w="9525">
-                      <a:solidFill>
-                        <a:srgbClr val="D3DEEA"/>
-                      </a:solidFill>
-                      <a:prstDash val="solid"/>
-                    </a:lnB>
-                    <a:solidFill>
-                      <a:srgbClr val="FFFFFF"/>
-                    </a:solidFill>
-                  </a:tcPr>
-                </a:tc>
-              </a:tr>
-              <a:tr h="638175">
-                <a:tc>
-                  <a:txBody>
-                    <a:bodyPr/>
-                    <a:lstStyle/>
-                    <a:p>
-                      <a:r>
-                        <a:rPr sz="1650" b="0">
-                          <a:solidFill>
-                            <a:srgbClr val="14243A"/>
-                          </a:solidFill>
-                        </a:rPr>
-                        <a:t>前端 Vitest</a:t>
-                      </a:r>
-                    </a:p>
-                  </a:txBody>
-                  <a:tcPr marL="114300" marR="114300" marT="76200" marB="76200" anchor="ctr">
-                    <a:lnL w="9525">
-                      <a:solidFill>
-                        <a:srgbClr val="D3DEEA"/>
-                      </a:solidFill>
-                      <a:prstDash val="solid"/>
-                    </a:lnL>
-                    <a:lnR w="9525">
-                      <a:solidFill>
-                        <a:srgbClr val="D3DEEA"/>
-                      </a:solidFill>
-                      <a:prstDash val="solid"/>
-                    </a:lnR>
-                    <a:lnB w="9525">
-                      <a:solidFill>
-                        <a:srgbClr val="D3DEEA"/>
-                      </a:solidFill>
-                      <a:prstDash val="solid"/>
-                    </a:lnB>
-                    <a:solidFill>
-                      <a:srgbClr val="F0F5FB"/>
-                    </a:solidFill>
-                  </a:tcPr>
-                </a:tc>
-                <a:tc>
-                  <a:txBody>
-                    <a:bodyPr/>
-                    <a:lstStyle/>
-                    <a:p>
-                      <a:r>
-                        <a:rPr sz="1650" b="0">
-                          <a:solidFill>
-                            <a:srgbClr val="14243A"/>
-                          </a:solidFill>
-                        </a:rPr>
-                        <a:t>43 通過｜2026/10/12</a:t>
-                      </a:r>
-                    </a:p>
-                  </a:txBody>
-                  <a:tcPr marL="114300" marR="114300" marT="76200" marB="76200" anchor="ctr">
-                    <a:lnR w="9525">
-                      <a:solidFill>
-                        <a:srgbClr val="D3DEEA"/>
-                      </a:solidFill>
-                      <a:prstDash val="solid"/>
-                    </a:lnR>
-                    <a:lnB w="9525">
-                      <a:solidFill>
-                        <a:srgbClr val="D3DEEA"/>
-                      </a:solidFill>
-                      <a:prstDash val="solid"/>
-                    </a:lnB>
-                    <a:solidFill>
-                      <a:srgbClr val="F0F5FB"/>
-                    </a:solidFill>
-                  </a:tcPr>
-                </a:tc>
-                <a:tc>
-                  <a:txBody>
-                    <a:bodyPr/>
-                    <a:lstStyle/>
-                    <a:p>
-                      <a:r>
-                        <a:rPr sz="1650" b="0">
-                          <a:solidFill>
-                            <a:srgbClr val="14243A"/>
-                          </a:solidFill>
-                        </a:rPr>
-                        <a:t>vitest-20261012.xml</a:t>
-                      </a:r>
-                    </a:p>
-                  </a:txBody>
-                  <a:tcPr marL="114300" marR="114300" marT="76200" marB="76200" anchor="ctr">
-                    <a:lnR w="9525">
-                      <a:solidFill>
-                        <a:srgbClr val="D3DEEA"/>
-                      </a:solidFill>
-                      <a:prstDash val="solid"/>
-                    </a:lnR>
-                    <a:lnB w="9525">
-                      <a:solidFill>
-                        <a:srgbClr val="D3DEEA"/>
-                      </a:solidFill>
-                      <a:prstDash val="solid"/>
-                    </a:lnB>
-                    <a:solidFill>
-                      <a:srgbClr val="F0F5FB"/>
-                    </a:solidFill>
-                  </a:tcPr>
-                </a:tc>
-              </a:tr>
-            </a:tbl>
-          </a:graphicData>
-        </a:graphic>
-      </p:graphicFrame>
-      <p:sp>
-        <p:nvSpPr>
-          <p:cNvPr id="4" name="測試能支持流程；外部模型的固定回應不能證明回答品質。">
-            <a:extLst xmlns:a="http://schemas.openxmlformats.org/drawingml/2006/main">
-              <a:ext uri="{FF2B5EF4-FFF2-40B4-BE49-F238E27FC236}">
-                <a16:creationId xmlns:a16="http://schemas.microsoft.com/office/drawing/2014/main" id="{2794C48B-BB46-47CC-BC47-B9099746190B}"/>
-              </a:ext>
-            </a:extLst>
-          </p:cNvPr>
-          <p:cNvSpPr>
-            <a:spLocks xmlns:a="http://schemas.openxmlformats.org/drawingml/2006/main" noGrp="1"/>
-          </p:cNvSpPr>
-          <p:nvPr/>
-        </p:nvSpPr>
-        <p:spPr>
-          <a:xfrm xmlns:a="http://schemas.openxmlformats.org/drawingml/2006/main">
-            <a:off x="733425" y="5181600"/>
-            <a:ext cx="10725150" cy="381000"/>
-          </a:xfrm>
-          <a:prstGeom xmlns:a="http://schemas.openxmlformats.org/drawingml/2006/main" prst="rect">
-            <a:avLst/>
-          </a:prstGeom>
-          <a:noFill xmlns:a="http://schemas.openxmlformats.org/drawingml/2006/main"/>
-          <a:ln xmlns:a="http://schemas.openxmlformats.org/drawingml/2006/main" w="0">
-            <a:noFill/>
-          </a:ln>
-        </p:spPr>
-        <p:txBody>
-          <a:bodyPr xmlns:a="http://schemas.openxmlformats.org/drawingml/2006/main" lIns="0" tIns="0" rIns="0" bIns="0"/>
-          <a:lstStyle xmlns:a="http://schemas.openxmlformats.org/drawingml/2006/main">
-            <a:defPPr>
-              <a:defRPr sz="1800" b="0">
-                <a:solidFill>
-                  <a:srgbClr val="465E78"/>
-                </a:solidFill>
-              </a:defRPr>
-            </a:defPPr>
-          </a:lstStyle>
-          <a:p xmlns:a="http://schemas.openxmlformats.org/drawingml/2006/main">
-            <a:pPr>
-              <a:buNone/>
-              <a:defRPr sz="1800" b="0">
-                <a:solidFill>
-                  <a:srgbClr val="465E78"/>
-                </a:solidFill>
-              </a:defRPr>
-            </a:pPr>
-            <a:r>
-              <a:rPr sz="1800" b="0">
-                <a:solidFill>
-                  <a:srgbClr val="465E78"/>
-                </a:solidFill>
-              </a:rPr>
-              <a:t>測試能支持流程；外部模型的固定回應不能證明回答品質。</a:t>
-            </a:r>
-          </a:p>
-        </p:txBody>
-      </p:sp>
-      <p:sp>
-        <p:nvSpPr>
-          <p:cNvPr id="5" name="">
-            <a:extLst xmlns:a="http://schemas.openxmlformats.org/drawingml/2006/main">
-              <a:ext uri="{FF2B5EF4-FFF2-40B4-BE49-F238E27FC236}">
-                <a16:creationId xmlns:a16="http://schemas.microsoft.com/office/drawing/2014/main" id="{023D7C7B-A4A7-4323-83BE-56D71FBE95AF}"/>
-              </a:ext>
-            </a:extLst>
-          </p:cNvPr>
-          <p:cNvSpPr>
-            <a:spLocks xmlns:a="http://schemas.openxmlformats.org/drawingml/2006/main" noGrp="1"/>
-          </p:cNvSpPr>
-          <p:nvPr/>
-        </p:nvSpPr>
-        <p:spPr>
-          <a:xfrm xmlns:a="http://schemas.openxmlformats.org/drawingml/2006/main">
-            <a:off x="733425" y="5743575"/>
-            <a:ext cx="10725150" cy="514350"/>
-          </a:xfrm>
-          <a:prstGeom xmlns:a="http://schemas.openxmlformats.org/drawingml/2006/main" prst="roundRect">
-            <a:avLst>
-              <a:gd name="adj" fmla="val 25926"/>
-            </a:avLst>
-          </a:prstGeom>
-          <a:solidFill xmlns:a="http://schemas.openxmlformats.org/drawingml/2006/main">
-            <a:srgbClr val="E2EEFA"/>
-          </a:solidFill>
-          <a:ln xmlns:a="http://schemas.openxmlformats.org/drawingml/2006/main" w="9525">
-            <a:solidFill>
-              <a:srgbClr val="D3DEEA"/>
-            </a:solidFill>
-          </a:ln>
-        </p:spPr>
-        <p:txBody xmlns:a="http://schemas.openxmlformats.org/drawingml/2006/main">
-          <a:bodyPr/>
-          <a:p/>
-        </p:txBody>
-      </p:sp>
-      <p:sp>
-        <p:nvSpPr>
-          <p:cNvPr id="6" name="以上為歷史紀錄，本次未重跑系統測試；不同日期、範圍的測試不累">
-            <a:extLst xmlns:a="http://schemas.openxmlformats.org/drawingml/2006/main">
-              <a:ext uri="{FF2B5EF4-FFF2-40B4-BE49-F238E27FC236}">
-                <a16:creationId xmlns:a16="http://schemas.microsoft.com/office/drawing/2014/main" id="{474FE176-8F6C-43D2-BF97-B262F2A7F8E8}"/>
-              </a:ext>
-            </a:extLst>
-          </p:cNvPr>
-          <p:cNvSpPr>
-            <a:spLocks xmlns:a="http://schemas.openxmlformats.org/drawingml/2006/main" noGrp="1"/>
-          </p:cNvSpPr>
-          <p:nvPr/>
-        </p:nvSpPr>
-        <p:spPr>
-          <a:xfrm xmlns:a="http://schemas.openxmlformats.org/drawingml/2006/main">
-            <a:off x="914400" y="5857875"/>
-            <a:ext cx="10363200" cy="304800"/>
-          </a:xfrm>
-          <a:prstGeom xmlns:a="http://schemas.openxmlformats.org/drawingml/2006/main" prst="rect">
-            <a:avLst/>
-          </a:prstGeom>
-          <a:noFill xmlns:a="http://schemas.openxmlformats.org/drawingml/2006/main"/>
-          <a:ln xmlns:a="http://schemas.openxmlformats.org/drawingml/2006/main" w="0">
-            <a:noFill/>
-          </a:ln>
-        </p:spPr>
-        <p:txBody>
-          <a:bodyPr xmlns:a="http://schemas.openxmlformats.org/drawingml/2006/main" lIns="0" tIns="0" rIns="0" bIns="0"/>
-          <a:lstStyle xmlns:a="http://schemas.openxmlformats.org/drawingml/2006/main">
-            <a:defPPr>
-              <a:defRPr sz="1500" b="1">
-                <a:solidFill>
-                  <a:srgbClr val="2073BE"/>
-                </a:solidFill>
-              </a:defRPr>
-            </a:defPPr>
-          </a:lstStyle>
-          <a:p xmlns:a="http://schemas.openxmlformats.org/drawingml/2006/main">
-            <a:pPr>
-              <a:buNone/>
-              <a:defRPr sz="1500" b="1">
-                <a:solidFill>
-                  <a:srgbClr val="2073BE"/>
-                </a:solidFill>
-              </a:defRPr>
-            </a:pPr>
-            <a:r>
-              <a:rPr sz="1500" b="1">
-                <a:solidFill>
-                  <a:srgbClr val="2073BE"/>
-                </a:solidFill>
-              </a:rPr>
-              <a:t>單元／API 測試 10/12 重跑並保存 XML；PostgreSQL、E2E 為先前報告，不同日期不累加。</a:t>
-            </a:r>
-          </a:p>
-        </p:txBody>
-      </p:sp>
-      <p:sp>
-        <p:nvSpPr>
-          <p:cNvPr id="8" name="16">
-            <a:extLst xmlns:a="http://schemas.openxmlformats.org/drawingml/2006/main">
-              <a:ext uri="{FF2B5EF4-FFF2-40B4-BE49-F238E27FC236}">
-                <a16:creationId xmlns:a16="http://schemas.microsoft.com/office/drawing/2014/main" id="{0F8FF5F3-E919-4AB8-85B5-F26C52CDFB82}"/>
-              </a:ext>
-            </a:extLst>
-          </p:cNvPr>
-          <p:cNvSpPr>
-            <a:spLocks xmlns:a="http://schemas.openxmlformats.org/drawingml/2006/main" noGrp="1"/>
-          </p:cNvSpPr>
-          <p:nvPr/>
-        </p:nvSpPr>
-        <p:spPr>
-          <a:xfrm xmlns:a="http://schemas.openxmlformats.org/drawingml/2006/main">
-            <a:off x="733425" y="6391275"/>
-            <a:ext cx="762000" cy="257175"/>
-          </a:xfrm>
-          <a:prstGeom xmlns:a="http://schemas.openxmlformats.org/drawingml/2006/main" prst="rect">
-            <a:avLst/>
-          </a:prstGeom>
-          <a:noFill xmlns:a="http://schemas.openxmlformats.org/drawingml/2006/main"/>
-          <a:ln xmlns:a="http://schemas.openxmlformats.org/drawingml/2006/main" w="0">
-            <a:noFill/>
-          </a:ln>
-        </p:spPr>
-        <p:txBody>
-          <a:bodyPr xmlns:a="http://schemas.openxmlformats.org/drawingml/2006/main" lIns="0" tIns="0" rIns="0" bIns="0"/>
-          <a:lstStyle xmlns:a="http://schemas.openxmlformats.org/drawingml/2006/main">
-            <a:defPPr>
-              <a:defRPr sz="1275" b="0">
-                <a:solidFill>
-                  <a:srgbClr val="465E78"/>
-                </a:solidFill>
-              </a:defRPr>
-            </a:defPPr>
-          </a:lstStyle>
-          <a:p xmlns:a="http://schemas.openxmlformats.org/drawingml/2006/main">
-            <a:pPr>
-              <a:buNone/>
-              <a:defRPr sz="1275" b="0">
-                <a:solidFill>
-                  <a:srgbClr val="465E78"/>
-                </a:solidFill>
-              </a:defRPr>
-            </a:pPr>
-            <a:r>
-              <a:rPr sz="1275" b="0">
-                <a:solidFill>
-                  <a:srgbClr val="465E78"/>
-                </a:solidFill>
-              </a:rPr>
-              <a:t>16</a:t>
-            </a:r>
-          </a:p>
-        </p:txBody>
-      </p:sp>
-    </p:spTree>
-    <p:extLst>
-      <p:ext uri="{BB962C8B-B14F-4D97-AF65-F5344CB8AC3E}">
-        <p14:creationId xmlns:p14="http://schemas.microsoft.com/office/powerpoint/2010/main" val="243830329"/>
-      </p:ext>
-    </p:extLst>
-  </p:cSld>
-</p:sld>
-</file>
-
 <file path=ppt/slides/slide17.xml><?xml version="1.0" encoding="utf-8"?>
 <p:sld xmlns:p="http://schemas.openxmlformats.org/presentationml/2006/main">
   <p:cSld>
@@ -13286,7 +12333,7 @@
                   <a:srgbClr val="465E78"/>
                 </a:solidFill>
               </a:rPr>
-              <a:t>17</a:t>
+              <a:t>16</a:t>
             </a:r>
           </a:p>
         </p:txBody>
@@ -14140,7 +13187,7 @@
                   <a:srgbClr val="465E78"/>
                 </a:solidFill>
               </a:rPr>
-              <a:t>18</a:t>
+              <a:t>17</a:t>
             </a:r>
           </a:p>
         </p:txBody>
@@ -15201,7 +14248,7 @@
                   <a:srgbClr val="465E78"/>
                 </a:solidFill>
               </a:rPr>
-              <a:t>19</a:t>
+              <a:t>18</a:t>
             </a:r>
           </a:p>
         </p:txBody>
@@ -16027,7 +15074,7 @@
                 <a:ea typeface="Microsoft JhengHei"/>
                 <a:cs typeface="Microsoft JhengHei"/>
               </a:rPr>
-              <a:t>實機展示、測試證據</a:t>
+              <a:t>實機展示</a:t>
             </a:r>
             <a:endParaRPr sz="1400"/>
           </a:p>
@@ -17363,7 +16410,7 @@
                             <a:srgbClr val="14243A"/>
                           </a:solidFill>
                         </a:rPr>
-                        <a:t>p17 實際月份</a:t>
+                        <a:t>p16 實際月份</a:t>
                       </a:r>
                     </a:p>
                   </a:txBody>
@@ -17470,7 +16517,7 @@
                             <a:srgbClr val="14243A"/>
                           </a:solidFill>
                         </a:rPr>
-                        <a:t>p17 提交紀錄；p18 分工</a:t>
+                        <a:t>p16 提交紀錄；p17 分工</a:t>
                       </a:r>
                     </a:p>
                   </a:txBody>
@@ -17690,7 +16737,7 @@
                   <a:srgbClr val="465E78"/>
                 </a:solidFill>
               </a:rPr>
-              <a:t>20</a:t>
+              <a:t>19</a:t>
             </a:r>
           </a:p>
         </p:txBody>
@@ -18625,7 +17672,7 @@
                             <a:srgbClr val="14243A"/>
                           </a:solidFill>
                         </a:rPr>
-                        <a:t>p8 TOWS；p19 後續策略</a:t>
+                        <a:t>p8 TOWS；p18 後續策略</a:t>
                       </a:r>
                     </a:p>
                   </a:txBody>
@@ -18941,7 +17988,7 @@
                   <a:srgbClr val="465E78"/>
                 </a:solidFill>
               </a:rPr>
-              <a:t>21</a:t>
+              <a:t>20</a:t>
             </a:r>
           </a:p>
         </p:txBody>
@@ -19715,7 +18762,7 @@
                   <a:srgbClr val="465E78"/>
                 </a:solidFill>
               </a:rPr>
-              <a:t>22</a:t>
+              <a:t>21</a:t>
             </a:r>
           </a:p>
         </p:txBody>
@@ -19984,7 +19031,7 @@
                   <a:srgbClr val="465E78"/>
                 </a:solidFill>
               </a:rPr>
-              <a:t>23</a:t>
+              <a:t>22</a:t>
             </a:r>
           </a:p>
         </p:txBody>
@@ -20253,7 +19300,7 @@
                   <a:srgbClr val="465E78"/>
                 </a:solidFill>
               </a:rPr>
-              <a:t>24</a:t>
+              <a:t>23</a:t>
             </a:r>
           </a:p>
         </p:txBody>
@@ -21290,7 +20337,7 @@
                   <a:srgbClr val="465E78"/>
                 </a:solidFill>
               </a:rPr>
-              <a:t>25</a:t>
+              <a:t>24</a:t>
             </a:r>
           </a:p>
         </p:txBody>

</xml_diff>

<commit_message>
Sync the deck with the Q&A retrieval fix
Speaker notes for the cost and RAG slides describe the new flow, the
appendix cost row reflects the measured prompt size (still about
NT$0.06), and the timeline and commit counts are current. The review
log records which claims were checked against code and which still rely
on the team.

Co-Authored-By: Claude Opus 5.5 <noreply@anthropic.com>
</commit_message>
<xml_diff>
--- a/output/ppt-review-20261011/final/MeBOD_複審簡報_第二輪修訂版.pptx
+++ b/output/ppt-review-20261011/final/MeBOD_複審簡報_第二輪修訂版.pptx
@@ -748,7 +748,7 @@
           <a:lstStyle xmlns:a="http://schemas.openxmlformats.org/drawingml/2006/main"/>
           <a:p xmlns:a="http://schemas.openxmlformats.org/drawingml/2006/main">
             <a:r>
-              <a:t>【許家全｜45 秒】初評指出只有 keyword 比對。現在先解析問題意圖，再以關鍵字和向量雙路找證據，RRF 合併排序後給模型作答。資料預先切段並建立向量；向量無結果時回退關鍵字。引用支持人工回查，不保證每句結論都有充分證據。尚未完成專家知識庫和固定題組評估。來源：backend/app/services/rag_service.py（parse_question_intent、RRF_K、混合檢索）；embedding_service.py；article_compressor.py。</a:t>
+              <a:t>【許家全｜45 秒】初評指出只有 keyword 比對。現在先解析問題意圖，再以關鍵字和向量雙路找證據，RRF 合併排序後給模型作答。在 AI 問答頁提問時，檢索範圍會套用使用者在 Dashboard 選的關鍵字與期間，回答以檢索到的文章為證據、Dashboard 數字為背景，引用清單就是這些文章。資料預先切段並建立向量；向量無結果時回退關鍵字，完全找不到文章時才只用 Dashboard 數字回答。引用支持人工回查，不保證每句結論都有充分證據；尚未完成專家知識庫和固定題組評估。來源：backend/app/services/rag_service.py（answer_question、scope_intent_to_dashboard、RRF_K）；embedding_service.py。</a:t>
             </a:r>
           </a:p>
         </p:txBody>
@@ -1101,7 +1101,7 @@
           <a:lstStyle xmlns:a="http://schemas.openxmlformats.org/drawingml/2006/main"/>
           <a:p xmlns:a="http://schemas.openxmlformats.org/drawingml/2006/main">
             <a:r>
-              <a:t>【陳威帆｜45 秒】甘特圖保留原稿115/2至116/1的計畫，10月後為計畫工作。繳件與展覽日期沿用原稿，發表前仍按學校公告確認。右側里程碑依各功能第一次提交的月份：5月PTT爬蟲、儀表板與WebSocket；7月帳號登入；8月Dcard、Mobile01、Threads；9月方案額度、Alembic與向量檢索；10月情緒一致性與預警權限修正。提交數由GitHub於10/12統計：5月14、6月0、7月27、8月42、9月47、10月34，共164次，皆已推送；提交集中於單一帳號，不能當作兩位組員的貢獻比例。</a:t>
+              <a:t>【陳威帆｜45 秒】甘特圖保留原稿115/2至116/1的計畫，10月後為計畫工作。繳件與展覽日期沿用原稿，發表前仍按學校公告確認。右側里程碑依各功能第一次提交的月份：5月PTT爬蟲、儀表板與WebSocket；7月帳號登入；8月Dcard、Mobile01、Threads；9月方案額度、Alembic與向量檢索；10月情緒一致性、預警權限與問答檢索修正。提交數由GitHub於10/12統計：5月14、6月0、7月27、8月42、9月47、10月36，共166次，皆已推送；提交集中於單一帳號，不能當作兩位組員的貢獻比例。</a:t>
             </a:r>
             <a:endParaRPr/>
           </a:p>
@@ -1243,7 +1243,7 @@
           <a:lstStyle xmlns:a="http://schemas.openxmlformats.org/drawingml/2006/main"/>
           <a:p xmlns:a="http://schemas.openxmlformats.org/drawingml/2006/main">
             <a:r>
-              <a:t>【陳威帆｜105 秒】總結三點：一、四平台到問答與報告形成完整研究流程；二、RAG與分數規則已可說明，後端493項、前端43項自動化測試通過；三、尚未把品質驗證說成全部完成。下一步依序補Linux部署回歸、建立人工標註和檢索題組、辨識業配，再與實際使用者訪談試用。營運上，實測重算後4個專業版帳號可打平雲端支出，算入人力則需12到21個。與通用代理的差異需要同題實測，現階段著重長期資料、來源回查與持續監測。原第16頁測試頁已刪除，主講約13分55秒，可在Demo或此頁多說約35秒。</a:t>
+              <a:t>【陳威帆｜105 秒】總結三點：一、四平台到問答與報告形成完整研究流程；二、RAG與分數規則已可說明，後端498項、前端43項自動化測試通過；三、尚未把品質驗證說成全部完成。下一步依序補Linux部署回歸、建立人工標註和檢索題組、辨識業配，再與實際使用者訪談試用。營運上，實測重算後4個專業版帳號可打平雲端支出，算入人力則需12到21個。與通用代理的差異需要同題實測，現階段著重長期資料、來源回查與持續監測。原第16頁測試頁已刪除，主講約13分55秒，可在Demo或此頁多說約35秒。</a:t>
             </a:r>
             <a:endParaRPr/>
           </a:p>
@@ -2090,7 +2090,7 @@
           <a:lstStyle xmlns:a="http://schemas.openxmlformats.org/drawingml/2006/main"/>
           <a:p xmlns:a="http://schemas.openxmlformats.org/drawingml/2006/main">
             <a:r>
-              <a:t>【陳威帆｜45 秒】初評說我們沒有量化，這頁用實測重算，不再沿用原稿的假設單價。一次 AI 問答：用系統程式組出真實 prompt，最多約 9 千 token 輸入、2 千 token 輸出，以 Gemini 2.5 Flash-Lite 官方價每百萬 0.10／0.40 美元計算，約 0.06 元，原稿假設 0.33 元高估了五倍。專業版用戶每月 100 次問答、60 次洞察，加上 3% 金流手續費，變動成本約 27 元。固定支出以 render.yaml 的雲端部署計：主機 25 美元、資料庫 19 美元，加網域與每日判讀約 1,450 元。收入 490N、支出 1,450＋27N，4 個帳號就能打平，每月餘 402 元。但這還沒算人力，算進去要 12 到 21 個帳號，見附錄 C；每個數字的出處在附錄 F。</a:t>
+              <a:t>【陳威帆｜45 秒】初評說我們沒有量化，這頁用實測重算，不再沿用原稿的假設單價。一次 AI 問答包含問題解析與依證據回答兩次呼叫，用系統程式組出真實 prompt，最多約 9,800 token 輸入、2,150 token 輸出，以 Gemini 2.5 Flash-Lite 官方價每百萬 0.10／0.40 美元計算，約 0.06 元，原稿假設 0.33 元高估了五倍。專業版用戶每月 100 次問答、60 次洞察，加上 3% 金流手續費，變動成本約 27 元。固定支出以 render.yaml 的雲端部署計：主機 25 美元、資料庫 19 美元，加網域與每日判讀約 1,450 元。收入 490N、支出 1,450＋27N，4 個帳號就能打平，每月餘 402 元。但這還沒算人力，算進去要 12 到 21 個帳號，見附錄 C；每個數字的出處在附錄 F。</a:t>
             </a:r>
             <a:endParaRPr/>
           </a:p>
@@ -3223,7 +3223,7 @@
                 <a:ea typeface="Microsoft JhengHei"/>
                 <a:cs typeface="Microsoft JhengHei"/>
               </a:rPr>
-              <a:t>GitHub 每月提交（共 164 次）</a:t>
+              <a:t>GitHub 每月提交（共 166 次）</a:t>
             </a:r>
           </a:p>
         </c:rich>
@@ -3317,7 +3317,7 @@
                   <c:v>47</c:v>
                 </c:pt>
                 <c:pt idx="5">
-                  <c:v>34</c:v>
+                  <c:v>36</c:v>
                 </c:pt>
               </c:numCache>
             </c:numRef>
@@ -12189,7 +12189,7 @@
                 <a:ea typeface="Microsoft JhengHei"/>
                 <a:cs typeface="Microsoft JhengHei"/>
               </a:rPr>
-              <a:t>情緒一致性、預警權限修正</a:t>
+              <a:t>情緒一致性、預警與問答修正</a:t>
             </a:r>
             <a:endParaRPr sz="1400"/>
           </a:p>
@@ -12274,7 +12274,7 @@
                 <a:ea typeface="Microsoft JhengHei"/>
                 <a:cs typeface="Microsoft JhengHei"/>
               </a:rPr>
-              <a:t>GitHub：7–10 月 150 次提交（10/12 統計，皆已推送）；非逐人貢獻比例。</a:t>
+              <a:t>GitHub：7–10 月 152 次提交（10/12 統計，皆已推送）；非逐人貢獻比例。</a:t>
             </a:r>
             <a:endParaRPr sz="1400"/>
           </a:p>
@@ -19593,7 +19593,7 @@
                             <a:srgbClr val="14243A"/>
                           </a:solidFill>
                         </a:rPr>
-                        <a:t>輸入 8,963＋輸出 2,150 token ≈ 0.06 元</a:t>
+                        <a:t>兩次呼叫：輸入 9,794＋輸出 2,150 ≈ 0.06 元</a:t>
                       </a:r>
                     </a:p>
                   </a:txBody>

</xml_diff>

<commit_message>
Turn slide 7 into a cost breakdown with formulas and a break-even table
The three summary cards and the line chart are replaced by an itemised
cost table (fixed vs per-account costs, each with its formula), the
revenue and cost equations, and a revenue/cost/profit table for 0-10 pro
accounts with the break-even row highlighted.

Co-Authored-By: Claude Opus 5.5 <noreply@anthropic.com>
</commit_message>
<xml_diff>
--- a/output/ppt-review-20261011/final/MeBOD_複審簡報_第二輪修訂版.pptx
+++ b/output/ppt-review-20261011/final/MeBOD_複審簡報_第二輪修訂版.pptx
@@ -27905,860 +27905,2864 @@
           </a:p>
         </p:txBody>
       </p:sp>
-      <p:sp>
-        <p:nvSpPr>
-          <p:cNvPr id="6" name="Shape 4">
-            <a:extLst>
-              <a:ext uri="{FF2B5EF4-FFF2-40B4-BE49-F238E27FC236}">
-                <a16:creationId xmlns:a16="http://schemas.microsoft.com/office/drawing/2014/main" id="{02ABE0FF-C9C7-43A7-B316-AB3805180185}"/>
-              </a:ext>
-            </a:extLst>
-          </p:cNvPr>
-          <p:cNvSpPr>
-            <a:spLocks noGrp="1"/>
-          </p:cNvSpPr>
-          <p:nvPr/>
-        </p:nvSpPr>
-        <p:spPr>
-          <a:xfrm>
-            <a:off x="731520" y="1783080"/>
-            <a:ext cx="2560320" cy="1965960"/>
-          </a:xfrm>
-          <a:prstGeom prst="roundRect">
-            <a:avLst>
-              <a:gd name="adj" fmla="val 7442"/>
-            </a:avLst>
-          </a:prstGeom>
-          <a:solidFill>
-            <a:srgbClr val="FFFFFF"/>
-          </a:solidFill>
-          <a:ln w="12700">
-            <a:solidFill>
-              <a:srgbClr val="D3DEEA"/>
-            </a:solidFill>
-            <a:prstDash val="solid"/>
-          </a:ln>
-        </p:spPr>
-        <p:txBody>
-          <a:bodyPr/>
-          <a:lstStyle/>
-          <a:p>
-            <a:endParaRPr/>
-          </a:p>
-        </p:txBody>
-      </p:sp>
-      <p:sp>
-        <p:nvSpPr>
-          <p:cNvPr id="7" name="Text 5">
-            <a:extLst>
-              <a:ext uri="{FF2B5EF4-FFF2-40B4-BE49-F238E27FC236}">
-                <a16:creationId xmlns:a16="http://schemas.microsoft.com/office/drawing/2014/main" id="{985A3F5F-CAC5-40D7-A02D-39DBD2B4ABE9}"/>
-              </a:ext>
-            </a:extLst>
-          </p:cNvPr>
-          <p:cNvSpPr>
-            <a:spLocks noGrp="1"/>
-          </p:cNvSpPr>
-          <p:nvPr/>
-        </p:nvSpPr>
-        <p:spPr>
-          <a:xfrm>
-            <a:off x="822960" y="2057400"/>
-            <a:ext cx="2377440" cy="777240"/>
+      <p:graphicFrame>
+        <p:nvGraphicFramePr>
+          <p:cNvPr id="30" name="Cost Table"/>
+          <p:cNvGraphicFramePr>
+            <a:graphicFrameLocks noGrp="1"/>
+          </p:cNvGraphicFramePr>
+          <p:nvPr/>
+        </p:nvGraphicFramePr>
+        <p:xfrm>
+          <a:off x="731520" y="1627632"/>
+          <a:ext cx="6492240" cy="3470148"/>
+        </p:xfrm>
+        <a:graphic>
+          <a:graphicData uri="http://schemas.openxmlformats.org/drawingml/2006/table">
+            <a:tbl>
+              <a:tblPr/>
+              <a:tblGrid>
+                <a:gridCol w="1965960"/>
+                <a:gridCol w="3429000"/>
+                <a:gridCol w="1097280"/>
+              </a:tblGrid>
+              <a:tr h="315468">
+                <a:tc>
+                  <a:txBody>
+                    <a:bodyPr wrap="square"/>
+                    <a:lstStyle/>
+                    <a:p>
+                      <a:pPr algn="l"/>
+                      <a:r>
+                        <a:rPr sz="1300" b="1">
+                          <a:solidFill>
+                            <a:srgbClr val="2073BE"/>
+                          </a:solidFill>
+                          <a:latin typeface="Microsoft JhengHei"/>
+                          <a:ea typeface="Microsoft JhengHei"/>
+                          <a:cs typeface="Microsoft JhengHei"/>
+                        </a:rPr>
+                        <a:t>項目</a:t>
+                      </a:r>
+                    </a:p>
+                  </a:txBody>
+                  <a:tcPr anchor="ctr" marL="91440" marR="91440" marT="18288" marB="18288">
+                    <a:lnL w="9525">
+                      <a:solidFill>
+                        <a:srgbClr val="D3DEEA"/>
+                      </a:solidFill>
+                    </a:lnL>
+                    <a:lnR w="9525">
+                      <a:solidFill>
+                        <a:srgbClr val="D3DEEA"/>
+                      </a:solidFill>
+                    </a:lnR>
+                    <a:lnT w="9525">
+                      <a:solidFill>
+                        <a:srgbClr val="D3DEEA"/>
+                      </a:solidFill>
+                    </a:lnT>
+                    <a:lnB w="9525">
+                      <a:solidFill>
+                        <a:srgbClr val="D3DEEA"/>
+                      </a:solidFill>
+                    </a:lnB>
+                    <a:solidFill>
+                      <a:srgbClr val="E2EEFA"/>
+                    </a:solidFill>
+                  </a:tcPr>
+                </a:tc>
+                <a:tc>
+                  <a:txBody>
+                    <a:bodyPr wrap="square"/>
+                    <a:lstStyle/>
+                    <a:p>
+                      <a:pPr algn="l"/>
+                      <a:r>
+                        <a:rPr sz="1300" b="1">
+                          <a:solidFill>
+                            <a:srgbClr val="2073BE"/>
+                          </a:solidFill>
+                          <a:latin typeface="Microsoft JhengHei"/>
+                          <a:ea typeface="Microsoft JhengHei"/>
+                          <a:cs typeface="Microsoft JhengHei"/>
+                        </a:rPr>
+                        <a:t>計算式</a:t>
+                      </a:r>
+                    </a:p>
+                  </a:txBody>
+                  <a:tcPr anchor="ctr" marL="91440" marR="91440" marT="18288" marB="18288">
+                    <a:lnL w="9525">
+                      <a:solidFill>
+                        <a:srgbClr val="D3DEEA"/>
+                      </a:solidFill>
+                    </a:lnL>
+                    <a:lnR w="9525">
+                      <a:solidFill>
+                        <a:srgbClr val="D3DEEA"/>
+                      </a:solidFill>
+                    </a:lnR>
+                    <a:lnT w="9525">
+                      <a:solidFill>
+                        <a:srgbClr val="D3DEEA"/>
+                      </a:solidFill>
+                    </a:lnT>
+                    <a:lnB w="9525">
+                      <a:solidFill>
+                        <a:srgbClr val="D3DEEA"/>
+                      </a:solidFill>
+                    </a:lnB>
+                    <a:solidFill>
+                      <a:srgbClr val="E2EEFA"/>
+                    </a:solidFill>
+                  </a:tcPr>
+                </a:tc>
+                <a:tc>
+                  <a:txBody>
+                    <a:bodyPr wrap="square"/>
+                    <a:lstStyle/>
+                    <a:p>
+                      <a:pPr algn="r"/>
+                      <a:r>
+                        <a:rPr sz="1300" b="1">
+                          <a:solidFill>
+                            <a:srgbClr val="2073BE"/>
+                          </a:solidFill>
+                          <a:latin typeface="Microsoft JhengHei"/>
+                          <a:ea typeface="Microsoft JhengHei"/>
+                          <a:cs typeface="Microsoft JhengHei"/>
+                        </a:rPr>
+                        <a:t>元／月</a:t>
+                      </a:r>
+                    </a:p>
+                  </a:txBody>
+                  <a:tcPr anchor="ctr" marL="91440" marR="91440" marT="18288" marB="18288">
+                    <a:lnL w="9525">
+                      <a:solidFill>
+                        <a:srgbClr val="D3DEEA"/>
+                      </a:solidFill>
+                    </a:lnL>
+                    <a:lnR w="9525">
+                      <a:solidFill>
+                        <a:srgbClr val="D3DEEA"/>
+                      </a:solidFill>
+                    </a:lnR>
+                    <a:lnT w="9525">
+                      <a:solidFill>
+                        <a:srgbClr val="D3DEEA"/>
+                      </a:solidFill>
+                    </a:lnT>
+                    <a:lnB w="9525">
+                      <a:solidFill>
+                        <a:srgbClr val="D3DEEA"/>
+                      </a:solidFill>
+                    </a:lnB>
+                    <a:solidFill>
+                      <a:srgbClr val="E2EEFA"/>
+                    </a:solidFill>
+                  </a:tcPr>
+                </a:tc>
+              </a:tr>
+              <a:tr h="315468">
+                <a:tc gridSpan="3">
+                  <a:txBody>
+                    <a:bodyPr wrap="square"/>
+                    <a:lstStyle/>
+                    <a:p>
+                      <a:pPr algn="l"/>
+                      <a:r>
+                        <a:rPr sz="1200" b="1">
+                          <a:solidFill>
+                            <a:srgbClr val="3F546C"/>
+                          </a:solidFill>
+                          <a:latin typeface="Microsoft JhengHei"/>
+                          <a:ea typeface="Microsoft JhengHei"/>
+                          <a:cs typeface="Microsoft JhengHei"/>
+                        </a:rPr>
+                        <a:t>固定支出 F：每月都要付，與帳號數無關</a:t>
+                      </a:r>
+                    </a:p>
+                  </a:txBody>
+                  <a:tcPr anchor="ctr" marL="91440" marR="91440" marT="18288" marB="18288">
+                    <a:lnL w="9525">
+                      <a:solidFill>
+                        <a:srgbClr val="D3DEEA"/>
+                      </a:solidFill>
+                    </a:lnL>
+                    <a:lnR w="9525">
+                      <a:solidFill>
+                        <a:srgbClr val="D3DEEA"/>
+                      </a:solidFill>
+                    </a:lnR>
+                    <a:lnT w="9525">
+                      <a:solidFill>
+                        <a:srgbClr val="D3DEEA"/>
+                      </a:solidFill>
+                    </a:lnT>
+                    <a:lnB w="9525">
+                      <a:solidFill>
+                        <a:srgbClr val="D3DEEA"/>
+                      </a:solidFill>
+                    </a:lnB>
+                    <a:solidFill>
+                      <a:srgbClr val="EEF4FB"/>
+                    </a:solidFill>
+                  </a:tcPr>
+                </a:tc>
+                <a:tc hMerge="1">
+                  <a:txBody>
+                    <a:bodyPr/>
+                    <a:lstStyle/>
+                    <a:p/>
+                  </a:txBody>
+                  <a:tcPr/>
+                </a:tc>
+                <a:tc hMerge="1">
+                  <a:txBody>
+                    <a:bodyPr/>
+                    <a:lstStyle/>
+                    <a:p/>
+                  </a:txBody>
+                  <a:tcPr/>
+                </a:tc>
+              </a:tr>
+              <a:tr h="315468">
+                <a:tc>
+                  <a:txBody>
+                    <a:bodyPr wrap="square"/>
+                    <a:lstStyle/>
+                    <a:p>
+                      <a:pPr algn="l"/>
+                      <a:r>
+                        <a:rPr sz="1200" b="0">
+                          <a:solidFill>
+                            <a:srgbClr val="14243A"/>
+                          </a:solidFill>
+                          <a:latin typeface="Microsoft JhengHei"/>
+                          <a:ea typeface="Microsoft JhengHei"/>
+                          <a:cs typeface="Microsoft JhengHei"/>
+                        </a:rPr>
+                        <a:t>雲端主機＋資料庫</a:t>
+                      </a:r>
+                    </a:p>
+                  </a:txBody>
+                  <a:tcPr anchor="ctr" marL="91440" marR="91440" marT="18288" marB="18288">
+                    <a:lnL w="9525">
+                      <a:solidFill>
+                        <a:srgbClr val="D3DEEA"/>
+                      </a:solidFill>
+                    </a:lnL>
+                    <a:lnR w="9525">
+                      <a:solidFill>
+                        <a:srgbClr val="D3DEEA"/>
+                      </a:solidFill>
+                    </a:lnR>
+                    <a:lnT w="9525">
+                      <a:solidFill>
+                        <a:srgbClr val="D3DEEA"/>
+                      </a:solidFill>
+                    </a:lnT>
+                    <a:lnB w="9525">
+                      <a:solidFill>
+                        <a:srgbClr val="D3DEEA"/>
+                      </a:solidFill>
+                    </a:lnB>
+                    <a:solidFill>
+                      <a:srgbClr val="FFFFFF"/>
+                    </a:solidFill>
+                  </a:tcPr>
+                </a:tc>
+                <a:tc>
+                  <a:txBody>
+                    <a:bodyPr wrap="square"/>
+                    <a:lstStyle/>
+                    <a:p>
+                      <a:pPr algn="l"/>
+                      <a:r>
+                        <a:rPr sz="1200" b="0">
+                          <a:solidFill>
+                            <a:srgbClr val="3F546C"/>
+                          </a:solidFill>
+                          <a:latin typeface="Microsoft JhengHei"/>
+                          <a:ea typeface="Microsoft JhengHei"/>
+                          <a:cs typeface="Microsoft JhengHei"/>
+                        </a:rPr>
+                        <a:t>（US$25＋US$19）× 匯率 32</a:t>
+                      </a:r>
+                    </a:p>
+                  </a:txBody>
+                  <a:tcPr anchor="ctr" marL="91440" marR="91440" marT="18288" marB="18288">
+                    <a:lnL w="9525">
+                      <a:solidFill>
+                        <a:srgbClr val="D3DEEA"/>
+                      </a:solidFill>
+                    </a:lnL>
+                    <a:lnR w="9525">
+                      <a:solidFill>
+                        <a:srgbClr val="D3DEEA"/>
+                      </a:solidFill>
+                    </a:lnR>
+                    <a:lnT w="9525">
+                      <a:solidFill>
+                        <a:srgbClr val="D3DEEA"/>
+                      </a:solidFill>
+                    </a:lnT>
+                    <a:lnB w="9525">
+                      <a:solidFill>
+                        <a:srgbClr val="D3DEEA"/>
+                      </a:solidFill>
+                    </a:lnB>
+                    <a:solidFill>
+                      <a:srgbClr val="FFFFFF"/>
+                    </a:solidFill>
+                  </a:tcPr>
+                </a:tc>
+                <a:tc>
+                  <a:txBody>
+                    <a:bodyPr wrap="square"/>
+                    <a:lstStyle/>
+                    <a:p>
+                      <a:pPr algn="r"/>
+                      <a:r>
+                        <a:rPr sz="1200" b="1">
+                          <a:solidFill>
+                            <a:srgbClr val="14243A"/>
+                          </a:solidFill>
+                          <a:latin typeface="Microsoft JhengHei"/>
+                          <a:ea typeface="Microsoft JhengHei"/>
+                          <a:cs typeface="Microsoft JhengHei"/>
+                        </a:rPr>
+                        <a:t>1,408</a:t>
+                      </a:r>
+                    </a:p>
+                  </a:txBody>
+                  <a:tcPr anchor="ctr" marL="91440" marR="91440" marT="18288" marB="18288">
+                    <a:lnL w="9525">
+                      <a:solidFill>
+                        <a:srgbClr val="D3DEEA"/>
+                      </a:solidFill>
+                    </a:lnL>
+                    <a:lnR w="9525">
+                      <a:solidFill>
+                        <a:srgbClr val="D3DEEA"/>
+                      </a:solidFill>
+                    </a:lnR>
+                    <a:lnT w="9525">
+                      <a:solidFill>
+                        <a:srgbClr val="D3DEEA"/>
+                      </a:solidFill>
+                    </a:lnT>
+                    <a:lnB w="9525">
+                      <a:solidFill>
+                        <a:srgbClr val="D3DEEA"/>
+                      </a:solidFill>
+                    </a:lnB>
+                    <a:solidFill>
+                      <a:srgbClr val="FFFFFF"/>
+                    </a:solidFill>
+                  </a:tcPr>
+                </a:tc>
+              </a:tr>
+              <a:tr h="315468">
+                <a:tc>
+                  <a:txBody>
+                    <a:bodyPr wrap="square"/>
+                    <a:lstStyle/>
+                    <a:p>
+                      <a:pPr algn="l"/>
+                      <a:r>
+                        <a:rPr sz="1200" b="0">
+                          <a:solidFill>
+                            <a:srgbClr val="14243A"/>
+                          </a:solidFill>
+                          <a:latin typeface="Microsoft JhengHei"/>
+                          <a:ea typeface="Microsoft JhengHei"/>
+                          <a:cs typeface="Microsoft JhengHei"/>
+                        </a:rPr>
+                        <a:t>網域</a:t>
+                      </a:r>
+                    </a:p>
+                  </a:txBody>
+                  <a:tcPr anchor="ctr" marL="91440" marR="91440" marT="18288" marB="18288">
+                    <a:lnL w="9525">
+                      <a:solidFill>
+                        <a:srgbClr val="D3DEEA"/>
+                      </a:solidFill>
+                    </a:lnL>
+                    <a:lnR w="9525">
+                      <a:solidFill>
+                        <a:srgbClr val="D3DEEA"/>
+                      </a:solidFill>
+                    </a:lnR>
+                    <a:lnT w="9525">
+                      <a:solidFill>
+                        <a:srgbClr val="D3DEEA"/>
+                      </a:solidFill>
+                    </a:lnT>
+                    <a:lnB w="9525">
+                      <a:solidFill>
+                        <a:srgbClr val="D3DEEA"/>
+                      </a:solidFill>
+                    </a:lnB>
+                    <a:solidFill>
+                      <a:srgbClr val="F3F7FC"/>
+                    </a:solidFill>
+                  </a:tcPr>
+                </a:tc>
+                <a:tc>
+                  <a:txBody>
+                    <a:bodyPr wrap="square"/>
+                    <a:lstStyle/>
+                    <a:p>
+                      <a:pPr algn="l"/>
+                      <a:r>
+                        <a:rPr sz="1200" b="0">
+                          <a:solidFill>
+                            <a:srgbClr val="3F546C"/>
+                          </a:solidFill>
+                          <a:latin typeface="Microsoft JhengHei"/>
+                          <a:ea typeface="Microsoft JhengHei"/>
+                          <a:cs typeface="Microsoft JhengHei"/>
+                        </a:rPr>
+                        <a:t>年費 420 ÷ 12 個月</a:t>
+                      </a:r>
+                    </a:p>
+                  </a:txBody>
+                  <a:tcPr anchor="ctr" marL="91440" marR="91440" marT="18288" marB="18288">
+                    <a:lnL w="9525">
+                      <a:solidFill>
+                        <a:srgbClr val="D3DEEA"/>
+                      </a:solidFill>
+                    </a:lnL>
+                    <a:lnR w="9525">
+                      <a:solidFill>
+                        <a:srgbClr val="D3DEEA"/>
+                      </a:solidFill>
+                    </a:lnR>
+                    <a:lnT w="9525">
+                      <a:solidFill>
+                        <a:srgbClr val="D3DEEA"/>
+                      </a:solidFill>
+                    </a:lnT>
+                    <a:lnB w="9525">
+                      <a:solidFill>
+                        <a:srgbClr val="D3DEEA"/>
+                      </a:solidFill>
+                    </a:lnB>
+                    <a:solidFill>
+                      <a:srgbClr val="F3F7FC"/>
+                    </a:solidFill>
+                  </a:tcPr>
+                </a:tc>
+                <a:tc>
+                  <a:txBody>
+                    <a:bodyPr wrap="square"/>
+                    <a:lstStyle/>
+                    <a:p>
+                      <a:pPr algn="r"/>
+                      <a:r>
+                        <a:rPr sz="1200" b="1">
+                          <a:solidFill>
+                            <a:srgbClr val="14243A"/>
+                          </a:solidFill>
+                          <a:latin typeface="Microsoft JhengHei"/>
+                          <a:ea typeface="Microsoft JhengHei"/>
+                          <a:cs typeface="Microsoft JhengHei"/>
+                        </a:rPr>
+                        <a:t>35</a:t>
+                      </a:r>
+                    </a:p>
+                  </a:txBody>
+                  <a:tcPr anchor="ctr" marL="91440" marR="91440" marT="18288" marB="18288">
+                    <a:lnL w="9525">
+                      <a:solidFill>
+                        <a:srgbClr val="D3DEEA"/>
+                      </a:solidFill>
+                    </a:lnL>
+                    <a:lnR w="9525">
+                      <a:solidFill>
+                        <a:srgbClr val="D3DEEA"/>
+                      </a:solidFill>
+                    </a:lnR>
+                    <a:lnT w="9525">
+                      <a:solidFill>
+                        <a:srgbClr val="D3DEEA"/>
+                      </a:solidFill>
+                    </a:lnT>
+                    <a:lnB w="9525">
+                      <a:solidFill>
+                        <a:srgbClr val="D3DEEA"/>
+                      </a:solidFill>
+                    </a:lnB>
+                    <a:solidFill>
+                      <a:srgbClr val="F3F7FC"/>
+                    </a:solidFill>
+                  </a:tcPr>
+                </a:tc>
+              </a:tr>
+              <a:tr h="315468">
+                <a:tc>
+                  <a:txBody>
+                    <a:bodyPr wrap="square"/>
+                    <a:lstStyle/>
+                    <a:p>
+                      <a:pPr algn="l"/>
+                      <a:r>
+                        <a:rPr sz="1200" b="0">
+                          <a:solidFill>
+                            <a:srgbClr val="14243A"/>
+                          </a:solidFill>
+                          <a:latin typeface="Microsoft JhengHei"/>
+                          <a:ea typeface="Microsoft JhengHei"/>
+                          <a:cs typeface="Microsoft JhengHei"/>
+                        </a:rPr>
+                        <a:t>情緒判讀＋向量</a:t>
+                      </a:r>
+                    </a:p>
+                  </a:txBody>
+                  <a:tcPr anchor="ctr" marL="91440" marR="91440" marT="18288" marB="18288">
+                    <a:lnL w="9525">
+                      <a:solidFill>
+                        <a:srgbClr val="D3DEEA"/>
+                      </a:solidFill>
+                    </a:lnL>
+                    <a:lnR w="9525">
+                      <a:solidFill>
+                        <a:srgbClr val="D3DEEA"/>
+                      </a:solidFill>
+                    </a:lnR>
+                    <a:lnT w="9525">
+                      <a:solidFill>
+                        <a:srgbClr val="D3DEEA"/>
+                      </a:solidFill>
+                    </a:lnT>
+                    <a:lnB w="9525">
+                      <a:solidFill>
+                        <a:srgbClr val="D3DEEA"/>
+                      </a:solidFill>
+                    </a:lnB>
+                    <a:solidFill>
+                      <a:srgbClr val="FFFFFF"/>
+                    </a:solidFill>
+                  </a:tcPr>
+                </a:tc>
+                <a:tc>
+                  <a:txBody>
+                    <a:bodyPr wrap="square"/>
+                    <a:lstStyle/>
+                    <a:p>
+                      <a:pPr algn="l"/>
+                      <a:r>
+                        <a:rPr sz="1200" b="0">
+                          <a:solidFill>
+                            <a:srgbClr val="3F546C"/>
+                          </a:solidFill>
+                          <a:latin typeface="Microsoft JhengHei"/>
+                          <a:ea typeface="Microsoft JhengHei"/>
+                          <a:cs typeface="Microsoft JhengHei"/>
+                        </a:rPr>
+                        <a:t>近 30 天 897 篇＋3,216 則留言</a:t>
+                      </a:r>
+                    </a:p>
+                  </a:txBody>
+                  <a:tcPr anchor="ctr" marL="91440" marR="91440" marT="18288" marB="18288">
+                    <a:lnL w="9525">
+                      <a:solidFill>
+                        <a:srgbClr val="D3DEEA"/>
+                      </a:solidFill>
+                    </a:lnL>
+                    <a:lnR w="9525">
+                      <a:solidFill>
+                        <a:srgbClr val="D3DEEA"/>
+                      </a:solidFill>
+                    </a:lnR>
+                    <a:lnT w="9525">
+                      <a:solidFill>
+                        <a:srgbClr val="D3DEEA"/>
+                      </a:solidFill>
+                    </a:lnT>
+                    <a:lnB w="9525">
+                      <a:solidFill>
+                        <a:srgbClr val="D3DEEA"/>
+                      </a:solidFill>
+                    </a:lnB>
+                    <a:solidFill>
+                      <a:srgbClr val="FFFFFF"/>
+                    </a:solidFill>
+                  </a:tcPr>
+                </a:tc>
+                <a:tc>
+                  <a:txBody>
+                    <a:bodyPr wrap="square"/>
+                    <a:lstStyle/>
+                    <a:p>
+                      <a:pPr algn="r"/>
+                      <a:r>
+                        <a:rPr sz="1200" b="1">
+                          <a:solidFill>
+                            <a:srgbClr val="14243A"/>
+                          </a:solidFill>
+                          <a:latin typeface="Microsoft JhengHei"/>
+                          <a:ea typeface="Microsoft JhengHei"/>
+                          <a:cs typeface="Microsoft JhengHei"/>
+                        </a:rPr>
+                        <a:t>13</a:t>
+                      </a:r>
+                    </a:p>
+                  </a:txBody>
+                  <a:tcPr anchor="ctr" marL="91440" marR="91440" marT="18288" marB="18288">
+                    <a:lnL w="9525">
+                      <a:solidFill>
+                        <a:srgbClr val="D3DEEA"/>
+                      </a:solidFill>
+                    </a:lnL>
+                    <a:lnR w="9525">
+                      <a:solidFill>
+                        <a:srgbClr val="D3DEEA"/>
+                      </a:solidFill>
+                    </a:lnR>
+                    <a:lnT w="9525">
+                      <a:solidFill>
+                        <a:srgbClr val="D3DEEA"/>
+                      </a:solidFill>
+                    </a:lnT>
+                    <a:lnB w="9525">
+                      <a:solidFill>
+                        <a:srgbClr val="D3DEEA"/>
+                      </a:solidFill>
+                    </a:lnB>
+                    <a:solidFill>
+                      <a:srgbClr val="FFFFFF"/>
+                    </a:solidFill>
+                  </a:tcPr>
+                </a:tc>
+              </a:tr>
+              <a:tr h="315468">
+                <a:tc>
+                  <a:txBody>
+                    <a:bodyPr wrap="square"/>
+                    <a:lstStyle/>
+                    <a:p>
+                      <a:pPr algn="l"/>
+                      <a:r>
+                        <a:rPr sz="1300" b="1">
+                          <a:solidFill>
+                            <a:srgbClr val="D46A12"/>
+                          </a:solidFill>
+                          <a:latin typeface="Microsoft JhengHei"/>
+                          <a:ea typeface="Microsoft JhengHei"/>
+                          <a:cs typeface="Microsoft JhengHei"/>
+                        </a:rPr>
+                        <a:t>固定支出 F</a:t>
+                      </a:r>
+                    </a:p>
+                  </a:txBody>
+                  <a:tcPr anchor="ctr" marL="91440" marR="91440" marT="18288" marB="18288">
+                    <a:lnL w="9525">
+                      <a:solidFill>
+                        <a:srgbClr val="D3DEEA"/>
+                      </a:solidFill>
+                    </a:lnL>
+                    <a:lnR w="9525">
+                      <a:solidFill>
+                        <a:srgbClr val="D3DEEA"/>
+                      </a:solidFill>
+                    </a:lnR>
+                    <a:lnT w="9525">
+                      <a:solidFill>
+                        <a:srgbClr val="D3DEEA"/>
+                      </a:solidFill>
+                    </a:lnT>
+                    <a:lnB w="9525">
+                      <a:solidFill>
+                        <a:srgbClr val="D3DEEA"/>
+                      </a:solidFill>
+                    </a:lnB>
+                    <a:solidFill>
+                      <a:srgbClr val="FDEEDF"/>
+                    </a:solidFill>
+                  </a:tcPr>
+                </a:tc>
+                <a:tc>
+                  <a:txBody>
+                    <a:bodyPr wrap="square"/>
+                    <a:lstStyle/>
+                    <a:p>
+                      <a:pPr algn="l"/>
+                      <a:r>
+                        <a:rPr sz="1200" b="0">
+                          <a:solidFill>
+                            <a:srgbClr val="3F546C"/>
+                          </a:solidFill>
+                          <a:latin typeface="Microsoft JhengHei"/>
+                          <a:ea typeface="Microsoft JhengHei"/>
+                          <a:cs typeface="Microsoft JhengHei"/>
+                        </a:rPr>
+                        <a:t>以上三項合計</a:t>
+                      </a:r>
+                    </a:p>
+                  </a:txBody>
+                  <a:tcPr anchor="ctr" marL="91440" marR="91440" marT="18288" marB="18288">
+                    <a:lnL w="9525">
+                      <a:solidFill>
+                        <a:srgbClr val="D3DEEA"/>
+                      </a:solidFill>
+                    </a:lnL>
+                    <a:lnR w="9525">
+                      <a:solidFill>
+                        <a:srgbClr val="D3DEEA"/>
+                      </a:solidFill>
+                    </a:lnR>
+                    <a:lnT w="9525">
+                      <a:solidFill>
+                        <a:srgbClr val="D3DEEA"/>
+                      </a:solidFill>
+                    </a:lnT>
+                    <a:lnB w="9525">
+                      <a:solidFill>
+                        <a:srgbClr val="D3DEEA"/>
+                      </a:solidFill>
+                    </a:lnB>
+                    <a:solidFill>
+                      <a:srgbClr val="FDEEDF"/>
+                    </a:solidFill>
+                  </a:tcPr>
+                </a:tc>
+                <a:tc>
+                  <a:txBody>
+                    <a:bodyPr wrap="square"/>
+                    <a:lstStyle/>
+                    <a:p>
+                      <a:pPr algn="r"/>
+                      <a:r>
+                        <a:rPr sz="1400" b="1">
+                          <a:solidFill>
+                            <a:srgbClr val="D46A12"/>
+                          </a:solidFill>
+                          <a:latin typeface="Microsoft JhengHei"/>
+                          <a:ea typeface="Microsoft JhengHei"/>
+                          <a:cs typeface="Microsoft JhengHei"/>
+                        </a:rPr>
+                        <a:t>1,456</a:t>
+                      </a:r>
+                    </a:p>
+                  </a:txBody>
+                  <a:tcPr anchor="ctr" marL="91440" marR="91440" marT="18288" marB="18288">
+                    <a:lnL w="9525">
+                      <a:solidFill>
+                        <a:srgbClr val="D3DEEA"/>
+                      </a:solidFill>
+                    </a:lnL>
+                    <a:lnR w="9525">
+                      <a:solidFill>
+                        <a:srgbClr val="D3DEEA"/>
+                      </a:solidFill>
+                    </a:lnR>
+                    <a:lnT w="9525">
+                      <a:solidFill>
+                        <a:srgbClr val="D3DEEA"/>
+                      </a:solidFill>
+                    </a:lnT>
+                    <a:lnB w="9525">
+                      <a:solidFill>
+                        <a:srgbClr val="D3DEEA"/>
+                      </a:solidFill>
+                    </a:lnB>
+                    <a:solidFill>
+                      <a:srgbClr val="FDEEDF"/>
+                    </a:solidFill>
+                  </a:tcPr>
+                </a:tc>
+              </a:tr>
+              <a:tr h="315468">
+                <a:tc gridSpan="3">
+                  <a:txBody>
+                    <a:bodyPr wrap="square"/>
+                    <a:lstStyle/>
+                    <a:p>
+                      <a:pPr algn="l"/>
+                      <a:r>
+                        <a:rPr sz="1200" b="1">
+                          <a:solidFill>
+                            <a:srgbClr val="3F546C"/>
+                          </a:solidFill>
+                          <a:latin typeface="Microsoft JhengHei"/>
+                          <a:ea typeface="Microsoft JhengHei"/>
+                          <a:cs typeface="Microsoft JhengHei"/>
+                        </a:rPr>
+                        <a:t>變動成本 v：每多 1 位專業版用戶，每月增加</a:t>
+                      </a:r>
+                    </a:p>
+                  </a:txBody>
+                  <a:tcPr anchor="ctr" marL="91440" marR="91440" marT="18288" marB="18288">
+                    <a:lnL w="9525">
+                      <a:solidFill>
+                        <a:srgbClr val="D3DEEA"/>
+                      </a:solidFill>
+                    </a:lnL>
+                    <a:lnR w="9525">
+                      <a:solidFill>
+                        <a:srgbClr val="D3DEEA"/>
+                      </a:solidFill>
+                    </a:lnR>
+                    <a:lnT w="9525">
+                      <a:solidFill>
+                        <a:srgbClr val="D3DEEA"/>
+                      </a:solidFill>
+                    </a:lnT>
+                    <a:lnB w="9525">
+                      <a:solidFill>
+                        <a:srgbClr val="D3DEEA"/>
+                      </a:solidFill>
+                    </a:lnB>
+                    <a:solidFill>
+                      <a:srgbClr val="EEF4FB"/>
+                    </a:solidFill>
+                  </a:tcPr>
+                </a:tc>
+                <a:tc hMerge="1">
+                  <a:txBody>
+                    <a:bodyPr/>
+                    <a:lstStyle/>
+                    <a:p/>
+                  </a:txBody>
+                  <a:tcPr/>
+                </a:tc>
+                <a:tc hMerge="1">
+                  <a:txBody>
+                    <a:bodyPr/>
+                    <a:lstStyle/>
+                    <a:p/>
+                  </a:txBody>
+                  <a:tcPr/>
+                </a:tc>
+              </a:tr>
+              <a:tr h="315468">
+                <a:tc>
+                  <a:txBody>
+                    <a:bodyPr wrap="square"/>
+                    <a:lstStyle/>
+                    <a:p>
+                      <a:pPr algn="l"/>
+                      <a:r>
+                        <a:rPr sz="1200" b="0">
+                          <a:solidFill>
+                            <a:srgbClr val="14243A"/>
+                          </a:solidFill>
+                          <a:latin typeface="Microsoft JhengHei"/>
+                          <a:ea typeface="Microsoft JhengHei"/>
+                          <a:cs typeface="Microsoft JhengHei"/>
+                        </a:rPr>
+                        <a:t>AI 問答 100 次</a:t>
+                      </a:r>
+                    </a:p>
+                  </a:txBody>
+                  <a:tcPr anchor="ctr" marL="91440" marR="91440" marT="18288" marB="18288">
+                    <a:lnL w="9525">
+                      <a:solidFill>
+                        <a:srgbClr val="D3DEEA"/>
+                      </a:solidFill>
+                    </a:lnL>
+                    <a:lnR w="9525">
+                      <a:solidFill>
+                        <a:srgbClr val="D3DEEA"/>
+                      </a:solidFill>
+                    </a:lnR>
+                    <a:lnT w="9525">
+                      <a:solidFill>
+                        <a:srgbClr val="D3DEEA"/>
+                      </a:solidFill>
+                    </a:lnT>
+                    <a:lnB w="9525">
+                      <a:solidFill>
+                        <a:srgbClr val="D3DEEA"/>
+                      </a:solidFill>
+                    </a:lnB>
+                    <a:solidFill>
+                      <a:srgbClr val="FFFFFF"/>
+                    </a:solidFill>
+                  </a:tcPr>
+                </a:tc>
+                <a:tc>
+                  <a:txBody>
+                    <a:bodyPr wrap="square"/>
+                    <a:lstStyle/>
+                    <a:p>
+                      <a:pPr algn="l"/>
+                      <a:r>
+                        <a:rPr sz="1200" b="0">
+                          <a:solidFill>
+                            <a:srgbClr val="3F546C"/>
+                          </a:solidFill>
+                          <a:latin typeface="Microsoft JhengHei"/>
+                          <a:ea typeface="Microsoft JhengHei"/>
+                          <a:cs typeface="Microsoft JhengHei"/>
+                        </a:rPr>
+                        <a:t>100 × 0.18 元</a:t>
+                      </a:r>
+                    </a:p>
+                  </a:txBody>
+                  <a:tcPr anchor="ctr" marL="91440" marR="91440" marT="18288" marB="18288">
+                    <a:lnL w="9525">
+                      <a:solidFill>
+                        <a:srgbClr val="D3DEEA"/>
+                      </a:solidFill>
+                    </a:lnL>
+                    <a:lnR w="9525">
+                      <a:solidFill>
+                        <a:srgbClr val="D3DEEA"/>
+                      </a:solidFill>
+                    </a:lnR>
+                    <a:lnT w="9525">
+                      <a:solidFill>
+                        <a:srgbClr val="D3DEEA"/>
+                      </a:solidFill>
+                    </a:lnT>
+                    <a:lnB w="9525">
+                      <a:solidFill>
+                        <a:srgbClr val="D3DEEA"/>
+                      </a:solidFill>
+                    </a:lnB>
+                    <a:solidFill>
+                      <a:srgbClr val="FFFFFF"/>
+                    </a:solidFill>
+                  </a:tcPr>
+                </a:tc>
+                <a:tc>
+                  <a:txBody>
+                    <a:bodyPr wrap="square"/>
+                    <a:lstStyle/>
+                    <a:p>
+                      <a:pPr algn="r"/>
+                      <a:r>
+                        <a:rPr sz="1200" b="1">
+                          <a:solidFill>
+                            <a:srgbClr val="14243A"/>
+                          </a:solidFill>
+                          <a:latin typeface="Microsoft JhengHei"/>
+                          <a:ea typeface="Microsoft JhengHei"/>
+                          <a:cs typeface="Microsoft JhengHei"/>
+                        </a:rPr>
+                        <a:t>18</a:t>
+                      </a:r>
+                    </a:p>
+                  </a:txBody>
+                  <a:tcPr anchor="ctr" marL="91440" marR="91440" marT="18288" marB="18288">
+                    <a:lnL w="9525">
+                      <a:solidFill>
+                        <a:srgbClr val="D3DEEA"/>
+                      </a:solidFill>
+                    </a:lnL>
+                    <a:lnR w="9525">
+                      <a:solidFill>
+                        <a:srgbClr val="D3DEEA"/>
+                      </a:solidFill>
+                    </a:lnR>
+                    <a:lnT w="9525">
+                      <a:solidFill>
+                        <a:srgbClr val="D3DEEA"/>
+                      </a:solidFill>
+                    </a:lnT>
+                    <a:lnB w="9525">
+                      <a:solidFill>
+                        <a:srgbClr val="D3DEEA"/>
+                      </a:solidFill>
+                    </a:lnB>
+                    <a:solidFill>
+                      <a:srgbClr val="FFFFFF"/>
+                    </a:solidFill>
+                  </a:tcPr>
+                </a:tc>
+              </a:tr>
+              <a:tr h="315468">
+                <a:tc>
+                  <a:txBody>
+                    <a:bodyPr wrap="square"/>
+                    <a:lstStyle/>
+                    <a:p>
+                      <a:pPr algn="l"/>
+                      <a:r>
+                        <a:rPr sz="1200" b="0">
+                          <a:solidFill>
+                            <a:srgbClr val="14243A"/>
+                          </a:solidFill>
+                          <a:latin typeface="Microsoft JhengHei"/>
+                          <a:ea typeface="Microsoft JhengHei"/>
+                          <a:cs typeface="Microsoft JhengHei"/>
+                        </a:rPr>
+                        <a:t>儀表板洞察 60 次</a:t>
+                      </a:r>
+                    </a:p>
+                  </a:txBody>
+                  <a:tcPr anchor="ctr" marL="91440" marR="91440" marT="18288" marB="18288">
+                    <a:lnL w="9525">
+                      <a:solidFill>
+                        <a:srgbClr val="D3DEEA"/>
+                      </a:solidFill>
+                    </a:lnL>
+                    <a:lnR w="9525">
+                      <a:solidFill>
+                        <a:srgbClr val="D3DEEA"/>
+                      </a:solidFill>
+                    </a:lnR>
+                    <a:lnT w="9525">
+                      <a:solidFill>
+                        <a:srgbClr val="D3DEEA"/>
+                      </a:solidFill>
+                    </a:lnT>
+                    <a:lnB w="9525">
+                      <a:solidFill>
+                        <a:srgbClr val="D3DEEA"/>
+                      </a:solidFill>
+                    </a:lnB>
+                    <a:solidFill>
+                      <a:srgbClr val="F3F7FC"/>
+                    </a:solidFill>
+                  </a:tcPr>
+                </a:tc>
+                <a:tc>
+                  <a:txBody>
+                    <a:bodyPr wrap="square"/>
+                    <a:lstStyle/>
+                    <a:p>
+                      <a:pPr algn="l"/>
+                      <a:r>
+                        <a:rPr sz="1200" b="0">
+                          <a:solidFill>
+                            <a:srgbClr val="3F546C"/>
+                          </a:solidFill>
+                          <a:latin typeface="Microsoft JhengHei"/>
+                          <a:ea typeface="Microsoft JhengHei"/>
+                          <a:cs typeface="Microsoft JhengHei"/>
+                        </a:rPr>
+                        <a:t>60 × 0.33 元</a:t>
+                      </a:r>
+                    </a:p>
+                  </a:txBody>
+                  <a:tcPr anchor="ctr" marL="91440" marR="91440" marT="18288" marB="18288">
+                    <a:lnL w="9525">
+                      <a:solidFill>
+                        <a:srgbClr val="D3DEEA"/>
+                      </a:solidFill>
+                    </a:lnL>
+                    <a:lnR w="9525">
+                      <a:solidFill>
+                        <a:srgbClr val="D3DEEA"/>
+                      </a:solidFill>
+                    </a:lnR>
+                    <a:lnT w="9525">
+                      <a:solidFill>
+                        <a:srgbClr val="D3DEEA"/>
+                      </a:solidFill>
+                    </a:lnT>
+                    <a:lnB w="9525">
+                      <a:solidFill>
+                        <a:srgbClr val="D3DEEA"/>
+                      </a:solidFill>
+                    </a:lnB>
+                    <a:solidFill>
+                      <a:srgbClr val="F3F7FC"/>
+                    </a:solidFill>
+                  </a:tcPr>
+                </a:tc>
+                <a:tc>
+                  <a:txBody>
+                    <a:bodyPr wrap="square"/>
+                    <a:lstStyle/>
+                    <a:p>
+                      <a:pPr algn="r"/>
+                      <a:r>
+                        <a:rPr sz="1200" b="1">
+                          <a:solidFill>
+                            <a:srgbClr val="14243A"/>
+                          </a:solidFill>
+                          <a:latin typeface="Microsoft JhengHei"/>
+                          <a:ea typeface="Microsoft JhengHei"/>
+                          <a:cs typeface="Microsoft JhengHei"/>
+                        </a:rPr>
+                        <a:t>20</a:t>
+                      </a:r>
+                    </a:p>
+                  </a:txBody>
+                  <a:tcPr anchor="ctr" marL="91440" marR="91440" marT="18288" marB="18288">
+                    <a:lnL w="9525">
+                      <a:solidFill>
+                        <a:srgbClr val="D3DEEA"/>
+                      </a:solidFill>
+                    </a:lnL>
+                    <a:lnR w="9525">
+                      <a:solidFill>
+                        <a:srgbClr val="D3DEEA"/>
+                      </a:solidFill>
+                    </a:lnR>
+                    <a:lnT w="9525">
+                      <a:solidFill>
+                        <a:srgbClr val="D3DEEA"/>
+                      </a:solidFill>
+                    </a:lnT>
+                    <a:lnB w="9525">
+                      <a:solidFill>
+                        <a:srgbClr val="D3DEEA"/>
+                      </a:solidFill>
+                    </a:lnB>
+                    <a:solidFill>
+                      <a:srgbClr val="F3F7FC"/>
+                    </a:solidFill>
+                  </a:tcPr>
+                </a:tc>
+              </a:tr>
+              <a:tr h="315468">
+                <a:tc>
+                  <a:txBody>
+                    <a:bodyPr wrap="square"/>
+                    <a:lstStyle/>
+                    <a:p>
+                      <a:pPr algn="l"/>
+                      <a:r>
+                        <a:rPr sz="1200" b="0">
+                          <a:solidFill>
+                            <a:srgbClr val="14243A"/>
+                          </a:solidFill>
+                          <a:latin typeface="Microsoft JhengHei"/>
+                          <a:ea typeface="Microsoft JhengHei"/>
+                          <a:cs typeface="Microsoft JhengHei"/>
+                        </a:rPr>
+                        <a:t>金流手續費</a:t>
+                      </a:r>
+                    </a:p>
+                  </a:txBody>
+                  <a:tcPr anchor="ctr" marL="91440" marR="91440" marT="18288" marB="18288">
+                    <a:lnL w="9525">
+                      <a:solidFill>
+                        <a:srgbClr val="D3DEEA"/>
+                      </a:solidFill>
+                    </a:lnL>
+                    <a:lnR w="9525">
+                      <a:solidFill>
+                        <a:srgbClr val="D3DEEA"/>
+                      </a:solidFill>
+                    </a:lnR>
+                    <a:lnT w="9525">
+                      <a:solidFill>
+                        <a:srgbClr val="D3DEEA"/>
+                      </a:solidFill>
+                    </a:lnT>
+                    <a:lnB w="9525">
+                      <a:solidFill>
+                        <a:srgbClr val="D3DEEA"/>
+                      </a:solidFill>
+                    </a:lnB>
+                    <a:solidFill>
+                      <a:srgbClr val="FFFFFF"/>
+                    </a:solidFill>
+                  </a:tcPr>
+                </a:tc>
+                <a:tc>
+                  <a:txBody>
+                    <a:bodyPr wrap="square"/>
+                    <a:lstStyle/>
+                    <a:p>
+                      <a:pPr algn="l"/>
+                      <a:r>
+                        <a:rPr sz="1200" b="0">
+                          <a:solidFill>
+                            <a:srgbClr val="3F546C"/>
+                          </a:solidFill>
+                          <a:latin typeface="Microsoft JhengHei"/>
+                          <a:ea typeface="Microsoft JhengHei"/>
+                          <a:cs typeface="Microsoft JhengHei"/>
+                        </a:rPr>
+                        <a:t>月費 490 × 3%</a:t>
+                      </a:r>
+                    </a:p>
+                  </a:txBody>
+                  <a:tcPr anchor="ctr" marL="91440" marR="91440" marT="18288" marB="18288">
+                    <a:lnL w="9525">
+                      <a:solidFill>
+                        <a:srgbClr val="D3DEEA"/>
+                      </a:solidFill>
+                    </a:lnL>
+                    <a:lnR w="9525">
+                      <a:solidFill>
+                        <a:srgbClr val="D3DEEA"/>
+                      </a:solidFill>
+                    </a:lnR>
+                    <a:lnT w="9525">
+                      <a:solidFill>
+                        <a:srgbClr val="D3DEEA"/>
+                      </a:solidFill>
+                    </a:lnT>
+                    <a:lnB w="9525">
+                      <a:solidFill>
+                        <a:srgbClr val="D3DEEA"/>
+                      </a:solidFill>
+                    </a:lnB>
+                    <a:solidFill>
+                      <a:srgbClr val="FFFFFF"/>
+                    </a:solidFill>
+                  </a:tcPr>
+                </a:tc>
+                <a:tc>
+                  <a:txBody>
+                    <a:bodyPr wrap="square"/>
+                    <a:lstStyle/>
+                    <a:p>
+                      <a:pPr algn="r"/>
+                      <a:r>
+                        <a:rPr sz="1200" b="1">
+                          <a:solidFill>
+                            <a:srgbClr val="14243A"/>
+                          </a:solidFill>
+                          <a:latin typeface="Microsoft JhengHei"/>
+                          <a:ea typeface="Microsoft JhengHei"/>
+                          <a:cs typeface="Microsoft JhengHei"/>
+                        </a:rPr>
+                        <a:t>15</a:t>
+                      </a:r>
+                    </a:p>
+                  </a:txBody>
+                  <a:tcPr anchor="ctr" marL="91440" marR="91440" marT="18288" marB="18288">
+                    <a:lnL w="9525">
+                      <a:solidFill>
+                        <a:srgbClr val="D3DEEA"/>
+                      </a:solidFill>
+                    </a:lnL>
+                    <a:lnR w="9525">
+                      <a:solidFill>
+                        <a:srgbClr val="D3DEEA"/>
+                      </a:solidFill>
+                    </a:lnR>
+                    <a:lnT w="9525">
+                      <a:solidFill>
+                        <a:srgbClr val="D3DEEA"/>
+                      </a:solidFill>
+                    </a:lnT>
+                    <a:lnB w="9525">
+                      <a:solidFill>
+                        <a:srgbClr val="D3DEEA"/>
+                      </a:solidFill>
+                    </a:lnB>
+                    <a:solidFill>
+                      <a:srgbClr val="FFFFFF"/>
+                    </a:solidFill>
+                  </a:tcPr>
+                </a:tc>
+              </a:tr>
+              <a:tr h="315468">
+                <a:tc>
+                  <a:txBody>
+                    <a:bodyPr wrap="square"/>
+                    <a:lstStyle/>
+                    <a:p>
+                      <a:pPr algn="l"/>
+                      <a:r>
+                        <a:rPr sz="1300" b="1">
+                          <a:solidFill>
+                            <a:srgbClr val="D46A12"/>
+                          </a:solidFill>
+                          <a:latin typeface="Microsoft JhengHei"/>
+                          <a:ea typeface="Microsoft JhengHei"/>
+                          <a:cs typeface="Microsoft JhengHei"/>
+                        </a:rPr>
+                        <a:t>變動成本 v</a:t>
+                      </a:r>
+                    </a:p>
+                  </a:txBody>
+                  <a:tcPr anchor="ctr" marL="91440" marR="91440" marT="18288" marB="18288">
+                    <a:lnL w="9525">
+                      <a:solidFill>
+                        <a:srgbClr val="D3DEEA"/>
+                      </a:solidFill>
+                    </a:lnL>
+                    <a:lnR w="9525">
+                      <a:solidFill>
+                        <a:srgbClr val="D3DEEA"/>
+                      </a:solidFill>
+                    </a:lnR>
+                    <a:lnT w="9525">
+                      <a:solidFill>
+                        <a:srgbClr val="D3DEEA"/>
+                      </a:solidFill>
+                    </a:lnT>
+                    <a:lnB w="9525">
+                      <a:solidFill>
+                        <a:srgbClr val="D3DEEA"/>
+                      </a:solidFill>
+                    </a:lnB>
+                    <a:solidFill>
+                      <a:srgbClr val="FDEEDF"/>
+                    </a:solidFill>
+                  </a:tcPr>
+                </a:tc>
+                <a:tc>
+                  <a:txBody>
+                    <a:bodyPr wrap="square"/>
+                    <a:lstStyle/>
+                    <a:p>
+                      <a:pPr algn="l"/>
+                      <a:r>
+                        <a:rPr sz="1200" b="0">
+                          <a:solidFill>
+                            <a:srgbClr val="3F546C"/>
+                          </a:solidFill>
+                          <a:latin typeface="Microsoft JhengHei"/>
+                          <a:ea typeface="Microsoft JhengHei"/>
+                          <a:cs typeface="Microsoft JhengHei"/>
+                        </a:rPr>
+                        <a:t>以上三項合計（每位用戶／月）</a:t>
+                      </a:r>
+                    </a:p>
+                  </a:txBody>
+                  <a:tcPr anchor="ctr" marL="91440" marR="91440" marT="18288" marB="18288">
+                    <a:lnL w="9525">
+                      <a:solidFill>
+                        <a:srgbClr val="D3DEEA"/>
+                      </a:solidFill>
+                    </a:lnL>
+                    <a:lnR w="9525">
+                      <a:solidFill>
+                        <a:srgbClr val="D3DEEA"/>
+                      </a:solidFill>
+                    </a:lnR>
+                    <a:lnT w="9525">
+                      <a:solidFill>
+                        <a:srgbClr val="D3DEEA"/>
+                      </a:solidFill>
+                    </a:lnT>
+                    <a:lnB w="9525">
+                      <a:solidFill>
+                        <a:srgbClr val="D3DEEA"/>
+                      </a:solidFill>
+                    </a:lnB>
+                    <a:solidFill>
+                      <a:srgbClr val="FDEEDF"/>
+                    </a:solidFill>
+                  </a:tcPr>
+                </a:tc>
+                <a:tc>
+                  <a:txBody>
+                    <a:bodyPr wrap="square"/>
+                    <a:lstStyle/>
+                    <a:p>
+                      <a:pPr algn="r"/>
+                      <a:r>
+                        <a:rPr sz="1400" b="1">
+                          <a:solidFill>
+                            <a:srgbClr val="D46A12"/>
+                          </a:solidFill>
+                          <a:latin typeface="Microsoft JhengHei"/>
+                          <a:ea typeface="Microsoft JhengHei"/>
+                          <a:cs typeface="Microsoft JhengHei"/>
+                        </a:rPr>
+                        <a:t>53</a:t>
+                      </a:r>
+                    </a:p>
+                  </a:txBody>
+                  <a:tcPr anchor="ctr" marL="91440" marR="91440" marT="18288" marB="18288">
+                    <a:lnL w="9525">
+                      <a:solidFill>
+                        <a:srgbClr val="D3DEEA"/>
+                      </a:solidFill>
+                    </a:lnL>
+                    <a:lnR w="9525">
+                      <a:solidFill>
+                        <a:srgbClr val="D3DEEA"/>
+                      </a:solidFill>
+                    </a:lnR>
+                    <a:lnT w="9525">
+                      <a:solidFill>
+                        <a:srgbClr val="D3DEEA"/>
+                      </a:solidFill>
+                    </a:lnT>
+                    <a:lnB w="9525">
+                      <a:solidFill>
+                        <a:srgbClr val="D3DEEA"/>
+                      </a:solidFill>
+                    </a:lnB>
+                    <a:solidFill>
+                      <a:srgbClr val="FDEEDF"/>
+                    </a:solidFill>
+                  </a:tcPr>
+                </a:tc>
+              </a:tr>
+            </a:tbl>
+          </a:graphicData>
+        </a:graphic>
+      </p:graphicFrame>
+      <p:sp>
+        <p:nvSpPr>
+          <p:cNvPr id="31" name="Unit Cost Formula"/>
+          <p:cNvSpPr/>
+          <p:nvPr/>
+        </p:nvSpPr>
+        <p:spPr>
+          <a:xfrm>
+            <a:off x="731520" y="5125212"/>
+            <a:ext cx="6492240" cy="292608"/>
           </a:xfrm>
           <a:prstGeom prst="rect">
             <a:avLst/>
           </a:prstGeom>
           <a:noFill/>
-        </p:spPr>
-        <p:txBody>
-          <a:bodyPr wrap="square" lIns="0" tIns="0" rIns="0" bIns="0" anchor="ctr"/>
-          <a:lstStyle/>
-          <a:p>
-            <a:pPr marL="0" indent="0" algn="ctr">
-              <a:buNone/>
+          <a:ln>
+            <a:noFill/>
+          </a:ln>
+          <a:effectLst/>
+        </p:spPr>
+        <p:style>
+          <a:lnRef idx="1">
+            <a:schemeClr val="accent1"/>
+          </a:lnRef>
+          <a:fillRef idx="3">
+            <a:schemeClr val="accent1"/>
+          </a:fillRef>
+          <a:effectRef idx="2">
+            <a:schemeClr val="accent1"/>
+          </a:effectRef>
+          <a:fontRef idx="minor">
+            <a:schemeClr val="lt1"/>
+          </a:fontRef>
+        </p:style>
+        <p:txBody>
+          <a:bodyPr rtlCol="0" anchor="ctr" wrap="square" lIns="137160" rIns="137160"/>
+          <a:lstStyle/>
+          <a:p>
+            <a:pPr algn="l">
+              <a:spcAft>
+                <a:spcPts val="300"/>
+              </a:spcAft>
             </a:pPr>
             <a:r>
-              <a:rPr sz="3400" b="1">
-                <a:solidFill>
-                  <a:srgbClr val="1F6FB8"/>
+              <a:rPr sz="1050" b="0">
+                <a:solidFill>
+                  <a:srgbClr val="3F546C"/>
                 </a:solidFill>
                 <a:latin typeface="Microsoft JhengHei"/>
                 <a:ea typeface="Microsoft JhengHei"/>
                 <a:cs typeface="Microsoft JhengHei"/>
               </a:rPr>
-              <a:t>0.18 元</a:t>
-            </a:r>
-            <a:endParaRPr sz="3400"/>
-          </a:p>
-        </p:txBody>
-      </p:sp>
-      <p:sp>
-        <p:nvSpPr>
-          <p:cNvPr id="8" name="Text 6">
-            <a:extLst>
-              <a:ext uri="{FF2B5EF4-FFF2-40B4-BE49-F238E27FC236}">
-                <a16:creationId xmlns:a16="http://schemas.microsoft.com/office/drawing/2014/main" id="{D2BEA3D9-A009-4CEA-B0DD-D5E222787E0A}"/>
-              </a:ext>
-            </a:extLst>
-          </p:cNvPr>
-          <p:cNvSpPr>
-            <a:spLocks noGrp="1"/>
-          </p:cNvSpPr>
-          <p:nvPr/>
-        </p:nvSpPr>
-        <p:spPr>
-          <a:xfrm>
-            <a:off x="822960" y="2880360"/>
-            <a:ext cx="2377440" cy="365760"/>
-          </a:xfrm>
-          <a:prstGeom prst="rect">
-            <a:avLst/>
-          </a:prstGeom>
-          <a:noFill/>
-        </p:spPr>
-        <p:txBody>
-          <a:bodyPr wrap="square" lIns="0" tIns="0" rIns="0" bIns="0" anchor="ctr"/>
-          <a:lstStyle/>
-          <a:p>
-            <a:pPr marL="0" indent="0" algn="ctr">
-              <a:buNone/>
+              <a:t>單次費用＝（輸入 token × 0.25＋輸出 token × 1.50）÷ 10⁶ × 32 → 問答 0.18 元、洞察 0.33 元</a:t>
+            </a:r>
+          </a:p>
+        </p:txBody>
+      </p:sp>
+      <p:sp>
+        <p:nvSpPr>
+          <p:cNvPr id="32" name="Break-even Formula"/>
+          <p:cNvSpPr/>
+          <p:nvPr/>
+        </p:nvSpPr>
+        <p:spPr>
+          <a:xfrm>
+            <a:off x="7452360" y="1627632"/>
+            <a:ext cx="4005072" cy="1298448"/>
+          </a:xfrm>
+          <a:prstGeom prst="roundRect">
+            <a:avLst>
+              <a:gd name="adj" fmla="val 6000"/>
+            </a:avLst>
+          </a:prstGeom>
+          <a:solidFill>
+            <a:srgbClr val="E2EDF9"/>
+          </a:solidFill>
+          <a:ln w="12700">
+            <a:solidFill>
+              <a:srgbClr val="C9DAEE"/>
+            </a:solidFill>
+          </a:ln>
+          <a:effectLst/>
+        </p:spPr>
+        <p:style>
+          <a:lnRef idx="1">
+            <a:schemeClr val="accent1"/>
+          </a:lnRef>
+          <a:fillRef idx="3">
+            <a:schemeClr val="accent1"/>
+          </a:fillRef>
+          <a:effectRef idx="2">
+            <a:schemeClr val="accent1"/>
+          </a:effectRef>
+          <a:fontRef idx="minor">
+            <a:schemeClr val="lt1"/>
+          </a:fontRef>
+        </p:style>
+        <p:txBody>
+          <a:bodyPr rtlCol="0" anchor="ctr" wrap="square" lIns="137160" rIns="137160"/>
+          <a:lstStyle/>
+          <a:p>
+            <a:pPr algn="l">
+              <a:spcAft>
+                <a:spcPts val="300"/>
+              </a:spcAft>
             </a:pPr>
             <a:r>
-              <a:rPr sz="1600" b="1">
-                <a:solidFill>
-                  <a:srgbClr val="14243A"/>
+              <a:rPr sz="1400" b="1">
+                <a:solidFill>
+                  <a:srgbClr val="D46A12"/>
                 </a:solidFill>
                 <a:latin typeface="Microsoft JhengHei"/>
                 <a:ea typeface="Microsoft JhengHei"/>
                 <a:cs typeface="Microsoft JhengHei"/>
               </a:rPr>
-              <a:t>每次 AI 問答（保守上限）</a:t>
-            </a:r>
-            <a:endParaRPr sz="1600"/>
-          </a:p>
-        </p:txBody>
-      </p:sp>
-      <p:sp>
-        <p:nvSpPr>
-          <p:cNvPr id="9" name="Text 7">
-            <a:extLst>
-              <a:ext uri="{FF2B5EF4-FFF2-40B4-BE49-F238E27FC236}">
-                <a16:creationId xmlns:a16="http://schemas.microsoft.com/office/drawing/2014/main" id="{5C76224E-6880-42E4-BCC5-DD201F63DAD7}"/>
-              </a:ext>
-            </a:extLst>
-          </p:cNvPr>
-          <p:cNvSpPr>
-            <a:spLocks noGrp="1"/>
-          </p:cNvSpPr>
-          <p:nvPr/>
-        </p:nvSpPr>
-        <p:spPr>
-          <a:xfrm>
-            <a:off x="868680" y="3291840"/>
-            <a:ext cx="2286000" cy="365760"/>
-          </a:xfrm>
-          <a:prstGeom prst="rect">
-            <a:avLst/>
-          </a:prstGeom>
-          <a:noFill/>
-        </p:spPr>
-        <p:txBody>
-          <a:bodyPr wrap="square" lIns="0" tIns="0" rIns="0" bIns="0" anchor="t"/>
-          <a:lstStyle/>
-          <a:p>
-            <a:pPr marL="0" indent="0" algn="ctr">
-              <a:buNone/>
+              <a:t>損益平衡怎麼算</a:t>
+            </a:r>
+          </a:p>
+          <a:p>
+            <a:pPr algn="l">
+              <a:spcAft>
+                <a:spcPts val="300"/>
+              </a:spcAft>
             </a:pPr>
             <a:r>
-              <a:rPr sz="1200">
-                <a:solidFill>
-                  <a:srgbClr val="3F546C"/>
+              <a:rPr sz="1400" b="1">
+                <a:solidFill>
+                  <a:srgbClr val="14243A"/>
                 </a:solidFill>
                 <a:latin typeface="Microsoft JhengHei"/>
                 <a:ea typeface="Microsoft JhengHei"/>
                 <a:cs typeface="Microsoft JhengHei"/>
               </a:rPr>
-              <a:t>實測 prompt×官方單價</a:t>
-            </a:r>
-            <a:endParaRPr sz="1200"/>
-          </a:p>
-        </p:txBody>
-      </p:sp>
-      <p:sp>
-        <p:nvSpPr>
-          <p:cNvPr id="10" name="Shape 8">
-            <a:extLst>
-              <a:ext uri="{FF2B5EF4-FFF2-40B4-BE49-F238E27FC236}">
-                <a16:creationId xmlns:a16="http://schemas.microsoft.com/office/drawing/2014/main" id="{9F5898B4-0D91-400B-A3E6-1EA3FA362362}"/>
-              </a:ext>
-            </a:extLst>
-          </p:cNvPr>
-          <p:cNvSpPr>
-            <a:spLocks noGrp="1"/>
-          </p:cNvSpPr>
-          <p:nvPr/>
-        </p:nvSpPr>
-        <p:spPr>
-          <a:xfrm>
-            <a:off x="3474720" y="1783080"/>
-            <a:ext cx="2560320" cy="1965960"/>
-          </a:xfrm>
-          <a:prstGeom prst="roundRect">
-            <a:avLst>
-              <a:gd name="adj" fmla="val 7442"/>
-            </a:avLst>
-          </a:prstGeom>
-          <a:solidFill>
-            <a:srgbClr val="FFFFFF"/>
-          </a:solidFill>
-          <a:ln w="12700">
-            <a:solidFill>
-              <a:srgbClr val="D3DEEA"/>
-            </a:solidFill>
-            <a:prstDash val="solid"/>
-          </a:ln>
-        </p:spPr>
-        <p:txBody>
-          <a:bodyPr/>
-          <a:lstStyle/>
-          <a:p>
-            <a:endParaRPr/>
-          </a:p>
-        </p:txBody>
-      </p:sp>
-      <p:sp>
-        <p:nvSpPr>
-          <p:cNvPr id="11" name="Text 9">
-            <a:extLst>
-              <a:ext uri="{FF2B5EF4-FFF2-40B4-BE49-F238E27FC236}">
-                <a16:creationId xmlns:a16="http://schemas.microsoft.com/office/drawing/2014/main" id="{B8A85723-AC44-4CA2-ACCB-8AE9A59763C9}"/>
-              </a:ext>
-            </a:extLst>
-          </p:cNvPr>
-          <p:cNvSpPr>
-            <a:spLocks noGrp="1"/>
-          </p:cNvSpPr>
-          <p:nvPr/>
-        </p:nvSpPr>
-        <p:spPr>
-          <a:xfrm>
-            <a:off x="3566160" y="2057400"/>
-            <a:ext cx="2377440" cy="777240"/>
-          </a:xfrm>
-          <a:prstGeom prst="rect">
-            <a:avLst/>
-          </a:prstGeom>
-          <a:noFill/>
-        </p:spPr>
-        <p:txBody>
-          <a:bodyPr wrap="square" lIns="0" tIns="0" rIns="0" bIns="0" anchor="ctr"/>
-          <a:lstStyle/>
-          <a:p>
-            <a:pPr marL="0" indent="0" algn="ctr">
-              <a:buNone/>
+              <a:t>月收入 R(N)＝490 × N</a:t>
+            </a:r>
+          </a:p>
+          <a:p>
+            <a:pPr algn="l">
+              <a:spcAft>
+                <a:spcPts val="300"/>
+              </a:spcAft>
             </a:pPr>
             <a:r>
-              <a:rPr sz="3400" b="1">
-                <a:solidFill>
-                  <a:srgbClr val="1F6FB8"/>
+              <a:rPr sz="1400" b="1">
+                <a:solidFill>
+                  <a:srgbClr val="14243A"/>
                 </a:solidFill>
                 <a:latin typeface="Microsoft JhengHei"/>
                 <a:ea typeface="Microsoft JhengHei"/>
                 <a:cs typeface="Microsoft JhengHei"/>
               </a:rPr>
-              <a:t>53 元</a:t>
-            </a:r>
-            <a:endParaRPr sz="3400"/>
-          </a:p>
-        </p:txBody>
-      </p:sp>
-      <p:sp>
-        <p:nvSpPr>
-          <p:cNvPr id="12" name="Text 10">
-            <a:extLst>
-              <a:ext uri="{FF2B5EF4-FFF2-40B4-BE49-F238E27FC236}">
-                <a16:creationId xmlns:a16="http://schemas.microsoft.com/office/drawing/2014/main" id="{4DCBBE7D-2D2D-4D5C-8E2C-9C15E8694073}"/>
-              </a:ext>
-            </a:extLst>
-          </p:cNvPr>
-          <p:cNvSpPr>
-            <a:spLocks noGrp="1"/>
-          </p:cNvSpPr>
-          <p:nvPr/>
-        </p:nvSpPr>
-        <p:spPr>
-          <a:xfrm>
-            <a:off x="3566160" y="2880360"/>
-            <a:ext cx="2377440" cy="365760"/>
-          </a:xfrm>
-          <a:prstGeom prst="rect">
-            <a:avLst/>
-          </a:prstGeom>
-          <a:noFill/>
-        </p:spPr>
-        <p:txBody>
-          <a:bodyPr wrap="square" lIns="0" tIns="0" rIns="0" bIns="0" anchor="ctr"/>
-          <a:lstStyle/>
-          <a:p>
-            <a:pPr marL="0" indent="0" algn="ctr">
-              <a:buNone/>
+              <a:t>月支出 C(N)＝1,456＋53 × N</a:t>
+            </a:r>
+          </a:p>
+          <a:p>
+            <a:pPr algn="l">
+              <a:spcAft>
+                <a:spcPts val="300"/>
+              </a:spcAft>
             </a:pPr>
             <a:r>
-              <a:rPr sz="1600" b="1">
-                <a:solidFill>
-                  <a:srgbClr val="14243A"/>
+              <a:rPr sz="1300" b="1">
+                <a:solidFill>
+                  <a:srgbClr val="2073BE"/>
                 </a:solidFill>
                 <a:latin typeface="Microsoft JhengHei"/>
                 <a:ea typeface="Microsoft JhengHei"/>
                 <a:cs typeface="Microsoft JhengHei"/>
               </a:rPr>
-              <a:t>每位專業版用戶／月</a:t>
-            </a:r>
-            <a:endParaRPr sz="1600"/>
-          </a:p>
-        </p:txBody>
-      </p:sp>
-      <p:sp>
-        <p:nvSpPr>
-          <p:cNvPr id="13" name="Text 11">
-            <a:extLst>
-              <a:ext uri="{FF2B5EF4-FFF2-40B4-BE49-F238E27FC236}">
-                <a16:creationId xmlns:a16="http://schemas.microsoft.com/office/drawing/2014/main" id="{2E7B73D4-0CE7-48A5-BF08-571B22683F5C}"/>
-              </a:ext>
-            </a:extLst>
-          </p:cNvPr>
-          <p:cNvSpPr>
-            <a:spLocks noGrp="1"/>
-          </p:cNvSpPr>
-          <p:nvPr/>
-        </p:nvSpPr>
-        <p:spPr>
-          <a:xfrm>
-            <a:off x="3611880" y="3291840"/>
-            <a:ext cx="2286000" cy="365760"/>
-          </a:xfrm>
-          <a:prstGeom prst="rect">
-            <a:avLst/>
-          </a:prstGeom>
-          <a:noFill/>
-        </p:spPr>
-        <p:txBody>
-          <a:bodyPr wrap="square" lIns="0" tIns="0" rIns="0" bIns="0" anchor="t"/>
-          <a:lstStyle/>
-          <a:p>
-            <a:pPr marL="0" indent="0" algn="ctr">
-              <a:buNone/>
-            </a:pPr>
-            <a:r>
-              <a:rPr sz="1200">
-                <a:solidFill>
-                  <a:srgbClr val="3F546C"/>
-                </a:solidFill>
-                <a:latin typeface="Microsoft JhengHei"/>
-                <a:ea typeface="Microsoft JhengHei"/>
-                <a:cs typeface="Microsoft JhengHei"/>
-              </a:rPr>
-              <a:t>問答100、洞察60、金流3%</a:t>
-            </a:r>
-            <a:endParaRPr sz="1200"/>
-          </a:p>
-        </p:txBody>
-      </p:sp>
-      <p:sp>
-        <p:nvSpPr>
-          <p:cNvPr id="14" name="Shape 12">
-            <a:extLst>
-              <a:ext uri="{FF2B5EF4-FFF2-40B4-BE49-F238E27FC236}">
-                <a16:creationId xmlns:a16="http://schemas.microsoft.com/office/drawing/2014/main" id="{269880F6-9021-42D8-857E-6B3D32E8F860}"/>
-              </a:ext>
-            </a:extLst>
-          </p:cNvPr>
-          <p:cNvSpPr>
-            <a:spLocks noGrp="1"/>
-          </p:cNvSpPr>
-          <p:nvPr/>
-        </p:nvSpPr>
-        <p:spPr>
-          <a:xfrm>
-            <a:off x="6217920" y="1783080"/>
-            <a:ext cx="2560320" cy="1965960"/>
-          </a:xfrm>
-          <a:prstGeom prst="roundRect">
-            <a:avLst>
-              <a:gd name="adj" fmla="val 7442"/>
-            </a:avLst>
-          </a:prstGeom>
-          <a:solidFill>
-            <a:srgbClr val="FFFFFF"/>
-          </a:solidFill>
-          <a:ln w="12700">
-            <a:solidFill>
-              <a:srgbClr val="D3DEEA"/>
-            </a:solidFill>
-            <a:prstDash val="solid"/>
-          </a:ln>
-        </p:spPr>
-        <p:txBody>
-          <a:bodyPr/>
-          <a:lstStyle/>
-          <a:p>
-            <a:endParaRPr/>
-          </a:p>
-        </p:txBody>
-      </p:sp>
-      <p:sp>
-        <p:nvSpPr>
-          <p:cNvPr id="15" name="Text 13">
-            <a:extLst>
-              <a:ext uri="{FF2B5EF4-FFF2-40B4-BE49-F238E27FC236}">
-                <a16:creationId xmlns:a16="http://schemas.microsoft.com/office/drawing/2014/main" id="{D4D12D62-5D8D-4E45-BCFC-ED5E485912D6}"/>
-              </a:ext>
-            </a:extLst>
-          </p:cNvPr>
-          <p:cNvSpPr>
-            <a:spLocks noGrp="1"/>
-          </p:cNvSpPr>
-          <p:nvPr/>
-        </p:nvSpPr>
-        <p:spPr>
-          <a:xfrm>
-            <a:off x="6309360" y="2057400"/>
-            <a:ext cx="2377440" cy="777240"/>
-          </a:xfrm>
-          <a:prstGeom prst="rect">
-            <a:avLst/>
-          </a:prstGeom>
-          <a:noFill/>
-        </p:spPr>
-        <p:txBody>
-          <a:bodyPr wrap="square" lIns="0" tIns="0" rIns="0" bIns="0" anchor="ctr"/>
-          <a:lstStyle/>
-          <a:p>
-            <a:pPr marL="0" indent="0" algn="ctr">
-              <a:buNone/>
-            </a:pPr>
-            <a:r>
-              <a:rPr sz="3400" b="1">
-                <a:solidFill>
-                  <a:srgbClr val="1F6FB8"/>
-                </a:solidFill>
-                <a:latin typeface="Microsoft JhengHei"/>
-                <a:ea typeface="Microsoft JhengHei"/>
-                <a:cs typeface="Microsoft JhengHei"/>
-              </a:rPr>
-              <a:t>1,456 元</a:t>
-            </a:r>
-            <a:endParaRPr sz="3400"/>
-          </a:p>
-        </p:txBody>
-      </p:sp>
-      <p:sp>
-        <p:nvSpPr>
-          <p:cNvPr id="16" name="Text 14">
-            <a:extLst>
-              <a:ext uri="{FF2B5EF4-FFF2-40B4-BE49-F238E27FC236}">
-                <a16:creationId xmlns:a16="http://schemas.microsoft.com/office/drawing/2014/main" id="{2ED8EA77-2B5E-469E-8275-5A4B4D5F31DC}"/>
-              </a:ext>
-            </a:extLst>
-          </p:cNvPr>
-          <p:cNvSpPr>
-            <a:spLocks noGrp="1"/>
-          </p:cNvSpPr>
-          <p:nvPr/>
-        </p:nvSpPr>
-        <p:spPr>
-          <a:xfrm>
-            <a:off x="6309360" y="2880360"/>
-            <a:ext cx="2377440" cy="365760"/>
-          </a:xfrm>
-          <a:prstGeom prst="rect">
-            <a:avLst/>
-          </a:prstGeom>
-          <a:noFill/>
-        </p:spPr>
-        <p:txBody>
-          <a:bodyPr wrap="square" lIns="0" tIns="0" rIns="0" bIns="0" anchor="ctr"/>
-          <a:lstStyle/>
-          <a:p>
-            <a:pPr marL="0" indent="0" algn="ctr">
-              <a:buNone/>
-            </a:pPr>
-            <a:r>
-              <a:rPr sz="1600" b="1">
-                <a:solidFill>
-                  <a:srgbClr val="14243A"/>
-                </a:solidFill>
-                <a:latin typeface="Microsoft JhengHei"/>
-                <a:ea typeface="Microsoft JhengHei"/>
-                <a:cs typeface="Microsoft JhengHei"/>
-              </a:rPr>
-              <a:t>每月雲端固定支出</a:t>
-            </a:r>
-            <a:endParaRPr sz="1600"/>
-          </a:p>
-        </p:txBody>
-      </p:sp>
-      <p:sp>
-        <p:nvSpPr>
-          <p:cNvPr id="17" name="Text 15">
-            <a:extLst>
-              <a:ext uri="{FF2B5EF4-FFF2-40B4-BE49-F238E27FC236}">
-                <a16:creationId xmlns:a16="http://schemas.microsoft.com/office/drawing/2014/main" id="{0AC93142-C0A9-4B69-9623-0ABACA098C3D}"/>
-              </a:ext>
-            </a:extLst>
-          </p:cNvPr>
-          <p:cNvSpPr>
-            <a:spLocks noGrp="1"/>
-          </p:cNvSpPr>
-          <p:nvPr/>
-        </p:nvSpPr>
-        <p:spPr>
-          <a:xfrm>
-            <a:off x="6355080" y="3291840"/>
-            <a:ext cx="2286000" cy="365760"/>
-          </a:xfrm>
-          <a:prstGeom prst="rect">
-            <a:avLst/>
-          </a:prstGeom>
-          <a:noFill/>
-        </p:spPr>
-        <p:txBody>
-          <a:bodyPr wrap="square" lIns="0" tIns="0" rIns="0" bIns="0" anchor="t"/>
-          <a:lstStyle/>
-          <a:p>
-            <a:pPr marL="0" indent="0" algn="ctr">
-              <a:buNone/>
-            </a:pPr>
-            <a:r>
-              <a:rPr sz="1200">
-                <a:solidFill>
-                  <a:srgbClr val="3F546C"/>
-                </a:solidFill>
-                <a:latin typeface="Microsoft JhengHei"/>
-                <a:ea typeface="Microsoft JhengHei"/>
-                <a:cs typeface="Microsoft JhengHei"/>
-              </a:rPr>
-              <a:t>主機、資料庫、網域、判讀</a:t>
-            </a:r>
-            <a:endParaRPr sz="1200"/>
-          </a:p>
-        </p:txBody>
-      </p:sp>
-      <p:sp>
-        <p:nvSpPr>
-          <p:cNvPr id="18" name="Shape 16">
-            <a:extLst>
-              <a:ext uri="{FF2B5EF4-FFF2-40B4-BE49-F238E27FC236}">
-                <a16:creationId xmlns:a16="http://schemas.microsoft.com/office/drawing/2014/main" id="{5EC6AB01-C01E-4038-B70A-DD2D8BA2BB57}"/>
-              </a:ext>
-            </a:extLst>
-          </p:cNvPr>
-          <p:cNvSpPr>
-            <a:spLocks noGrp="1"/>
-          </p:cNvSpPr>
-          <p:nvPr/>
-        </p:nvSpPr>
-        <p:spPr>
-          <a:xfrm>
-            <a:off x="9052560" y="1783080"/>
-            <a:ext cx="2404872" cy="3703320"/>
-          </a:xfrm>
-          <a:prstGeom prst="roundRect">
-            <a:avLst>
-              <a:gd name="adj" fmla="val 6084"/>
-            </a:avLst>
-          </a:prstGeom>
-          <a:solidFill>
-            <a:srgbClr val="E2EDF9"/>
-          </a:solidFill>
-          <a:ln w="19050">
-            <a:solidFill>
-              <a:srgbClr val="D46A12"/>
-            </a:solidFill>
-            <a:prstDash val="solid"/>
-          </a:ln>
-        </p:spPr>
-        <p:txBody>
-          <a:bodyPr/>
-          <a:lstStyle/>
-          <a:p>
-            <a:endParaRPr/>
-          </a:p>
-        </p:txBody>
-      </p:sp>
-      <p:sp>
-        <p:nvSpPr>
-          <p:cNvPr id="19" name="Text 17">
-            <a:extLst>
-              <a:ext uri="{FF2B5EF4-FFF2-40B4-BE49-F238E27FC236}">
-                <a16:creationId xmlns:a16="http://schemas.microsoft.com/office/drawing/2014/main" id="{8F08BD10-8E54-4639-B49F-5A1262B8B7C0}"/>
-              </a:ext>
-            </a:extLst>
-          </p:cNvPr>
-          <p:cNvSpPr>
-            <a:spLocks noGrp="1"/>
-          </p:cNvSpPr>
-          <p:nvPr/>
-        </p:nvSpPr>
-        <p:spPr>
-          <a:xfrm>
-            <a:off x="9052560" y="2057400"/>
-            <a:ext cx="2404872" cy="365760"/>
-          </a:xfrm>
-          <a:prstGeom prst="rect">
-            <a:avLst/>
-          </a:prstGeom>
-          <a:noFill/>
-        </p:spPr>
-        <p:txBody>
-          <a:bodyPr wrap="square" lIns="0" tIns="0" rIns="0" bIns="0" anchor="ctr"/>
-          <a:lstStyle/>
-          <a:p>
-            <a:pPr marL="0" indent="0" algn="ctr">
-              <a:buNone/>
-            </a:pPr>
-            <a:r>
-              <a:rPr sz="1600" b="1">
-                <a:solidFill>
-                  <a:srgbClr val="D46A12"/>
-                </a:solidFill>
-                <a:latin typeface="Microsoft JhengHei"/>
-                <a:ea typeface="Microsoft JhengHei"/>
-                <a:cs typeface="Microsoft JhengHei"/>
-              </a:rPr>
-              <a:t>損益平衡點</a:t>
-            </a:r>
-            <a:endParaRPr sz="1600"/>
-          </a:p>
-        </p:txBody>
-      </p:sp>
-      <p:sp>
-        <p:nvSpPr>
-          <p:cNvPr id="20" name="Text 18">
-            <a:extLst>
-              <a:ext uri="{FF2B5EF4-FFF2-40B4-BE49-F238E27FC236}">
-                <a16:creationId xmlns:a16="http://schemas.microsoft.com/office/drawing/2014/main" id="{3CBD95C2-6776-488D-8AA1-A33AB42A5892}"/>
-              </a:ext>
-            </a:extLst>
-          </p:cNvPr>
-          <p:cNvSpPr>
-            <a:spLocks noGrp="1"/>
-          </p:cNvSpPr>
-          <p:nvPr/>
-        </p:nvSpPr>
-        <p:spPr>
-          <a:xfrm>
-            <a:off x="9052560" y="2514600"/>
-            <a:ext cx="2404872" cy="1005840"/>
-          </a:xfrm>
-          <a:prstGeom prst="rect">
-            <a:avLst/>
-          </a:prstGeom>
-          <a:noFill/>
-        </p:spPr>
-        <p:txBody>
-          <a:bodyPr wrap="square" lIns="0" tIns="0" rIns="0" bIns="0" anchor="ctr"/>
-          <a:lstStyle/>
-          <a:p>
-            <a:pPr marL="0" indent="0" algn="ctr">
-              <a:buNone/>
-            </a:pPr>
-            <a:r>
-              <a:rPr sz="5200" b="1">
-                <a:solidFill>
-                  <a:srgbClr val="14243A"/>
-                </a:solidFill>
-                <a:latin typeface="Microsoft JhengHei"/>
-                <a:ea typeface="Microsoft JhengHei"/>
-                <a:cs typeface="Microsoft JhengHei"/>
-              </a:rPr>
-              <a:t>4 個</a:t>
-            </a:r>
-            <a:endParaRPr sz="5200"/>
-          </a:p>
-        </p:txBody>
-      </p:sp>
-      <p:sp>
-        <p:nvSpPr>
-          <p:cNvPr id="21" name="Text 19">
-            <a:extLst>
-              <a:ext uri="{FF2B5EF4-FFF2-40B4-BE49-F238E27FC236}">
-                <a16:creationId xmlns:a16="http://schemas.microsoft.com/office/drawing/2014/main" id="{2A99349E-721C-4384-ABAB-AE70C0D15DA7}"/>
-              </a:ext>
-            </a:extLst>
-          </p:cNvPr>
-          <p:cNvSpPr>
-            <a:spLocks noGrp="1"/>
-          </p:cNvSpPr>
-          <p:nvPr/>
-        </p:nvSpPr>
-        <p:spPr>
-          <a:xfrm>
-            <a:off x="9052560" y="3657600"/>
-            <a:ext cx="2404872" cy="320040"/>
-          </a:xfrm>
-          <a:prstGeom prst="rect">
-            <a:avLst/>
-          </a:prstGeom>
-          <a:noFill/>
-        </p:spPr>
-        <p:txBody>
-          <a:bodyPr wrap="square" lIns="0" tIns="0" rIns="0" bIns="0" anchor="ctr"/>
-          <a:lstStyle/>
-          <a:p>
-            <a:pPr marL="0" indent="0" algn="ctr">
-              <a:buNone/>
-            </a:pPr>
-            <a:r>
-              <a:rPr sz="1400" b="1">
-                <a:solidFill>
-                  <a:srgbClr val="3F546C"/>
-                </a:solidFill>
-                <a:latin typeface="Microsoft JhengHei"/>
-                <a:ea typeface="Microsoft JhengHei"/>
-                <a:cs typeface="Microsoft JhengHei"/>
-              </a:rPr>
-              <a:t>專業版付費帳號／月</a:t>
-            </a:r>
-            <a:endParaRPr sz="1200"/>
-          </a:p>
-        </p:txBody>
-      </p:sp>
-      <p:sp>
-        <p:nvSpPr>
-          <p:cNvPr id="22" name="Text 20">
-            <a:extLst>
-              <a:ext uri="{FF2B5EF4-FFF2-40B4-BE49-F238E27FC236}">
-                <a16:creationId xmlns:a16="http://schemas.microsoft.com/office/drawing/2014/main" id="{F05FECCB-D9C7-4154-8CE1-A7738D358DAF}"/>
-              </a:ext>
-            </a:extLst>
-          </p:cNvPr>
-          <p:cNvSpPr>
-            <a:spLocks noGrp="1"/>
-          </p:cNvSpPr>
-          <p:nvPr/>
-        </p:nvSpPr>
-        <p:spPr>
-          <a:xfrm>
-            <a:off x="9052560" y="4069080"/>
-            <a:ext cx="2404872" cy="320040"/>
-          </a:xfrm>
-          <a:prstGeom prst="rect">
-            <a:avLst/>
-          </a:prstGeom>
-          <a:noFill/>
-        </p:spPr>
-        <p:txBody>
-          <a:bodyPr wrap="square" lIns="0" tIns="0" rIns="0" bIns="0" anchor="ctr"/>
-          <a:lstStyle/>
-          <a:p>
-            <a:pPr marL="0" indent="0" algn="ctr">
-              <a:buNone/>
-            </a:pPr>
-            <a:r>
-              <a:rPr sz="1400">
-                <a:solidFill>
-                  <a:srgbClr val="3F546C"/>
-                </a:solidFill>
-                <a:latin typeface="Microsoft JhengHei"/>
-                <a:ea typeface="Microsoft JhengHei"/>
-                <a:cs typeface="Microsoft JhengHei"/>
-              </a:rPr>
-              <a:t>收入 1,960 ＞ 支出 1,668</a:t>
-            </a:r>
-            <a:endParaRPr sz="1200"/>
-          </a:p>
-        </p:txBody>
-      </p:sp>
-      <p:sp>
-        <p:nvSpPr>
-          <p:cNvPr id="23" name="Text 21">
-            <a:extLst>
-              <a:ext uri="{FF2B5EF4-FFF2-40B4-BE49-F238E27FC236}">
-                <a16:creationId xmlns:a16="http://schemas.microsoft.com/office/drawing/2014/main" id="{831788AA-EE2A-4983-B910-E496729D9D25}"/>
-              </a:ext>
-            </a:extLst>
-          </p:cNvPr>
-          <p:cNvSpPr>
-            <a:spLocks noGrp="1"/>
-          </p:cNvSpPr>
-          <p:nvPr/>
-        </p:nvSpPr>
-        <p:spPr>
-          <a:xfrm>
-            <a:off x="9052560" y="4754880"/>
-            <a:ext cx="2404872" cy="320040"/>
-          </a:xfrm>
-          <a:prstGeom prst="rect">
-            <a:avLst/>
-          </a:prstGeom>
-          <a:noFill/>
-        </p:spPr>
-        <p:txBody>
-          <a:bodyPr wrap="square" lIns="0" tIns="0" rIns="0" bIns="0" anchor="ctr"/>
-          <a:lstStyle/>
-          <a:p>
-            <a:pPr marL="0" indent="0" algn="ctr">
-              <a:buNone/>
-            </a:pPr>
-            <a:r>
-              <a:rPr sz="1200">
-                <a:solidFill>
-                  <a:srgbClr val="D46A12"/>
-                </a:solidFill>
-                <a:latin typeface="Microsoft JhengHei"/>
-                <a:ea typeface="Microsoft JhengHei"/>
-                <a:cs typeface="Microsoft JhengHei"/>
-              </a:rPr>
-              <a:t>每月 1,456 固定支出＋每帳號 53</a:t>
-            </a:r>
-            <a:endParaRPr sz="1200"/>
-          </a:p>
-        </p:txBody>
-      </p:sp>
-      <p:sp>
-        <p:nvSpPr>
-          <p:cNvPr id="24" name="Shape 22">
-            <a:extLst>
-              <a:ext uri="{FF2B5EF4-FFF2-40B4-BE49-F238E27FC236}">
-                <a16:creationId xmlns:a16="http://schemas.microsoft.com/office/drawing/2014/main" id="{21E81070-A35F-42FD-8834-66AC620E07BF}"/>
-              </a:ext>
-            </a:extLst>
-          </p:cNvPr>
-          <p:cNvSpPr>
-            <a:spLocks noGrp="1"/>
-          </p:cNvSpPr>
-          <p:nvPr/>
-        </p:nvSpPr>
-        <p:spPr>
-          <a:xfrm>
-            <a:off x="731520" y="3886200"/>
-            <a:ext cx="8046720" cy="1600200"/>
-          </a:xfrm>
-          <a:prstGeom prst="roundRect">
-            <a:avLst>
-              <a:gd name="adj" fmla="val 9143"/>
-            </a:avLst>
-          </a:prstGeom>
-          <a:solidFill>
-            <a:srgbClr val="FFFFFF"/>
-          </a:solidFill>
-          <a:ln w="12700">
-            <a:solidFill>
-              <a:srgbClr val="D3DEEA"/>
-            </a:solidFill>
-            <a:prstDash val="solid"/>
-          </a:ln>
-        </p:spPr>
-        <p:txBody>
-          <a:bodyPr/>
-          <a:lstStyle/>
-          <a:p>
-            <a:endParaRPr/>
-          </a:p>
-        </p:txBody>
-      </p:sp>
+              <a:t>打平：N ≥ 1,456 ÷（490－53）＝3.3 → 4 個</a:t>
+            </a:r>
+          </a:p>
+        </p:txBody>
+      </p:sp>
+      <p:graphicFrame>
+        <p:nvGraphicFramePr>
+          <p:cNvPr id="33" name="Break-even Table"/>
+          <p:cNvGraphicFramePr>
+            <a:graphicFrameLocks noGrp="1"/>
+          </p:cNvGraphicFramePr>
+          <p:nvPr/>
+        </p:nvGraphicFramePr>
+        <p:xfrm>
+          <a:off x="7452360" y="3017520"/>
+          <a:ext cx="4005072" cy="2080260"/>
+        </p:xfrm>
+        <a:graphic>
+          <a:graphicData uri="http://schemas.openxmlformats.org/drawingml/2006/table">
+            <a:tbl>
+              <a:tblPr/>
+              <a:tblGrid>
+                <a:gridCol w="914400"/>
+                <a:gridCol w="987552"/>
+                <a:gridCol w="987552"/>
+                <a:gridCol w="1115568"/>
+              </a:tblGrid>
+              <a:tr h="297180">
+                <a:tc>
+                  <a:txBody>
+                    <a:bodyPr wrap="square"/>
+                    <a:lstStyle/>
+                    <a:p>
+                      <a:pPr algn="ctr"/>
+                      <a:r>
+                        <a:rPr sz="1200" b="1">
+                          <a:solidFill>
+                            <a:srgbClr val="2073BE"/>
+                          </a:solidFill>
+                          <a:latin typeface="Microsoft JhengHei"/>
+                          <a:ea typeface="Microsoft JhengHei"/>
+                          <a:cs typeface="Microsoft JhengHei"/>
+                        </a:rPr>
+                        <a:t>帳號數 N</a:t>
+                      </a:r>
+                    </a:p>
+                  </a:txBody>
+                  <a:tcPr anchor="ctr" marL="91440" marR="91440" marT="18288" marB="18288">
+                    <a:lnL w="9525">
+                      <a:solidFill>
+                        <a:srgbClr val="D3DEEA"/>
+                      </a:solidFill>
+                    </a:lnL>
+                    <a:lnR w="9525">
+                      <a:solidFill>
+                        <a:srgbClr val="D3DEEA"/>
+                      </a:solidFill>
+                    </a:lnR>
+                    <a:lnT w="9525">
+                      <a:solidFill>
+                        <a:srgbClr val="D3DEEA"/>
+                      </a:solidFill>
+                    </a:lnT>
+                    <a:lnB w="9525">
+                      <a:solidFill>
+                        <a:srgbClr val="D3DEEA"/>
+                      </a:solidFill>
+                    </a:lnB>
+                    <a:solidFill>
+                      <a:srgbClr val="E2EEFA"/>
+                    </a:solidFill>
+                  </a:tcPr>
+                </a:tc>
+                <a:tc>
+                  <a:txBody>
+                    <a:bodyPr wrap="square"/>
+                    <a:lstStyle/>
+                    <a:p>
+                      <a:pPr algn="ctr"/>
+                      <a:r>
+                        <a:rPr sz="1200" b="1">
+                          <a:solidFill>
+                            <a:srgbClr val="2073BE"/>
+                          </a:solidFill>
+                          <a:latin typeface="Microsoft JhengHei"/>
+                          <a:ea typeface="Microsoft JhengHei"/>
+                          <a:cs typeface="Microsoft JhengHei"/>
+                        </a:rPr>
+                        <a:t>收入</a:t>
+                      </a:r>
+                    </a:p>
+                  </a:txBody>
+                  <a:tcPr anchor="ctr" marL="91440" marR="91440" marT="18288" marB="18288">
+                    <a:lnL w="9525">
+                      <a:solidFill>
+                        <a:srgbClr val="D3DEEA"/>
+                      </a:solidFill>
+                    </a:lnL>
+                    <a:lnR w="9525">
+                      <a:solidFill>
+                        <a:srgbClr val="D3DEEA"/>
+                      </a:solidFill>
+                    </a:lnR>
+                    <a:lnT w="9525">
+                      <a:solidFill>
+                        <a:srgbClr val="D3DEEA"/>
+                      </a:solidFill>
+                    </a:lnT>
+                    <a:lnB w="9525">
+                      <a:solidFill>
+                        <a:srgbClr val="D3DEEA"/>
+                      </a:solidFill>
+                    </a:lnB>
+                    <a:solidFill>
+                      <a:srgbClr val="E2EEFA"/>
+                    </a:solidFill>
+                  </a:tcPr>
+                </a:tc>
+                <a:tc>
+                  <a:txBody>
+                    <a:bodyPr wrap="square"/>
+                    <a:lstStyle/>
+                    <a:p>
+                      <a:pPr algn="ctr"/>
+                      <a:r>
+                        <a:rPr sz="1200" b="1">
+                          <a:solidFill>
+                            <a:srgbClr val="2073BE"/>
+                          </a:solidFill>
+                          <a:latin typeface="Microsoft JhengHei"/>
+                          <a:ea typeface="Microsoft JhengHei"/>
+                          <a:cs typeface="Microsoft JhengHei"/>
+                        </a:rPr>
+                        <a:t>支出</a:t>
+                      </a:r>
+                    </a:p>
+                  </a:txBody>
+                  <a:tcPr anchor="ctr" marL="91440" marR="91440" marT="18288" marB="18288">
+                    <a:lnL w="9525">
+                      <a:solidFill>
+                        <a:srgbClr val="D3DEEA"/>
+                      </a:solidFill>
+                    </a:lnL>
+                    <a:lnR w="9525">
+                      <a:solidFill>
+                        <a:srgbClr val="D3DEEA"/>
+                      </a:solidFill>
+                    </a:lnR>
+                    <a:lnT w="9525">
+                      <a:solidFill>
+                        <a:srgbClr val="D3DEEA"/>
+                      </a:solidFill>
+                    </a:lnT>
+                    <a:lnB w="9525">
+                      <a:solidFill>
+                        <a:srgbClr val="D3DEEA"/>
+                      </a:solidFill>
+                    </a:lnB>
+                    <a:solidFill>
+                      <a:srgbClr val="E2EEFA"/>
+                    </a:solidFill>
+                  </a:tcPr>
+                </a:tc>
+                <a:tc>
+                  <a:txBody>
+                    <a:bodyPr wrap="square"/>
+                    <a:lstStyle/>
+                    <a:p>
+                      <a:pPr algn="ctr"/>
+                      <a:r>
+                        <a:rPr sz="1200" b="1">
+                          <a:solidFill>
+                            <a:srgbClr val="2073BE"/>
+                          </a:solidFill>
+                          <a:latin typeface="Microsoft JhengHei"/>
+                          <a:ea typeface="Microsoft JhengHei"/>
+                          <a:cs typeface="Microsoft JhengHei"/>
+                        </a:rPr>
+                        <a:t>損益</a:t>
+                      </a:r>
+                    </a:p>
+                  </a:txBody>
+                  <a:tcPr anchor="ctr" marL="91440" marR="91440" marT="18288" marB="18288">
+                    <a:lnL w="9525">
+                      <a:solidFill>
+                        <a:srgbClr val="D3DEEA"/>
+                      </a:solidFill>
+                    </a:lnL>
+                    <a:lnR w="9525">
+                      <a:solidFill>
+                        <a:srgbClr val="D3DEEA"/>
+                      </a:solidFill>
+                    </a:lnR>
+                    <a:lnT w="9525">
+                      <a:solidFill>
+                        <a:srgbClr val="D3DEEA"/>
+                      </a:solidFill>
+                    </a:lnT>
+                    <a:lnB w="9525">
+                      <a:solidFill>
+                        <a:srgbClr val="D3DEEA"/>
+                      </a:solidFill>
+                    </a:lnB>
+                    <a:solidFill>
+                      <a:srgbClr val="E2EEFA"/>
+                    </a:solidFill>
+                  </a:tcPr>
+                </a:tc>
+              </a:tr>
+              <a:tr h="297180">
+                <a:tc>
+                  <a:txBody>
+                    <a:bodyPr wrap="square"/>
+                    <a:lstStyle/>
+                    <a:p>
+                      <a:pPr algn="ctr"/>
+                      <a:r>
+                        <a:rPr sz="1200" b="0">
+                          <a:solidFill>
+                            <a:srgbClr val="14243A"/>
+                          </a:solidFill>
+                          <a:latin typeface="Microsoft JhengHei"/>
+                          <a:ea typeface="Microsoft JhengHei"/>
+                          <a:cs typeface="Microsoft JhengHei"/>
+                        </a:rPr>
+                        <a:t>0 個</a:t>
+                      </a:r>
+                    </a:p>
+                  </a:txBody>
+                  <a:tcPr anchor="ctr" marL="91440" marR="91440" marT="18288" marB="18288">
+                    <a:lnL w="9525">
+                      <a:solidFill>
+                        <a:srgbClr val="D3DEEA"/>
+                      </a:solidFill>
+                    </a:lnL>
+                    <a:lnR w="9525">
+                      <a:solidFill>
+                        <a:srgbClr val="D3DEEA"/>
+                      </a:solidFill>
+                    </a:lnR>
+                    <a:lnT w="9525">
+                      <a:solidFill>
+                        <a:srgbClr val="D3DEEA"/>
+                      </a:solidFill>
+                    </a:lnT>
+                    <a:lnB w="9525">
+                      <a:solidFill>
+                        <a:srgbClr val="D3DEEA"/>
+                      </a:solidFill>
+                    </a:lnB>
+                    <a:solidFill>
+                      <a:srgbClr val="FFFFFF"/>
+                    </a:solidFill>
+                  </a:tcPr>
+                </a:tc>
+                <a:tc>
+                  <a:txBody>
+                    <a:bodyPr wrap="square"/>
+                    <a:lstStyle/>
+                    <a:p>
+                      <a:pPr algn="r"/>
+                      <a:r>
+                        <a:rPr sz="1200" b="0">
+                          <a:solidFill>
+                            <a:srgbClr val="14243A"/>
+                          </a:solidFill>
+                          <a:latin typeface="Microsoft JhengHei"/>
+                          <a:ea typeface="Microsoft JhengHei"/>
+                          <a:cs typeface="Microsoft JhengHei"/>
+                        </a:rPr>
+                        <a:t>0</a:t>
+                      </a:r>
+                    </a:p>
+                  </a:txBody>
+                  <a:tcPr anchor="ctr" marL="91440" marR="91440" marT="18288" marB="18288">
+                    <a:lnL w="9525">
+                      <a:solidFill>
+                        <a:srgbClr val="D3DEEA"/>
+                      </a:solidFill>
+                    </a:lnL>
+                    <a:lnR w="9525">
+                      <a:solidFill>
+                        <a:srgbClr val="D3DEEA"/>
+                      </a:solidFill>
+                    </a:lnR>
+                    <a:lnT w="9525">
+                      <a:solidFill>
+                        <a:srgbClr val="D3DEEA"/>
+                      </a:solidFill>
+                    </a:lnT>
+                    <a:lnB w="9525">
+                      <a:solidFill>
+                        <a:srgbClr val="D3DEEA"/>
+                      </a:solidFill>
+                    </a:lnB>
+                    <a:solidFill>
+                      <a:srgbClr val="FFFFFF"/>
+                    </a:solidFill>
+                  </a:tcPr>
+                </a:tc>
+                <a:tc>
+                  <a:txBody>
+                    <a:bodyPr wrap="square"/>
+                    <a:lstStyle/>
+                    <a:p>
+                      <a:pPr algn="r"/>
+                      <a:r>
+                        <a:rPr sz="1200" b="0">
+                          <a:solidFill>
+                            <a:srgbClr val="14243A"/>
+                          </a:solidFill>
+                          <a:latin typeface="Microsoft JhengHei"/>
+                          <a:ea typeface="Microsoft JhengHei"/>
+                          <a:cs typeface="Microsoft JhengHei"/>
+                        </a:rPr>
+                        <a:t>1,456</a:t>
+                      </a:r>
+                    </a:p>
+                  </a:txBody>
+                  <a:tcPr anchor="ctr" marL="91440" marR="91440" marT="18288" marB="18288">
+                    <a:lnL w="9525">
+                      <a:solidFill>
+                        <a:srgbClr val="D3DEEA"/>
+                      </a:solidFill>
+                    </a:lnL>
+                    <a:lnR w="9525">
+                      <a:solidFill>
+                        <a:srgbClr val="D3DEEA"/>
+                      </a:solidFill>
+                    </a:lnR>
+                    <a:lnT w="9525">
+                      <a:solidFill>
+                        <a:srgbClr val="D3DEEA"/>
+                      </a:solidFill>
+                    </a:lnT>
+                    <a:lnB w="9525">
+                      <a:solidFill>
+                        <a:srgbClr val="D3DEEA"/>
+                      </a:solidFill>
+                    </a:lnB>
+                    <a:solidFill>
+                      <a:srgbClr val="FFFFFF"/>
+                    </a:solidFill>
+                  </a:tcPr>
+                </a:tc>
+                <a:tc>
+                  <a:txBody>
+                    <a:bodyPr wrap="square"/>
+                    <a:lstStyle/>
+                    <a:p>
+                      <a:pPr algn="r"/>
+                      <a:r>
+                        <a:rPr sz="1200" b="1">
+                          <a:solidFill>
+                            <a:srgbClr val="3F546C"/>
+                          </a:solidFill>
+                          <a:latin typeface="Microsoft JhengHei"/>
+                          <a:ea typeface="Microsoft JhengHei"/>
+                          <a:cs typeface="Microsoft JhengHei"/>
+                        </a:rPr>
+                        <a:t>−1,456</a:t>
+                      </a:r>
+                    </a:p>
+                  </a:txBody>
+                  <a:tcPr anchor="ctr" marL="91440" marR="91440" marT="18288" marB="18288">
+                    <a:lnL w="9525">
+                      <a:solidFill>
+                        <a:srgbClr val="D3DEEA"/>
+                      </a:solidFill>
+                    </a:lnL>
+                    <a:lnR w="9525">
+                      <a:solidFill>
+                        <a:srgbClr val="D3DEEA"/>
+                      </a:solidFill>
+                    </a:lnR>
+                    <a:lnT w="9525">
+                      <a:solidFill>
+                        <a:srgbClr val="D3DEEA"/>
+                      </a:solidFill>
+                    </a:lnT>
+                    <a:lnB w="9525">
+                      <a:solidFill>
+                        <a:srgbClr val="D3DEEA"/>
+                      </a:solidFill>
+                    </a:lnB>
+                    <a:solidFill>
+                      <a:srgbClr val="FFFFFF"/>
+                    </a:solidFill>
+                  </a:tcPr>
+                </a:tc>
+              </a:tr>
+              <a:tr h="297180">
+                <a:tc>
+                  <a:txBody>
+                    <a:bodyPr wrap="square"/>
+                    <a:lstStyle/>
+                    <a:p>
+                      <a:pPr algn="ctr"/>
+                      <a:r>
+                        <a:rPr sz="1200" b="0">
+                          <a:solidFill>
+                            <a:srgbClr val="14243A"/>
+                          </a:solidFill>
+                          <a:latin typeface="Microsoft JhengHei"/>
+                          <a:ea typeface="Microsoft JhengHei"/>
+                          <a:cs typeface="Microsoft JhengHei"/>
+                        </a:rPr>
+                        <a:t>2 個</a:t>
+                      </a:r>
+                    </a:p>
+                  </a:txBody>
+                  <a:tcPr anchor="ctr" marL="91440" marR="91440" marT="18288" marB="18288">
+                    <a:lnL w="9525">
+                      <a:solidFill>
+                        <a:srgbClr val="D3DEEA"/>
+                      </a:solidFill>
+                    </a:lnL>
+                    <a:lnR w="9525">
+                      <a:solidFill>
+                        <a:srgbClr val="D3DEEA"/>
+                      </a:solidFill>
+                    </a:lnR>
+                    <a:lnT w="9525">
+                      <a:solidFill>
+                        <a:srgbClr val="D3DEEA"/>
+                      </a:solidFill>
+                    </a:lnT>
+                    <a:lnB w="9525">
+                      <a:solidFill>
+                        <a:srgbClr val="D3DEEA"/>
+                      </a:solidFill>
+                    </a:lnB>
+                    <a:solidFill>
+                      <a:srgbClr val="F3F7FC"/>
+                    </a:solidFill>
+                  </a:tcPr>
+                </a:tc>
+                <a:tc>
+                  <a:txBody>
+                    <a:bodyPr wrap="square"/>
+                    <a:lstStyle/>
+                    <a:p>
+                      <a:pPr algn="r"/>
+                      <a:r>
+                        <a:rPr sz="1200" b="0">
+                          <a:solidFill>
+                            <a:srgbClr val="14243A"/>
+                          </a:solidFill>
+                          <a:latin typeface="Microsoft JhengHei"/>
+                          <a:ea typeface="Microsoft JhengHei"/>
+                          <a:cs typeface="Microsoft JhengHei"/>
+                        </a:rPr>
+                        <a:t>980</a:t>
+                      </a:r>
+                    </a:p>
+                  </a:txBody>
+                  <a:tcPr anchor="ctr" marL="91440" marR="91440" marT="18288" marB="18288">
+                    <a:lnL w="9525">
+                      <a:solidFill>
+                        <a:srgbClr val="D3DEEA"/>
+                      </a:solidFill>
+                    </a:lnL>
+                    <a:lnR w="9525">
+                      <a:solidFill>
+                        <a:srgbClr val="D3DEEA"/>
+                      </a:solidFill>
+                    </a:lnR>
+                    <a:lnT w="9525">
+                      <a:solidFill>
+                        <a:srgbClr val="D3DEEA"/>
+                      </a:solidFill>
+                    </a:lnT>
+                    <a:lnB w="9525">
+                      <a:solidFill>
+                        <a:srgbClr val="D3DEEA"/>
+                      </a:solidFill>
+                    </a:lnB>
+                    <a:solidFill>
+                      <a:srgbClr val="F3F7FC"/>
+                    </a:solidFill>
+                  </a:tcPr>
+                </a:tc>
+                <a:tc>
+                  <a:txBody>
+                    <a:bodyPr wrap="square"/>
+                    <a:lstStyle/>
+                    <a:p>
+                      <a:pPr algn="r"/>
+                      <a:r>
+                        <a:rPr sz="1200" b="0">
+                          <a:solidFill>
+                            <a:srgbClr val="14243A"/>
+                          </a:solidFill>
+                          <a:latin typeface="Microsoft JhengHei"/>
+                          <a:ea typeface="Microsoft JhengHei"/>
+                          <a:cs typeface="Microsoft JhengHei"/>
+                        </a:rPr>
+                        <a:t>1,562</a:t>
+                      </a:r>
+                    </a:p>
+                  </a:txBody>
+                  <a:tcPr anchor="ctr" marL="91440" marR="91440" marT="18288" marB="18288">
+                    <a:lnL w="9525">
+                      <a:solidFill>
+                        <a:srgbClr val="D3DEEA"/>
+                      </a:solidFill>
+                    </a:lnL>
+                    <a:lnR w="9525">
+                      <a:solidFill>
+                        <a:srgbClr val="D3DEEA"/>
+                      </a:solidFill>
+                    </a:lnR>
+                    <a:lnT w="9525">
+                      <a:solidFill>
+                        <a:srgbClr val="D3DEEA"/>
+                      </a:solidFill>
+                    </a:lnT>
+                    <a:lnB w="9525">
+                      <a:solidFill>
+                        <a:srgbClr val="D3DEEA"/>
+                      </a:solidFill>
+                    </a:lnB>
+                    <a:solidFill>
+                      <a:srgbClr val="F3F7FC"/>
+                    </a:solidFill>
+                  </a:tcPr>
+                </a:tc>
+                <a:tc>
+                  <a:txBody>
+                    <a:bodyPr wrap="square"/>
+                    <a:lstStyle/>
+                    <a:p>
+                      <a:pPr algn="r"/>
+                      <a:r>
+                        <a:rPr sz="1200" b="1">
+                          <a:solidFill>
+                            <a:srgbClr val="3F546C"/>
+                          </a:solidFill>
+                          <a:latin typeface="Microsoft JhengHei"/>
+                          <a:ea typeface="Microsoft JhengHei"/>
+                          <a:cs typeface="Microsoft JhengHei"/>
+                        </a:rPr>
+                        <a:t>−582</a:t>
+                      </a:r>
+                    </a:p>
+                  </a:txBody>
+                  <a:tcPr anchor="ctr" marL="91440" marR="91440" marT="18288" marB="18288">
+                    <a:lnL w="9525">
+                      <a:solidFill>
+                        <a:srgbClr val="D3DEEA"/>
+                      </a:solidFill>
+                    </a:lnL>
+                    <a:lnR w="9525">
+                      <a:solidFill>
+                        <a:srgbClr val="D3DEEA"/>
+                      </a:solidFill>
+                    </a:lnR>
+                    <a:lnT w="9525">
+                      <a:solidFill>
+                        <a:srgbClr val="D3DEEA"/>
+                      </a:solidFill>
+                    </a:lnT>
+                    <a:lnB w="9525">
+                      <a:solidFill>
+                        <a:srgbClr val="D3DEEA"/>
+                      </a:solidFill>
+                    </a:lnB>
+                    <a:solidFill>
+                      <a:srgbClr val="F3F7FC"/>
+                    </a:solidFill>
+                  </a:tcPr>
+                </a:tc>
+              </a:tr>
+              <a:tr h="297180">
+                <a:tc>
+                  <a:txBody>
+                    <a:bodyPr wrap="square"/>
+                    <a:lstStyle/>
+                    <a:p>
+                      <a:pPr algn="ctr"/>
+                      <a:r>
+                        <a:rPr sz="1200" b="0">
+                          <a:solidFill>
+                            <a:srgbClr val="14243A"/>
+                          </a:solidFill>
+                          <a:latin typeface="Microsoft JhengHei"/>
+                          <a:ea typeface="Microsoft JhengHei"/>
+                          <a:cs typeface="Microsoft JhengHei"/>
+                        </a:rPr>
+                        <a:t>3 個</a:t>
+                      </a:r>
+                    </a:p>
+                  </a:txBody>
+                  <a:tcPr anchor="ctr" marL="91440" marR="91440" marT="18288" marB="18288">
+                    <a:lnL w="9525">
+                      <a:solidFill>
+                        <a:srgbClr val="D3DEEA"/>
+                      </a:solidFill>
+                    </a:lnL>
+                    <a:lnR w="9525">
+                      <a:solidFill>
+                        <a:srgbClr val="D3DEEA"/>
+                      </a:solidFill>
+                    </a:lnR>
+                    <a:lnT w="9525">
+                      <a:solidFill>
+                        <a:srgbClr val="D3DEEA"/>
+                      </a:solidFill>
+                    </a:lnT>
+                    <a:lnB w="9525">
+                      <a:solidFill>
+                        <a:srgbClr val="D3DEEA"/>
+                      </a:solidFill>
+                    </a:lnB>
+                    <a:solidFill>
+                      <a:srgbClr val="FFFFFF"/>
+                    </a:solidFill>
+                  </a:tcPr>
+                </a:tc>
+                <a:tc>
+                  <a:txBody>
+                    <a:bodyPr wrap="square"/>
+                    <a:lstStyle/>
+                    <a:p>
+                      <a:pPr algn="r"/>
+                      <a:r>
+                        <a:rPr sz="1200" b="0">
+                          <a:solidFill>
+                            <a:srgbClr val="14243A"/>
+                          </a:solidFill>
+                          <a:latin typeface="Microsoft JhengHei"/>
+                          <a:ea typeface="Microsoft JhengHei"/>
+                          <a:cs typeface="Microsoft JhengHei"/>
+                        </a:rPr>
+                        <a:t>1,470</a:t>
+                      </a:r>
+                    </a:p>
+                  </a:txBody>
+                  <a:tcPr anchor="ctr" marL="91440" marR="91440" marT="18288" marB="18288">
+                    <a:lnL w="9525">
+                      <a:solidFill>
+                        <a:srgbClr val="D3DEEA"/>
+                      </a:solidFill>
+                    </a:lnL>
+                    <a:lnR w="9525">
+                      <a:solidFill>
+                        <a:srgbClr val="D3DEEA"/>
+                      </a:solidFill>
+                    </a:lnR>
+                    <a:lnT w="9525">
+                      <a:solidFill>
+                        <a:srgbClr val="D3DEEA"/>
+                      </a:solidFill>
+                    </a:lnT>
+                    <a:lnB w="9525">
+                      <a:solidFill>
+                        <a:srgbClr val="D3DEEA"/>
+                      </a:solidFill>
+                    </a:lnB>
+                    <a:solidFill>
+                      <a:srgbClr val="FFFFFF"/>
+                    </a:solidFill>
+                  </a:tcPr>
+                </a:tc>
+                <a:tc>
+                  <a:txBody>
+                    <a:bodyPr wrap="square"/>
+                    <a:lstStyle/>
+                    <a:p>
+                      <a:pPr algn="r"/>
+                      <a:r>
+                        <a:rPr sz="1200" b="0">
+                          <a:solidFill>
+                            <a:srgbClr val="14243A"/>
+                          </a:solidFill>
+                          <a:latin typeface="Microsoft JhengHei"/>
+                          <a:ea typeface="Microsoft JhengHei"/>
+                          <a:cs typeface="Microsoft JhengHei"/>
+                        </a:rPr>
+                        <a:t>1,615</a:t>
+                      </a:r>
+                    </a:p>
+                  </a:txBody>
+                  <a:tcPr anchor="ctr" marL="91440" marR="91440" marT="18288" marB="18288">
+                    <a:lnL w="9525">
+                      <a:solidFill>
+                        <a:srgbClr val="D3DEEA"/>
+                      </a:solidFill>
+                    </a:lnL>
+                    <a:lnR w="9525">
+                      <a:solidFill>
+                        <a:srgbClr val="D3DEEA"/>
+                      </a:solidFill>
+                    </a:lnR>
+                    <a:lnT w="9525">
+                      <a:solidFill>
+                        <a:srgbClr val="D3DEEA"/>
+                      </a:solidFill>
+                    </a:lnT>
+                    <a:lnB w="9525">
+                      <a:solidFill>
+                        <a:srgbClr val="D3DEEA"/>
+                      </a:solidFill>
+                    </a:lnB>
+                    <a:solidFill>
+                      <a:srgbClr val="FFFFFF"/>
+                    </a:solidFill>
+                  </a:tcPr>
+                </a:tc>
+                <a:tc>
+                  <a:txBody>
+                    <a:bodyPr wrap="square"/>
+                    <a:lstStyle/>
+                    <a:p>
+                      <a:pPr algn="r"/>
+                      <a:r>
+                        <a:rPr sz="1200" b="1">
+                          <a:solidFill>
+                            <a:srgbClr val="3F546C"/>
+                          </a:solidFill>
+                          <a:latin typeface="Microsoft JhengHei"/>
+                          <a:ea typeface="Microsoft JhengHei"/>
+                          <a:cs typeface="Microsoft JhengHei"/>
+                        </a:rPr>
+                        <a:t>−145</a:t>
+                      </a:r>
+                    </a:p>
+                  </a:txBody>
+                  <a:tcPr anchor="ctr" marL="91440" marR="91440" marT="18288" marB="18288">
+                    <a:lnL w="9525">
+                      <a:solidFill>
+                        <a:srgbClr val="D3DEEA"/>
+                      </a:solidFill>
+                    </a:lnL>
+                    <a:lnR w="9525">
+                      <a:solidFill>
+                        <a:srgbClr val="D3DEEA"/>
+                      </a:solidFill>
+                    </a:lnR>
+                    <a:lnT w="9525">
+                      <a:solidFill>
+                        <a:srgbClr val="D3DEEA"/>
+                      </a:solidFill>
+                    </a:lnT>
+                    <a:lnB w="9525">
+                      <a:solidFill>
+                        <a:srgbClr val="D3DEEA"/>
+                      </a:solidFill>
+                    </a:lnB>
+                    <a:solidFill>
+                      <a:srgbClr val="FFFFFF"/>
+                    </a:solidFill>
+                  </a:tcPr>
+                </a:tc>
+              </a:tr>
+              <a:tr h="297180">
+                <a:tc>
+                  <a:txBody>
+                    <a:bodyPr wrap="square"/>
+                    <a:lstStyle/>
+                    <a:p>
+                      <a:pPr algn="ctr"/>
+                      <a:r>
+                        <a:rPr sz="1200" b="1">
+                          <a:solidFill>
+                            <a:srgbClr val="D46A12"/>
+                          </a:solidFill>
+                          <a:latin typeface="Microsoft JhengHei"/>
+                          <a:ea typeface="Microsoft JhengHei"/>
+                          <a:cs typeface="Microsoft JhengHei"/>
+                        </a:rPr>
+                        <a:t>4 個 ✓</a:t>
+                      </a:r>
+                    </a:p>
+                  </a:txBody>
+                  <a:tcPr anchor="ctr" marL="91440" marR="91440" marT="18288" marB="18288">
+                    <a:lnL w="9525">
+                      <a:solidFill>
+                        <a:srgbClr val="D3DEEA"/>
+                      </a:solidFill>
+                    </a:lnL>
+                    <a:lnR w="9525">
+                      <a:solidFill>
+                        <a:srgbClr val="D3DEEA"/>
+                      </a:solidFill>
+                    </a:lnR>
+                    <a:lnT w="9525">
+                      <a:solidFill>
+                        <a:srgbClr val="D3DEEA"/>
+                      </a:solidFill>
+                    </a:lnT>
+                    <a:lnB w="9525">
+                      <a:solidFill>
+                        <a:srgbClr val="D3DEEA"/>
+                      </a:solidFill>
+                    </a:lnB>
+                    <a:solidFill>
+                      <a:srgbClr val="FDEEDF"/>
+                    </a:solidFill>
+                  </a:tcPr>
+                </a:tc>
+                <a:tc>
+                  <a:txBody>
+                    <a:bodyPr wrap="square"/>
+                    <a:lstStyle/>
+                    <a:p>
+                      <a:pPr algn="r"/>
+                      <a:r>
+                        <a:rPr sz="1200" b="1">
+                          <a:solidFill>
+                            <a:srgbClr val="14243A"/>
+                          </a:solidFill>
+                          <a:latin typeface="Microsoft JhengHei"/>
+                          <a:ea typeface="Microsoft JhengHei"/>
+                          <a:cs typeface="Microsoft JhengHei"/>
+                        </a:rPr>
+                        <a:t>1,960</a:t>
+                      </a:r>
+                    </a:p>
+                  </a:txBody>
+                  <a:tcPr anchor="ctr" marL="91440" marR="91440" marT="18288" marB="18288">
+                    <a:lnL w="9525">
+                      <a:solidFill>
+                        <a:srgbClr val="D3DEEA"/>
+                      </a:solidFill>
+                    </a:lnL>
+                    <a:lnR w="9525">
+                      <a:solidFill>
+                        <a:srgbClr val="D3DEEA"/>
+                      </a:solidFill>
+                    </a:lnR>
+                    <a:lnT w="9525">
+                      <a:solidFill>
+                        <a:srgbClr val="D3DEEA"/>
+                      </a:solidFill>
+                    </a:lnT>
+                    <a:lnB w="9525">
+                      <a:solidFill>
+                        <a:srgbClr val="D3DEEA"/>
+                      </a:solidFill>
+                    </a:lnB>
+                    <a:solidFill>
+                      <a:srgbClr val="FDEEDF"/>
+                    </a:solidFill>
+                  </a:tcPr>
+                </a:tc>
+                <a:tc>
+                  <a:txBody>
+                    <a:bodyPr wrap="square"/>
+                    <a:lstStyle/>
+                    <a:p>
+                      <a:pPr algn="r"/>
+                      <a:r>
+                        <a:rPr sz="1200" b="1">
+                          <a:solidFill>
+                            <a:srgbClr val="14243A"/>
+                          </a:solidFill>
+                          <a:latin typeface="Microsoft JhengHei"/>
+                          <a:ea typeface="Microsoft JhengHei"/>
+                          <a:cs typeface="Microsoft JhengHei"/>
+                        </a:rPr>
+                        <a:t>1,668</a:t>
+                      </a:r>
+                    </a:p>
+                  </a:txBody>
+                  <a:tcPr anchor="ctr" marL="91440" marR="91440" marT="18288" marB="18288">
+                    <a:lnL w="9525">
+                      <a:solidFill>
+                        <a:srgbClr val="D3DEEA"/>
+                      </a:solidFill>
+                    </a:lnL>
+                    <a:lnR w="9525">
+                      <a:solidFill>
+                        <a:srgbClr val="D3DEEA"/>
+                      </a:solidFill>
+                    </a:lnR>
+                    <a:lnT w="9525">
+                      <a:solidFill>
+                        <a:srgbClr val="D3DEEA"/>
+                      </a:solidFill>
+                    </a:lnT>
+                    <a:lnB w="9525">
+                      <a:solidFill>
+                        <a:srgbClr val="D3DEEA"/>
+                      </a:solidFill>
+                    </a:lnB>
+                    <a:solidFill>
+                      <a:srgbClr val="FDEEDF"/>
+                    </a:solidFill>
+                  </a:tcPr>
+                </a:tc>
+                <a:tc>
+                  <a:txBody>
+                    <a:bodyPr wrap="square"/>
+                    <a:lstStyle/>
+                    <a:p>
+                      <a:pPr algn="r"/>
+                      <a:r>
+                        <a:rPr sz="1200" b="1">
+                          <a:solidFill>
+                            <a:srgbClr val="D46A12"/>
+                          </a:solidFill>
+                          <a:latin typeface="Microsoft JhengHei"/>
+                          <a:ea typeface="Microsoft JhengHei"/>
+                          <a:cs typeface="Microsoft JhengHei"/>
+                        </a:rPr>
+                        <a:t>+292</a:t>
+                      </a:r>
+                    </a:p>
+                  </a:txBody>
+                  <a:tcPr anchor="ctr" marL="91440" marR="91440" marT="18288" marB="18288">
+                    <a:lnL w="9525">
+                      <a:solidFill>
+                        <a:srgbClr val="D3DEEA"/>
+                      </a:solidFill>
+                    </a:lnL>
+                    <a:lnR w="9525">
+                      <a:solidFill>
+                        <a:srgbClr val="D3DEEA"/>
+                      </a:solidFill>
+                    </a:lnR>
+                    <a:lnT w="9525">
+                      <a:solidFill>
+                        <a:srgbClr val="D3DEEA"/>
+                      </a:solidFill>
+                    </a:lnT>
+                    <a:lnB w="9525">
+                      <a:solidFill>
+                        <a:srgbClr val="D3DEEA"/>
+                      </a:solidFill>
+                    </a:lnB>
+                    <a:solidFill>
+                      <a:srgbClr val="FDEEDF"/>
+                    </a:solidFill>
+                  </a:tcPr>
+                </a:tc>
+              </a:tr>
+              <a:tr h="297180">
+                <a:tc>
+                  <a:txBody>
+                    <a:bodyPr wrap="square"/>
+                    <a:lstStyle/>
+                    <a:p>
+                      <a:pPr algn="ctr"/>
+                      <a:r>
+                        <a:rPr sz="1200" b="0">
+                          <a:solidFill>
+                            <a:srgbClr val="14243A"/>
+                          </a:solidFill>
+                          <a:latin typeface="Microsoft JhengHei"/>
+                          <a:ea typeface="Microsoft JhengHei"/>
+                          <a:cs typeface="Microsoft JhengHei"/>
+                        </a:rPr>
+                        <a:t>5 個</a:t>
+                      </a:r>
+                    </a:p>
+                  </a:txBody>
+                  <a:tcPr anchor="ctr" marL="91440" marR="91440" marT="18288" marB="18288">
+                    <a:lnL w="9525">
+                      <a:solidFill>
+                        <a:srgbClr val="D3DEEA"/>
+                      </a:solidFill>
+                    </a:lnL>
+                    <a:lnR w="9525">
+                      <a:solidFill>
+                        <a:srgbClr val="D3DEEA"/>
+                      </a:solidFill>
+                    </a:lnR>
+                    <a:lnT w="9525">
+                      <a:solidFill>
+                        <a:srgbClr val="D3DEEA"/>
+                      </a:solidFill>
+                    </a:lnT>
+                    <a:lnB w="9525">
+                      <a:solidFill>
+                        <a:srgbClr val="D3DEEA"/>
+                      </a:solidFill>
+                    </a:lnB>
+                    <a:solidFill>
+                      <a:srgbClr val="FFFFFF"/>
+                    </a:solidFill>
+                  </a:tcPr>
+                </a:tc>
+                <a:tc>
+                  <a:txBody>
+                    <a:bodyPr wrap="square"/>
+                    <a:lstStyle/>
+                    <a:p>
+                      <a:pPr algn="r"/>
+                      <a:r>
+                        <a:rPr sz="1200" b="0">
+                          <a:solidFill>
+                            <a:srgbClr val="14243A"/>
+                          </a:solidFill>
+                          <a:latin typeface="Microsoft JhengHei"/>
+                          <a:ea typeface="Microsoft JhengHei"/>
+                          <a:cs typeface="Microsoft JhengHei"/>
+                        </a:rPr>
+                        <a:t>2,450</a:t>
+                      </a:r>
+                    </a:p>
+                  </a:txBody>
+                  <a:tcPr anchor="ctr" marL="91440" marR="91440" marT="18288" marB="18288">
+                    <a:lnL w="9525">
+                      <a:solidFill>
+                        <a:srgbClr val="D3DEEA"/>
+                      </a:solidFill>
+                    </a:lnL>
+                    <a:lnR w="9525">
+                      <a:solidFill>
+                        <a:srgbClr val="D3DEEA"/>
+                      </a:solidFill>
+                    </a:lnR>
+                    <a:lnT w="9525">
+                      <a:solidFill>
+                        <a:srgbClr val="D3DEEA"/>
+                      </a:solidFill>
+                    </a:lnT>
+                    <a:lnB w="9525">
+                      <a:solidFill>
+                        <a:srgbClr val="D3DEEA"/>
+                      </a:solidFill>
+                    </a:lnB>
+                    <a:solidFill>
+                      <a:srgbClr val="FFFFFF"/>
+                    </a:solidFill>
+                  </a:tcPr>
+                </a:tc>
+                <a:tc>
+                  <a:txBody>
+                    <a:bodyPr wrap="square"/>
+                    <a:lstStyle/>
+                    <a:p>
+                      <a:pPr algn="r"/>
+                      <a:r>
+                        <a:rPr sz="1200" b="0">
+                          <a:solidFill>
+                            <a:srgbClr val="14243A"/>
+                          </a:solidFill>
+                          <a:latin typeface="Microsoft JhengHei"/>
+                          <a:ea typeface="Microsoft JhengHei"/>
+                          <a:cs typeface="Microsoft JhengHei"/>
+                        </a:rPr>
+                        <a:t>1,721</a:t>
+                      </a:r>
+                    </a:p>
+                  </a:txBody>
+                  <a:tcPr anchor="ctr" marL="91440" marR="91440" marT="18288" marB="18288">
+                    <a:lnL w="9525">
+                      <a:solidFill>
+                        <a:srgbClr val="D3DEEA"/>
+                      </a:solidFill>
+                    </a:lnL>
+                    <a:lnR w="9525">
+                      <a:solidFill>
+                        <a:srgbClr val="D3DEEA"/>
+                      </a:solidFill>
+                    </a:lnR>
+                    <a:lnT w="9525">
+                      <a:solidFill>
+                        <a:srgbClr val="D3DEEA"/>
+                      </a:solidFill>
+                    </a:lnT>
+                    <a:lnB w="9525">
+                      <a:solidFill>
+                        <a:srgbClr val="D3DEEA"/>
+                      </a:solidFill>
+                    </a:lnB>
+                    <a:solidFill>
+                      <a:srgbClr val="FFFFFF"/>
+                    </a:solidFill>
+                  </a:tcPr>
+                </a:tc>
+                <a:tc>
+                  <a:txBody>
+                    <a:bodyPr wrap="square"/>
+                    <a:lstStyle/>
+                    <a:p>
+                      <a:pPr algn="r"/>
+                      <a:r>
+                        <a:rPr sz="1200" b="1">
+                          <a:solidFill>
+                            <a:srgbClr val="2073BE"/>
+                          </a:solidFill>
+                          <a:latin typeface="Microsoft JhengHei"/>
+                          <a:ea typeface="Microsoft JhengHei"/>
+                          <a:cs typeface="Microsoft JhengHei"/>
+                        </a:rPr>
+                        <a:t>+729</a:t>
+                      </a:r>
+                    </a:p>
+                  </a:txBody>
+                  <a:tcPr anchor="ctr" marL="91440" marR="91440" marT="18288" marB="18288">
+                    <a:lnL w="9525">
+                      <a:solidFill>
+                        <a:srgbClr val="D3DEEA"/>
+                      </a:solidFill>
+                    </a:lnL>
+                    <a:lnR w="9525">
+                      <a:solidFill>
+                        <a:srgbClr val="D3DEEA"/>
+                      </a:solidFill>
+                    </a:lnR>
+                    <a:lnT w="9525">
+                      <a:solidFill>
+                        <a:srgbClr val="D3DEEA"/>
+                      </a:solidFill>
+                    </a:lnT>
+                    <a:lnB w="9525">
+                      <a:solidFill>
+                        <a:srgbClr val="D3DEEA"/>
+                      </a:solidFill>
+                    </a:lnB>
+                    <a:solidFill>
+                      <a:srgbClr val="FFFFFF"/>
+                    </a:solidFill>
+                  </a:tcPr>
+                </a:tc>
+              </a:tr>
+              <a:tr h="297180">
+                <a:tc>
+                  <a:txBody>
+                    <a:bodyPr wrap="square"/>
+                    <a:lstStyle/>
+                    <a:p>
+                      <a:pPr algn="ctr"/>
+                      <a:r>
+                        <a:rPr sz="1200" b="0">
+                          <a:solidFill>
+                            <a:srgbClr val="14243A"/>
+                          </a:solidFill>
+                          <a:latin typeface="Microsoft JhengHei"/>
+                          <a:ea typeface="Microsoft JhengHei"/>
+                          <a:cs typeface="Microsoft JhengHei"/>
+                        </a:rPr>
+                        <a:t>10 個</a:t>
+                      </a:r>
+                    </a:p>
+                  </a:txBody>
+                  <a:tcPr anchor="ctr" marL="91440" marR="91440" marT="18288" marB="18288">
+                    <a:lnL w="9525">
+                      <a:solidFill>
+                        <a:srgbClr val="D3DEEA"/>
+                      </a:solidFill>
+                    </a:lnL>
+                    <a:lnR w="9525">
+                      <a:solidFill>
+                        <a:srgbClr val="D3DEEA"/>
+                      </a:solidFill>
+                    </a:lnR>
+                    <a:lnT w="9525">
+                      <a:solidFill>
+                        <a:srgbClr val="D3DEEA"/>
+                      </a:solidFill>
+                    </a:lnT>
+                    <a:lnB w="9525">
+                      <a:solidFill>
+                        <a:srgbClr val="D3DEEA"/>
+                      </a:solidFill>
+                    </a:lnB>
+                    <a:solidFill>
+                      <a:srgbClr val="F3F7FC"/>
+                    </a:solidFill>
+                  </a:tcPr>
+                </a:tc>
+                <a:tc>
+                  <a:txBody>
+                    <a:bodyPr wrap="square"/>
+                    <a:lstStyle/>
+                    <a:p>
+                      <a:pPr algn="r"/>
+                      <a:r>
+                        <a:rPr sz="1200" b="0">
+                          <a:solidFill>
+                            <a:srgbClr val="14243A"/>
+                          </a:solidFill>
+                          <a:latin typeface="Microsoft JhengHei"/>
+                          <a:ea typeface="Microsoft JhengHei"/>
+                          <a:cs typeface="Microsoft JhengHei"/>
+                        </a:rPr>
+                        <a:t>4,900</a:t>
+                      </a:r>
+                    </a:p>
+                  </a:txBody>
+                  <a:tcPr anchor="ctr" marL="91440" marR="91440" marT="18288" marB="18288">
+                    <a:lnL w="9525">
+                      <a:solidFill>
+                        <a:srgbClr val="D3DEEA"/>
+                      </a:solidFill>
+                    </a:lnL>
+                    <a:lnR w="9525">
+                      <a:solidFill>
+                        <a:srgbClr val="D3DEEA"/>
+                      </a:solidFill>
+                    </a:lnR>
+                    <a:lnT w="9525">
+                      <a:solidFill>
+                        <a:srgbClr val="D3DEEA"/>
+                      </a:solidFill>
+                    </a:lnT>
+                    <a:lnB w="9525">
+                      <a:solidFill>
+                        <a:srgbClr val="D3DEEA"/>
+                      </a:solidFill>
+                    </a:lnB>
+                    <a:solidFill>
+                      <a:srgbClr val="F3F7FC"/>
+                    </a:solidFill>
+                  </a:tcPr>
+                </a:tc>
+                <a:tc>
+                  <a:txBody>
+                    <a:bodyPr wrap="square"/>
+                    <a:lstStyle/>
+                    <a:p>
+                      <a:pPr algn="r"/>
+                      <a:r>
+                        <a:rPr sz="1200" b="0">
+                          <a:solidFill>
+                            <a:srgbClr val="14243A"/>
+                          </a:solidFill>
+                          <a:latin typeface="Microsoft JhengHei"/>
+                          <a:ea typeface="Microsoft JhengHei"/>
+                          <a:cs typeface="Microsoft JhengHei"/>
+                        </a:rPr>
+                        <a:t>1,986</a:t>
+                      </a:r>
+                    </a:p>
+                  </a:txBody>
+                  <a:tcPr anchor="ctr" marL="91440" marR="91440" marT="18288" marB="18288">
+                    <a:lnL w="9525">
+                      <a:solidFill>
+                        <a:srgbClr val="D3DEEA"/>
+                      </a:solidFill>
+                    </a:lnL>
+                    <a:lnR w="9525">
+                      <a:solidFill>
+                        <a:srgbClr val="D3DEEA"/>
+                      </a:solidFill>
+                    </a:lnR>
+                    <a:lnT w="9525">
+                      <a:solidFill>
+                        <a:srgbClr val="D3DEEA"/>
+                      </a:solidFill>
+                    </a:lnT>
+                    <a:lnB w="9525">
+                      <a:solidFill>
+                        <a:srgbClr val="D3DEEA"/>
+                      </a:solidFill>
+                    </a:lnB>
+                    <a:solidFill>
+                      <a:srgbClr val="F3F7FC"/>
+                    </a:solidFill>
+                  </a:tcPr>
+                </a:tc>
+                <a:tc>
+                  <a:txBody>
+                    <a:bodyPr wrap="square"/>
+                    <a:lstStyle/>
+                    <a:p>
+                      <a:pPr algn="r"/>
+                      <a:r>
+                        <a:rPr sz="1200" b="1">
+                          <a:solidFill>
+                            <a:srgbClr val="2073BE"/>
+                          </a:solidFill>
+                          <a:latin typeface="Microsoft JhengHei"/>
+                          <a:ea typeface="Microsoft JhengHei"/>
+                          <a:cs typeface="Microsoft JhengHei"/>
+                        </a:rPr>
+                        <a:t>+2,914</a:t>
+                      </a:r>
+                    </a:p>
+                  </a:txBody>
+                  <a:tcPr anchor="ctr" marL="91440" marR="91440" marT="18288" marB="18288">
+                    <a:lnL w="9525">
+                      <a:solidFill>
+                        <a:srgbClr val="D3DEEA"/>
+                      </a:solidFill>
+                    </a:lnL>
+                    <a:lnR w="9525">
+                      <a:solidFill>
+                        <a:srgbClr val="D3DEEA"/>
+                      </a:solidFill>
+                    </a:lnR>
+                    <a:lnT w="9525">
+                      <a:solidFill>
+                        <a:srgbClr val="D3DEEA"/>
+                      </a:solidFill>
+                    </a:lnT>
+                    <a:lnB w="9525">
+                      <a:solidFill>
+                        <a:srgbClr val="D3DEEA"/>
+                      </a:solidFill>
+                    </a:lnB>
+                    <a:solidFill>
+                      <a:srgbClr val="F3F7FC"/>
+                    </a:solidFill>
+                  </a:tcPr>
+                </a:tc>
+              </a:tr>
+            </a:tbl>
+          </a:graphicData>
+        </a:graphic>
+      </p:graphicFrame>
       <p:sp>
         <p:nvSpPr>
           <p:cNvPr id="26" name="Shape 23">
@@ -28841,7 +30845,7 @@
                 <a:ea typeface="Microsoft JhengHei"/>
                 <a:cs typeface="Microsoft JhengHei"/>
               </a:rPr>
-              <a:t>新臺幣／月；Gemini 3.1 Flash-Lite 官方單價查於 10/18（1 USD≈32 元）；未含人力，見附錄 C、F。</a:t>
+              <a:t>新臺幣／月；Gemini 3.1 Flash-Lite 每百萬 token 0.25／1.50 美元（10/18 查，1 USD≈32 元）；未含人力，見附錄 C、F。</a:t>
             </a:r>
             <a:endParaRPr sz="1400"/>
           </a:p>
@@ -28905,28 +30909,6 @@
           </a:p>
         </p:txBody>
       </p:sp>
-      <p:graphicFrame>
-        <p:nvGraphicFramePr>
-          <p:cNvPr id="30" name="Chart">
-            <a:extLst>
-              <a:ext uri="{FF2B5EF4-FFF2-40B4-BE49-F238E27FC236}">
-                <a16:creationId xmlns:a16="http://schemas.microsoft.com/office/drawing/2014/main" id="{CF1A1B14-1B85-4032-AA9E-AA4200B256E5}"/>
-              </a:ext>
-            </a:extLst>
-          </p:cNvPr>
-          <p:cNvGraphicFramePr/>
-          <p:nvPr/>
-        </p:nvGraphicFramePr>
-        <p:xfrm>
-          <a:off x="868680" y="3959352"/>
-          <a:ext cx="7772400" cy="1463040"/>
-        </p:xfrm>
-        <a:graphic>
-          <a:graphicData uri="http://schemas.openxmlformats.org/drawingml/2006/chart">
-            <c:chart xmlns:c="http://schemas.openxmlformats.org/drawingml/2006/chart" xmlns:r="http://schemas.openxmlformats.org/officeDocument/2006/relationships" r:id="rId3"/>
-          </a:graphicData>
-        </a:graphic>
-      </p:graphicFrame>
     </p:spTree>
     <p:extLst>
       <p:ext uri="{BB962C8B-B14F-4D97-AF65-F5344CB8AC3E}">

</xml_diff>

<commit_message>
Give every card in the deck the same border and fill
One card each on slides 2, 6, 8, 13 and 18 had a thick orange outline
(and an orange fill on slide 8), unlike its neighbours. They now use the
standard white fill and light border, and the orange text inside the
slide 8 and 18 cards matches the other cards in the row.

Co-Authored-By: Claude Opus 5.5 <noreply@anthropic.com>
</commit_message>
<xml_diff>
--- a/output/ppt-review-20261011/final/MeBOD_複審簡報_第二輪修訂版.pptx
+++ b/output/ppt-review-20261011/final/MeBOD_複審簡報_第二輪修訂版.pptx
@@ -7556,9 +7556,9 @@
           <a:solidFill>
             <a:srgbClr val="FFFFFF"/>
           </a:solidFill>
-          <a:ln w="19050">
+          <a:ln w="12700">
             <a:solidFill>
-              <a:srgbClr val="D46A12"/>
+              <a:srgbClr val="D3DEEA"/>
             </a:solidFill>
             <a:prstDash val="solid"/>
           </a:ln>
@@ -14127,9 +14127,9 @@
           <a:solidFill>
             <a:srgbClr val="FFFFFF"/>
           </a:solidFill>
-          <a:ln w="19050">
+          <a:ln w="12700">
             <a:solidFill>
-              <a:srgbClr val="D46A12"/>
+              <a:srgbClr val="D3DEEA"/>
             </a:solidFill>
             <a:prstDash val="solid"/>
           </a:ln>
@@ -14246,7 +14246,7 @@
             <a:r>
               <a:rPr sz="1800" b="1">
                 <a:solidFill>
-                  <a:srgbClr val="D46A12"/>
+                  <a:srgbClr val="14243A"/>
                 </a:solidFill>
                 <a:latin typeface="Microsoft JhengHei"/>
                 <a:ea typeface="Microsoft JhengHei"/>
@@ -16249,9 +16249,9 @@
           <a:solidFill>
             <a:srgbClr val="FFFFFF"/>
           </a:solidFill>
-          <a:ln w="19050">
+          <a:ln w="12700">
             <a:solidFill>
-              <a:srgbClr val="D46A12"/>
+              <a:srgbClr val="D3DEEA"/>
             </a:solidFill>
             <a:prstDash val="solid"/>
           </a:ln>
@@ -26495,9 +26495,9 @@
           <a:solidFill>
             <a:srgbClr val="FFFFFF"/>
           </a:solidFill>
-          <a:ln w="19050">
+          <a:ln w="12700">
             <a:solidFill>
-              <a:srgbClr val="D46A12"/>
+              <a:srgbClr val="D3DEEA"/>
             </a:solidFill>
             <a:prstDash val="solid"/>
           </a:ln>
@@ -31873,11 +31873,11 @@
             </a:avLst>
           </a:prstGeom>
           <a:solidFill>
-            <a:srgbClr val="FDEEDF"/>
+            <a:srgbClr val="FFFFFF"/>
           </a:solidFill>
-          <a:ln w="19050">
+          <a:ln w="12700">
             <a:solidFill>
-              <a:srgbClr val="D46A12"/>
+              <a:srgbClr val="D3DEEA"/>
             </a:solidFill>
             <a:prstDash val="solid"/>
           </a:ln>
@@ -31924,7 +31924,7 @@
             <a:r>
               <a:rPr sz="1600" b="1">
                 <a:solidFill>
-                  <a:srgbClr val="D46A12"/>
+                  <a:srgbClr val="14243A"/>
                 </a:solidFill>
                 <a:latin typeface="Microsoft JhengHei"/>
                 <a:ea typeface="Microsoft JhengHei"/>
@@ -32033,7 +32033,7 @@
             <a:r>
               <a:rPr sz="1200">
                 <a:solidFill>
-                  <a:srgbClr val="D46A12"/>
+                  <a:srgbClr val="1F6FB8"/>
                 </a:solidFill>
                 <a:latin typeface="Microsoft JhengHei"/>
                 <a:ea typeface="Microsoft JhengHei"/>

</xml_diff>

<commit_message>
Sync the deck appendices and notes with the Gemini 3.1 Flash-Lite costs
Appendix C and F now use the slide 7 figures (437 NT margin, 13-22 accounts
with labour, 0.25/1.50 USD pricing). Speaker notes on slides 6, 7, 15 and
18 are updated, and the table count is 19 after qa_conversations.

Co-Authored-By: Claude Opus 5.5 <noreply@anthropic.com>
</commit_message>
<xml_diff>
--- a/output/ppt-review-20261011/final/MeBOD_複審簡報_第二輪修訂版.pptx
+++ b/output/ppt-review-20261011/final/MeBOD_複審簡報_第二輪修訂版.pptx
@@ -1471,7 +1471,7 @@
           <a:lstStyle/>
           <a:p>
             <a:r>
-              <a:t>【許家全｜140 秒】預先登入正確帳號並備妥兩筆歷史。0–45秒：查詢醫美、設定平台與期間，讀趨勢並點文章。45–95秒：詢問消費者關注重點，展開引用並回原文；可用已完成的答案避免現場等待。95–140秒：歷史比較並匯出Excel。若網站10秒無回應，改以本頁和附錄實際畫面說明，不宣稱即時成功。畫面為原稿嵌入截圖，其數字只屬拍攝當時查詢。</a:t>
+              <a:t>【許家全｜140 秒】預先以專業版或管理員帳號登入並備妥兩筆歷史；Dashboard 開啟時為空白，需先輸入關鍵字再搜尋，訪客與免費版只能查近 7 天。0–45秒：查詢醫美、設定平台與期間，讀趨勢並點文章。45–95秒：詢問消費者關注重點，展開引用並回原文；可用已完成的答案避免現場等待。95–140秒：歷史比較並匯出Excel。若網站10秒無回應，改以本頁和附錄實際畫面說明，不宣稱即時成功。畫面為原稿嵌入截圖，其數字只屬拍攝當時查詢。</a:t>
             </a:r>
           </a:p>
         </p:txBody>
@@ -1702,7 +1702,7 @@
           <a:lstStyle/>
           <a:p>
             <a:r>
-              <a:t>【陳威帆｜105 秒】總結三點：一、四平台到問答與報告形成完整研究流程；二、RAG與分數規則已可說明，後端498項、前端43項自動化測試通過；三、尚未把品質驗證說成全部完成。下一步依序補Linux部署回歸、建立人工標註和檢索題組、辨識業配，再與實際使用者訪談試用。營運上，實測重算後4個專業版帳號可打平雲端支出，算入人力則需12到21個。與通用代理的差異需要同題實測，現階段著重長期資料、來源回查與持續監測。原第16頁測試頁已刪除，主講約13分55秒，可在Demo或此頁多說約35秒。</a:t>
+              <a:t>【陳威帆｜105 秒】總結三點：一、四平台到問答與報告形成完整研究流程；二、RAG與分數規則已可說明，後端522項、前端47項自動化測試通過；三、尚未把品質驗證說成全部完成。下一步依序補Linux部署回歸、建立人工標註和檢索題組、辨識業配，再與實際使用者訪談試用。營運上，實測重算後4個專業版帳號可打平雲端支出，算入人力則需13到22個。與通用代理的差異需要同題實測，現階段著重長期資料、來源回查與持續監測。原第16頁測試頁已刪除，主講約13分55秒，可在Demo或此頁多說約35秒。</a:t>
             </a:r>
           </a:p>
         </p:txBody>
@@ -2010,7 +2010,7 @@
           <a:lstStyle/>
           <a:p>
             <a:r>
-              <a:t>備詢：人力以115年基本工資時薪196元計，每月20或40小時維運。固定支出1,450＋3,920＝5,370，÷463取整為12；1,450＋7,840＝9,290，÷463取整為21。企業版建議價1,990為假設：重度使用者每月1,000次問答約60元、200次洞察約20元、金流3%約60元，貢獻約1,850元，約等於4個專業版。要回答何時獲利，還需實際帳單、獲客速度與開發投入，目前沒有可支持的日期。</a:t>
+              <a:t>備詢：人力以115年基本工資時薪196元計，每月20或40小時維運。固定支出1,456＋3,920＝5,376，÷437取整為13；1,456＋7,840＝9,296，÷437取整為22。企業版建議價1,990為假設：重度使用者每月1,000次問答約182元、200次洞察約66元、金流3%約60元，貢獻約1,682元，約等於3.8個專業版。要回答何時獲利，還需實際帳單、獲客速度與開發投入，目前沒有可支持的日期。</a:t>
             </a:r>
           </a:p>
         </p:txBody>
@@ -2241,7 +2241,7 @@
           <a:lstStyle/>
           <a:p>
             <a:r>
-              <a:t>備詢：本頁列出第7頁與附錄C每個數字的算法。token數由backend/scripts/measure_llm_cost.py以系統實際組prompt的函式量測，不呼叫模型；中文以1字約1 token估算，英文與數字其實更省，結果偏高。Gemini單價查自ai.google.dev/gemini-api/docs/pricing（10/12）；embedding單價依Google開發者部落格公告；Render價格為第三方整理，正式採用前要以官網確認；金流3%為假設。</a:t>
+              <a:t>備詢：本頁列出第7頁與附錄C每個數字的算法。token數由backend/scripts/measure_llm_cost.py以系統實際組prompt的函式量測，不呼叫模型；中文以1字約1 token估算，英文與數字其實更省，結果偏高。Gemini 3.1 Flash-Lite單價查自ai.google.dev/gemini-api/docs/pricing（10/18）；思考token依輸出計價，系統設為minimal；embedding單價依Google開發者部落格公告；Render價格為第三方整理，正式採用前要以官網確認；金流3%為假設。</a:t>
             </a:r>
           </a:p>
         </p:txBody>
@@ -2542,7 +2542,7 @@
           <a:lstStyle/>
           <a:p>
             <a:r>
-              <a:t>【陳威帆｜35 秒】九個區塊串起訂閱服務：小型團隊透過網頁整理口碑，我們維護收錄、分析與檢索，以方案額度區分免費、專業、企業三級。專業版 490、企業版 1,990 都是假設價格，系統已有方案額度但尚未串接收款。成本結構依下一頁實測重算：雲端主機與資料庫是主要固定支出，模型呼叫很便宜，金流手續費與維運人力反而是大頭。來源：backend/app/models/database_models.py（plans）；附錄 C、F。</a:t>
+              <a:t>【陳威帆｜35 秒】九個區塊串起訂閱服務：小型團隊透過網頁整理口碑，我們維護收錄、分析與檢索，以方案額度區分免費、專業、企業三級。專業版 490、企業版 1,990 都是假設價格，系統已有方案額度但尚未串接收款。成本結構依下一頁實測重算：雲端主機與資料庫是主要固定支出；每位專業版用戶每月模型費用約 38 元，加金流手續費約 15 元，變動成本約 53 元；維運人力則是最大的隱藏成本。來源：backend/app/models/database_models.py（plans）；附錄 C、F。</a:t>
             </a:r>
           </a:p>
         </p:txBody>
@@ -2619,7 +2619,7 @@
           <a:lstStyle/>
           <a:p>
             <a:r>
-              <a:t>【陳威帆｜45 秒】初評說我們沒有量化，這頁用實測重算，不再沿用原稿的假設單價。一次 AI 問答包含問題解析與依證據回答兩次呼叫，用系統程式組出真實 prompt，最多約 9,800 token 輸入、2,150 token 輸出，以 Gemini 3.1 Flash-Lite 官方價每百萬 0.25／1.50 美元計算，約 0.18 元；一次洞察約 0.33 元。專業版用戶每月 100 次問答、60 次洞察，加上 3% 金流手續費，變動成本約 53 元。固定支出以 render.yaml 的雲端部署計：主機 25 美元、資料庫 19 美元，加網域與每日判讀約 1,456 元。收入 490N、支出 1,456＋53N，4 個帳號就能打平，每月餘 292 元。但這還沒算人力，算進去要 13 到 22 個帳號，見附錄 C；每個數字的出處在附錄 F。</a:t>
+              <a:t>【陳威帆｜45 秒】初評說我們沒有量化，這頁用實測重算，不再沿用原稿的假設單價。一次 AI 問答包含問題解析與依證據回答兩次呼叫，用系統程式組出真實 prompt，最多約 9,800 token 輸入、2,150 token 輸出，系統已改用 Gemini 3.1 Flash-Lite，思考等級設為 minimal，以官方價每百萬 0.25／1.50 美元計算，約 0.18 元；一次洞察約 0.33 元。專業版用戶每月 100 次問答、60 次洞察，加上 3% 金流手續費，變動成本約 53 元。固定支出以 render.yaml 的雲端部署計：主機 25 美元、資料庫 19 美元，加網域與每日判讀約 1,456 元。收入 490N、支出 1,456＋53N，4 個帳號就能打平，每月餘 292 元。但這還沒算人力，算進去要 13 到 22 個帳號，見附錄 C；每個數字的出處在附錄 F。</a:t>
             </a:r>
           </a:p>
         </p:txBody>
@@ -2773,7 +2773,7 @@
           <a:lstStyle/>
           <a:p>
             <a:r>
-              <a:t>【許家全｜45 秒】Vue介面透過FastAPI存取PostgreSQL，服務層提供分析、檢索及匯出，另接Gemini和四平台收錄。現行ORM有18張表。權限一律在後端檢查；上一版列為缺口的預警已讀端點，已於10/12修正為只能操作自己的預警，並補上跨帳號測試。來源：backend/app/models/database_models.py、backend/app/routers/monitor.py、backend/tests/test_monitor_api.py。</a:t>
+              <a:t>【許家全｜45 秒】Vue介面透過FastAPI存取PostgreSQL，服務層提供分析、檢索及匯出，另接Gemini和四平台收錄。現行ORM有19張表，10/18新增qa_conversations，AI問答對話改存資料庫並依帳號隔離。權限一律在後端檢查；上一版列為缺口的預警已讀端點，已於10/12修正為只能操作自己的預警，並補上跨帳號測試。來源：backend/app/models/database_models.py、backend/app/routers/monitor.py、backend/tests/test_monitor_api.py。</a:t>
             </a:r>
           </a:p>
         </p:txBody>
@@ -4588,7 +4588,7 @@
                 <a:ea typeface="Microsoft JhengHei"/>
                 <a:cs typeface="Microsoft JhengHei"/>
               </a:rPr>
-              <a:t>18 張資料表</a:t>
+              <a:t>19 張資料表</a:t>
             </a:r>
             <a:endParaRPr sz="1400"/>
           </a:p>
@@ -19304,7 +19304,7 @@
                   <a:srgbClr val="14243A"/>
                 </a:solidFill>
               </a:rPr>
-              <a:t>附錄 C｜加入維運人力後，平衡帳號數變成 12～21 個</a:t>
+              <a:t>附錄 C｜加入維運人力後，平衡帳號數變成 13～22 個</a:t>
             </a:r>
           </a:p>
         </p:txBody>
@@ -19560,7 +19560,7 @@
                             <a:srgbClr val="14243A"/>
                           </a:solidFill>
                         </a:rPr>
-                        <a:t>1,450</a:t>
+                        <a:t>1,456</a:t>
                       </a:r>
                     </a:p>
                   </a:txBody>
@@ -19611,7 +19611,7 @@
                             <a:srgbClr val="14243A"/>
                           </a:solidFill>
                         </a:rPr>
-                        <a:t>⌈1,450 ÷ 463⌉ = 4</a:t>
+                        <a:t>⌈1,456 ÷ 437⌉ = 4</a:t>
                       </a:r>
                     </a:p>
                   </a:txBody>
@@ -19717,7 +19717,7 @@
                             <a:srgbClr val="14243A"/>
                           </a:solidFill>
                         </a:rPr>
-                        <a:t>5,370</a:t>
+                        <a:t>5,376</a:t>
                       </a:r>
                     </a:p>
                   </a:txBody>
@@ -19768,7 +19768,7 @@
                             <a:srgbClr val="14243A"/>
                           </a:solidFill>
                         </a:rPr>
-                        <a:t>⌈5,370 ÷ 463⌉ = 12</a:t>
+                        <a:t>⌈5,376 ÷ 437⌉ = 13</a:t>
                       </a:r>
                     </a:p>
                   </a:txBody>
@@ -19874,7 +19874,7 @@
                             <a:srgbClr val="14243A"/>
                           </a:solidFill>
                         </a:rPr>
-                        <a:t>9,290</a:t>
+                        <a:t>9,296</a:t>
                       </a:r>
                     </a:p>
                   </a:txBody>
@@ -19925,7 +19925,7 @@
                             <a:srgbClr val="14243A"/>
                           </a:solidFill>
                         </a:rPr>
-                        <a:t>⌈9,290 ÷ 463⌉ = 21</a:t>
+                        <a:t>⌈9,296 ÷ 437⌉ = 22</a:t>
                       </a:r>
                     </a:p>
                   </a:txBody>
@@ -20028,7 +20028,7 @@
                   <a:srgbClr val="2073BE"/>
                 </a:solidFill>
               </a:rPr>
-              <a:t>每帳號月貢獻＝月費 490 − 變動成本 27＝463 元</a:t>
+              <a:t>每帳號月貢獻＝月費 490 − 變動成本 53＝437 元</a:t>
             </a:r>
           </a:p>
         </p:txBody>
@@ -21099,7 +21099,7 @@
                             <a:srgbClr val="14243A"/>
                           </a:solidFill>
                         </a:rPr>
-                        <a:t>兩次呼叫：輸入 9,794＋輸出 2,150 ≈ 0.06 元</a:t>
+                        <a:t>兩次呼叫：輸入 9,794＋輸出 2,150 ≈ 0.18 元</a:t>
                       </a:r>
                     </a:p>
                   </a:txBody>
@@ -21150,7 +21150,7 @@
                             <a:srgbClr val="14243A"/>
                           </a:solidFill>
                         </a:rPr>
-                        <a:t>Gemini 官方價 0.10／0.40 美元／百萬 token</a:t>
+                        <a:t>Gemini 3.1 Flash-Lite 0.25／1.50 美元／百萬 token；思考等級 minimal</a:t>
                       </a:r>
                     </a:p>
                   </a:txBody>
@@ -21256,7 +21256,7 @@
                             <a:srgbClr val="14243A"/>
                           </a:solidFill>
                         </a:rPr>
-                        <a:t>輸入 14,341＋輸出 4,519 token ≈ 0.10 元</a:t>
+                        <a:t>輸入 14,341＋輸出 4,519 token ≈ 0.33 元</a:t>
                       </a:r>
                     </a:p>
                   </a:txBody>
@@ -21413,7 +21413,7 @@
                             <a:srgbClr val="14243A"/>
                           </a:solidFill>
                         </a:rPr>
-                        <a:t>近 30 天 897 篇＋3,216 則 ≈ 6.3 元（計 7）</a:t>
+                        <a:t>近 30 天 897 篇＋3,216 則 ≈ 12.5 元（計 13）</a:t>
                       </a:r>
                     </a:p>
                   </a:txBody>
@@ -24315,7 +24315,7 @@
                             <a:srgbClr val="14243A"/>
                           </a:solidFill>
                         </a:rPr>
-                        <a:t>四平台、18 張表、分層測試紀錄</a:t>
+                        <a:t>四平台、19 張表、分層測試紀錄</a:t>
                       </a:r>
                     </a:p>
                   </a:txBody>
@@ -33440,7 +33440,7 @@
                 <a:ea typeface="Microsoft JhengHei"/>
                 <a:cs typeface="Microsoft JhengHei"/>
               </a:rPr>
-              <a:t>18 張表・Alembic 遷移</a:t>
+              <a:t>19 張表・Alembic 遷移</a:t>
             </a:r>
             <a:endParaRPr sz="1200"/>
           </a:p>

</xml_diff>

<commit_message>
Add the full speaker script for part 4 (slides 16-18) by Xu Jia-quan
Slides 16-18 are presented by Xu Jia-quan, matching the agenda on slide 2,
and their notes now hold the complete spoken script. The deck also keeps
the presenters' own edits from 10/20 to slides 6, 7, 8, 12, 16 and 24.

Co-Authored-By: Claude Opus 5.5 <noreply@anthropic.com>
</commit_message>
<xml_diff>
--- a/output/ppt-review-20261011/final/MeBOD_複審簡報_第二輪修訂版.pptx
+++ b/output/ppt-review-20261011/final/MeBOD_複審簡報_第二輪修訂版.pptx
@@ -145,367 +145,6 @@
 </file>
 
 <file path=ppt/charts/chart1.xml><?xml version="1.0" encoding="utf-8"?>
-<c:chartSpace xmlns:c="http://schemas.openxmlformats.org/drawingml/2006/chart" xmlns:a="http://schemas.openxmlformats.org/drawingml/2006/main" xmlns:r="http://schemas.openxmlformats.org/officeDocument/2006/relationships" xmlns:c16r2="http://schemas.microsoft.com/office/drawing/2015/06/chart">
-  <c:date1904 val="1"/>
-  <c:lang val="en-US"/>
-  <c:roundedCorners val="1"/>
-  <c:style val="2"/>
-  <c:chart>
-    <c:autoTitleDeleted val="1"/>
-    <c:plotArea>
-      <c:layout/>
-      <c:lineChart>
-        <c:grouping val="standard"/>
-        <c:varyColors val="0"/>
-        <c:ser>
-          <c:idx val="0"/>
-          <c:order val="0"/>
-          <c:tx>
-            <c:strRef>
-              <c:f>Sheet1!$B$1</c:f>
-              <c:strCache>
-                <c:ptCount val="1"/>
-                <c:pt idx="0">
-                  <c:v>月收入</c:v>
-                </c:pt>
-              </c:strCache>
-            </c:strRef>
-          </c:tx>
-          <c:spPr>
-            <a:ln w="28575">
-              <a:solidFill>
-                <a:srgbClr val="2073BE"/>
-              </a:solidFill>
-            </a:ln>
-          </c:spPr>
-          <c:marker>
-            <c:symbol val="circle"/>
-            <c:size val="5"/>
-            <c:spPr>
-              <a:solidFill>
-                <a:srgbClr val="2073BE"/>
-              </a:solidFill>
-            </c:spPr>
-          </c:marker>
-          <c:cat>
-            <c:strRef>
-              <c:f>Sheet1!$A$2:$A$7</c:f>
-              <c:strCache>
-                <c:ptCount val="6"/>
-                <c:pt idx="0">
-                  <c:v>0</c:v>
-                </c:pt>
-                <c:pt idx="1">
-                  <c:v>2</c:v>
-                </c:pt>
-                <c:pt idx="2">
-                  <c:v>4</c:v>
-                </c:pt>
-                <c:pt idx="3">
-                  <c:v>6</c:v>
-                </c:pt>
-                <c:pt idx="4">
-                  <c:v>8</c:v>
-                </c:pt>
-                <c:pt idx="5">
-                  <c:v>10</c:v>
-                </c:pt>
-              </c:strCache>
-            </c:strRef>
-          </c:cat>
-          <c:val>
-            <c:numRef>
-              <c:f>Sheet1!$B$2:$B$7</c:f>
-              <c:numCache>
-                <c:formatCode>General</c:formatCode>
-                <c:ptCount val="6"/>
-                <c:pt idx="0">
-                  <c:v>0</c:v>
-                </c:pt>
-                <c:pt idx="1">
-                  <c:v>980</c:v>
-                </c:pt>
-                <c:pt idx="2">
-                  <c:v>1960</c:v>
-                </c:pt>
-                <c:pt idx="3">
-                  <c:v>2940</c:v>
-                </c:pt>
-                <c:pt idx="4">
-                  <c:v>3920</c:v>
-                </c:pt>
-                <c:pt idx="5">
-                  <c:v>4900</c:v>
-                </c:pt>
-              </c:numCache>
-            </c:numRef>
-          </c:val>
-          <c:smooth val="1"/>
-          <c:extLst>
-            <c:ext xmlns:c16="http://schemas.microsoft.com/office/drawing/2014/chart" uri="{C3380CC4-5D6E-409C-BE32-E72D297353CC}">
-              <c16:uniqueId val="{00000000-E6DB-481F-8D9D-1C27ECDCE128}"/>
-            </c:ext>
-          </c:extLst>
-        </c:ser>
-        <c:ser>
-          <c:idx val="1"/>
-          <c:order val="1"/>
-          <c:tx>
-            <c:strRef>
-              <c:f>Sheet1!$C$1</c:f>
-              <c:strCache>
-                <c:ptCount val="1"/>
-                <c:pt idx="0">
-                  <c:v>月支出</c:v>
-                </c:pt>
-              </c:strCache>
-            </c:strRef>
-          </c:tx>
-          <c:spPr>
-            <a:ln w="28575">
-              <a:solidFill>
-                <a:srgbClr val="D46A12"/>
-              </a:solidFill>
-            </a:ln>
-          </c:spPr>
-          <c:marker>
-            <c:symbol val="circle"/>
-            <c:size val="5"/>
-            <c:spPr>
-              <a:solidFill>
-                <a:srgbClr val="D46A12"/>
-              </a:solidFill>
-            </c:spPr>
-          </c:marker>
-          <c:cat>
-            <c:strRef>
-              <c:f>Sheet1!$A$2:$A$7</c:f>
-              <c:strCache>
-                <c:ptCount val="6"/>
-                <c:pt idx="0">
-                  <c:v>0</c:v>
-                </c:pt>
-                <c:pt idx="1">
-                  <c:v>2</c:v>
-                </c:pt>
-                <c:pt idx="2">
-                  <c:v>4</c:v>
-                </c:pt>
-                <c:pt idx="3">
-                  <c:v>6</c:v>
-                </c:pt>
-                <c:pt idx="4">
-                  <c:v>8</c:v>
-                </c:pt>
-                <c:pt idx="5">
-                  <c:v>10</c:v>
-                </c:pt>
-              </c:strCache>
-            </c:strRef>
-          </c:cat>
-          <c:val>
-            <c:numRef>
-              <c:f>Sheet1!$C$2:$C$7</c:f>
-              <c:numCache>
-                <c:formatCode>General</c:formatCode>
-                <c:ptCount val="6"/>
-                <c:pt idx="0">
-                  <c:v>1456</c:v>
-                </c:pt>
-                <c:pt idx="1">
-                  <c:v>1562</c:v>
-                </c:pt>
-                <c:pt idx="2">
-                  <c:v>1668</c:v>
-                </c:pt>
-                <c:pt idx="3">
-                  <c:v>1774</c:v>
-                </c:pt>
-                <c:pt idx="4">
-                  <c:v>1880</c:v>
-                </c:pt>
-                <c:pt idx="5">
-                  <c:v>1986</c:v>
-                </c:pt>
-              </c:numCache>
-            </c:numRef>
-          </c:val>
-          <c:smooth val="1"/>
-          <c:extLst>
-            <c:ext xmlns:c16="http://schemas.microsoft.com/office/drawing/2014/chart" uri="{C3380CC4-5D6E-409C-BE32-E72D297353CC}">
-              <c16:uniqueId val="{00000001-E6DB-481F-8D9D-1C27ECDCE128}"/>
-            </c:ext>
-          </c:extLst>
-        </c:ser>
-        <c:dLbls>
-          <c:showLegendKey val="0"/>
-          <c:showVal val="0"/>
-          <c:showCatName val="0"/>
-          <c:showSerName val="0"/>
-          <c:showPercent val="0"/>
-          <c:showBubbleSize val="0"/>
-        </c:dLbls>
-        <c:marker val="1"/>
-        <c:smooth val="0"/>
-        <c:axId val="48650112"/>
-        <c:axId val="48672768"/>
-      </c:lineChart>
-      <c:catAx>
-        <c:axId val="48650112"/>
-        <c:scaling>
-          <c:orientation val="minMax"/>
-        </c:scaling>
-        <c:delete val="0"/>
-        <c:axPos val="b"/>
-        <c:title>
-          <c:tx>
-            <c:rich>
-              <a:bodyPr/>
-              <a:lstStyle/>
-              <a:p>
-                <a:r>
-                  <a:rPr lang="zh-TW" altLang="en-US">
-                    <a:latin typeface="Microsoft JhengHei"/>
-                    <a:ea typeface="Microsoft JhengHei"/>
-                    <a:cs typeface="Microsoft JhengHei"/>
-                  </a:rPr>
-                  <a:t>付費帳號數</a:t>
-                </a:r>
-              </a:p>
-            </c:rich>
-          </c:tx>
-          <c:overlay val="0"/>
-        </c:title>
-        <c:numFmt formatCode="General" sourceLinked="1"/>
-        <c:majorTickMark val="none"/>
-        <c:minorTickMark val="none"/>
-        <c:tickLblPos val="nextTo"/>
-        <c:spPr>
-          <a:ln w="9525">
-            <a:solidFill>
-              <a:srgbClr val="D4D4D4"/>
-            </a:solidFill>
-            <a:prstDash val="solid"/>
-          </a:ln>
-        </c:spPr>
-        <c:txPr>
-          <a:bodyPr anchorCtr="1"/>
-          <a:lstStyle/>
-          <a:p>
-            <a:pPr>
-              <a:defRPr sz="1200">
-                <a:solidFill>
-                  <a:srgbClr val="465E78"/>
-                </a:solidFill>
-                <a:latin typeface="Microsoft JhengHei"/>
-                <a:ea typeface="Microsoft JhengHei"/>
-                <a:cs typeface="Microsoft JhengHei"/>
-              </a:defRPr>
-            </a:pPr>
-            <a:endParaRPr lang="en-US"/>
-          </a:p>
-        </c:txPr>
-        <c:crossAx val="48672768"/>
-        <c:crosses val="autoZero"/>
-        <c:auto val="1"/>
-        <c:lblAlgn val="ctr"/>
-        <c:lblOffset val="100"/>
-        <c:noMultiLvlLbl val="1"/>
-      </c:catAx>
-      <c:valAx>
-        <c:axId val="48672768"/>
-        <c:scaling>
-          <c:orientation val="minMax"/>
-          <c:max val="5000"/>
-        </c:scaling>
-        <c:delete val="0"/>
-        <c:axPos val="l"/>
-        <c:majorGridlines>
-          <c:spPr>
-            <a:ln w="9525">
-              <a:solidFill>
-                <a:srgbClr val="E2EEFA"/>
-              </a:solidFill>
-            </a:ln>
-          </c:spPr>
-        </c:majorGridlines>
-        <c:numFmt formatCode="General" sourceLinked="1"/>
-        <c:majorTickMark val="none"/>
-        <c:minorTickMark val="none"/>
-        <c:tickLblPos val="nextTo"/>
-        <c:spPr>
-          <a:ln w="9525">
-            <a:solidFill>
-              <a:srgbClr val="D4D4D4"/>
-            </a:solidFill>
-            <a:prstDash val="solid"/>
-          </a:ln>
-        </c:spPr>
-        <c:txPr>
-          <a:bodyPr anchorCtr="1"/>
-          <a:lstStyle/>
-          <a:p>
-            <a:pPr>
-              <a:defRPr sz="1200">
-                <a:solidFill>
-                  <a:srgbClr val="465E78"/>
-                </a:solidFill>
-                <a:latin typeface="Microsoft JhengHei"/>
-                <a:ea typeface="Microsoft JhengHei"/>
-                <a:cs typeface="Microsoft JhengHei"/>
-              </a:defRPr>
-            </a:pPr>
-            <a:endParaRPr lang="en-US"/>
-          </a:p>
-        </c:txPr>
-        <c:crossAx val="48650112"/>
-        <c:crosses val="autoZero"/>
-        <c:crossBetween val="between"/>
-        <c:majorUnit val="2500"/>
-      </c:valAx>
-      <c:spPr>
-        <a:solidFill>
-          <a:srgbClr val="FFFFFF"/>
-        </a:solidFill>
-      </c:spPr>
-    </c:plotArea>
-    <c:legend>
-      <c:legendPos val="r"/>
-      <c:overlay val="0"/>
-      <c:txPr>
-        <a:bodyPr anchorCtr="1"/>
-        <a:lstStyle/>
-        <a:p>
-          <a:pPr>
-            <a:defRPr sz="1200">
-              <a:solidFill>
-                <a:srgbClr val="465E78"/>
-              </a:solidFill>
-              <a:latin typeface="Microsoft JhengHei"/>
-              <a:ea typeface="Microsoft JhengHei"/>
-              <a:cs typeface="Microsoft JhengHei"/>
-            </a:defRPr>
-          </a:pPr>
-          <a:endParaRPr lang="en-US"/>
-        </a:p>
-      </c:txPr>
-    </c:legend>
-    <c:plotVisOnly val="1"/>
-    <c:dispBlanksAs val="zero"/>
-    <c:showDLblsOverMax val="1"/>
-  </c:chart>
-  <c:spPr>
-    <a:solidFill>
-      <a:srgbClr val="FFFFFF"/>
-    </a:solidFill>
-  </c:spPr>
-  <c:externalData r:id="rId1">
-    <c:autoUpdate val="0"/>
-  </c:externalData>
-</c:chartSpace>
-</file>
-
-<file path=ppt/charts/chart2.xml><?xml version="1.0" encoding="utf-8"?>
 <c:chartSpace xmlns:c="http://schemas.openxmlformats.org/drawingml/2006/chart" xmlns:a="http://schemas.openxmlformats.org/drawingml/2006/main" xmlns:r="http://schemas.openxmlformats.org/officeDocument/2006/relationships" xmlns:c16r2="http://schemas.microsoft.com/office/drawing/2015/06/chart">
   <c:date1904 val="1"/>
   <c:lang val="en-US"/>
@@ -1548,7 +1187,27 @@
           <a:lstStyle/>
           <a:p>
             <a:r>
-              <a:t>【陳威帆｜45 秒】甘特圖保留原稿115/2至116/1的計畫，10月後為計畫工作。繳件與展覽日期沿用原稿，發表前仍按學校公告確認。右側里程碑依各功能第一次提交的月份：5月PTT爬蟲、儀表板與WebSocket；7月帳號登入；8月Dcard、Mobile01、Threads；9月方案額度、Alembic與向量檢索；10月情緒一致性、預警權限與問答檢索修正。提交數由GitHub於10/12統計：5月14、6月0、7月27、8月42、9月47、10月36，共166次，皆已推送；提交集中於單一帳號，不能當作兩位組員的貢獻比例。</a:t>
+              <a:t>【許家全｜45 秒】</a:t>
+            </a:r>
+          </a:p>
+          <a:p>
+            <a:r>
+              <a:t>接下來由我說明進度管理與後續規劃。</a:t>
+            </a:r>
+          </a:p>
+          <a:p>
+            <a:r>
+              <a:t>初評時老師提醒甘特圖要用實際年月，所以這頁從 115 年 2 月排到 116 年 1 月，分成起始、精化、建構、移轉四個階段，目前正在移轉階段。上方標出四個查核點：6 月 2 日初審、10 月 13 日複審繳件、11 月 25 日觀摩展，以及 12 月 29 日最終版。</a:t>
+            </a:r>
+          </a:p>
+          <a:p>
+            <a:r>
+              <a:t>左邊是 GitHub 每月提交數，統計到 10 月 12 日共 166 次；右邊是各月份第一次完成的功能：5 月 PTT 爬蟲與儀表板，7 月帳號與權限，8 月擴充到 Dcard、Mobile01、Threads，9 月加入方案額度、資料庫遷移與向量檢索，10 月則完成情緒一致性與問答修正。</a:t>
+            </a:r>
+          </a:p>
+          <a:p>
+            <a:r>
+              <a:t>來源：GitHub 提交紀錄（10/12 統計：5 月 14、6 月 0、7 月 27、8 月 42、9 月 47、10 月 36）。</a:t>
             </a:r>
           </a:p>
         </p:txBody>
@@ -1625,7 +1284,27 @@
           <a:lstStyle/>
           <a:p>
             <a:r>
-              <a:t>【陳威帆｜30 秒】威帆負責需求、營運、文件統整與報告；家全負責架構、後端、爬蟲、模型、前端與測試。沿用原稿工作分配；程式提交和文件交付分別佐證，不能把單一作者提交數當兩人貢獻比例。來源：使用者原稿第16頁；本機Git提交歷史。</a:t>
+              <a:t>【許家全｜30 秒】</a:t>
+            </a:r>
+          </a:p>
+          <a:p>
+            <a:r>
+              <a:t>分工上，組長威帆負責需求企劃與雜誌社交流，以及成本、STP、TOWS 等營運計畫，並統整系統手冊第 1 到 6 章與簡報。</a:t>
+            </a:r>
+          </a:p>
+          <a:p>
+            <a:r>
+              <a:t>我負責系統架構、資料庫與 FastAPI 後端，四平台爬蟲和每日排程，AI 問答、情緒評分與向量檢索，也包含前端介面、測試，以及手冊第 7 到 12 章。</a:t>
+            </a:r>
+          </a:p>
+          <a:p>
+            <a:r>
+              <a:t>另外說明，程式提交集中在單一帳號，所以提交次數不能直接當作兩個人的貢獻比例。</a:t>
+            </a:r>
+          </a:p>
+          <a:p>
+            <a:r>
+              <a:t>來源：使用者原稿第 16 頁工作分配；本機 Git 提交歷史。</a:t>
             </a:r>
           </a:p>
         </p:txBody>
@@ -1702,7 +1381,37 @@
           <a:lstStyle/>
           <a:p>
             <a:r>
-              <a:t>【陳威帆｜105 秒】總結三點：一、四平台到問答與報告形成完整研究流程；二、RAG與分數規則已可說明，後端522項、前端47項自動化測試通過；三、尚未把品質驗證說成全部完成。下一步依序補Linux部署回歸、建立人工標註和檢索題組、辨識業配，再與實際使用者訪談試用。營運上，實測重算後4個專業版帳號可打平雲端支出，算入人力則需13到22個。與通用代理的差異需要同題實測，現階段著重長期資料、來源回查與持續監測。原第16頁測試頁已刪除，主講約13分55秒，可在Demo或此頁多說約35秒。</a:t>
+              <a:t>【許家全｜105 秒】</a:t>
+            </a:r>
+          </a:p>
+          <a:p>
+            <a:r>
+              <a:t>最後做個總結。</a:t>
+            </a:r>
+          </a:p>
+          <a:p>
+            <a:r>
+              <a:t>先說已經完成的：系統每天自動收錄四個平台的討論；AI 問答用關鍵字加向量的混合檢索，每個回答都附引用來源；情緒評分有 100 篇重跑的一致性紀錄；帳號、方案額度與監測預警都在後端檢查，目前後端 528 項、前端 47 項自動化測試全部通過。營運面依實測重算，4 個專業版帳號就能打平每月約 1,456 元的雲端支出；如果算入每月 20 到 40 小時的維運人力，則需要 13 到 22 個帳號。</a:t>
+            </a:r>
+          </a:p>
+          <a:p>
+            <a:r>
+              <a:t>但我們也要清楚說明還差什麼。下一步依序是：補上 Linux 部署的回歸驗證；建立人工標註，驗證情緒判讀的準確度；用固定題組評估檢索品質；開發業配辨識；最後和實際使用者進行正式的需求訪談與試用。</a:t>
+            </a:r>
+          </a:p>
+          <a:p>
+            <a:r>
+              <a:t>至於評審提到的通用 AI 代理：它確實能自己搜尋、整理資料，我們不宣稱一定比它好。MeBOD 的定位是長期累積的歷史資料、每個回答都能回查原文，以及依帳號持續監測與預警；兩者的差異，我們會用同一題實際比較來驗證。</a:t>
+            </a:r>
+          </a:p>
+          <a:p>
+            <a:r>
+              <a:t>以上是我們的報告，謝謝老師，敬請指教。</a:t>
+            </a:r>
+          </a:p>
+          <a:p>
+            <a:r>
+              <a:t>備註：測試數為 10/20 統計（後端 528 項通過、1 項略過；前端 47 項）。</a:t>
             </a:r>
           </a:p>
         </p:txBody>
@@ -6618,7 +6327,7 @@
               <a:buNone/>
             </a:pPr>
             <a:r>
-              <a:rPr sz="1600" b="1">
+              <a:rPr lang="zh-CN" altLang="en-US" sz="1600" b="1" dirty="0">
                 <a:solidFill>
                   <a:srgbClr val="14243A"/>
                 </a:solidFill>
@@ -6626,9 +6335,31 @@
                 <a:ea typeface="Microsoft JhengHei"/>
                 <a:cs typeface="Microsoft JhengHei"/>
               </a:rPr>
-              <a:t>本批 100 篇標籤變動</a:t>
-            </a:r>
-            <a:endParaRPr sz="1600"/>
+              <a:t>同</a:t>
+            </a:r>
+            <a:r>
+              <a:rPr sz="1600" b="1" dirty="0">
+                <a:solidFill>
+                  <a:srgbClr val="14243A"/>
+                </a:solidFill>
+                <a:latin typeface="Microsoft JhengHei"/>
+                <a:ea typeface="Microsoft JhengHei"/>
+                <a:cs typeface="Microsoft JhengHei"/>
+              </a:rPr>
+              <a:t>批 100 </a:t>
+            </a:r>
+            <a:r>
+              <a:rPr sz="1600" b="1" dirty="0" err="1">
+                <a:solidFill>
+                  <a:srgbClr val="14243A"/>
+                </a:solidFill>
+                <a:latin typeface="Microsoft JhengHei"/>
+                <a:ea typeface="Microsoft JhengHei"/>
+                <a:cs typeface="Microsoft JhengHei"/>
+              </a:rPr>
+              <a:t>篇標籤變動</a:t>
+            </a:r>
+            <a:endParaRPr sz="1600" dirty="0"/>
           </a:p>
         </p:txBody>
       </p:sp>
@@ -6794,11 +6525,9 @@
           <a:bodyPr wrap="square" lIns="0" tIns="0" rIns="0" bIns="0" anchor="ctr"/>
           <a:lstStyle/>
           <a:p>
-            <a:pPr marL="0" indent="0" algn="ctr">
-              <a:buNone/>
-            </a:pPr>
-            <a:r>
-              <a:rPr sz="1600" b="1">
+            <a:pPr algn="ctr"/>
+            <a:r>
+              <a:rPr sz="1600" b="1" dirty="0" err="1">
                 <a:solidFill>
                   <a:srgbClr val="14243A"/>
                 </a:solidFill>
@@ -6806,9 +6535,50 @@
                 <a:ea typeface="Microsoft JhengHei"/>
                 <a:cs typeface="Microsoft JhengHei"/>
               </a:rPr>
-              <a:t>負面 precision（AI 對照）</a:t>
-            </a:r>
-            <a:endParaRPr sz="1600"/>
+              <a:t>負面</a:t>
+            </a:r>
+            <a:r>
+              <a:rPr lang="zh-TW" altLang="en-US" sz="1600" b="1" dirty="0">
+                <a:solidFill>
+                  <a:srgbClr val="14243A"/>
+                </a:solidFill>
+              </a:rPr>
+              <a:t>精確率</a:t>
+            </a:r>
+            <a:r>
+              <a:rPr sz="1600" b="1" dirty="0">
+                <a:solidFill>
+                  <a:srgbClr val="14243A"/>
+                </a:solidFill>
+                <a:latin typeface="Microsoft JhengHei"/>
+                <a:ea typeface="Microsoft JhengHei"/>
+                <a:cs typeface="Microsoft JhengHei"/>
+              </a:rPr>
+              <a:t>（AI </a:t>
+            </a:r>
+            <a:r>
+              <a:rPr sz="1600" b="1" dirty="0" err="1">
+                <a:solidFill>
+                  <a:srgbClr val="14243A"/>
+                </a:solidFill>
+                <a:latin typeface="Microsoft JhengHei"/>
+                <a:ea typeface="Microsoft JhengHei"/>
+                <a:cs typeface="Microsoft JhengHei"/>
+              </a:rPr>
+              <a:t>對照</a:t>
+            </a:r>
+            <a:r>
+              <a:rPr sz="1600" b="1" dirty="0">
+                <a:solidFill>
+                  <a:srgbClr val="14243A"/>
+                </a:solidFill>
+                <a:latin typeface="Microsoft JhengHei"/>
+                <a:ea typeface="Microsoft JhengHei"/>
+                <a:cs typeface="Microsoft JhengHei"/>
+              </a:rPr>
+              <a:t>）</a:t>
+            </a:r>
+            <a:endParaRPr sz="1600" dirty="0"/>
           </a:p>
         </p:txBody>
       </p:sp>
@@ -7066,7 +6836,7 @@
               <a:buNone/>
             </a:pPr>
             <a:r>
-              <a:rPr sz="1400" b="1">
+              <a:rPr sz="1400" b="1" dirty="0" err="1">
                 <a:solidFill>
                   <a:srgbClr val="D46A12"/>
                 </a:solidFill>
@@ -7074,9 +6844,64 @@
                 <a:ea typeface="Microsoft JhengHei"/>
                 <a:cs typeface="Microsoft JhengHei"/>
               </a:rPr>
-              <a:t>全庫 1.6 萬筆已改 temperature 0 重評；模型一致率不等於正確率，人工標註待補。</a:t>
-            </a:r>
-            <a:endParaRPr sz="1400"/>
+              <a:t>全庫</a:t>
+            </a:r>
+            <a:r>
+              <a:rPr sz="1400" b="1" dirty="0">
+                <a:solidFill>
+                  <a:srgbClr val="D46A12"/>
+                </a:solidFill>
+                <a:latin typeface="Microsoft JhengHei"/>
+                <a:ea typeface="Microsoft JhengHei"/>
+                <a:cs typeface="Microsoft JhengHei"/>
+              </a:rPr>
+              <a:t> 1.6 </a:t>
+            </a:r>
+            <a:r>
+              <a:rPr sz="1400" b="1" dirty="0" err="1">
+                <a:solidFill>
+                  <a:srgbClr val="D46A12"/>
+                </a:solidFill>
+                <a:latin typeface="Microsoft JhengHei"/>
+                <a:ea typeface="Microsoft JhengHei"/>
+                <a:cs typeface="Microsoft JhengHei"/>
+              </a:rPr>
+              <a:t>萬筆已改</a:t>
+            </a:r>
+            <a:r>
+              <a:rPr sz="1400" b="1" dirty="0">
+                <a:solidFill>
+                  <a:srgbClr val="D46A12"/>
+                </a:solidFill>
+                <a:latin typeface="Microsoft JhengHei"/>
+                <a:ea typeface="Microsoft JhengHei"/>
+                <a:cs typeface="Microsoft JhengHei"/>
+              </a:rPr>
+              <a:t> temperature 0 </a:t>
+            </a:r>
+            <a:r>
+              <a:rPr sz="1400" b="1" dirty="0" err="1">
+                <a:solidFill>
+                  <a:srgbClr val="D46A12"/>
+                </a:solidFill>
+                <a:latin typeface="Microsoft JhengHei"/>
+                <a:ea typeface="Microsoft JhengHei"/>
+                <a:cs typeface="Microsoft JhengHei"/>
+              </a:rPr>
+              <a:t>重評；模型一致率不等於正確率，人工標註待補</a:t>
+            </a:r>
+            <a:r>
+              <a:rPr sz="1400" b="1" dirty="0">
+                <a:solidFill>
+                  <a:srgbClr val="D46A12"/>
+                </a:solidFill>
+                <a:latin typeface="Microsoft JhengHei"/>
+                <a:ea typeface="Microsoft JhengHei"/>
+                <a:cs typeface="Microsoft JhengHei"/>
+              </a:rPr>
+              <a:t>。</a:t>
+            </a:r>
+            <a:endParaRPr sz="1400" dirty="0"/>
           </a:p>
         </p:txBody>
       </p:sp>
@@ -9685,13 +9510,30 @@
               </a:defRPr>
             </a:pPr>
             <a:r>
-              <a:rPr sz="2700" b="1">
+              <a:rPr sz="2700" b="1" dirty="0" err="1">
+                <a:hlinkClick r:id="rId3">
+                  <a:extLst>
+                    <a:ext uri="{A12FA001-AC4F-418D-AE19-62706E023703}">
+                      <ahyp:hlinkClr xmlns:ahyp="http://schemas.microsoft.com/office/drawing/2018/hyperlinkcolor" val="tx"/>
+                    </a:ext>
+                  </a:extLst>
+                </a:hlinkClick>
+              </a:rPr>
+              <a:t>Demo</a:t>
+            </a:r>
+            <a:r>
+              <a:rPr sz="2700" b="1" dirty="0" err="1">
                 <a:solidFill>
                   <a:srgbClr val="14243A"/>
                 </a:solidFill>
               </a:rPr>
-              <a:t>Demo：完成一次跨平台口碑研究</a:t>
-            </a:r>
+              <a:t>：完成一次跨平台口碑研究</a:t>
+            </a:r>
+            <a:endParaRPr sz="2700" b="1" dirty="0">
+              <a:solidFill>
+                <a:srgbClr val="14243A"/>
+              </a:solidFill>
+            </a:endParaRPr>
           </a:p>
         </p:txBody>
       </p:sp>
@@ -9710,7 +9552,7 @@
           <p:nvPr/>
         </p:nvPicPr>
         <p:blipFill>
-          <a:blip r:embed="rId3"/>
+          <a:blip r:embed="rId4"/>
           <a:stretch/>
         </p:blipFill>
         <p:spPr>
@@ -12492,7 +12334,7 @@
               <a:buNone/>
             </a:pPr>
             <a:r>
-              <a:rPr sz="1400" b="1">
+              <a:rPr sz="1400" b="1" dirty="0">
                 <a:solidFill>
                   <a:srgbClr val="D46A12"/>
                 </a:solidFill>
@@ -12500,9 +12342,75 @@
                 <a:ea typeface="Microsoft JhengHei"/>
                 <a:cs typeface="Microsoft JhengHei"/>
               </a:rPr>
-              <a:t>GitHub：7–10 月 152 次提交（10/12 統計，皆已推送）；非逐人貢獻比例。</a:t>
-            </a:r>
-            <a:endParaRPr sz="1400"/>
+              <a:t>GitHub：7–10 月 1</a:t>
+            </a:r>
+            <a:r>
+              <a:rPr lang="en-US" sz="1400" b="1" dirty="0">
+                <a:solidFill>
+                  <a:srgbClr val="D46A12"/>
+                </a:solidFill>
+                <a:latin typeface="Microsoft JhengHei"/>
+                <a:ea typeface="Microsoft JhengHei"/>
+                <a:cs typeface="Microsoft JhengHei"/>
+              </a:rPr>
+              <a:t>66</a:t>
+            </a:r>
+            <a:r>
+              <a:rPr sz="1400" b="1" dirty="0">
+                <a:solidFill>
+                  <a:srgbClr val="D46A12"/>
+                </a:solidFill>
+                <a:latin typeface="Microsoft JhengHei"/>
+                <a:ea typeface="Microsoft JhengHei"/>
+                <a:cs typeface="Microsoft JhengHei"/>
+              </a:rPr>
+              <a:t> 次提交（10/1</a:t>
+            </a:r>
+            <a:r>
+              <a:rPr lang="en-US" sz="1400" b="1" dirty="0">
+                <a:solidFill>
+                  <a:srgbClr val="D46A12"/>
+                </a:solidFill>
+                <a:latin typeface="Microsoft JhengHei"/>
+                <a:ea typeface="Microsoft JhengHei"/>
+                <a:cs typeface="Microsoft JhengHei"/>
+              </a:rPr>
+              <a:t>1</a:t>
+            </a:r>
+            <a:r>
+              <a:rPr sz="1400" b="1" dirty="0">
+                <a:solidFill>
+                  <a:srgbClr val="D46A12"/>
+                </a:solidFill>
+                <a:latin typeface="Microsoft JhengHei"/>
+                <a:ea typeface="Microsoft JhengHei"/>
+                <a:cs typeface="Microsoft JhengHei"/>
+              </a:rPr>
+              <a:t> </a:t>
+            </a:r>
+            <a:r>
+              <a:rPr sz="1400" b="1" dirty="0" err="1">
+                <a:solidFill>
+                  <a:srgbClr val="D46A12"/>
+                </a:solidFill>
+                <a:latin typeface="Microsoft JhengHei"/>
+                <a:ea typeface="Microsoft JhengHei"/>
+                <a:cs typeface="Microsoft JhengHei"/>
+              </a:rPr>
+              <a:t>統計</a:t>
+            </a:r>
+            <a:r>
+              <a:rPr sz="1400" b="1" dirty="0">
+                <a:solidFill>
+                  <a:srgbClr val="D46A12"/>
+                </a:solidFill>
+                <a:latin typeface="Microsoft JhengHei"/>
+                <a:ea typeface="Microsoft JhengHei"/>
+                <a:cs typeface="Microsoft JhengHei"/>
+              </a:rPr>
+              <a:t>）。</a:t>
+            </a:r>
+            <a:endParaRPr sz="1400" dirty="0"/>
           </a:p>
         </p:txBody>
       </p:sp>
@@ -20862,7 +20770,7 @@
         </p:nvGraphicFramePr>
         <p:xfrm>
           <a:off x="733425" y="1771650"/>
-          <a:ext cx="10725912" cy="3712463"/>
+          <a:ext cx="10725912" cy="3791712"/>
         </p:xfrm>
         <a:graphic>
           <a:graphicData uri="http://schemas.openxmlformats.org/drawingml/2006/table">
@@ -27041,7 +26949,7 @@
               <a:buNone/>
             </a:pPr>
             <a:r>
-              <a:rPr sz="1400">
+              <a:rPr sz="1400" dirty="0" err="1">
                 <a:solidFill>
                   <a:srgbClr val="3F546C"/>
                 </a:solidFill>
@@ -27049,16 +26957,27 @@
                 <a:ea typeface="Microsoft JhengHei"/>
                 <a:cs typeface="Microsoft JhengHei"/>
               </a:rPr>
-              <a:t>免費／專業 490／企業 1,990</a:t>
-            </a:r>
-            <a:endParaRPr sz="1400"/>
+              <a:t>免費／專業</a:t>
+            </a:r>
+            <a:r>
+              <a:rPr sz="1400" dirty="0">
+                <a:solidFill>
+                  <a:srgbClr val="3F546C"/>
+                </a:solidFill>
+                <a:latin typeface="Microsoft JhengHei"/>
+                <a:ea typeface="Microsoft JhengHei"/>
+                <a:cs typeface="Microsoft JhengHei"/>
+              </a:rPr>
+              <a:t> 490</a:t>
+            </a:r>
+            <a:endParaRPr sz="1400" dirty="0"/>
           </a:p>
           <a:p>
             <a:pPr marL="0" indent="0" algn="ctr">
               <a:buNone/>
             </a:pPr>
             <a:r>
-              <a:rPr sz="1400">
+              <a:rPr sz="1400" dirty="0" err="1">
                 <a:solidFill>
                   <a:srgbClr val="3F546C"/>
                 </a:solidFill>
@@ -27068,7 +26987,7 @@
               </a:rPr>
               <a:t>月費皆為假設，待付費意願驗證</a:t>
             </a:r>
-            <a:endParaRPr sz="1400"/>
+            <a:endParaRPr sz="1400" dirty="0"/>
           </a:p>
         </p:txBody>
       </p:sp>
@@ -27887,11 +27806,8 @@
           <a:bodyPr wrap="square" lIns="0" tIns="0" rIns="0" bIns="0" anchor="ctr"/>
           <a:lstStyle/>
           <a:p>
-            <a:pPr marL="0" indent="0">
-              <a:buNone/>
-            </a:pPr>
-            <a:r>
-              <a:rPr sz="3000" b="1">
+            <a:r>
+              <a:rPr sz="3000" b="1" dirty="0" err="1">
                 <a:solidFill>
                   <a:srgbClr val="14243A"/>
                 </a:solidFill>
@@ -27899,9 +27815,39 @@
                 <a:ea typeface="Microsoft JhengHei"/>
                 <a:cs typeface="Microsoft JhengHei"/>
               </a:rPr>
-              <a:t>成本重算：4 個專業版帳號可打平雲端支出</a:t>
-            </a:r>
-            <a:endParaRPr sz="3000"/>
+              <a:t>成本</a:t>
+            </a:r>
+            <a:r>
+              <a:rPr lang="zh-TW" altLang="en-US" sz="3000" b="1" dirty="0">
+                <a:solidFill>
+                  <a:srgbClr val="14243A"/>
+                </a:solidFill>
+              </a:rPr>
+              <a:t>情境</a:t>
+            </a:r>
+            <a:r>
+              <a:rPr sz="3000" b="1" dirty="0">
+                <a:solidFill>
+                  <a:srgbClr val="14243A"/>
+                </a:solidFill>
+                <a:latin typeface="Microsoft JhengHei"/>
+                <a:ea typeface="Microsoft JhengHei"/>
+                <a:cs typeface="Microsoft JhengHei"/>
+              </a:rPr>
+              <a:t>：4 </a:t>
+            </a:r>
+            <a:r>
+              <a:rPr sz="3000" b="1" dirty="0" err="1">
+                <a:solidFill>
+                  <a:srgbClr val="14243A"/>
+                </a:solidFill>
+                <a:latin typeface="Microsoft JhengHei"/>
+                <a:ea typeface="Microsoft JhengHei"/>
+                <a:cs typeface="Microsoft JhengHei"/>
+              </a:rPr>
+              <a:t>個專業版帳號可打平雲端支出</a:t>
+            </a:r>
+            <a:endParaRPr sz="3000" dirty="0"/>
           </a:p>
         </p:txBody>
       </p:sp>
@@ -27911,7 +27857,13 @@
           <p:cNvGraphicFramePr>
             <a:graphicFrameLocks noGrp="1"/>
           </p:cNvGraphicFramePr>
-          <p:nvPr/>
+          <p:nvPr>
+            <p:extLst>
+              <p:ext uri="{D42A27DB-BD31-4B8C-83A1-F6EECF244321}">
+                <p14:modId xmlns:p14="http://schemas.microsoft.com/office/powerpoint/2010/main" val="2352038850"/>
+              </p:ext>
+            </p:extLst>
+          </p:nvPr>
         </p:nvGraphicFramePr>
         <p:xfrm>
           <a:off x="731520" y="1627632"/>
@@ -27922,14 +27874,32 @@
             <a:tbl>
               <a:tblPr/>
               <a:tblGrid>
-                <a:gridCol w="1965960"/>
-                <a:gridCol w="3429000"/>
-                <a:gridCol w="1097280"/>
+                <a:gridCol w="1965960">
+                  <a:extLst>
+                    <a:ext uri="{9D8B030D-6E8A-4147-A177-3AD203B41FA5}">
+                      <a16:colId xmlns:a16="http://schemas.microsoft.com/office/drawing/2014/main" val="20000"/>
+                    </a:ext>
+                  </a:extLst>
+                </a:gridCol>
+                <a:gridCol w="3429000">
+                  <a:extLst>
+                    <a:ext uri="{9D8B030D-6E8A-4147-A177-3AD203B41FA5}">
+                      <a16:colId xmlns:a16="http://schemas.microsoft.com/office/drawing/2014/main" val="20001"/>
+                    </a:ext>
+                  </a:extLst>
+                </a:gridCol>
+                <a:gridCol w="1097280">
+                  <a:extLst>
+                    <a:ext uri="{9D8B030D-6E8A-4147-A177-3AD203B41FA5}">
+                      <a16:colId xmlns:a16="http://schemas.microsoft.com/office/drawing/2014/main" val="20002"/>
+                    </a:ext>
+                  </a:extLst>
+                </a:gridCol>
               </a:tblGrid>
               <a:tr h="315468">
                 <a:tc>
                   <a:txBody>
-                    <a:bodyPr wrap="square"/>
+                    <a:bodyPr/>
                     <a:lstStyle/>
                     <a:p>
                       <a:pPr algn="l"/>
@@ -27946,7 +27916,7 @@
                       </a:r>
                     </a:p>
                   </a:txBody>
-                  <a:tcPr anchor="ctr" marL="91440" marR="91440" marT="18288" marB="18288">
+                  <a:tcPr marT="18288" marB="18288" anchor="ctr">
                     <a:lnL w="9525">
                       <a:solidFill>
                         <a:srgbClr val="D3DEEA"/>
@@ -27974,7 +27944,7 @@
                 </a:tc>
                 <a:tc>
                   <a:txBody>
-                    <a:bodyPr wrap="square"/>
+                    <a:bodyPr/>
                     <a:lstStyle/>
                     <a:p>
                       <a:pPr algn="l"/>
@@ -27991,7 +27961,7 @@
                       </a:r>
                     </a:p>
                   </a:txBody>
-                  <a:tcPr anchor="ctr" marL="91440" marR="91440" marT="18288" marB="18288">
+                  <a:tcPr marT="18288" marB="18288" anchor="ctr">
                     <a:lnL w="9525">
                       <a:solidFill>
                         <a:srgbClr val="D3DEEA"/>
@@ -28019,7 +27989,7 @@
                 </a:tc>
                 <a:tc>
                   <a:txBody>
-                    <a:bodyPr wrap="square"/>
+                    <a:bodyPr/>
                     <a:lstStyle/>
                     <a:p>
                       <a:pPr algn="r"/>
@@ -28036,7 +28006,7 @@
                       </a:r>
                     </a:p>
                   </a:txBody>
-                  <a:tcPr anchor="ctr" marL="91440" marR="91440" marT="18288" marB="18288">
+                  <a:tcPr marT="18288" marB="18288" anchor="ctr">
                     <a:lnL w="9525">
                       <a:solidFill>
                         <a:srgbClr val="D3DEEA"/>
@@ -28062,11 +28032,16 @@
                     </a:solidFill>
                   </a:tcPr>
                 </a:tc>
+                <a:extLst>
+                  <a:ext uri="{0D108BD9-81ED-4DB2-BD59-A6C34878D82A}">
+                    <a16:rowId xmlns:a16="http://schemas.microsoft.com/office/drawing/2014/main" val="10000"/>
+                  </a:ext>
+                </a:extLst>
               </a:tr>
               <a:tr h="315468">
                 <a:tc gridSpan="3">
                   <a:txBody>
-                    <a:bodyPr wrap="square"/>
+                    <a:bodyPr/>
                     <a:lstStyle/>
                     <a:p>
                       <a:pPr algn="l"/>
@@ -28083,7 +28058,7 @@
                       </a:r>
                     </a:p>
                   </a:txBody>
-                  <a:tcPr anchor="ctr" marL="91440" marR="91440" marT="18288" marB="18288">
+                  <a:tcPr marT="18288" marB="18288" anchor="ctr">
                     <a:lnL w="9525">
                       <a:solidFill>
                         <a:srgbClr val="D3DEEA"/>
@@ -28113,7 +28088,9 @@
                   <a:txBody>
                     <a:bodyPr/>
                     <a:lstStyle/>
-                    <a:p/>
+                    <a:p>
+                      <a:endParaRPr/>
+                    </a:p>
                   </a:txBody>
                   <a:tcPr/>
                 </a:tc>
@@ -28121,15 +28098,22 @@
                   <a:txBody>
                     <a:bodyPr/>
                     <a:lstStyle/>
-                    <a:p/>
+                    <a:p>
+                      <a:endParaRPr/>
+                    </a:p>
                   </a:txBody>
                   <a:tcPr/>
                 </a:tc>
+                <a:extLst>
+                  <a:ext uri="{0D108BD9-81ED-4DB2-BD59-A6C34878D82A}">
+                    <a16:rowId xmlns:a16="http://schemas.microsoft.com/office/drawing/2014/main" val="10001"/>
+                  </a:ext>
+                </a:extLst>
               </a:tr>
               <a:tr h="315468">
                 <a:tc>
                   <a:txBody>
-                    <a:bodyPr wrap="square"/>
+                    <a:bodyPr/>
                     <a:lstStyle/>
                     <a:p>
                       <a:pPr algn="l"/>
@@ -28146,7 +28130,7 @@
                       </a:r>
                     </a:p>
                   </a:txBody>
-                  <a:tcPr anchor="ctr" marL="91440" marR="91440" marT="18288" marB="18288">
+                  <a:tcPr marT="18288" marB="18288" anchor="ctr">
                     <a:lnL w="9525">
                       <a:solidFill>
                         <a:srgbClr val="D3DEEA"/>
@@ -28174,12 +28158,12 @@
                 </a:tc>
                 <a:tc>
                   <a:txBody>
-                    <a:bodyPr wrap="square"/>
+                    <a:bodyPr/>
                     <a:lstStyle/>
                     <a:p>
                       <a:pPr algn="l"/>
                       <a:r>
-                        <a:rPr sz="1200" b="0">
+                        <a:rPr sz="1200" b="0" dirty="0">
                           <a:solidFill>
                             <a:srgbClr val="3F546C"/>
                           </a:solidFill>
@@ -28187,11 +28171,33 @@
                           <a:ea typeface="Microsoft JhengHei"/>
                           <a:cs typeface="Microsoft JhengHei"/>
                         </a:rPr>
-                        <a:t>（US$25＋US$19）× 匯率 32</a:t>
+                        <a:t>（US$25＋US$19）× </a:t>
+                      </a:r>
+                      <a:r>
+                        <a:rPr sz="1200" b="0" dirty="0" err="1">
+                          <a:solidFill>
+                            <a:srgbClr val="3F546C"/>
+                          </a:solidFill>
+                          <a:latin typeface="Microsoft JhengHei"/>
+                          <a:ea typeface="Microsoft JhengHei"/>
+                          <a:cs typeface="Microsoft JhengHei"/>
+                        </a:rPr>
+                        <a:t>匯率</a:t>
+                      </a:r>
+                      <a:r>
+                        <a:rPr sz="1200" b="0" dirty="0">
+                          <a:solidFill>
+                            <a:srgbClr val="3F546C"/>
+                          </a:solidFill>
+                          <a:latin typeface="Microsoft JhengHei"/>
+                          <a:ea typeface="Microsoft JhengHei"/>
+                          <a:cs typeface="Microsoft JhengHei"/>
+                        </a:rPr>
+                        <a:t> 32</a:t>
                       </a:r>
                     </a:p>
                   </a:txBody>
-                  <a:tcPr anchor="ctr" marL="91440" marR="91440" marT="18288" marB="18288">
+                  <a:tcPr marT="18288" marB="18288" anchor="ctr">
                     <a:lnL w="9525">
                       <a:solidFill>
                         <a:srgbClr val="D3DEEA"/>
@@ -28219,7 +28225,7 @@
                 </a:tc>
                 <a:tc>
                   <a:txBody>
-                    <a:bodyPr wrap="square"/>
+                    <a:bodyPr/>
                     <a:lstStyle/>
                     <a:p>
                       <a:pPr algn="r"/>
@@ -28236,7 +28242,7 @@
                       </a:r>
                     </a:p>
                   </a:txBody>
-                  <a:tcPr anchor="ctr" marL="91440" marR="91440" marT="18288" marB="18288">
+                  <a:tcPr marT="18288" marB="18288" anchor="ctr">
                     <a:lnL w="9525">
                       <a:solidFill>
                         <a:srgbClr val="D3DEEA"/>
@@ -28262,11 +28268,16 @@
                     </a:solidFill>
                   </a:tcPr>
                 </a:tc>
+                <a:extLst>
+                  <a:ext uri="{0D108BD9-81ED-4DB2-BD59-A6C34878D82A}">
+                    <a16:rowId xmlns:a16="http://schemas.microsoft.com/office/drawing/2014/main" val="10002"/>
+                  </a:ext>
+                </a:extLst>
               </a:tr>
               <a:tr h="315468">
                 <a:tc>
                   <a:txBody>
-                    <a:bodyPr wrap="square"/>
+                    <a:bodyPr/>
                     <a:lstStyle/>
                     <a:p>
                       <a:pPr algn="l"/>
@@ -28283,7 +28294,7 @@
                       </a:r>
                     </a:p>
                   </a:txBody>
-                  <a:tcPr anchor="ctr" marL="91440" marR="91440" marT="18288" marB="18288">
+                  <a:tcPr marT="18288" marB="18288" anchor="ctr">
                     <a:lnL w="9525">
                       <a:solidFill>
                         <a:srgbClr val="D3DEEA"/>
@@ -28311,7 +28322,7 @@
                 </a:tc>
                 <a:tc>
                   <a:txBody>
-                    <a:bodyPr wrap="square"/>
+                    <a:bodyPr/>
                     <a:lstStyle/>
                     <a:p>
                       <a:pPr algn="l"/>
@@ -28328,7 +28339,7 @@
                       </a:r>
                     </a:p>
                   </a:txBody>
-                  <a:tcPr anchor="ctr" marL="91440" marR="91440" marT="18288" marB="18288">
+                  <a:tcPr marT="18288" marB="18288" anchor="ctr">
                     <a:lnL w="9525">
                       <a:solidFill>
                         <a:srgbClr val="D3DEEA"/>
@@ -28356,7 +28367,7 @@
                 </a:tc>
                 <a:tc>
                   <a:txBody>
-                    <a:bodyPr wrap="square"/>
+                    <a:bodyPr/>
                     <a:lstStyle/>
                     <a:p>
                       <a:pPr algn="r"/>
@@ -28373,7 +28384,7 @@
                       </a:r>
                     </a:p>
                   </a:txBody>
-                  <a:tcPr anchor="ctr" marL="91440" marR="91440" marT="18288" marB="18288">
+                  <a:tcPr marT="18288" marB="18288" anchor="ctr">
                     <a:lnL w="9525">
                       <a:solidFill>
                         <a:srgbClr val="D3DEEA"/>
@@ -28399,11 +28410,16 @@
                     </a:solidFill>
                   </a:tcPr>
                 </a:tc>
+                <a:extLst>
+                  <a:ext uri="{0D108BD9-81ED-4DB2-BD59-A6C34878D82A}">
+                    <a16:rowId xmlns:a16="http://schemas.microsoft.com/office/drawing/2014/main" val="10003"/>
+                  </a:ext>
+                </a:extLst>
               </a:tr>
               <a:tr h="315468">
                 <a:tc>
                   <a:txBody>
-                    <a:bodyPr wrap="square"/>
+                    <a:bodyPr/>
                     <a:lstStyle/>
                     <a:p>
                       <a:pPr algn="l"/>
@@ -28420,7 +28436,7 @@
                       </a:r>
                     </a:p>
                   </a:txBody>
-                  <a:tcPr anchor="ctr" marL="91440" marR="91440" marT="18288" marB="18288">
+                  <a:tcPr marT="18288" marB="18288" anchor="ctr">
                     <a:lnL w="9525">
                       <a:solidFill>
                         <a:srgbClr val="D3DEEA"/>
@@ -28448,7 +28464,7 @@
                 </a:tc>
                 <a:tc>
                   <a:txBody>
-                    <a:bodyPr wrap="square"/>
+                    <a:bodyPr/>
                     <a:lstStyle/>
                     <a:p>
                       <a:pPr algn="l"/>
@@ -28465,7 +28481,7 @@
                       </a:r>
                     </a:p>
                   </a:txBody>
-                  <a:tcPr anchor="ctr" marL="91440" marR="91440" marT="18288" marB="18288">
+                  <a:tcPr marT="18288" marB="18288" anchor="ctr">
                     <a:lnL w="9525">
                       <a:solidFill>
                         <a:srgbClr val="D3DEEA"/>
@@ -28493,7 +28509,7 @@
                 </a:tc>
                 <a:tc>
                   <a:txBody>
-                    <a:bodyPr wrap="square"/>
+                    <a:bodyPr/>
                     <a:lstStyle/>
                     <a:p>
                       <a:pPr algn="r"/>
@@ -28510,7 +28526,7 @@
                       </a:r>
                     </a:p>
                   </a:txBody>
-                  <a:tcPr anchor="ctr" marL="91440" marR="91440" marT="18288" marB="18288">
+                  <a:tcPr marT="18288" marB="18288" anchor="ctr">
                     <a:lnL w="9525">
                       <a:solidFill>
                         <a:srgbClr val="D3DEEA"/>
@@ -28536,11 +28552,16 @@
                     </a:solidFill>
                   </a:tcPr>
                 </a:tc>
+                <a:extLst>
+                  <a:ext uri="{0D108BD9-81ED-4DB2-BD59-A6C34878D82A}">
+                    <a16:rowId xmlns:a16="http://schemas.microsoft.com/office/drawing/2014/main" val="10004"/>
+                  </a:ext>
+                </a:extLst>
               </a:tr>
               <a:tr h="315468">
                 <a:tc>
                   <a:txBody>
-                    <a:bodyPr wrap="square"/>
+                    <a:bodyPr/>
                     <a:lstStyle/>
                     <a:p>
                       <a:pPr algn="l"/>
@@ -28557,7 +28578,7 @@
                       </a:r>
                     </a:p>
                   </a:txBody>
-                  <a:tcPr anchor="ctr" marL="91440" marR="91440" marT="18288" marB="18288">
+                  <a:tcPr marT="18288" marB="18288" anchor="ctr">
                     <a:lnL w="9525">
                       <a:solidFill>
                         <a:srgbClr val="D3DEEA"/>
@@ -28585,7 +28606,7 @@
                 </a:tc>
                 <a:tc>
                   <a:txBody>
-                    <a:bodyPr wrap="square"/>
+                    <a:bodyPr/>
                     <a:lstStyle/>
                     <a:p>
                       <a:pPr algn="l"/>
@@ -28602,7 +28623,7 @@
                       </a:r>
                     </a:p>
                   </a:txBody>
-                  <a:tcPr anchor="ctr" marL="91440" marR="91440" marT="18288" marB="18288">
+                  <a:tcPr marT="18288" marB="18288" anchor="ctr">
                     <a:lnL w="9525">
                       <a:solidFill>
                         <a:srgbClr val="D3DEEA"/>
@@ -28630,7 +28651,7 @@
                 </a:tc>
                 <a:tc>
                   <a:txBody>
-                    <a:bodyPr wrap="square"/>
+                    <a:bodyPr/>
                     <a:lstStyle/>
                     <a:p>
                       <a:pPr algn="r"/>
@@ -28647,7 +28668,7 @@
                       </a:r>
                     </a:p>
                   </a:txBody>
-                  <a:tcPr anchor="ctr" marL="91440" marR="91440" marT="18288" marB="18288">
+                  <a:tcPr marT="18288" marB="18288" anchor="ctr">
                     <a:lnL w="9525">
                       <a:solidFill>
                         <a:srgbClr val="D3DEEA"/>
@@ -28673,28 +28694,41 @@
                     </a:solidFill>
                   </a:tcPr>
                 </a:tc>
+                <a:extLst>
+                  <a:ext uri="{0D108BD9-81ED-4DB2-BD59-A6C34878D82A}">
+                    <a16:rowId xmlns:a16="http://schemas.microsoft.com/office/drawing/2014/main" val="10005"/>
+                  </a:ext>
+                </a:extLst>
               </a:tr>
               <a:tr h="315468">
                 <a:tc gridSpan="3">
                   <a:txBody>
-                    <a:bodyPr wrap="square"/>
+                    <a:bodyPr/>
                     <a:lstStyle/>
                     <a:p>
                       <a:pPr algn="l"/>
                       <a:r>
-                        <a:rPr sz="1200" b="1">
+                        <a:rPr lang="zh-TW" altLang="en-US" sz="1200" b="1" dirty="0">
                           <a:solidFill>
                             <a:srgbClr val="3F546C"/>
                           </a:solidFill>
-                          <a:latin typeface="Microsoft JhengHei"/>
+                          <a:latin typeface="+mn-lt"/>
                           <a:ea typeface="Microsoft JhengHei"/>
                           <a:cs typeface="Microsoft JhengHei"/>
                         </a:rPr>
-                        <a:t>變動成本 v：每多 1 位專業版用戶，每月增加</a:t>
+                        <a:t>每位專業版用戶的月用量情境 </a:t>
                       </a:r>
+                      <a:endParaRPr lang="en-US" altLang="zh-TW" sz="1200" b="1" dirty="0">
+                        <a:solidFill>
+                          <a:srgbClr val="3F546C"/>
+                        </a:solidFill>
+                        <a:latin typeface="+mn-lt"/>
+                        <a:ea typeface="Microsoft JhengHei"/>
+                        <a:cs typeface="Microsoft JhengHei"/>
+                      </a:endParaRPr>
                     </a:p>
                   </a:txBody>
-                  <a:tcPr anchor="ctr" marL="91440" marR="91440" marT="18288" marB="18288">
+                  <a:tcPr marT="18288" marB="18288" anchor="ctr">
                     <a:lnL w="9525">
                       <a:solidFill>
                         <a:srgbClr val="D3DEEA"/>
@@ -28724,7 +28758,9 @@
                   <a:txBody>
                     <a:bodyPr/>
                     <a:lstStyle/>
-                    <a:p/>
+                    <a:p>
+                      <a:endParaRPr/>
+                    </a:p>
                   </a:txBody>
                   <a:tcPr/>
                 </a:tc>
@@ -28732,15 +28768,22 @@
                   <a:txBody>
                     <a:bodyPr/>
                     <a:lstStyle/>
-                    <a:p/>
+                    <a:p>
+                      <a:endParaRPr/>
+                    </a:p>
                   </a:txBody>
                   <a:tcPr/>
                 </a:tc>
+                <a:extLst>
+                  <a:ext uri="{0D108BD9-81ED-4DB2-BD59-A6C34878D82A}">
+                    <a16:rowId xmlns:a16="http://schemas.microsoft.com/office/drawing/2014/main" val="10006"/>
+                  </a:ext>
+                </a:extLst>
               </a:tr>
               <a:tr h="315468">
                 <a:tc>
                   <a:txBody>
-                    <a:bodyPr wrap="square"/>
+                    <a:bodyPr/>
                     <a:lstStyle/>
                     <a:p>
                       <a:pPr algn="l"/>
@@ -28757,7 +28800,7 @@
                       </a:r>
                     </a:p>
                   </a:txBody>
-                  <a:tcPr anchor="ctr" marL="91440" marR="91440" marT="18288" marB="18288">
+                  <a:tcPr marT="18288" marB="18288" anchor="ctr">
                     <a:lnL w="9525">
                       <a:solidFill>
                         <a:srgbClr val="D3DEEA"/>
@@ -28785,7 +28828,7 @@
                 </a:tc>
                 <a:tc>
                   <a:txBody>
-                    <a:bodyPr wrap="square"/>
+                    <a:bodyPr/>
                     <a:lstStyle/>
                     <a:p>
                       <a:pPr algn="l"/>
@@ -28802,7 +28845,7 @@
                       </a:r>
                     </a:p>
                   </a:txBody>
-                  <a:tcPr anchor="ctr" marL="91440" marR="91440" marT="18288" marB="18288">
+                  <a:tcPr marT="18288" marB="18288" anchor="ctr">
                     <a:lnL w="9525">
                       <a:solidFill>
                         <a:srgbClr val="D3DEEA"/>
@@ -28830,7 +28873,7 @@
                 </a:tc>
                 <a:tc>
                   <a:txBody>
-                    <a:bodyPr wrap="square"/>
+                    <a:bodyPr/>
                     <a:lstStyle/>
                     <a:p>
                       <a:pPr algn="r"/>
@@ -28847,7 +28890,7 @@
                       </a:r>
                     </a:p>
                   </a:txBody>
-                  <a:tcPr anchor="ctr" marL="91440" marR="91440" marT="18288" marB="18288">
+                  <a:tcPr marT="18288" marB="18288" anchor="ctr">
                     <a:lnL w="9525">
                       <a:solidFill>
                         <a:srgbClr val="D3DEEA"/>
@@ -28873,11 +28916,16 @@
                     </a:solidFill>
                   </a:tcPr>
                 </a:tc>
+                <a:extLst>
+                  <a:ext uri="{0D108BD9-81ED-4DB2-BD59-A6C34878D82A}">
+                    <a16:rowId xmlns:a16="http://schemas.microsoft.com/office/drawing/2014/main" val="10007"/>
+                  </a:ext>
+                </a:extLst>
               </a:tr>
               <a:tr h="315468">
                 <a:tc>
                   <a:txBody>
-                    <a:bodyPr wrap="square"/>
+                    <a:bodyPr/>
                     <a:lstStyle/>
                     <a:p>
                       <a:pPr algn="l"/>
@@ -28894,7 +28942,7 @@
                       </a:r>
                     </a:p>
                   </a:txBody>
-                  <a:tcPr anchor="ctr" marL="91440" marR="91440" marT="18288" marB="18288">
+                  <a:tcPr marT="18288" marB="18288" anchor="ctr">
                     <a:lnL w="9525">
                       <a:solidFill>
                         <a:srgbClr val="D3DEEA"/>
@@ -28922,7 +28970,7 @@
                 </a:tc>
                 <a:tc>
                   <a:txBody>
-                    <a:bodyPr wrap="square"/>
+                    <a:bodyPr/>
                     <a:lstStyle/>
                     <a:p>
                       <a:pPr algn="l"/>
@@ -28939,7 +28987,7 @@
                       </a:r>
                     </a:p>
                   </a:txBody>
-                  <a:tcPr anchor="ctr" marL="91440" marR="91440" marT="18288" marB="18288">
+                  <a:tcPr marT="18288" marB="18288" anchor="ctr">
                     <a:lnL w="9525">
                       <a:solidFill>
                         <a:srgbClr val="D3DEEA"/>
@@ -28967,7 +29015,7 @@
                 </a:tc>
                 <a:tc>
                   <a:txBody>
-                    <a:bodyPr wrap="square"/>
+                    <a:bodyPr/>
                     <a:lstStyle/>
                     <a:p>
                       <a:pPr algn="r"/>
@@ -28984,7 +29032,7 @@
                       </a:r>
                     </a:p>
                   </a:txBody>
-                  <a:tcPr anchor="ctr" marL="91440" marR="91440" marT="18288" marB="18288">
+                  <a:tcPr marT="18288" marB="18288" anchor="ctr">
                     <a:lnL w="9525">
                       <a:solidFill>
                         <a:srgbClr val="D3DEEA"/>
@@ -29010,11 +29058,16 @@
                     </a:solidFill>
                   </a:tcPr>
                 </a:tc>
+                <a:extLst>
+                  <a:ext uri="{0D108BD9-81ED-4DB2-BD59-A6C34878D82A}">
+                    <a16:rowId xmlns:a16="http://schemas.microsoft.com/office/drawing/2014/main" val="10008"/>
+                  </a:ext>
+                </a:extLst>
               </a:tr>
               <a:tr h="315468">
                 <a:tc>
                   <a:txBody>
-                    <a:bodyPr wrap="square"/>
+                    <a:bodyPr/>
                     <a:lstStyle/>
                     <a:p>
                       <a:pPr algn="l"/>
@@ -29031,7 +29084,7 @@
                       </a:r>
                     </a:p>
                   </a:txBody>
-                  <a:tcPr anchor="ctr" marL="91440" marR="91440" marT="18288" marB="18288">
+                  <a:tcPr marT="18288" marB="18288" anchor="ctr">
                     <a:lnL w="9525">
                       <a:solidFill>
                         <a:srgbClr val="D3DEEA"/>
@@ -29059,7 +29112,7 @@
                 </a:tc>
                 <a:tc>
                   <a:txBody>
-                    <a:bodyPr wrap="square"/>
+                    <a:bodyPr/>
                     <a:lstStyle/>
                     <a:p>
                       <a:pPr algn="l"/>
@@ -29076,7 +29129,7 @@
                       </a:r>
                     </a:p>
                   </a:txBody>
-                  <a:tcPr anchor="ctr" marL="91440" marR="91440" marT="18288" marB="18288">
+                  <a:tcPr marT="18288" marB="18288" anchor="ctr">
                     <a:lnL w="9525">
                       <a:solidFill>
                         <a:srgbClr val="D3DEEA"/>
@@ -29104,7 +29157,7 @@
                 </a:tc>
                 <a:tc>
                   <a:txBody>
-                    <a:bodyPr wrap="square"/>
+                    <a:bodyPr/>
                     <a:lstStyle/>
                     <a:p>
                       <a:pPr algn="r"/>
@@ -29121,7 +29174,7 @@
                       </a:r>
                     </a:p>
                   </a:txBody>
-                  <a:tcPr anchor="ctr" marL="91440" marR="91440" marT="18288" marB="18288">
+                  <a:tcPr marT="18288" marB="18288" anchor="ctr">
                     <a:lnL w="9525">
                       <a:solidFill>
                         <a:srgbClr val="D3DEEA"/>
@@ -29147,16 +29200,21 @@
                     </a:solidFill>
                   </a:tcPr>
                 </a:tc>
+                <a:extLst>
+                  <a:ext uri="{0D108BD9-81ED-4DB2-BD59-A6C34878D82A}">
+                    <a16:rowId xmlns:a16="http://schemas.microsoft.com/office/drawing/2014/main" val="10009"/>
+                  </a:ext>
+                </a:extLst>
               </a:tr>
               <a:tr h="315468">
                 <a:tc>
                   <a:txBody>
-                    <a:bodyPr wrap="square"/>
+                    <a:bodyPr/>
                     <a:lstStyle/>
                     <a:p>
                       <a:pPr algn="l"/>
                       <a:r>
-                        <a:rPr sz="1300" b="1">
+                        <a:rPr sz="1300" b="1" dirty="0" err="1">
                           <a:solidFill>
                             <a:srgbClr val="D46A12"/>
                           </a:solidFill>
@@ -29164,11 +29222,22 @@
                           <a:ea typeface="Microsoft JhengHei"/>
                           <a:cs typeface="Microsoft JhengHei"/>
                         </a:rPr>
-                        <a:t>變動成本 v</a:t>
+                        <a:t>變動成本</a:t>
+                      </a:r>
+                      <a:r>
+                        <a:rPr sz="1300" b="1" dirty="0">
+                          <a:solidFill>
+                            <a:srgbClr val="D46A12"/>
+                          </a:solidFill>
+                          <a:latin typeface="Microsoft JhengHei"/>
+                          <a:ea typeface="Microsoft JhengHei"/>
+                          <a:cs typeface="Microsoft JhengHei"/>
+                        </a:rPr>
+                        <a:t> </a:t>
                       </a:r>
                     </a:p>
                   </a:txBody>
-                  <a:tcPr anchor="ctr" marL="91440" marR="91440" marT="18288" marB="18288">
+                  <a:tcPr marT="18288" marB="18288" anchor="ctr">
                     <a:lnL w="9525">
                       <a:solidFill>
                         <a:srgbClr val="D3DEEA"/>
@@ -29196,7 +29265,7 @@
                 </a:tc>
                 <a:tc>
                   <a:txBody>
-                    <a:bodyPr wrap="square"/>
+                    <a:bodyPr/>
                     <a:lstStyle/>
                     <a:p>
                       <a:pPr algn="l"/>
@@ -29213,7 +29282,7 @@
                       </a:r>
                     </a:p>
                   </a:txBody>
-                  <a:tcPr anchor="ctr" marL="91440" marR="91440" marT="18288" marB="18288">
+                  <a:tcPr marT="18288" marB="18288" anchor="ctr">
                     <a:lnL w="9525">
                       <a:solidFill>
                         <a:srgbClr val="D3DEEA"/>
@@ -29241,12 +29310,12 @@
                 </a:tc>
                 <a:tc>
                   <a:txBody>
-                    <a:bodyPr wrap="square"/>
+                    <a:bodyPr/>
                     <a:lstStyle/>
                     <a:p>
                       <a:pPr algn="r"/>
                       <a:r>
-                        <a:rPr sz="1400" b="1">
+                        <a:rPr sz="1400" b="1" dirty="0">
                           <a:solidFill>
                             <a:srgbClr val="D46A12"/>
                           </a:solidFill>
@@ -29258,7 +29327,7 @@
                       </a:r>
                     </a:p>
                   </a:txBody>
-                  <a:tcPr anchor="ctr" marL="91440" marR="91440" marT="18288" marB="18288">
+                  <a:tcPr marT="18288" marB="18288" anchor="ctr">
                     <a:lnL w="9525">
                       <a:solidFill>
                         <a:srgbClr val="D3DEEA"/>
@@ -29284,6 +29353,11 @@
                     </a:solidFill>
                   </a:tcPr>
                 </a:tc>
+                <a:extLst>
+                  <a:ext uri="{0D108BD9-81ED-4DB2-BD59-A6C34878D82A}">
+                    <a16:rowId xmlns:a16="http://schemas.microsoft.com/office/drawing/2014/main" val="10010"/>
+                  </a:ext>
+                </a:extLst>
               </a:tr>
             </a:tbl>
           </a:graphicData>
@@ -29324,7 +29398,7 @@
           </a:fontRef>
         </p:style>
         <p:txBody>
-          <a:bodyPr rtlCol="0" anchor="ctr" wrap="square" lIns="137160" rIns="137160"/>
+          <a:bodyPr wrap="square" lIns="137160" rIns="137160" rtlCol="0" anchor="ctr"/>
           <a:lstStyle/>
           <a:p>
             <a:pPr algn="l">
@@ -29387,7 +29461,7 @@
           </a:fontRef>
         </p:style>
         <p:txBody>
-          <a:bodyPr rtlCol="0" anchor="ctr" wrap="square" lIns="137160" rIns="137160"/>
+          <a:bodyPr wrap="square" lIns="137160" rIns="137160" rtlCol="0" anchor="ctr"/>
           <a:lstStyle/>
           <a:p>
             <a:pPr algn="l">
@@ -29480,15 +29554,39 @@
             <a:tbl>
               <a:tblPr/>
               <a:tblGrid>
-                <a:gridCol w="914400"/>
-                <a:gridCol w="987552"/>
-                <a:gridCol w="987552"/>
-                <a:gridCol w="1115568"/>
+                <a:gridCol w="914400">
+                  <a:extLst>
+                    <a:ext uri="{9D8B030D-6E8A-4147-A177-3AD203B41FA5}">
+                      <a16:colId xmlns:a16="http://schemas.microsoft.com/office/drawing/2014/main" val="20000"/>
+                    </a:ext>
+                  </a:extLst>
+                </a:gridCol>
+                <a:gridCol w="987552">
+                  <a:extLst>
+                    <a:ext uri="{9D8B030D-6E8A-4147-A177-3AD203B41FA5}">
+                      <a16:colId xmlns:a16="http://schemas.microsoft.com/office/drawing/2014/main" val="20001"/>
+                    </a:ext>
+                  </a:extLst>
+                </a:gridCol>
+                <a:gridCol w="987552">
+                  <a:extLst>
+                    <a:ext uri="{9D8B030D-6E8A-4147-A177-3AD203B41FA5}">
+                      <a16:colId xmlns:a16="http://schemas.microsoft.com/office/drawing/2014/main" val="20002"/>
+                    </a:ext>
+                  </a:extLst>
+                </a:gridCol>
+                <a:gridCol w="1115568">
+                  <a:extLst>
+                    <a:ext uri="{9D8B030D-6E8A-4147-A177-3AD203B41FA5}">
+                      <a16:colId xmlns:a16="http://schemas.microsoft.com/office/drawing/2014/main" val="20003"/>
+                    </a:ext>
+                  </a:extLst>
+                </a:gridCol>
               </a:tblGrid>
               <a:tr h="297180">
                 <a:tc>
                   <a:txBody>
-                    <a:bodyPr wrap="square"/>
+                    <a:bodyPr/>
                     <a:lstStyle/>
                     <a:p>
                       <a:pPr algn="ctr"/>
@@ -29505,7 +29603,7 @@
                       </a:r>
                     </a:p>
                   </a:txBody>
-                  <a:tcPr anchor="ctr" marL="91440" marR="91440" marT="18288" marB="18288">
+                  <a:tcPr marT="18288" marB="18288" anchor="ctr">
                     <a:lnL w="9525">
                       <a:solidFill>
                         <a:srgbClr val="D3DEEA"/>
@@ -29533,7 +29631,7 @@
                 </a:tc>
                 <a:tc>
                   <a:txBody>
-                    <a:bodyPr wrap="square"/>
+                    <a:bodyPr/>
                     <a:lstStyle/>
                     <a:p>
                       <a:pPr algn="ctr"/>
@@ -29550,7 +29648,7 @@
                       </a:r>
                     </a:p>
                   </a:txBody>
-                  <a:tcPr anchor="ctr" marL="91440" marR="91440" marT="18288" marB="18288">
+                  <a:tcPr marT="18288" marB="18288" anchor="ctr">
                     <a:lnL w="9525">
                       <a:solidFill>
                         <a:srgbClr val="D3DEEA"/>
@@ -29578,7 +29676,7 @@
                 </a:tc>
                 <a:tc>
                   <a:txBody>
-                    <a:bodyPr wrap="square"/>
+                    <a:bodyPr/>
                     <a:lstStyle/>
                     <a:p>
                       <a:pPr algn="ctr"/>
@@ -29595,7 +29693,7 @@
                       </a:r>
                     </a:p>
                   </a:txBody>
-                  <a:tcPr anchor="ctr" marL="91440" marR="91440" marT="18288" marB="18288">
+                  <a:tcPr marT="18288" marB="18288" anchor="ctr">
                     <a:lnL w="9525">
                       <a:solidFill>
                         <a:srgbClr val="D3DEEA"/>
@@ -29623,7 +29721,7 @@
                 </a:tc>
                 <a:tc>
                   <a:txBody>
-                    <a:bodyPr wrap="square"/>
+                    <a:bodyPr/>
                     <a:lstStyle/>
                     <a:p>
                       <a:pPr algn="ctr"/>
@@ -29640,7 +29738,7 @@
                       </a:r>
                     </a:p>
                   </a:txBody>
-                  <a:tcPr anchor="ctr" marL="91440" marR="91440" marT="18288" marB="18288">
+                  <a:tcPr marT="18288" marB="18288" anchor="ctr">
                     <a:lnL w="9525">
                       <a:solidFill>
                         <a:srgbClr val="D3DEEA"/>
@@ -29666,11 +29764,16 @@
                     </a:solidFill>
                   </a:tcPr>
                 </a:tc>
+                <a:extLst>
+                  <a:ext uri="{0D108BD9-81ED-4DB2-BD59-A6C34878D82A}">
+                    <a16:rowId xmlns:a16="http://schemas.microsoft.com/office/drawing/2014/main" val="10000"/>
+                  </a:ext>
+                </a:extLst>
               </a:tr>
               <a:tr h="297180">
                 <a:tc>
                   <a:txBody>
-                    <a:bodyPr wrap="square"/>
+                    <a:bodyPr/>
                     <a:lstStyle/>
                     <a:p>
                       <a:pPr algn="ctr"/>
@@ -29687,7 +29790,7 @@
                       </a:r>
                     </a:p>
                   </a:txBody>
-                  <a:tcPr anchor="ctr" marL="91440" marR="91440" marT="18288" marB="18288">
+                  <a:tcPr marT="18288" marB="18288" anchor="ctr">
                     <a:lnL w="9525">
                       <a:solidFill>
                         <a:srgbClr val="D3DEEA"/>
@@ -29715,7 +29818,7 @@
                 </a:tc>
                 <a:tc>
                   <a:txBody>
-                    <a:bodyPr wrap="square"/>
+                    <a:bodyPr/>
                     <a:lstStyle/>
                     <a:p>
                       <a:pPr algn="r"/>
@@ -29732,7 +29835,7 @@
                       </a:r>
                     </a:p>
                   </a:txBody>
-                  <a:tcPr anchor="ctr" marL="91440" marR="91440" marT="18288" marB="18288">
+                  <a:tcPr marT="18288" marB="18288" anchor="ctr">
                     <a:lnL w="9525">
                       <a:solidFill>
                         <a:srgbClr val="D3DEEA"/>
@@ -29760,7 +29863,7 @@
                 </a:tc>
                 <a:tc>
                   <a:txBody>
-                    <a:bodyPr wrap="square"/>
+                    <a:bodyPr/>
                     <a:lstStyle/>
                     <a:p>
                       <a:pPr algn="r"/>
@@ -29777,7 +29880,7 @@
                       </a:r>
                     </a:p>
                   </a:txBody>
-                  <a:tcPr anchor="ctr" marL="91440" marR="91440" marT="18288" marB="18288">
+                  <a:tcPr marT="18288" marB="18288" anchor="ctr">
                     <a:lnL w="9525">
                       <a:solidFill>
                         <a:srgbClr val="D3DEEA"/>
@@ -29805,7 +29908,7 @@
                 </a:tc>
                 <a:tc>
                   <a:txBody>
-                    <a:bodyPr wrap="square"/>
+                    <a:bodyPr/>
                     <a:lstStyle/>
                     <a:p>
                       <a:pPr algn="r"/>
@@ -29822,7 +29925,7 @@
                       </a:r>
                     </a:p>
                   </a:txBody>
-                  <a:tcPr anchor="ctr" marL="91440" marR="91440" marT="18288" marB="18288">
+                  <a:tcPr marT="18288" marB="18288" anchor="ctr">
                     <a:lnL w="9525">
                       <a:solidFill>
                         <a:srgbClr val="D3DEEA"/>
@@ -29848,11 +29951,16 @@
                     </a:solidFill>
                   </a:tcPr>
                 </a:tc>
+                <a:extLst>
+                  <a:ext uri="{0D108BD9-81ED-4DB2-BD59-A6C34878D82A}">
+                    <a16:rowId xmlns:a16="http://schemas.microsoft.com/office/drawing/2014/main" val="10001"/>
+                  </a:ext>
+                </a:extLst>
               </a:tr>
               <a:tr h="297180">
                 <a:tc>
                   <a:txBody>
-                    <a:bodyPr wrap="square"/>
+                    <a:bodyPr/>
                     <a:lstStyle/>
                     <a:p>
                       <a:pPr algn="ctr"/>
@@ -29869,7 +29977,7 @@
                       </a:r>
                     </a:p>
                   </a:txBody>
-                  <a:tcPr anchor="ctr" marL="91440" marR="91440" marT="18288" marB="18288">
+                  <a:tcPr marT="18288" marB="18288" anchor="ctr">
                     <a:lnL w="9525">
                       <a:solidFill>
                         <a:srgbClr val="D3DEEA"/>
@@ -29897,7 +30005,7 @@
                 </a:tc>
                 <a:tc>
                   <a:txBody>
-                    <a:bodyPr wrap="square"/>
+                    <a:bodyPr/>
                     <a:lstStyle/>
                     <a:p>
                       <a:pPr algn="r"/>
@@ -29914,7 +30022,7 @@
                       </a:r>
                     </a:p>
                   </a:txBody>
-                  <a:tcPr anchor="ctr" marL="91440" marR="91440" marT="18288" marB="18288">
+                  <a:tcPr marT="18288" marB="18288" anchor="ctr">
                     <a:lnL w="9525">
                       <a:solidFill>
                         <a:srgbClr val="D3DEEA"/>
@@ -29942,7 +30050,7 @@
                 </a:tc>
                 <a:tc>
                   <a:txBody>
-                    <a:bodyPr wrap="square"/>
+                    <a:bodyPr/>
                     <a:lstStyle/>
                     <a:p>
                       <a:pPr algn="r"/>
@@ -29959,7 +30067,7 @@
                       </a:r>
                     </a:p>
                   </a:txBody>
-                  <a:tcPr anchor="ctr" marL="91440" marR="91440" marT="18288" marB="18288">
+                  <a:tcPr marT="18288" marB="18288" anchor="ctr">
                     <a:lnL w="9525">
                       <a:solidFill>
                         <a:srgbClr val="D3DEEA"/>
@@ -29987,7 +30095,7 @@
                 </a:tc>
                 <a:tc>
                   <a:txBody>
-                    <a:bodyPr wrap="square"/>
+                    <a:bodyPr/>
                     <a:lstStyle/>
                     <a:p>
                       <a:pPr algn="r"/>
@@ -30004,7 +30112,7 @@
                       </a:r>
                     </a:p>
                   </a:txBody>
-                  <a:tcPr anchor="ctr" marL="91440" marR="91440" marT="18288" marB="18288">
+                  <a:tcPr marT="18288" marB="18288" anchor="ctr">
                     <a:lnL w="9525">
                       <a:solidFill>
                         <a:srgbClr val="D3DEEA"/>
@@ -30030,11 +30138,16 @@
                     </a:solidFill>
                   </a:tcPr>
                 </a:tc>
+                <a:extLst>
+                  <a:ext uri="{0D108BD9-81ED-4DB2-BD59-A6C34878D82A}">
+                    <a16:rowId xmlns:a16="http://schemas.microsoft.com/office/drawing/2014/main" val="10002"/>
+                  </a:ext>
+                </a:extLst>
               </a:tr>
               <a:tr h="297180">
                 <a:tc>
                   <a:txBody>
-                    <a:bodyPr wrap="square"/>
+                    <a:bodyPr/>
                     <a:lstStyle/>
                     <a:p>
                       <a:pPr algn="ctr"/>
@@ -30051,7 +30164,7 @@
                       </a:r>
                     </a:p>
                   </a:txBody>
-                  <a:tcPr anchor="ctr" marL="91440" marR="91440" marT="18288" marB="18288">
+                  <a:tcPr marT="18288" marB="18288" anchor="ctr">
                     <a:lnL w="9525">
                       <a:solidFill>
                         <a:srgbClr val="D3DEEA"/>
@@ -30079,7 +30192,7 @@
                 </a:tc>
                 <a:tc>
                   <a:txBody>
-                    <a:bodyPr wrap="square"/>
+                    <a:bodyPr/>
                     <a:lstStyle/>
                     <a:p>
                       <a:pPr algn="r"/>
@@ -30096,7 +30209,7 @@
                       </a:r>
                     </a:p>
                   </a:txBody>
-                  <a:tcPr anchor="ctr" marL="91440" marR="91440" marT="18288" marB="18288">
+                  <a:tcPr marT="18288" marB="18288" anchor="ctr">
                     <a:lnL w="9525">
                       <a:solidFill>
                         <a:srgbClr val="D3DEEA"/>
@@ -30124,7 +30237,7 @@
                 </a:tc>
                 <a:tc>
                   <a:txBody>
-                    <a:bodyPr wrap="square"/>
+                    <a:bodyPr/>
                     <a:lstStyle/>
                     <a:p>
                       <a:pPr algn="r"/>
@@ -30141,7 +30254,7 @@
                       </a:r>
                     </a:p>
                   </a:txBody>
-                  <a:tcPr anchor="ctr" marL="91440" marR="91440" marT="18288" marB="18288">
+                  <a:tcPr marT="18288" marB="18288" anchor="ctr">
                     <a:lnL w="9525">
                       <a:solidFill>
                         <a:srgbClr val="D3DEEA"/>
@@ -30169,7 +30282,7 @@
                 </a:tc>
                 <a:tc>
                   <a:txBody>
-                    <a:bodyPr wrap="square"/>
+                    <a:bodyPr/>
                     <a:lstStyle/>
                     <a:p>
                       <a:pPr algn="r"/>
@@ -30186,7 +30299,7 @@
                       </a:r>
                     </a:p>
                   </a:txBody>
-                  <a:tcPr anchor="ctr" marL="91440" marR="91440" marT="18288" marB="18288">
+                  <a:tcPr marT="18288" marB="18288" anchor="ctr">
                     <a:lnL w="9525">
                       <a:solidFill>
                         <a:srgbClr val="D3DEEA"/>
@@ -30212,11 +30325,16 @@
                     </a:solidFill>
                   </a:tcPr>
                 </a:tc>
+                <a:extLst>
+                  <a:ext uri="{0D108BD9-81ED-4DB2-BD59-A6C34878D82A}">
+                    <a16:rowId xmlns:a16="http://schemas.microsoft.com/office/drawing/2014/main" val="10003"/>
+                  </a:ext>
+                </a:extLst>
               </a:tr>
               <a:tr h="297180">
                 <a:tc>
                   <a:txBody>
-                    <a:bodyPr wrap="square"/>
+                    <a:bodyPr/>
                     <a:lstStyle/>
                     <a:p>
                       <a:pPr algn="ctr"/>
@@ -30233,7 +30351,7 @@
                       </a:r>
                     </a:p>
                   </a:txBody>
-                  <a:tcPr anchor="ctr" marL="91440" marR="91440" marT="18288" marB="18288">
+                  <a:tcPr marT="18288" marB="18288" anchor="ctr">
                     <a:lnL w="9525">
                       <a:solidFill>
                         <a:srgbClr val="D3DEEA"/>
@@ -30261,7 +30379,7 @@
                 </a:tc>
                 <a:tc>
                   <a:txBody>
-                    <a:bodyPr wrap="square"/>
+                    <a:bodyPr/>
                     <a:lstStyle/>
                     <a:p>
                       <a:pPr algn="r"/>
@@ -30278,7 +30396,7 @@
                       </a:r>
                     </a:p>
                   </a:txBody>
-                  <a:tcPr anchor="ctr" marL="91440" marR="91440" marT="18288" marB="18288">
+                  <a:tcPr marT="18288" marB="18288" anchor="ctr">
                     <a:lnL w="9525">
                       <a:solidFill>
                         <a:srgbClr val="D3DEEA"/>
@@ -30306,7 +30424,7 @@
                 </a:tc>
                 <a:tc>
                   <a:txBody>
-                    <a:bodyPr wrap="square"/>
+                    <a:bodyPr/>
                     <a:lstStyle/>
                     <a:p>
                       <a:pPr algn="r"/>
@@ -30323,7 +30441,7 @@
                       </a:r>
                     </a:p>
                   </a:txBody>
-                  <a:tcPr anchor="ctr" marL="91440" marR="91440" marT="18288" marB="18288">
+                  <a:tcPr marT="18288" marB="18288" anchor="ctr">
                     <a:lnL w="9525">
                       <a:solidFill>
                         <a:srgbClr val="D3DEEA"/>
@@ -30351,7 +30469,7 @@
                 </a:tc>
                 <a:tc>
                   <a:txBody>
-                    <a:bodyPr wrap="square"/>
+                    <a:bodyPr/>
                     <a:lstStyle/>
                     <a:p>
                       <a:pPr algn="r"/>
@@ -30368,7 +30486,7 @@
                       </a:r>
                     </a:p>
                   </a:txBody>
-                  <a:tcPr anchor="ctr" marL="91440" marR="91440" marT="18288" marB="18288">
+                  <a:tcPr marT="18288" marB="18288" anchor="ctr">
                     <a:lnL w="9525">
                       <a:solidFill>
                         <a:srgbClr val="D3DEEA"/>
@@ -30394,11 +30512,16 @@
                     </a:solidFill>
                   </a:tcPr>
                 </a:tc>
+                <a:extLst>
+                  <a:ext uri="{0D108BD9-81ED-4DB2-BD59-A6C34878D82A}">
+                    <a16:rowId xmlns:a16="http://schemas.microsoft.com/office/drawing/2014/main" val="10004"/>
+                  </a:ext>
+                </a:extLst>
               </a:tr>
               <a:tr h="297180">
                 <a:tc>
                   <a:txBody>
-                    <a:bodyPr wrap="square"/>
+                    <a:bodyPr/>
                     <a:lstStyle/>
                     <a:p>
                       <a:pPr algn="ctr"/>
@@ -30415,7 +30538,7 @@
                       </a:r>
                     </a:p>
                   </a:txBody>
-                  <a:tcPr anchor="ctr" marL="91440" marR="91440" marT="18288" marB="18288">
+                  <a:tcPr marT="18288" marB="18288" anchor="ctr">
                     <a:lnL w="9525">
                       <a:solidFill>
                         <a:srgbClr val="D3DEEA"/>
@@ -30443,7 +30566,7 @@
                 </a:tc>
                 <a:tc>
                   <a:txBody>
-                    <a:bodyPr wrap="square"/>
+                    <a:bodyPr/>
                     <a:lstStyle/>
                     <a:p>
                       <a:pPr algn="r"/>
@@ -30460,7 +30583,7 @@
                       </a:r>
                     </a:p>
                   </a:txBody>
-                  <a:tcPr anchor="ctr" marL="91440" marR="91440" marT="18288" marB="18288">
+                  <a:tcPr marT="18288" marB="18288" anchor="ctr">
                     <a:lnL w="9525">
                       <a:solidFill>
                         <a:srgbClr val="D3DEEA"/>
@@ -30488,7 +30611,7 @@
                 </a:tc>
                 <a:tc>
                   <a:txBody>
-                    <a:bodyPr wrap="square"/>
+                    <a:bodyPr/>
                     <a:lstStyle/>
                     <a:p>
                       <a:pPr algn="r"/>
@@ -30505,7 +30628,7 @@
                       </a:r>
                     </a:p>
                   </a:txBody>
-                  <a:tcPr anchor="ctr" marL="91440" marR="91440" marT="18288" marB="18288">
+                  <a:tcPr marT="18288" marB="18288" anchor="ctr">
                     <a:lnL w="9525">
                       <a:solidFill>
                         <a:srgbClr val="D3DEEA"/>
@@ -30533,7 +30656,7 @@
                 </a:tc>
                 <a:tc>
                   <a:txBody>
-                    <a:bodyPr wrap="square"/>
+                    <a:bodyPr/>
                     <a:lstStyle/>
                     <a:p>
                       <a:pPr algn="r"/>
@@ -30550,7 +30673,7 @@
                       </a:r>
                     </a:p>
                   </a:txBody>
-                  <a:tcPr anchor="ctr" marL="91440" marR="91440" marT="18288" marB="18288">
+                  <a:tcPr marT="18288" marB="18288" anchor="ctr">
                     <a:lnL w="9525">
                       <a:solidFill>
                         <a:srgbClr val="D3DEEA"/>
@@ -30576,11 +30699,16 @@
                     </a:solidFill>
                   </a:tcPr>
                 </a:tc>
+                <a:extLst>
+                  <a:ext uri="{0D108BD9-81ED-4DB2-BD59-A6C34878D82A}">
+                    <a16:rowId xmlns:a16="http://schemas.microsoft.com/office/drawing/2014/main" val="10005"/>
+                  </a:ext>
+                </a:extLst>
               </a:tr>
               <a:tr h="297180">
                 <a:tc>
                   <a:txBody>
-                    <a:bodyPr wrap="square"/>
+                    <a:bodyPr/>
                     <a:lstStyle/>
                     <a:p>
                       <a:pPr algn="ctr"/>
@@ -30597,7 +30725,7 @@
                       </a:r>
                     </a:p>
                   </a:txBody>
-                  <a:tcPr anchor="ctr" marL="91440" marR="91440" marT="18288" marB="18288">
+                  <a:tcPr marT="18288" marB="18288" anchor="ctr">
                     <a:lnL w="9525">
                       <a:solidFill>
                         <a:srgbClr val="D3DEEA"/>
@@ -30625,7 +30753,7 @@
                 </a:tc>
                 <a:tc>
                   <a:txBody>
-                    <a:bodyPr wrap="square"/>
+                    <a:bodyPr/>
                     <a:lstStyle/>
                     <a:p>
                       <a:pPr algn="r"/>
@@ -30642,7 +30770,7 @@
                       </a:r>
                     </a:p>
                   </a:txBody>
-                  <a:tcPr anchor="ctr" marL="91440" marR="91440" marT="18288" marB="18288">
+                  <a:tcPr marT="18288" marB="18288" anchor="ctr">
                     <a:lnL w="9525">
                       <a:solidFill>
                         <a:srgbClr val="D3DEEA"/>
@@ -30670,7 +30798,7 @@
                 </a:tc>
                 <a:tc>
                   <a:txBody>
-                    <a:bodyPr wrap="square"/>
+                    <a:bodyPr/>
                     <a:lstStyle/>
                     <a:p>
                       <a:pPr algn="r"/>
@@ -30687,7 +30815,7 @@
                       </a:r>
                     </a:p>
                   </a:txBody>
-                  <a:tcPr anchor="ctr" marL="91440" marR="91440" marT="18288" marB="18288">
+                  <a:tcPr marT="18288" marB="18288" anchor="ctr">
                     <a:lnL w="9525">
                       <a:solidFill>
                         <a:srgbClr val="D3DEEA"/>
@@ -30715,7 +30843,7 @@
                 </a:tc>
                 <a:tc>
                   <a:txBody>
-                    <a:bodyPr wrap="square"/>
+                    <a:bodyPr/>
                     <a:lstStyle/>
                     <a:p>
                       <a:pPr algn="r"/>
@@ -30732,7 +30860,7 @@
                       </a:r>
                     </a:p>
                   </a:txBody>
-                  <a:tcPr anchor="ctr" marL="91440" marR="91440" marT="18288" marB="18288">
+                  <a:tcPr marT="18288" marB="18288" anchor="ctr">
                     <a:lnL w="9525">
                       <a:solidFill>
                         <a:srgbClr val="D3DEEA"/>
@@ -30758,6 +30886,11 @@
                     </a:solidFill>
                   </a:tcPr>
                 </a:tc>
+                <a:extLst>
+                  <a:ext uri="{0D108BD9-81ED-4DB2-BD59-A6C34878D82A}">
+                    <a16:rowId xmlns:a16="http://schemas.microsoft.com/office/drawing/2014/main" val="10006"/>
+                  </a:ext>
+                </a:extLst>
               </a:tr>
             </a:tbl>
           </a:graphicData>
@@ -30837,7 +30970,7 @@
               <a:buNone/>
             </a:pPr>
             <a:r>
-              <a:rPr sz="1400" b="1">
+              <a:rPr sz="1400" b="1" dirty="0" err="1">
                 <a:solidFill>
                   <a:srgbClr val="D46A12"/>
                 </a:solidFill>
@@ -30845,9 +30978,42 @@
                 <a:ea typeface="Microsoft JhengHei"/>
                 <a:cs typeface="Microsoft JhengHei"/>
               </a:rPr>
-              <a:t>新臺幣／月；Gemini 3.1 Flash-Lite 每百萬 token 0.25／1.50 美元（10/18 查，1 USD≈32 元）；未含人力，見附錄 C、F。</a:t>
-            </a:r>
-            <a:endParaRPr sz="1400"/>
+              <a:t>新臺幣／月；Gemini</a:t>
+            </a:r>
+            <a:r>
+              <a:rPr sz="1400" b="1" dirty="0">
+                <a:solidFill>
+                  <a:srgbClr val="D46A12"/>
+                </a:solidFill>
+                <a:latin typeface="Microsoft JhengHei"/>
+                <a:ea typeface="Microsoft JhengHei"/>
+                <a:cs typeface="Microsoft JhengHei"/>
+              </a:rPr>
+              <a:t> 3.1 Flash-Lite </a:t>
+            </a:r>
+            <a:r>
+              <a:rPr sz="1400" b="1" dirty="0" err="1">
+                <a:solidFill>
+                  <a:srgbClr val="D46A12"/>
+                </a:solidFill>
+                <a:latin typeface="Microsoft JhengHei"/>
+                <a:ea typeface="Microsoft JhengHei"/>
+                <a:cs typeface="Microsoft JhengHei"/>
+              </a:rPr>
+              <a:t>每百萬</a:t>
+            </a:r>
+            <a:r>
+              <a:rPr sz="1400" b="1" dirty="0">
+                <a:solidFill>
+                  <a:srgbClr val="D46A12"/>
+                </a:solidFill>
+                <a:latin typeface="Microsoft JhengHei"/>
+                <a:ea typeface="Microsoft JhengHei"/>
+                <a:cs typeface="Microsoft JhengHei"/>
+              </a:rPr>
+              <a:t> token 0.25／1.50 美元（1 USD≈32 元）。</a:t>
+            </a:r>
+            <a:endParaRPr sz="1400" dirty="0"/>
           </a:p>
         </p:txBody>
       </p:sp>
@@ -31017,16 +31183,22 @@
               <a:gd name="adj" fmla="val 18824"/>
             </a:avLst>
           </a:prstGeom>
-          <a:solidFill>
-            <a:srgbClr val="F5F8FC"/>
-          </a:solidFill>
-          <a:ln w="12700">
-            <a:solidFill>
-              <a:srgbClr val="F5F8FC"/>
-            </a:solidFill>
-            <a:prstDash val="solid"/>
-          </a:ln>
-        </p:spPr>
+          <a:ln/>
+        </p:spPr>
+        <p:style>
+          <a:lnRef idx="2">
+            <a:schemeClr val="accent3"/>
+          </a:lnRef>
+          <a:fillRef idx="1">
+            <a:schemeClr val="lt1"/>
+          </a:fillRef>
+          <a:effectRef idx="0">
+            <a:schemeClr val="accent3"/>
+          </a:effectRef>
+          <a:fontRef idx="minor">
+            <a:schemeClr val="dk1"/>
+          </a:fontRef>
+        </p:style>
         <p:txBody>
           <a:bodyPr/>
           <a:lstStyle/>
@@ -32479,7 +32651,7 @@
               <a:buNone/>
             </a:pPr>
             <a:r>
-              <a:rPr sz="1400" b="1">
+              <a:rPr sz="1400" b="1" dirty="0">
                 <a:solidFill>
                   <a:srgbClr val="D46A12"/>
                 </a:solidFill>
@@ -32487,9 +32659,42 @@
                 <a:ea typeface="Microsoft JhengHei"/>
                 <a:cs typeface="Microsoft JhengHei"/>
               </a:rPr>
-              <a:t>Agentic AI 是評審C最後的提問：通用 AI 能自己搜尋整理，我們靠累積資料與可回查做區隔</a:t>
-            </a:r>
-            <a:endParaRPr sz="1400"/>
+              <a:t>Agentic AI </a:t>
+            </a:r>
+            <a:r>
+              <a:rPr sz="1400" b="1" dirty="0" err="1">
+                <a:solidFill>
+                  <a:srgbClr val="D46A12"/>
+                </a:solidFill>
+                <a:latin typeface="Microsoft JhengHei"/>
+                <a:ea typeface="Microsoft JhengHei"/>
+                <a:cs typeface="Microsoft JhengHei"/>
+              </a:rPr>
+              <a:t>是評審最後的提問：通用</a:t>
+            </a:r>
+            <a:r>
+              <a:rPr sz="1400" b="1" dirty="0">
+                <a:solidFill>
+                  <a:srgbClr val="D46A12"/>
+                </a:solidFill>
+                <a:latin typeface="Microsoft JhengHei"/>
+                <a:ea typeface="Microsoft JhengHei"/>
+                <a:cs typeface="Microsoft JhengHei"/>
+              </a:rPr>
+              <a:t> AI </a:t>
+            </a:r>
+            <a:r>
+              <a:rPr sz="1400" b="1" dirty="0" err="1">
+                <a:solidFill>
+                  <a:srgbClr val="D46A12"/>
+                </a:solidFill>
+                <a:latin typeface="Microsoft JhengHei"/>
+                <a:ea typeface="Microsoft JhengHei"/>
+                <a:cs typeface="Microsoft JhengHei"/>
+              </a:rPr>
+              <a:t>能自己搜尋整理，我們靠累積資料與可回查做區隔</a:t>
+            </a:r>
+            <a:endParaRPr sz="1400" dirty="0"/>
           </a:p>
         </p:txBody>
       </p:sp>

</xml_diff>